<commit_message>
Remove ownership-transfer row and rebalance boxes on slides 2-3
Co-Authored-By: Claude Opus 5.5 <noreply@anthropic.com>
Claude-Session: https://claude.ai/code/session_01D73U26FQnMJ6VM9LfvsWf3
</commit_message>
<xml_diff>
--- a/عرض_الإيرادات_سيناريوهات_إقفال_2026.pptx
+++ b/عرض_الإيرادات_سيناريوهات_إقفال_2026.pptx
@@ -1023,25 +1023,22 @@
           </c:dLbls>
           <c:cat>
             <c:strRef>
-              <c:f>Sheet1!$A$2:$A$7</c:f>
+              <c:f>Sheet1!$A$2:$A$6</c:f>
               <c:strCache>
-                <c:ptCount val="6"/>
+                <c:ptCount val="5"/>
                 <c:pt idx="0">
-                  <c:v>نقل الملكية</c:v>
+                  <c:v>اخرى</c:v>
                 </c:pt>
                 <c:pt idx="1">
-                  <c:v>اخرى</c:v>
+                  <c:v>التبغ والايواء</c:v>
                 </c:pt>
                 <c:pt idx="2">
-                  <c:v>التبغ والايواء</c:v>
+                  <c:v>جزاءات وغرامات</c:v>
                 </c:pt>
                 <c:pt idx="3">
-                  <c:v>جزاءات وغرامات</c:v>
+                  <c:v>الرسوم والتراخيص</c:v>
                 </c:pt>
                 <c:pt idx="4">
-                  <c:v>الرسوم والتراخيص</c:v>
-                </c:pt>
-                <c:pt idx="5">
                   <c:v>ايرادات الاستثمارية</c:v>
                 </c:pt>
               </c:strCache>
@@ -1049,23 +1046,23 @@
           </c:cat>
           <c:val>
             <c:numRef>
-              <c:f>Sheet1!$B$2:$B$7</c:f>
+              <c:f>Sheet1!$B$2:$B$6</c:f>
               <c:numCache>
                 <c:formatCode>_(* #,##0_);_(* \(#,##0\);_(* "-"??_);_(@_)</c:formatCode>
-                <c:ptCount val="6"/>
-                <c:pt idx="1">
+                <c:ptCount val="5"/>
+                <c:pt idx="0">
                   <c:v>8675213.58</c:v>
                 </c:pt>
-                <c:pt idx="2">
+                <c:pt idx="1">
                   <c:v>23105866.589999996</c:v>
                 </c:pt>
-                <c:pt idx="3">
+                <c:pt idx="2">
                   <c:v>33306929.0</c:v>
                 </c:pt>
-                <c:pt idx="4">
+                <c:pt idx="3">
                   <c:v>78404496.24</c:v>
                 </c:pt>
-                <c:pt idx="5">
+                <c:pt idx="4">
                   <c:v>45487295.11</c:v>
                 </c:pt>
               </c:numCache>
@@ -1306,25 +1303,22 @@
           </c:dLbls>
           <c:cat>
             <c:strRef>
-              <c:f>Sheet1!$A$2:$A$7</c:f>
+              <c:f>Sheet1!$A$2:$A$6</c:f>
               <c:strCache>
-                <c:ptCount val="6"/>
+                <c:ptCount val="5"/>
                 <c:pt idx="0">
-                  <c:v>نقل الملكية</c:v>
+                  <c:v>اخرى</c:v>
                 </c:pt>
                 <c:pt idx="1">
-                  <c:v>اخرى</c:v>
+                  <c:v>التبغ والايواء</c:v>
                 </c:pt>
                 <c:pt idx="2">
-                  <c:v>التبغ والايواء</c:v>
+                  <c:v>جزاءات وغرامات</c:v>
                 </c:pt>
                 <c:pt idx="3">
-                  <c:v>جزاءات وغرامات</c:v>
+                  <c:v>الرسوم والتراخيص</c:v>
                 </c:pt>
                 <c:pt idx="4">
-                  <c:v>الرسوم والتراخيص</c:v>
-                </c:pt>
-                <c:pt idx="5">
                   <c:v>ايرادات الاستثمارية</c:v>
                 </c:pt>
               </c:strCache>
@@ -1332,23 +1326,23 @@
           </c:cat>
           <c:val>
             <c:numRef>
-              <c:f>Sheet1!$C$2:$C$7</c:f>
+              <c:f>Sheet1!$C$2:$C$6</c:f>
               <c:numCache>
                 <c:formatCode>_(* #,##0_);_(* \(#,##0\);_(* "-"??_);_(@_)</c:formatCode>
-                <c:ptCount val="6"/>
-                <c:pt idx="1">
+                <c:ptCount val="5"/>
+                <c:pt idx="0">
                   <c:v>8524595.42</c:v>
                 </c:pt>
-                <c:pt idx="2">
+                <c:pt idx="1">
                   <c:v>34427181.46</c:v>
                 </c:pt>
-                <c:pt idx="3">
+                <c:pt idx="2">
                   <c:v>50463196.19</c:v>
                 </c:pt>
-                <c:pt idx="4">
+                <c:pt idx="3">
                   <c:v>96839259.07000001</c:v>
                 </c:pt>
-                <c:pt idx="5">
+                <c:pt idx="4">
                   <c:v>229687321.85</c:v>
                 </c:pt>
               </c:numCache>
@@ -1778,25 +1772,22 @@
           </c:dLbls>
           <c:cat>
             <c:strRef>
-              <c:f>Sheet1!$A$2:$A$7</c:f>
+              <c:f>Sheet1!$A$2:$A$6</c:f>
               <c:strCache>
-                <c:ptCount val="6"/>
+                <c:ptCount val="5"/>
                 <c:pt idx="0">
-                  <c:v>نقل الملكية</c:v>
+                  <c:v>اخرى</c:v>
                 </c:pt>
                 <c:pt idx="1">
-                  <c:v>اخرى</c:v>
+                  <c:v>التبغ والايواء</c:v>
                 </c:pt>
                 <c:pt idx="2">
-                  <c:v>التبغ والايواء</c:v>
+                  <c:v>جزاءات وغرامات</c:v>
                 </c:pt>
                 <c:pt idx="3">
-                  <c:v>جزاءات وغرامات</c:v>
+                  <c:v>الرسوم والتراخيص</c:v>
                 </c:pt>
                 <c:pt idx="4">
-                  <c:v>الرسوم والتراخيص</c:v>
-                </c:pt>
-                <c:pt idx="5">
                   <c:v>ايرادات الاستثمارية</c:v>
                 </c:pt>
               </c:strCache>
@@ -1804,23 +1795,23 @@
           </c:cat>
           <c:val>
             <c:numRef>
-              <c:f>Sheet1!$B$2:$B$7</c:f>
+              <c:f>Sheet1!$B$2:$B$6</c:f>
               <c:numCache>
                 <c:formatCode>_(* #,##0_);_(* \(#,##0\);_(* "-"??_);_(@_)</c:formatCode>
-                <c:ptCount val="6"/>
-                <c:pt idx="1">
+                <c:ptCount val="5"/>
+                <c:pt idx="0">
                   <c:v>193343076.23</c:v>
                 </c:pt>
-                <c:pt idx="2">
+                <c:pt idx="1">
                   <c:v>209094919.82</c:v>
                 </c:pt>
-                <c:pt idx="3">
+                <c:pt idx="2">
                   <c:v>638994901.72</c:v>
                 </c:pt>
-                <c:pt idx="4">
+                <c:pt idx="3">
                   <c:v>893640140.0200001</c:v>
                 </c:pt>
-                <c:pt idx="5">
+                <c:pt idx="4">
                   <c:v>1052146902.93</c:v>
                 </c:pt>
               </c:numCache>
@@ -2061,25 +2052,22 @@
           </c:dLbls>
           <c:cat>
             <c:strRef>
-              <c:f>Sheet1!$A$2:$A$7</c:f>
+              <c:f>Sheet1!$A$2:$A$6</c:f>
               <c:strCache>
-                <c:ptCount val="6"/>
+                <c:ptCount val="5"/>
                 <c:pt idx="0">
-                  <c:v>نقل الملكية</c:v>
+                  <c:v>اخرى</c:v>
                 </c:pt>
                 <c:pt idx="1">
-                  <c:v>اخرى</c:v>
+                  <c:v>التبغ والايواء</c:v>
                 </c:pt>
                 <c:pt idx="2">
-                  <c:v>التبغ والايواء</c:v>
+                  <c:v>جزاءات وغرامات</c:v>
                 </c:pt>
                 <c:pt idx="3">
-                  <c:v>جزاءات وغرامات</c:v>
+                  <c:v>الرسوم والتراخيص</c:v>
                 </c:pt>
                 <c:pt idx="4">
-                  <c:v>الرسوم والتراخيص</c:v>
-                </c:pt>
-                <c:pt idx="5">
                   <c:v>ايرادات الاستثمارية</c:v>
                 </c:pt>
               </c:strCache>
@@ -2087,23 +2075,23 @@
           </c:cat>
           <c:val>
             <c:numRef>
-              <c:f>Sheet1!$C$2:$C$7</c:f>
+              <c:f>Sheet1!$C$2:$C$6</c:f>
               <c:numCache>
                 <c:formatCode>_(* #,##0_);_(* \(#,##0\);_(* "-"??_);_(@_)</c:formatCode>
-                <c:ptCount val="6"/>
-                <c:pt idx="1">
+                <c:ptCount val="5"/>
+                <c:pt idx="0">
                   <c:v>83216589.45</c:v>
                 </c:pt>
-                <c:pt idx="2">
+                <c:pt idx="1">
                   <c:v>308355656.8</c:v>
                 </c:pt>
-                <c:pt idx="3">
+                <c:pt idx="2">
                   <c:v>426733084.53999996</c:v>
                 </c:pt>
-                <c:pt idx="4">
+                <c:pt idx="3">
                   <c:v>895660932.61</c:v>
                 </c:pt>
-                <c:pt idx="5">
+                <c:pt idx="4">
                   <c:v>1038815836.0899998</c:v>
                 </c:pt>
               </c:numCache>
@@ -2533,25 +2521,22 @@
           </c:dLbls>
           <c:cat>
             <c:strRef>
-              <c:f>Sheet1!$A$2:$A$7</c:f>
+              <c:f>Sheet1!$A$2:$A$6</c:f>
               <c:strCache>
-                <c:ptCount val="6"/>
+                <c:ptCount val="5"/>
                 <c:pt idx="0">
-                  <c:v>نقل الملكية</c:v>
+                  <c:v>اخرى</c:v>
                 </c:pt>
                 <c:pt idx="1">
-                  <c:v>اخرى</c:v>
+                  <c:v>التبغ والايواء</c:v>
                 </c:pt>
                 <c:pt idx="2">
-                  <c:v>التبغ والايواء</c:v>
+                  <c:v>جزاءات وغرامات</c:v>
                 </c:pt>
                 <c:pt idx="3">
-                  <c:v>جزاءات وغرامات</c:v>
+                  <c:v>الرسوم والتراخيص</c:v>
                 </c:pt>
                 <c:pt idx="4">
-                  <c:v>الرسوم والتراخيص</c:v>
-                </c:pt>
-                <c:pt idx="5">
                   <c:v>ايرادات الاستثمارية</c:v>
                 </c:pt>
               </c:strCache>
@@ -2559,23 +2544,23 @@
           </c:cat>
           <c:val>
             <c:numRef>
-              <c:f>Sheet1!$B$2:$B$7</c:f>
+              <c:f>Sheet1!$B$2:$B$6</c:f>
               <c:numCache>
                 <c:formatCode>_(* #,##0_);_(* \(#,##0\);_(* "-"??_);_(@_)</c:formatCode>
-                <c:ptCount val="6"/>
-                <c:pt idx="1">
+                <c:ptCount val="5"/>
+                <c:pt idx="0">
                   <c:v>243725370.2</c:v>
                 </c:pt>
-                <c:pt idx="2">
+                <c:pt idx="1">
                   <c:v>250988908.01</c:v>
                 </c:pt>
-                <c:pt idx="3">
+                <c:pt idx="2">
                   <c:v>720929105.2900001</c:v>
                 </c:pt>
-                <c:pt idx="4">
+                <c:pt idx="3">
                   <c:v>1119994051.89</c:v>
                 </c:pt>
-                <c:pt idx="5">
+                <c:pt idx="4">
                   <c:v>1217698975.83</c:v>
                 </c:pt>
               </c:numCache>
@@ -2816,25 +2801,22 @@
           </c:dLbls>
           <c:cat>
             <c:strRef>
-              <c:f>Sheet1!$A$2:$A$7</c:f>
+              <c:f>Sheet1!$A$2:$A$6</c:f>
               <c:strCache>
-                <c:ptCount val="6"/>
+                <c:ptCount val="5"/>
                 <c:pt idx="0">
-                  <c:v>نقل الملكية</c:v>
+                  <c:v>اخرى</c:v>
                 </c:pt>
                 <c:pt idx="1">
-                  <c:v>اخرى</c:v>
+                  <c:v>التبغ والايواء</c:v>
                 </c:pt>
                 <c:pt idx="2">
-                  <c:v>التبغ والايواء</c:v>
+                  <c:v>جزاءات وغرامات</c:v>
                 </c:pt>
                 <c:pt idx="3">
-                  <c:v>جزاءات وغرامات</c:v>
+                  <c:v>الرسوم والتراخيص</c:v>
                 </c:pt>
                 <c:pt idx="4">
-                  <c:v>الرسوم والتراخيص</c:v>
-                </c:pt>
-                <c:pt idx="5">
                   <c:v>ايرادات الاستثمارية</c:v>
                 </c:pt>
               </c:strCache>
@@ -2842,23 +2824,23 @@
           </c:cat>
           <c:val>
             <c:numRef>
-              <c:f>Sheet1!$C$2:$C$7</c:f>
+              <c:f>Sheet1!$C$2:$C$6</c:f>
               <c:numCache>
                 <c:formatCode>_(* #,##0_);_(* \(#,##0\);_(* "-"??_);_(@_)</c:formatCode>
-                <c:ptCount val="6"/>
-                <c:pt idx="1">
+                <c:ptCount val="5"/>
+                <c:pt idx="0">
                   <c:v>105224924.66</c:v>
                 </c:pt>
-                <c:pt idx="2">
+                <c:pt idx="1">
                   <c:v>399149362.49</c:v>
                 </c:pt>
-                <c:pt idx="3">
+                <c:pt idx="2">
                   <c:v>561503111.5999999</c:v>
                 </c:pt>
-                <c:pt idx="4">
+                <c:pt idx="3">
                   <c:v>1156685874.2</c:v>
                 </c:pt>
-                <c:pt idx="5">
+                <c:pt idx="4">
                   <c:v>1827436727.0799997</c:v>
                 </c:pt>
               </c:numCache>
@@ -4100,25 +4082,22 @@
           </c:dLbls>
           <c:cat>
             <c:strRef>
-              <c:f>Sheet1!$A$2:$A$7</c:f>
+              <c:f>Sheet1!$A$2:$A$6</c:f>
               <c:strCache>
-                <c:ptCount val="6"/>
+                <c:ptCount val="5"/>
                 <c:pt idx="0">
-                  <c:v>نقل الملكية</c:v>
+                  <c:v>اخرى</c:v>
                 </c:pt>
                 <c:pt idx="1">
-                  <c:v>اخرى</c:v>
+                  <c:v>التبغ والايواء</c:v>
                 </c:pt>
                 <c:pt idx="2">
-                  <c:v>التبغ والايواء</c:v>
+                  <c:v>جزاءات وغرامات</c:v>
                 </c:pt>
                 <c:pt idx="3">
-                  <c:v>جزاءات وغرامات</c:v>
+                  <c:v>الرسوم والتراخيص</c:v>
                 </c:pt>
                 <c:pt idx="4">
-                  <c:v>الرسوم والتراخيص</c:v>
-                </c:pt>
-                <c:pt idx="5">
                   <c:v>ايرادات الاستثمارية</c:v>
                 </c:pt>
               </c:strCache>
@@ -4126,23 +4105,23 @@
           </c:cat>
           <c:val>
             <c:numRef>
-              <c:f>Sheet1!$B$2:$B$7</c:f>
+              <c:f>Sheet1!$B$2:$B$6</c:f>
               <c:numCache>
                 <c:formatCode>_(* #,##0_);_(* \(#,##0\);_(* "-"??_);_(@_)</c:formatCode>
-                <c:ptCount val="6"/>
-                <c:pt idx="1">
+                <c:ptCount val="5"/>
+                <c:pt idx="0">
                   <c:v>33910933.49</c:v>
                 </c:pt>
-                <c:pt idx="2">
+                <c:pt idx="1">
                   <c:v>19089205.89</c:v>
                 </c:pt>
-                <c:pt idx="3">
+                <c:pt idx="2">
                   <c:v>34474898.45</c:v>
                 </c:pt>
-                <c:pt idx="4">
+                <c:pt idx="3">
                   <c:v>73692912.65</c:v>
                 </c:pt>
-                <c:pt idx="5">
+                <c:pt idx="4">
                   <c:v>38481934.10000001</c:v>
                 </c:pt>
               </c:numCache>
@@ -4383,25 +4362,22 @@
           </c:dLbls>
           <c:cat>
             <c:strRef>
-              <c:f>Sheet1!$A$2:$A$7</c:f>
+              <c:f>Sheet1!$A$2:$A$6</c:f>
               <c:strCache>
-                <c:ptCount val="6"/>
+                <c:ptCount val="5"/>
                 <c:pt idx="0">
-                  <c:v>نقل الملكية</c:v>
+                  <c:v>اخرى</c:v>
                 </c:pt>
                 <c:pt idx="1">
-                  <c:v>اخرى</c:v>
+                  <c:v>التبغ والايواء</c:v>
                 </c:pt>
                 <c:pt idx="2">
-                  <c:v>التبغ والايواء</c:v>
+                  <c:v>جزاءات وغرامات</c:v>
                 </c:pt>
                 <c:pt idx="3">
-                  <c:v>جزاءات وغرامات</c:v>
+                  <c:v>الرسوم والتراخيص</c:v>
                 </c:pt>
                 <c:pt idx="4">
-                  <c:v>الرسوم والتراخيص</c:v>
-                </c:pt>
-                <c:pt idx="5">
                   <c:v>ايرادات الاستثمارية</c:v>
                 </c:pt>
               </c:strCache>
@@ -4409,23 +4385,23 @@
           </c:cat>
           <c:val>
             <c:numRef>
-              <c:f>Sheet1!$C$2:$C$7</c:f>
+              <c:f>Sheet1!$C$2:$C$6</c:f>
               <c:numCache>
                 <c:formatCode>_(* #,##0_);_(* \(#,##0\);_(* "-"??_);_(@_)</c:formatCode>
-                <c:ptCount val="6"/>
-                <c:pt idx="1">
+                <c:ptCount val="5"/>
+                <c:pt idx="0">
                   <c:v>10370583.68</c:v>
                 </c:pt>
-                <c:pt idx="2">
+                <c:pt idx="1">
                   <c:v>29501207.800000004</c:v>
                 </c:pt>
-                <c:pt idx="3">
+                <c:pt idx="2">
                   <c:v>44888053.81</c:v>
                 </c:pt>
-                <c:pt idx="4">
+                <c:pt idx="3">
                   <c:v>91097976.65000002</c:v>
                 </c:pt>
-                <c:pt idx="5">
+                <c:pt idx="4">
                   <c:v>63384343.059999995</c:v>
                 </c:pt>
               </c:numCache>
@@ -4855,25 +4831,22 @@
           </c:dLbls>
           <c:cat>
             <c:strRef>
-              <c:f>Sheet1!$A$2:$A$7</c:f>
+              <c:f>Sheet1!$A$2:$A$6</c:f>
               <c:strCache>
-                <c:ptCount val="6"/>
+                <c:ptCount val="5"/>
                 <c:pt idx="0">
-                  <c:v>نقل الملكية</c:v>
+                  <c:v>اخرى</c:v>
                 </c:pt>
                 <c:pt idx="1">
-                  <c:v>اخرى</c:v>
+                  <c:v>التبغ والايواء</c:v>
                 </c:pt>
                 <c:pt idx="2">
-                  <c:v>التبغ والايواء</c:v>
+                  <c:v>جزاءات وغرامات</c:v>
                 </c:pt>
                 <c:pt idx="3">
-                  <c:v>جزاءات وغرامات</c:v>
+                  <c:v>الرسوم والتراخيص</c:v>
                 </c:pt>
                 <c:pt idx="4">
-                  <c:v>الرسوم والتراخيص</c:v>
-                </c:pt>
-                <c:pt idx="5">
                   <c:v>ايرادات الاستثمارية</c:v>
                 </c:pt>
               </c:strCache>
@@ -4881,23 +4854,23 @@
           </c:cat>
           <c:val>
             <c:numRef>
-              <c:f>Sheet1!$B$2:$B$7</c:f>
+              <c:f>Sheet1!$B$2:$B$6</c:f>
               <c:numCache>
                 <c:formatCode>_(* #,##0_);_(* \(#,##0\);_(* "-"??_);_(@_)</c:formatCode>
-                <c:ptCount val="6"/>
-                <c:pt idx="1">
+                <c:ptCount val="5"/>
+                <c:pt idx="0">
                   <c:v>8234884.26</c:v>
                 </c:pt>
-                <c:pt idx="2">
+                <c:pt idx="1">
                   <c:v>17371217.88</c:v>
                 </c:pt>
-                <c:pt idx="3">
+                <c:pt idx="2">
                   <c:v>30024191.68</c:v>
                 </c:pt>
-                <c:pt idx="4">
+                <c:pt idx="3">
                   <c:v>74654772.45000002</c:v>
                 </c:pt>
-                <c:pt idx="5">
+                <c:pt idx="4">
                   <c:v>474087329.8899999</c:v>
                 </c:pt>
               </c:numCache>
@@ -5138,25 +5111,22 @@
           </c:dLbls>
           <c:cat>
             <c:strRef>
-              <c:f>Sheet1!$A$2:$A$7</c:f>
+              <c:f>Sheet1!$A$2:$A$6</c:f>
               <c:strCache>
-                <c:ptCount val="6"/>
+                <c:ptCount val="5"/>
                 <c:pt idx="0">
-                  <c:v>نقل الملكية</c:v>
+                  <c:v>اخرى</c:v>
                 </c:pt>
                 <c:pt idx="1">
-                  <c:v>اخرى</c:v>
+                  <c:v>التبغ والايواء</c:v>
                 </c:pt>
                 <c:pt idx="2">
-                  <c:v>التبغ والايواء</c:v>
+                  <c:v>جزاءات وغرامات</c:v>
                 </c:pt>
                 <c:pt idx="3">
-                  <c:v>جزاءات وغرامات</c:v>
+                  <c:v>الرسوم والتراخيص</c:v>
                 </c:pt>
                 <c:pt idx="4">
-                  <c:v>الرسوم والتراخيص</c:v>
-                </c:pt>
-                <c:pt idx="5">
                   <c:v>ايرادات الاستثمارية</c:v>
                 </c:pt>
               </c:strCache>
@@ -5164,23 +5134,23 @@
           </c:cat>
           <c:val>
             <c:numRef>
-              <c:f>Sheet1!$C$2:$C$7</c:f>
+              <c:f>Sheet1!$C$2:$C$6</c:f>
               <c:numCache>
                 <c:formatCode>_(* #,##0_);_(* \(#,##0\);_(* "-"??_);_(@_)</c:formatCode>
-                <c:ptCount val="6"/>
-                <c:pt idx="1">
+                <c:ptCount val="5"/>
+                <c:pt idx="0">
                   <c:v>3113156.1100000003</c:v>
                 </c:pt>
-                <c:pt idx="2">
+                <c:pt idx="1">
                   <c:v>26865316.43</c:v>
                 </c:pt>
-                <c:pt idx="3">
+                <c:pt idx="2">
                   <c:v>39418777.06</c:v>
                 </c:pt>
-                <c:pt idx="4">
+                <c:pt idx="3">
                   <c:v>73087705.87</c:v>
                 </c:pt>
-                <c:pt idx="5">
+                <c:pt idx="4">
                   <c:v>495549226.08</c:v>
                 </c:pt>
               </c:numCache>
@@ -5610,25 +5580,22 @@
           </c:dLbls>
           <c:cat>
             <c:strRef>
-              <c:f>Sheet1!$A$2:$A$7</c:f>
+              <c:f>Sheet1!$A$2:$A$6</c:f>
               <c:strCache>
-                <c:ptCount val="6"/>
+                <c:ptCount val="5"/>
                 <c:pt idx="0">
-                  <c:v>نقل الملكية</c:v>
+                  <c:v>اخرى</c:v>
                 </c:pt>
                 <c:pt idx="1">
-                  <c:v>اخرى</c:v>
+                  <c:v>التبغ والايواء</c:v>
                 </c:pt>
                 <c:pt idx="2">
-                  <c:v>التبغ والايواء</c:v>
+                  <c:v>جزاءات وغرامات</c:v>
                 </c:pt>
                 <c:pt idx="3">
-                  <c:v>جزاءات وغرامات</c:v>
+                  <c:v>الرسوم والتراخيص</c:v>
                 </c:pt>
                 <c:pt idx="4">
-                  <c:v>الرسوم والتراخيص</c:v>
-                </c:pt>
-                <c:pt idx="5">
                   <c:v>ايرادات الاستثمارية</c:v>
                 </c:pt>
               </c:strCache>
@@ -5636,23 +5603,23 @@
           </c:cat>
           <c:val>
             <c:numRef>
-              <c:f>Sheet1!$B$2:$B$7</c:f>
+              <c:f>Sheet1!$B$2:$B$6</c:f>
               <c:numCache>
                 <c:formatCode>_(* #,##0_);_(* \(#,##0\);_(* "-"??_);_(@_)</c:formatCode>
-                <c:ptCount val="6"/>
-                <c:pt idx="1">
+                <c:ptCount val="5"/>
+                <c:pt idx="0">
                   <c:v>9434464.65</c:v>
                 </c:pt>
-                <c:pt idx="2">
+                <c:pt idx="1">
                   <c:v>26698792.11999981</c:v>
                 </c:pt>
-                <c:pt idx="3">
+                <c:pt idx="2">
                   <c:v>44335914.15</c:v>
                 </c:pt>
-                <c:pt idx="4">
+                <c:pt idx="3">
                   <c:v>78108897.81</c:v>
                 </c:pt>
-                <c:pt idx="5">
+                <c:pt idx="4">
                   <c:v>100179709.84</c:v>
                 </c:pt>
               </c:numCache>
@@ -5893,25 +5860,22 @@
           </c:dLbls>
           <c:cat>
             <c:strRef>
-              <c:f>Sheet1!$A$2:$A$7</c:f>
+              <c:f>Sheet1!$A$2:$A$6</c:f>
               <c:strCache>
-                <c:ptCount val="6"/>
+                <c:ptCount val="5"/>
                 <c:pt idx="0">
-                  <c:v>نقل الملكية</c:v>
+                  <c:v>اخرى</c:v>
                 </c:pt>
                 <c:pt idx="1">
-                  <c:v>اخرى</c:v>
+                  <c:v>التبغ والايواء</c:v>
                 </c:pt>
                 <c:pt idx="2">
-                  <c:v>التبغ والايواء</c:v>
+                  <c:v>جزاءات وغرامات</c:v>
                 </c:pt>
                 <c:pt idx="3">
-                  <c:v>جزاءات وغرامات</c:v>
+                  <c:v>الرسوم والتراخيص</c:v>
                 </c:pt>
                 <c:pt idx="4">
-                  <c:v>الرسوم والتراخيص</c:v>
-                </c:pt>
-                <c:pt idx="5">
                   <c:v>ايرادات الاستثمارية</c:v>
                 </c:pt>
               </c:strCache>
@@ -5919,23 +5883,23 @@
           </c:cat>
           <c:val>
             <c:numRef>
-              <c:f>Sheet1!$C$2:$C$7</c:f>
+              <c:f>Sheet1!$C$2:$C$6</c:f>
               <c:numCache>
                 <c:formatCode>_(* #,##0_);_(* \(#,##0\);_(* "-"??_);_(@_)</c:formatCode>
-                <c:ptCount val="6"/>
-                <c:pt idx="1">
+                <c:ptCount val="5"/>
+                <c:pt idx="0">
                   <c:v>8524595.42</c:v>
                 </c:pt>
-                <c:pt idx="2">
+                <c:pt idx="1">
                   <c:v>34427181.46</c:v>
                 </c:pt>
-                <c:pt idx="3">
+                <c:pt idx="2">
                   <c:v>50463196.19</c:v>
                 </c:pt>
-                <c:pt idx="4">
+                <c:pt idx="3">
                   <c:v>96839259.07000001</c:v>
                 </c:pt>
-                <c:pt idx="5">
+                <c:pt idx="4">
                   <c:v>229687321.85</c:v>
                 </c:pt>
               </c:numCache>
@@ -6365,25 +6329,22 @@
           </c:dLbls>
           <c:cat>
             <c:strRef>
-              <c:f>Sheet1!$A$2:$A$7</c:f>
+              <c:f>Sheet1!$A$2:$A$6</c:f>
               <c:strCache>
-                <c:ptCount val="6"/>
+                <c:ptCount val="5"/>
                 <c:pt idx="0">
-                  <c:v>نقل الملكية</c:v>
+                  <c:v>اخرى</c:v>
                 </c:pt>
                 <c:pt idx="1">
-                  <c:v>اخرى</c:v>
+                  <c:v>التبغ والايواء</c:v>
                 </c:pt>
                 <c:pt idx="2">
-                  <c:v>التبغ والايواء</c:v>
+                  <c:v>جزاءات وغرامات</c:v>
                 </c:pt>
                 <c:pt idx="3">
-                  <c:v>جزاءات وغرامات</c:v>
+                  <c:v>الرسوم والتراخيص</c:v>
                 </c:pt>
                 <c:pt idx="4">
-                  <c:v>الرسوم والتراخيص</c:v>
-                </c:pt>
-                <c:pt idx="5">
                   <c:v>ايرادات الاستثمارية</c:v>
                 </c:pt>
               </c:strCache>
@@ -6391,23 +6352,23 @@
           </c:cat>
           <c:val>
             <c:numRef>
-              <c:f>Sheet1!$B$2:$B$7</c:f>
+              <c:f>Sheet1!$B$2:$B$6</c:f>
               <c:numCache>
                 <c:formatCode>_(* #,##0_);_(* \(#,##0\);_(* "-"??_);_(@_)</c:formatCode>
-                <c:ptCount val="6"/>
-                <c:pt idx="1">
+                <c:ptCount val="5"/>
+                <c:pt idx="0">
                   <c:v>193343076.23</c:v>
                 </c:pt>
-                <c:pt idx="2">
+                <c:pt idx="1">
                   <c:v>209094919.82</c:v>
                 </c:pt>
-                <c:pt idx="3">
+                <c:pt idx="2">
                   <c:v>638994901.72</c:v>
                 </c:pt>
-                <c:pt idx="4">
+                <c:pt idx="3">
                   <c:v>893640140.0200001</c:v>
                 </c:pt>
-                <c:pt idx="5">
+                <c:pt idx="4">
                   <c:v>1052146902.93</c:v>
                 </c:pt>
               </c:numCache>
@@ -6648,25 +6609,22 @@
           </c:dLbls>
           <c:cat>
             <c:strRef>
-              <c:f>Sheet1!$A$2:$A$7</c:f>
+              <c:f>Sheet1!$A$2:$A$6</c:f>
               <c:strCache>
-                <c:ptCount val="6"/>
+                <c:ptCount val="5"/>
                 <c:pt idx="0">
-                  <c:v>نقل الملكية</c:v>
+                  <c:v>اخرى</c:v>
                 </c:pt>
                 <c:pt idx="1">
-                  <c:v>اخرى</c:v>
+                  <c:v>التبغ والايواء</c:v>
                 </c:pt>
                 <c:pt idx="2">
-                  <c:v>التبغ والايواء</c:v>
+                  <c:v>جزاءات وغرامات</c:v>
                 </c:pt>
                 <c:pt idx="3">
-                  <c:v>جزاءات وغرامات</c:v>
+                  <c:v>الرسوم والتراخيص</c:v>
                 </c:pt>
                 <c:pt idx="4">
-                  <c:v>الرسوم والتراخيص</c:v>
-                </c:pt>
-                <c:pt idx="5">
                   <c:v>ايرادات الاستثمارية</c:v>
                 </c:pt>
               </c:strCache>
@@ -6674,23 +6632,23 @@
           </c:cat>
           <c:val>
             <c:numRef>
-              <c:f>Sheet1!$C$2:$C$7</c:f>
+              <c:f>Sheet1!$C$2:$C$6</c:f>
               <c:numCache>
                 <c:formatCode>_(* #,##0_);_(* \(#,##0\);_(* "-"??_);_(@_)</c:formatCode>
-                <c:ptCount val="6"/>
-                <c:pt idx="1">
+                <c:ptCount val="5"/>
+                <c:pt idx="0">
                   <c:v>83216589.45</c:v>
                 </c:pt>
-                <c:pt idx="2">
+                <c:pt idx="1">
                   <c:v>308355656.8</c:v>
                 </c:pt>
-                <c:pt idx="3">
+                <c:pt idx="2">
                   <c:v>426733084.53999996</c:v>
                 </c:pt>
-                <c:pt idx="4">
+                <c:pt idx="3">
                   <c:v>895660932.61</c:v>
                 </c:pt>
-                <c:pt idx="5">
+                <c:pt idx="4">
                   <c:v>1038815836.0899998</c:v>
                 </c:pt>
               </c:numCache>
@@ -7120,25 +7078,22 @@
           </c:dLbls>
           <c:cat>
             <c:strRef>
-              <c:f>Sheet1!$A$2:$A$7</c:f>
+              <c:f>Sheet1!$A$2:$A$6</c:f>
               <c:strCache>
-                <c:ptCount val="6"/>
+                <c:ptCount val="5"/>
                 <c:pt idx="0">
-                  <c:v>نقل الملكية</c:v>
+                  <c:v>اخرى</c:v>
                 </c:pt>
                 <c:pt idx="1">
-                  <c:v>اخرى</c:v>
+                  <c:v>التبغ والايواء</c:v>
                 </c:pt>
                 <c:pt idx="2">
-                  <c:v>التبغ والايواء</c:v>
+                  <c:v>جزاءات وغرامات</c:v>
                 </c:pt>
                 <c:pt idx="3">
-                  <c:v>جزاءات وغرامات</c:v>
+                  <c:v>الرسوم والتراخيص</c:v>
                 </c:pt>
                 <c:pt idx="4">
-                  <c:v>الرسوم والتراخيص</c:v>
-                </c:pt>
-                <c:pt idx="5">
                   <c:v>ايرادات الاستثمارية</c:v>
                 </c:pt>
               </c:strCache>
@@ -7146,23 +7101,23 @@
           </c:cat>
           <c:val>
             <c:numRef>
-              <c:f>Sheet1!$B$2:$B$7</c:f>
+              <c:f>Sheet1!$B$2:$B$6</c:f>
               <c:numCache>
                 <c:formatCode>_(* #,##0_);_(* \(#,##0\);_(* "-"??_);_(@_)</c:formatCode>
-                <c:ptCount val="6"/>
-                <c:pt idx="1">
+                <c:ptCount val="5"/>
+                <c:pt idx="0">
                   <c:v>244923358.63</c:v>
                 </c:pt>
-                <c:pt idx="2">
+                <c:pt idx="1">
                   <c:v>272254135.7099998</c:v>
                 </c:pt>
-                <c:pt idx="3">
+                <c:pt idx="2">
                   <c:v>747829906.0</c:v>
                 </c:pt>
-                <c:pt idx="4">
+                <c:pt idx="3">
                   <c:v>1120096722.93</c:v>
                 </c:pt>
-                <c:pt idx="5">
+                <c:pt idx="4">
                   <c:v>1664895876.76</c:v>
                 </c:pt>
               </c:numCache>
@@ -7403,25 +7358,22 @@
           </c:dLbls>
           <c:cat>
             <c:strRef>
-              <c:f>Sheet1!$A$2:$A$7</c:f>
+              <c:f>Sheet1!$A$2:$A$6</c:f>
               <c:strCache>
-                <c:ptCount val="6"/>
+                <c:ptCount val="5"/>
                 <c:pt idx="0">
-                  <c:v>نقل الملكية</c:v>
+                  <c:v>اخرى</c:v>
                 </c:pt>
                 <c:pt idx="1">
-                  <c:v>اخرى</c:v>
+                  <c:v>التبغ والايواء</c:v>
                 </c:pt>
                 <c:pt idx="2">
-                  <c:v>التبغ والايواء</c:v>
+                  <c:v>جزاءات وغرامات</c:v>
                 </c:pt>
                 <c:pt idx="3">
-                  <c:v>جزاءات وغرامات</c:v>
+                  <c:v>الرسوم والتراخيص</c:v>
                 </c:pt>
                 <c:pt idx="4">
-                  <c:v>الرسوم والتراخيص</c:v>
-                </c:pt>
-                <c:pt idx="5">
                   <c:v>ايرادات الاستثمارية</c:v>
                 </c:pt>
               </c:strCache>
@@ -7429,23 +7381,23 @@
           </c:cat>
           <c:val>
             <c:numRef>
-              <c:f>Sheet1!$C$2:$C$7</c:f>
+              <c:f>Sheet1!$C$2:$C$6</c:f>
               <c:numCache>
                 <c:formatCode>_(* #,##0_);_(* \(#,##0\);_(* "-"??_);_(@_)</c:formatCode>
-                <c:ptCount val="6"/>
-                <c:pt idx="1">
+                <c:ptCount val="5"/>
+                <c:pt idx="0">
                   <c:v>105224924.66</c:v>
                 </c:pt>
-                <c:pt idx="2">
+                <c:pt idx="1">
                   <c:v>399149362.49</c:v>
                 </c:pt>
-                <c:pt idx="3">
+                <c:pt idx="2">
                   <c:v>561503111.5999999</c:v>
                 </c:pt>
-                <c:pt idx="4">
+                <c:pt idx="3">
                   <c:v>1156685874.2</c:v>
                 </c:pt>
-                <c:pt idx="5">
+                <c:pt idx="4">
                   <c:v>1827436727.0799997</c:v>
                 </c:pt>
               </c:numCache>
@@ -8687,25 +8639,22 @@
           </c:dLbls>
           <c:cat>
             <c:strRef>
-              <c:f>Sheet1!$A$2:$A$7</c:f>
+              <c:f>Sheet1!$A$2:$A$6</c:f>
               <c:strCache>
-                <c:ptCount val="6"/>
+                <c:ptCount val="5"/>
                 <c:pt idx="0">
-                  <c:v>نقل الملكية</c:v>
+                  <c:v>اخرى</c:v>
                 </c:pt>
                 <c:pt idx="1">
-                  <c:v>اخرى</c:v>
+                  <c:v>التبغ والايواء</c:v>
                 </c:pt>
                 <c:pt idx="2">
-                  <c:v>التبغ والايواء</c:v>
+                  <c:v>جزاءات وغرامات</c:v>
                 </c:pt>
                 <c:pt idx="3">
-                  <c:v>جزاءات وغرامات</c:v>
+                  <c:v>الرسوم والتراخيص</c:v>
                 </c:pt>
                 <c:pt idx="4">
-                  <c:v>الرسوم والتراخيص</c:v>
-                </c:pt>
-                <c:pt idx="5">
                   <c:v>ايرادات الاستثمارية</c:v>
                 </c:pt>
               </c:strCache>
@@ -8713,23 +8662,23 @@
           </c:cat>
           <c:val>
             <c:numRef>
-              <c:f>Sheet1!$B$2:$B$7</c:f>
+              <c:f>Sheet1!$B$2:$B$6</c:f>
               <c:numCache>
                 <c:formatCode>_(* #,##0_);_(* \(#,##0\);_(* "-"??_);_(@_)</c:formatCode>
-                <c:ptCount val="6"/>
-                <c:pt idx="1">
+                <c:ptCount val="5"/>
+                <c:pt idx="0">
                   <c:v>33698904.559999995</c:v>
                 </c:pt>
-                <c:pt idx="2">
+                <c:pt idx="1">
                   <c:v>9836293.05</c:v>
                 </c:pt>
-                <c:pt idx="3">
+                <c:pt idx="2">
                   <c:v>25609460.23</c:v>
                 </c:pt>
-                <c:pt idx="4">
+                <c:pt idx="3">
                   <c:v>83284790.61</c:v>
                 </c:pt>
-                <c:pt idx="5">
+                <c:pt idx="4">
                   <c:v>42058613.78</c:v>
                 </c:pt>
               </c:numCache>
@@ -8970,25 +8919,22 @@
           </c:dLbls>
           <c:cat>
             <c:strRef>
-              <c:f>Sheet1!$A$2:$A$7</c:f>
+              <c:f>Sheet1!$A$2:$A$6</c:f>
               <c:strCache>
-                <c:ptCount val="6"/>
+                <c:ptCount val="5"/>
                 <c:pt idx="0">
-                  <c:v>نقل الملكية</c:v>
+                  <c:v>اخرى</c:v>
                 </c:pt>
                 <c:pt idx="1">
-                  <c:v>اخرى</c:v>
+                  <c:v>التبغ والايواء</c:v>
                 </c:pt>
                 <c:pt idx="2">
-                  <c:v>التبغ والايواء</c:v>
+                  <c:v>جزاءات وغرامات</c:v>
                 </c:pt>
                 <c:pt idx="3">
-                  <c:v>جزاءات وغرامات</c:v>
+                  <c:v>الرسوم والتراخيص</c:v>
                 </c:pt>
                 <c:pt idx="4">
-                  <c:v>الرسوم والتراخيص</c:v>
-                </c:pt>
-                <c:pt idx="5">
                   <c:v>ايرادات الاستثمارية</c:v>
                 </c:pt>
               </c:strCache>
@@ -8996,23 +8942,23 @@
           </c:cat>
           <c:val>
             <c:numRef>
-              <c:f>Sheet1!$C$2:$C$7</c:f>
+              <c:f>Sheet1!$C$2:$C$6</c:f>
               <c:numCache>
                 <c:formatCode>_(* #,##0_);_(* \(#,##0\);_(* "-"??_);_(@_)</c:formatCode>
-                <c:ptCount val="6"/>
-                <c:pt idx="1">
+                <c:ptCount val="5"/>
+                <c:pt idx="0">
                   <c:v>10370583.68</c:v>
                 </c:pt>
-                <c:pt idx="2">
+                <c:pt idx="1">
                   <c:v>29501207.800000004</c:v>
                 </c:pt>
-                <c:pt idx="3">
+                <c:pt idx="2">
                   <c:v>44888053.81</c:v>
                 </c:pt>
-                <c:pt idx="4">
+                <c:pt idx="3">
                   <c:v>91097976.65000002</c:v>
                 </c:pt>
-                <c:pt idx="5">
+                <c:pt idx="4">
                   <c:v>63384343.059999995</c:v>
                 </c:pt>
               </c:numCache>
@@ -9442,25 +9388,22 @@
           </c:dLbls>
           <c:cat>
             <c:strRef>
-              <c:f>Sheet1!$A$2:$A$7</c:f>
+              <c:f>Sheet1!$A$2:$A$6</c:f>
               <c:strCache>
-                <c:ptCount val="6"/>
+                <c:ptCount val="5"/>
                 <c:pt idx="0">
-                  <c:v>نقل الملكية</c:v>
+                  <c:v>اخرى</c:v>
                 </c:pt>
                 <c:pt idx="1">
-                  <c:v>اخرى</c:v>
+                  <c:v>التبغ والايواء</c:v>
                 </c:pt>
                 <c:pt idx="2">
-                  <c:v>التبغ والايواء</c:v>
+                  <c:v>جزاءات وغرامات</c:v>
                 </c:pt>
                 <c:pt idx="3">
-                  <c:v>جزاءات وغرامات</c:v>
+                  <c:v>الرسوم والتراخيص</c:v>
                 </c:pt>
                 <c:pt idx="4">
-                  <c:v>الرسوم والتراخيص</c:v>
-                </c:pt>
-                <c:pt idx="5">
                   <c:v>ايرادات الاستثمارية</c:v>
                 </c:pt>
               </c:strCache>
@@ -9468,23 +9411,23 @@
           </c:cat>
           <c:val>
             <c:numRef>
-              <c:f>Sheet1!$B$2:$B$7</c:f>
+              <c:f>Sheet1!$B$2:$B$6</c:f>
               <c:numCache>
                 <c:formatCode>_(* #,##0_);_(* \(#,##0\);_(* "-"??_);_(@_)</c:formatCode>
-                <c:ptCount val="6"/>
-                <c:pt idx="1">
+                <c:ptCount val="5"/>
+                <c:pt idx="0">
                   <c:v>8008175.83</c:v>
                 </c:pt>
-                <c:pt idx="2">
+                <c:pt idx="1">
                   <c:v>8951828.549999999</c:v>
                 </c:pt>
-                <c:pt idx="3">
+                <c:pt idx="2">
                   <c:v>23017814.34</c:v>
                 </c:pt>
-                <c:pt idx="4">
+                <c:pt idx="3">
                   <c:v>64664625.02000001</c:v>
                 </c:pt>
-                <c:pt idx="5">
+                <c:pt idx="4">
                   <c:v>78006164.00999999</c:v>
                 </c:pt>
               </c:numCache>
@@ -9725,25 +9668,22 @@
           </c:dLbls>
           <c:cat>
             <c:strRef>
-              <c:f>Sheet1!$A$2:$A$7</c:f>
+              <c:f>Sheet1!$A$2:$A$6</c:f>
               <c:strCache>
-                <c:ptCount val="6"/>
+                <c:ptCount val="5"/>
                 <c:pt idx="0">
-                  <c:v>نقل الملكية</c:v>
+                  <c:v>اخرى</c:v>
                 </c:pt>
                 <c:pt idx="1">
-                  <c:v>اخرى</c:v>
+                  <c:v>التبغ والايواء</c:v>
                 </c:pt>
                 <c:pt idx="2">
-                  <c:v>التبغ والايواء</c:v>
+                  <c:v>جزاءات وغرامات</c:v>
                 </c:pt>
                 <c:pt idx="3">
-                  <c:v>جزاءات وغرامات</c:v>
+                  <c:v>الرسوم والتراخيص</c:v>
                 </c:pt>
                 <c:pt idx="4">
-                  <c:v>الرسوم والتراخيص</c:v>
-                </c:pt>
-                <c:pt idx="5">
                   <c:v>ايرادات الاستثمارية</c:v>
                 </c:pt>
               </c:strCache>
@@ -9751,23 +9691,23 @@
           </c:cat>
           <c:val>
             <c:numRef>
-              <c:f>Sheet1!$C$2:$C$7</c:f>
+              <c:f>Sheet1!$C$2:$C$6</c:f>
               <c:numCache>
                 <c:formatCode>_(* #,##0_);_(* \(#,##0\);_(* "-"??_);_(@_)</c:formatCode>
-                <c:ptCount val="6"/>
-                <c:pt idx="1">
+                <c:ptCount val="5"/>
+                <c:pt idx="0">
                   <c:v>3113156.1100000003</c:v>
                 </c:pt>
-                <c:pt idx="2">
+                <c:pt idx="1">
                   <c:v>26865316.43</c:v>
                 </c:pt>
-                <c:pt idx="3">
+                <c:pt idx="2">
                   <c:v>39418777.06</c:v>
                 </c:pt>
-                <c:pt idx="4">
+                <c:pt idx="3">
                   <c:v>73087705.87</c:v>
                 </c:pt>
-                <c:pt idx="5">
+                <c:pt idx="4">
                   <c:v>495549226.08</c:v>
                 </c:pt>
               </c:numCache>
@@ -37479,7 +37419,7 @@
           <p:spPr>
             <a:xfrm>
               <a:off x="9413204" y="3059678"/>
-              <a:ext cx="3077501" cy="1265361"/>
+              <a:ext cx="3077501" cy="1572768"/>
             </a:xfrm>
             <a:prstGeom prst="roundRect">
               <a:avLst>
@@ -37534,8 +37474,8 @@
           </p:nvSpPr>
           <p:spPr>
             <a:xfrm>
-              <a:off x="9413203" y="4617767"/>
-              <a:ext cx="3077501" cy="1265361"/>
+              <a:off x="9413203" y="4930540"/>
+              <a:ext cx="3077501" cy="1572768"/>
             </a:xfrm>
             <a:prstGeom prst="roundRect">
               <a:avLst>
@@ -37590,8 +37530,8 @@
           </p:nvSpPr>
           <p:spPr>
             <a:xfrm>
-              <a:off x="9413203" y="6175857"/>
-              <a:ext cx="3077501" cy="1265361"/>
+              <a:off x="9413203" y="6801402"/>
+              <a:ext cx="3077501" cy="1572768"/>
             </a:xfrm>
             <a:prstGeom prst="roundRect">
               <a:avLst>
@@ -37646,8 +37586,8 @@
           </p:nvSpPr>
           <p:spPr>
             <a:xfrm>
-              <a:off x="9413203" y="7733946"/>
-              <a:ext cx="3077501" cy="1265361"/>
+              <a:off x="9413203" y="8672264"/>
+              <a:ext cx="3077501" cy="1572768"/>
             </a:xfrm>
             <a:prstGeom prst="roundRect">
               <a:avLst>
@@ -37702,64 +37642,8 @@
           </p:nvSpPr>
           <p:spPr>
             <a:xfrm>
-              <a:off x="9413203" y="9292036"/>
-              <a:ext cx="3077501" cy="1265361"/>
-            </a:xfrm>
-            <a:prstGeom prst="roundRect">
-              <a:avLst>
-                <a:gd name="adj" fmla="val 5149"/>
-              </a:avLst>
-            </a:prstGeom>
-            <a:solidFill>
-              <a:srgbClr val="FBFBFA"/>
-            </a:solidFill>
-            <a:ln>
-              <a:solidFill>
-                <a:srgbClr val="D9D9D9"/>
-              </a:solidFill>
-            </a:ln>
-          </p:spPr>
-          <p:style>
-            <a:lnRef idx="2">
-              <a:schemeClr val="accent1">
-                <a:shade val="15000"/>
-              </a:schemeClr>
-            </a:lnRef>
-            <a:fillRef idx="1">
-              <a:schemeClr val="accent1"/>
-            </a:fillRef>
-            <a:effectRef idx="0">
-              <a:schemeClr val="accent1"/>
-            </a:effectRef>
-            <a:fontRef idx="minor">
-              <a:schemeClr val="lt1"/>
-            </a:fontRef>
-          </p:style>
-          <p:txBody>
-            <a:bodyPr rtlCol="0" anchor="ctr"/>
-            <a:lstStyle/>
-            <a:p>
-              <a:pPr algn="ctr"/>
-              <a:endParaRPr lang="en-US"/>
-            </a:p>
-          </p:txBody>
-        </p:sp>
-        <p:sp>
-          <p:nvSpPr>
-            <p:cNvPr id="47" name="Rectangle: Rounded Corners 46">
-              <a:extLst>
-                <a:ext uri="{FF2B5EF4-FFF2-40B4-BE49-F238E27FC236}">
-                  <a16:creationId xmlns:a16="http://schemas.microsoft.com/office/drawing/2014/main" id="{55E13CBA-83D3-E50A-D122-FE69DA41FAA5}"/>
-                </a:ext>
-              </a:extLst>
-            </p:cNvPr>
-            <p:cNvSpPr/>
-            <p:nvPr/>
-          </p:nvSpPr>
-          <p:spPr>
-            <a:xfrm>
-              <a:off x="9413203" y="10850125"/>
-              <a:ext cx="3077501" cy="1265361"/>
+              <a:off x="9413203" y="10543126"/>
+              <a:ext cx="3077501" cy="1572768"/>
             </a:xfrm>
             <a:prstGeom prst="roundRect">
               <a:avLst>
@@ -37814,7 +37698,7 @@
           </p:nvSpPr>
           <p:spPr>
             <a:xfrm>
-              <a:off x="9326765" y="3499172"/>
+              <a:off x="9326765" y="3627957"/>
               <a:ext cx="3216069" cy="436210"/>
             </a:xfrm>
             <a:prstGeom prst="rect">
@@ -37871,7 +37755,7 @@
           </p:nvSpPr>
           <p:spPr>
             <a:xfrm>
-              <a:off x="9343918" y="5078551"/>
+              <a:off x="9343918" y="5498819"/>
               <a:ext cx="3216069" cy="436210"/>
             </a:xfrm>
             <a:prstGeom prst="rect">
@@ -37928,7 +37812,7 @@
           </p:nvSpPr>
           <p:spPr>
             <a:xfrm>
-              <a:off x="9370896" y="6629117"/>
+              <a:off x="9370896" y="7369681"/>
               <a:ext cx="3216069" cy="436210"/>
             </a:xfrm>
             <a:prstGeom prst="rect">
@@ -37985,7 +37869,7 @@
           </p:nvSpPr>
           <p:spPr>
             <a:xfrm>
-              <a:off x="9310448" y="8148522"/>
+              <a:off x="9310448" y="9240543"/>
               <a:ext cx="3216069" cy="436210"/>
             </a:xfrm>
             <a:prstGeom prst="rect">
@@ -38042,7 +37926,7 @@
           </p:nvSpPr>
           <p:spPr>
             <a:xfrm>
-              <a:off x="9364888" y="9733384"/>
+              <a:off x="9364888" y="11111405"/>
               <a:ext cx="3216069" cy="436210"/>
             </a:xfrm>
             <a:prstGeom prst="rect">
@@ -38081,63 +37965,6 @@
               <a:r>
                 <a:rPr lang="ar-SA"/>
                 <a:t>أخرى</a:t>
-              </a:r>
-            </a:p>
-          </p:txBody>
-        </p:sp>
-        <p:sp>
-          <p:nvSpPr>
-            <p:cNvPr id="102" name="TextBox 101">
-              <a:extLst>
-                <a:ext uri="{FF2B5EF4-FFF2-40B4-BE49-F238E27FC236}">
-                  <a16:creationId xmlns:a16="http://schemas.microsoft.com/office/drawing/2014/main" id="{07A5DABC-6412-B716-F9BE-0549AD3CA379}"/>
-                </a:ext>
-              </a:extLst>
-            </p:cNvPr>
-            <p:cNvSpPr txBox="1"/>
-            <p:nvPr/>
-          </p:nvSpPr>
-          <p:spPr>
-            <a:xfrm>
-              <a:off x="9343918" y="11288531"/>
-              <a:ext cx="3216069" cy="436210"/>
-            </a:xfrm>
-            <a:prstGeom prst="rect">
-              <a:avLst/>
-            </a:prstGeom>
-            <a:noFill/>
-          </p:spPr>
-          <p:txBody>
-            <a:bodyPr wrap="square" rtlCol="0">
-              <a:spAutoFit/>
-            </a:bodyPr>
-            <a:lstStyle>
-              <a:defPPr marR="0" lvl="0" algn="l" rtl="0">
-                <a:lnSpc>
-                  <a:spcPct val="100000"/>
-                </a:lnSpc>
-                <a:spcBef>
-                  <a:spcPts val="0"/>
-                </a:spcBef>
-                <a:spcAft>
-                  <a:spcPts val="0"/>
-                </a:spcAft>
-                <a:defRPr/>
-              </a:defPPr>
-              <a:lvl1pPr algn="ctr">
-                <a:defRPr sz="2400">
-                  <a:solidFill>
-                    <a:srgbClr val="106946"/>
-                  </a:solidFill>
-                  <a:latin typeface="Bahij TheSansArabic Bold" panose="02040503050201020203" charset="-78"/>
-                  <a:cs typeface="Bahij TheSansArabic Bold" panose="02040503050201020203" charset="-78"/>
-                </a:defRPr>
-              </a:lvl1pPr>
-            </a:lstStyle>
-            <a:p>
-              <a:r>
-                <a:rPr lang="ar-SA"/>
-                <a:t>نقل الملكية</a:t>
               </a:r>
             </a:p>
           </p:txBody>
@@ -38355,7 +38182,7 @@
         <p:spPr>
           <a:xfrm>
             <a:off x="12045918" y="3094854"/>
-            <a:ext cx="1576718" cy="1265361"/>
+            <a:ext cx="1576718" cy="1572768"/>
           </a:xfrm>
           <a:prstGeom prst="roundRect">
             <a:avLst>
@@ -38410,8 +38237,8 @@
         </p:nvSpPr>
         <p:spPr>
           <a:xfrm>
-            <a:off x="12045918" y="4652943"/>
-            <a:ext cx="1576718" cy="1265361"/>
+            <a:off x="12045918" y="4965716"/>
+            <a:ext cx="1576718" cy="1572768"/>
           </a:xfrm>
           <a:prstGeom prst="roundRect">
             <a:avLst>
@@ -38466,8 +38293,8 @@
         </p:nvSpPr>
         <p:spPr>
           <a:xfrm>
-            <a:off x="12045918" y="6211032"/>
-            <a:ext cx="1576718" cy="1265361"/>
+            <a:off x="12045918" y="6836578"/>
+            <a:ext cx="1576718" cy="1572768"/>
           </a:xfrm>
           <a:prstGeom prst="roundRect">
             <a:avLst>
@@ -38522,8 +38349,8 @@
         </p:nvSpPr>
         <p:spPr>
           <a:xfrm>
-            <a:off x="12045918" y="7769121"/>
-            <a:ext cx="1576718" cy="1265361"/>
+            <a:off x="12045918" y="8707440"/>
+            <a:ext cx="1576718" cy="1572768"/>
           </a:xfrm>
           <a:prstGeom prst="roundRect">
             <a:avLst>
@@ -38578,64 +38405,8 @@
         </p:nvSpPr>
         <p:spPr>
           <a:xfrm>
-            <a:off x="12045918" y="9327210"/>
-            <a:ext cx="1576718" cy="1265361"/>
-          </a:xfrm>
-          <a:prstGeom prst="roundRect">
-            <a:avLst>
-              <a:gd name="adj" fmla="val 5149"/>
-            </a:avLst>
-          </a:prstGeom>
-          <a:solidFill>
-            <a:srgbClr val="FBFBFA"/>
-          </a:solidFill>
-          <a:ln>
-            <a:solidFill>
-              <a:srgbClr val="D9D9D9"/>
-            </a:solidFill>
-          </a:ln>
-        </p:spPr>
-        <p:style>
-          <a:lnRef idx="2">
-            <a:schemeClr val="accent1">
-              <a:shade val="15000"/>
-            </a:schemeClr>
-          </a:lnRef>
-          <a:fillRef idx="1">
-            <a:schemeClr val="accent1"/>
-          </a:fillRef>
-          <a:effectRef idx="0">
-            <a:schemeClr val="accent1"/>
-          </a:effectRef>
-          <a:fontRef idx="minor">
-            <a:schemeClr val="lt1"/>
-          </a:fontRef>
-        </p:style>
-        <p:txBody>
-          <a:bodyPr rtlCol="0" anchor="ctr"/>
-          <a:lstStyle/>
-          <a:p>
-            <a:pPr algn="ctr"/>
-            <a:endParaRPr lang="en-US"/>
-          </a:p>
-        </p:txBody>
-      </p:sp>
-      <p:sp>
-        <p:nvSpPr>
-          <p:cNvPr id="241" name="Rectangle: Rounded Corners 240">
-            <a:extLst>
-              <a:ext uri="{FF2B5EF4-FFF2-40B4-BE49-F238E27FC236}">
-                <a16:creationId xmlns:a16="http://schemas.microsoft.com/office/drawing/2014/main" id="{F8B1E50D-10A1-C0DC-A8F2-E501659A4D7A}"/>
-              </a:ext>
-            </a:extLst>
-          </p:cNvPr>
-          <p:cNvSpPr/>
-          <p:nvPr/>
-        </p:nvSpPr>
-        <p:spPr>
-          <a:xfrm>
-            <a:off x="12045918" y="10885301"/>
-            <a:ext cx="1576718" cy="1265361"/>
+            <a:off x="12045918" y="10578302"/>
+            <a:ext cx="1576718" cy="1572768"/>
           </a:xfrm>
           <a:prstGeom prst="roundRect">
             <a:avLst>
@@ -38740,7 +38511,7 @@
         <p:spPr>
           <a:xfrm>
             <a:off x="14117845" y="3094854"/>
-            <a:ext cx="1576718" cy="1265361"/>
+            <a:ext cx="1576718" cy="1572768"/>
           </a:xfrm>
           <a:prstGeom prst="roundRect">
             <a:avLst>
@@ -38795,8 +38566,8 @@
         </p:nvSpPr>
         <p:spPr>
           <a:xfrm>
-            <a:off x="14117845" y="4652943"/>
-            <a:ext cx="1576718" cy="1265361"/>
+            <a:off x="14117845" y="4965716"/>
+            <a:ext cx="1576718" cy="1572768"/>
           </a:xfrm>
           <a:prstGeom prst="roundRect">
             <a:avLst>
@@ -38851,8 +38622,8 @@
         </p:nvSpPr>
         <p:spPr>
           <a:xfrm>
-            <a:off x="14117845" y="6211032"/>
-            <a:ext cx="1576718" cy="1265361"/>
+            <a:off x="14117845" y="6836578"/>
+            <a:ext cx="1576718" cy="1572768"/>
           </a:xfrm>
           <a:prstGeom prst="roundRect">
             <a:avLst>
@@ -38907,8 +38678,8 @@
         </p:nvSpPr>
         <p:spPr>
           <a:xfrm>
-            <a:off x="14117845" y="7769121"/>
-            <a:ext cx="1576718" cy="1265361"/>
+            <a:off x="14117845" y="8707440"/>
+            <a:ext cx="1576718" cy="1572768"/>
           </a:xfrm>
           <a:prstGeom prst="roundRect">
             <a:avLst>
@@ -38963,64 +38734,8 @@
         </p:nvSpPr>
         <p:spPr>
           <a:xfrm>
-            <a:off x="14117845" y="9327210"/>
-            <a:ext cx="1576718" cy="1265361"/>
-          </a:xfrm>
-          <a:prstGeom prst="roundRect">
-            <a:avLst>
-              <a:gd name="adj" fmla="val 5149"/>
-            </a:avLst>
-          </a:prstGeom>
-          <a:solidFill>
-            <a:srgbClr val="FBFBFA"/>
-          </a:solidFill>
-          <a:ln>
-            <a:solidFill>
-              <a:srgbClr val="D9D9D9"/>
-            </a:solidFill>
-          </a:ln>
-        </p:spPr>
-        <p:style>
-          <a:lnRef idx="2">
-            <a:schemeClr val="accent1">
-              <a:shade val="15000"/>
-            </a:schemeClr>
-          </a:lnRef>
-          <a:fillRef idx="1">
-            <a:schemeClr val="accent1"/>
-          </a:fillRef>
-          <a:effectRef idx="0">
-            <a:schemeClr val="accent1"/>
-          </a:effectRef>
-          <a:fontRef idx="minor">
-            <a:schemeClr val="lt1"/>
-          </a:fontRef>
-        </p:style>
-        <p:txBody>
-          <a:bodyPr rtlCol="0" anchor="ctr"/>
-          <a:lstStyle/>
-          <a:p>
-            <a:pPr algn="ctr"/>
-            <a:endParaRPr lang="en-US"/>
-          </a:p>
-        </p:txBody>
-      </p:sp>
-      <p:sp>
-        <p:nvSpPr>
-          <p:cNvPr id="560" name="Rectangle: Rounded Corners 559">
-            <a:extLst>
-              <a:ext uri="{FF2B5EF4-FFF2-40B4-BE49-F238E27FC236}">
-                <a16:creationId xmlns:a16="http://schemas.microsoft.com/office/drawing/2014/main" id="{1F44F292-CE10-63C9-93C6-508383DDA38B}"/>
-              </a:ext>
-            </a:extLst>
-          </p:cNvPr>
-          <p:cNvSpPr/>
-          <p:nvPr/>
-        </p:nvSpPr>
-        <p:spPr>
-          <a:xfrm>
-            <a:off x="14117845" y="10885301"/>
-            <a:ext cx="1576718" cy="1265361"/>
+            <a:off x="14117845" y="10578302"/>
+            <a:ext cx="1576718" cy="1572768"/>
           </a:xfrm>
           <a:prstGeom prst="roundRect">
             <a:avLst>
@@ -39125,7 +38840,7 @@
         <p:spPr>
           <a:xfrm>
             <a:off x="16189772" y="3094854"/>
-            <a:ext cx="1576718" cy="1265361"/>
+            <a:ext cx="1576718" cy="1572768"/>
           </a:xfrm>
           <a:prstGeom prst="roundRect">
             <a:avLst>
@@ -39180,8 +38895,8 @@
         </p:nvSpPr>
         <p:spPr>
           <a:xfrm>
-            <a:off x="16189772" y="4652943"/>
-            <a:ext cx="1576718" cy="1265361"/>
+            <a:off x="16189772" y="4965716"/>
+            <a:ext cx="1576718" cy="1572768"/>
           </a:xfrm>
           <a:prstGeom prst="roundRect">
             <a:avLst>
@@ -39236,8 +38951,8 @@
         </p:nvSpPr>
         <p:spPr>
           <a:xfrm>
-            <a:off x="16189772" y="6211032"/>
-            <a:ext cx="1576718" cy="1265361"/>
+            <a:off x="16189772" y="6836578"/>
+            <a:ext cx="1576718" cy="1572768"/>
           </a:xfrm>
           <a:prstGeom prst="roundRect">
             <a:avLst>
@@ -39292,8 +39007,8 @@
         </p:nvSpPr>
         <p:spPr>
           <a:xfrm>
-            <a:off x="16189772" y="7769121"/>
-            <a:ext cx="1576718" cy="1265361"/>
+            <a:off x="16189772" y="8707440"/>
+            <a:ext cx="1576718" cy="1572768"/>
           </a:xfrm>
           <a:prstGeom prst="roundRect">
             <a:avLst>
@@ -39348,64 +39063,8 @@
         </p:nvSpPr>
         <p:spPr>
           <a:xfrm>
-            <a:off x="16189772" y="9327210"/>
-            <a:ext cx="1576718" cy="1265361"/>
-          </a:xfrm>
-          <a:prstGeom prst="roundRect">
-            <a:avLst>
-              <a:gd name="adj" fmla="val 5149"/>
-            </a:avLst>
-          </a:prstGeom>
-          <a:solidFill>
-            <a:srgbClr val="FBFBFA"/>
-          </a:solidFill>
-          <a:ln>
-            <a:solidFill>
-              <a:srgbClr val="D9D9D9"/>
-            </a:solidFill>
-          </a:ln>
-        </p:spPr>
-        <p:style>
-          <a:lnRef idx="2">
-            <a:schemeClr val="accent1">
-              <a:shade val="15000"/>
-            </a:schemeClr>
-          </a:lnRef>
-          <a:fillRef idx="1">
-            <a:schemeClr val="accent1"/>
-          </a:fillRef>
-          <a:effectRef idx="0">
-            <a:schemeClr val="accent1"/>
-          </a:effectRef>
-          <a:fontRef idx="minor">
-            <a:schemeClr val="lt1"/>
-          </a:fontRef>
-        </p:style>
-        <p:txBody>
-          <a:bodyPr rtlCol="0" anchor="ctr"/>
-          <a:lstStyle/>
-          <a:p>
-            <a:pPr algn="ctr"/>
-            <a:endParaRPr lang="en-US"/>
-          </a:p>
-        </p:txBody>
-      </p:sp>
-      <p:sp>
-        <p:nvSpPr>
-          <p:cNvPr id="586" name="Rectangle: Rounded Corners 585">
-            <a:extLst>
-              <a:ext uri="{FF2B5EF4-FFF2-40B4-BE49-F238E27FC236}">
-                <a16:creationId xmlns:a16="http://schemas.microsoft.com/office/drawing/2014/main" id="{E5A30E40-92CB-3AFA-A66D-282BE4CD1505}"/>
-              </a:ext>
-            </a:extLst>
-          </p:cNvPr>
-          <p:cNvSpPr/>
-          <p:nvPr/>
-        </p:nvSpPr>
-        <p:spPr>
-          <a:xfrm>
-            <a:off x="16189772" y="10885301"/>
-            <a:ext cx="1576718" cy="1265361"/>
+            <a:off x="16189772" y="10578302"/>
+            <a:ext cx="1576718" cy="1572768"/>
           </a:xfrm>
           <a:prstGeom prst="roundRect">
             <a:avLst>
@@ -39510,7 +39169,7 @@
         <p:spPr>
           <a:xfrm>
             <a:off x="18261699" y="3094854"/>
-            <a:ext cx="1576718" cy="1265361"/>
+            <a:ext cx="1576718" cy="1572768"/>
           </a:xfrm>
           <a:prstGeom prst="roundRect">
             <a:avLst>
@@ -39565,8 +39224,8 @@
         </p:nvSpPr>
         <p:spPr>
           <a:xfrm>
-            <a:off x="18261699" y="4652943"/>
-            <a:ext cx="1576718" cy="1265361"/>
+            <a:off x="18261699" y="4965716"/>
+            <a:ext cx="1576718" cy="1572768"/>
           </a:xfrm>
           <a:prstGeom prst="roundRect">
             <a:avLst>
@@ -39621,8 +39280,8 @@
         </p:nvSpPr>
         <p:spPr>
           <a:xfrm>
-            <a:off x="18261699" y="6211032"/>
-            <a:ext cx="1576718" cy="1265361"/>
+            <a:off x="18261699" y="6836578"/>
+            <a:ext cx="1576718" cy="1572768"/>
           </a:xfrm>
           <a:prstGeom prst="roundRect">
             <a:avLst>
@@ -39677,8 +39336,8 @@
         </p:nvSpPr>
         <p:spPr>
           <a:xfrm>
-            <a:off x="18261699" y="7769121"/>
-            <a:ext cx="1576718" cy="1265361"/>
+            <a:off x="18261699" y="8707440"/>
+            <a:ext cx="1576718" cy="1572768"/>
           </a:xfrm>
           <a:prstGeom prst="roundRect">
             <a:avLst>
@@ -39733,64 +39392,8 @@
         </p:nvSpPr>
         <p:spPr>
           <a:xfrm>
-            <a:off x="18261699" y="9327210"/>
-            <a:ext cx="1576718" cy="1265361"/>
-          </a:xfrm>
-          <a:prstGeom prst="roundRect">
-            <a:avLst>
-              <a:gd name="adj" fmla="val 5149"/>
-            </a:avLst>
-          </a:prstGeom>
-          <a:solidFill>
-            <a:srgbClr val="FBFBFA"/>
-          </a:solidFill>
-          <a:ln>
-            <a:solidFill>
-              <a:srgbClr val="D9D9D9"/>
-            </a:solidFill>
-          </a:ln>
-        </p:spPr>
-        <p:style>
-          <a:lnRef idx="2">
-            <a:schemeClr val="accent1">
-              <a:shade val="15000"/>
-            </a:schemeClr>
-          </a:lnRef>
-          <a:fillRef idx="1">
-            <a:schemeClr val="accent1"/>
-          </a:fillRef>
-          <a:effectRef idx="0">
-            <a:schemeClr val="accent1"/>
-          </a:effectRef>
-          <a:fontRef idx="minor">
-            <a:schemeClr val="lt1"/>
-          </a:fontRef>
-        </p:style>
-        <p:txBody>
-          <a:bodyPr rtlCol="0" anchor="ctr"/>
-          <a:lstStyle/>
-          <a:p>
-            <a:pPr algn="ctr"/>
-            <a:endParaRPr lang="en-US"/>
-          </a:p>
-        </p:txBody>
-      </p:sp>
-      <p:sp>
-        <p:nvSpPr>
-          <p:cNvPr id="612" name="Rectangle: Rounded Corners 611">
-            <a:extLst>
-              <a:ext uri="{FF2B5EF4-FFF2-40B4-BE49-F238E27FC236}">
-                <a16:creationId xmlns:a16="http://schemas.microsoft.com/office/drawing/2014/main" id="{49062E3F-F265-5A77-B81B-E54EEDB119A1}"/>
-              </a:ext>
-            </a:extLst>
-          </p:cNvPr>
-          <p:cNvSpPr/>
-          <p:nvPr/>
-        </p:nvSpPr>
-        <p:spPr>
-          <a:xfrm>
-            <a:off x="18261699" y="10885301"/>
-            <a:ext cx="1576718" cy="1265361"/>
+            <a:off x="18261699" y="10578302"/>
+            <a:ext cx="1576718" cy="1572768"/>
           </a:xfrm>
           <a:prstGeom prst="roundRect">
             <a:avLst>
@@ -40148,7 +39751,7 @@
         </p:nvGrpSpPr>
         <p:grpSpPr>
           <a:xfrm>
-            <a:off x="18991259" y="4667075"/>
+            <a:off x="18991259" y="4979848"/>
             <a:ext cx="847611" cy="310752"/>
             <a:chOff x="-6600343" y="4603178"/>
             <a:chExt cx="846866" cy="310752"/>
@@ -40282,7 +39885,7 @@
         </p:nvGrpSpPr>
         <p:grpSpPr>
           <a:xfrm>
-            <a:off x="18991259" y="6224195"/>
+            <a:off x="18991259" y="6849741"/>
             <a:ext cx="847611" cy="310752"/>
             <a:chOff x="-6600343" y="6171548"/>
             <a:chExt cx="846866" cy="310752"/>
@@ -40416,7 +40019,7 @@
         </p:nvGrpSpPr>
         <p:grpSpPr>
           <a:xfrm>
-            <a:off x="18991259" y="7781315"/>
+            <a:off x="18991259" y="8719634"/>
             <a:ext cx="847611" cy="310752"/>
             <a:chOff x="-6600343" y="7739918"/>
             <a:chExt cx="846866" cy="310752"/>
@@ -40550,7 +40153,7 @@
         </p:nvGrpSpPr>
         <p:grpSpPr>
           <a:xfrm>
-            <a:off x="18991259" y="9338435"/>
+            <a:off x="18991259" y="10589527"/>
             <a:ext cx="847611" cy="310752"/>
             <a:chOff x="6117941" y="9303259"/>
             <a:chExt cx="847611" cy="310752"/>
@@ -40640,138 +40243,6 @@
             <a:solidFill>
               <a:srgbClr val="A9D18E"/>
             </a:solidFill>
-            <a:ln>
-              <a:noFill/>
-            </a:ln>
-          </p:spPr>
-          <p:style>
-            <a:lnRef idx="2">
-              <a:schemeClr val="accent1">
-                <a:shade val="15000"/>
-              </a:schemeClr>
-            </a:lnRef>
-            <a:fillRef idx="1">
-              <a:schemeClr val="accent1"/>
-            </a:fillRef>
-            <a:effectRef idx="0">
-              <a:schemeClr val="accent1"/>
-            </a:effectRef>
-            <a:fontRef idx="minor">
-              <a:schemeClr val="lt1"/>
-            </a:fontRef>
-          </p:style>
-          <p:txBody>
-            <a:bodyPr rtlCol="0" anchor="ctr"/>
-            <a:lstStyle/>
-            <a:p>
-              <a:pPr algn="ctr"/>
-              <a:endParaRPr lang="en-US"/>
-            </a:p>
-          </p:txBody>
-        </p:sp>
-      </p:grpSp>
-      <p:grpSp>
-        <p:nvGrpSpPr>
-          <p:cNvPr id="619" name="Group 618">
-            <a:extLst>
-              <a:ext uri="{FF2B5EF4-FFF2-40B4-BE49-F238E27FC236}">
-                <a16:creationId xmlns:a16="http://schemas.microsoft.com/office/drawing/2014/main" id="{A138208B-4CE5-2882-9D82-0221E23856B6}"/>
-              </a:ext>
-            </a:extLst>
-          </p:cNvPr>
-          <p:cNvGrpSpPr/>
-          <p:nvPr/>
-        </p:nvGrpSpPr>
-        <p:grpSpPr>
-          <a:xfrm>
-            <a:off x="18991259" y="10895554"/>
-            <a:ext cx="847611" cy="310928"/>
-            <a:chOff x="1503088" y="10860378"/>
-            <a:chExt cx="846866" cy="310928"/>
-          </a:xfrm>
-        </p:grpSpPr>
-        <p:sp>
-          <p:nvSpPr>
-            <p:cNvPr id="622" name="Rectangle: Rounded Corners 621">
-              <a:extLst>
-                <a:ext uri="{FF2B5EF4-FFF2-40B4-BE49-F238E27FC236}">
-                  <a16:creationId xmlns:a16="http://schemas.microsoft.com/office/drawing/2014/main" id="{37BB6836-6E03-2BAC-228A-8DAE6800CC16}"/>
-                </a:ext>
-              </a:extLst>
-            </p:cNvPr>
-            <p:cNvSpPr/>
-            <p:nvPr/>
-          </p:nvSpPr>
-          <p:spPr>
-            <a:xfrm>
-              <a:off x="1503088" y="10860378"/>
-              <a:ext cx="846866" cy="310752"/>
-            </a:xfrm>
-            <a:prstGeom prst="roundRect">
-              <a:avLst/>
-            </a:prstGeom>
-            <a:solidFill>
-              <a:srgbClr val="01686A"/>
-            </a:solidFill>
-            <a:ln w="15875">
-              <a:noFill/>
-            </a:ln>
-          </p:spPr>
-          <p:style>
-            <a:lnRef idx="2">
-              <a:schemeClr val="accent1">
-                <a:shade val="15000"/>
-              </a:schemeClr>
-            </a:lnRef>
-            <a:fillRef idx="1">
-              <a:schemeClr val="accent1"/>
-            </a:fillRef>
-            <a:effectRef idx="0">
-              <a:schemeClr val="accent1"/>
-            </a:effectRef>
-            <a:fontRef idx="minor">
-              <a:schemeClr val="lt1"/>
-            </a:fontRef>
-          </p:style>
-          <p:txBody>
-            <a:bodyPr rtlCol="0" anchor="ctr"/>
-            <a:lstStyle/>
-            <a:p>
-              <a:pPr marL="182880" algn="ctr" rtl="1"/>
-              <a:r>
-                <a:rPr lang="en-US">
-                  <a:solidFill>
-                    <a:schemeClr val="bg1"/>
-                  </a:solidFill>
-                  <a:latin typeface="Bahij TheSansArabic Bold" panose="02040503050201020203" charset="-78"/>
-                  <a:cs typeface="Bahij TheSansArabic Bold" panose="02040503050201020203" charset="-78"/>
-                </a:rPr>
-                <a:t>—</a:t>
-              </a:r>
-            </a:p>
-          </p:txBody>
-        </p:sp>
-        <p:sp>
-          <p:nvSpPr>
-            <p:cNvPr id="623" name="Arrow: Down 622">
-              <a:extLst>
-                <a:ext uri="{FF2B5EF4-FFF2-40B4-BE49-F238E27FC236}">
-                  <a16:creationId xmlns:a16="http://schemas.microsoft.com/office/drawing/2014/main" id="{F06B954B-6797-DBBD-C719-42FB69D7C703}"/>
-                </a:ext>
-              </a:extLst>
-            </p:cNvPr>
-            <p:cNvSpPr/>
-            <p:nvPr/>
-          </p:nvSpPr>
-          <p:spPr>
-            <a:xfrm>
-              <a:off x="2107178" y="10879033"/>
-              <a:ext cx="234654" cy="292273"/>
-            </a:xfrm>
-            <a:prstGeom prst="downArrow">
-              <a:avLst/>
-            </a:prstGeom>
-            <a:noFill/>
             <a:ln>
               <a:noFill/>
             </a:ln>
@@ -40950,7 +40421,7 @@
         </p:nvGrpSpPr>
         <p:grpSpPr>
           <a:xfrm>
-            <a:off x="16919332" y="4667075"/>
+            <a:off x="16919332" y="4979848"/>
             <a:ext cx="847611" cy="310752"/>
             <a:chOff x="-6600343" y="4603178"/>
             <a:chExt cx="846866" cy="310752"/>
@@ -41084,7 +40555,7 @@
         </p:nvGrpSpPr>
         <p:grpSpPr>
           <a:xfrm>
-            <a:off x="16919332" y="6224195"/>
+            <a:off x="16919332" y="6849741"/>
             <a:ext cx="847611" cy="310752"/>
             <a:chOff x="-6600343" y="6171548"/>
             <a:chExt cx="846866" cy="310752"/>
@@ -41218,7 +40689,7 @@
         </p:nvGrpSpPr>
         <p:grpSpPr>
           <a:xfrm>
-            <a:off x="16919332" y="7781315"/>
+            <a:off x="16919332" y="8719634"/>
             <a:ext cx="847611" cy="310752"/>
             <a:chOff x="-6600343" y="7739918"/>
             <a:chExt cx="846866" cy="310752"/>
@@ -41352,7 +40823,7 @@
         </p:nvGrpSpPr>
         <p:grpSpPr>
           <a:xfrm>
-            <a:off x="16919332" y="9338435"/>
+            <a:off x="16919332" y="10589527"/>
             <a:ext cx="847611" cy="310752"/>
             <a:chOff x="4404594" y="9303259"/>
             <a:chExt cx="847611" cy="310752"/>
@@ -41442,138 +40913,6 @@
             <a:solidFill>
               <a:srgbClr val="A9D18E"/>
             </a:solidFill>
-            <a:ln>
-              <a:noFill/>
-            </a:ln>
-          </p:spPr>
-          <p:style>
-            <a:lnRef idx="2">
-              <a:schemeClr val="accent1">
-                <a:shade val="15000"/>
-              </a:schemeClr>
-            </a:lnRef>
-            <a:fillRef idx="1">
-              <a:schemeClr val="accent1"/>
-            </a:fillRef>
-            <a:effectRef idx="0">
-              <a:schemeClr val="accent1"/>
-            </a:effectRef>
-            <a:fontRef idx="minor">
-              <a:schemeClr val="lt1"/>
-            </a:fontRef>
-          </p:style>
-          <p:txBody>
-            <a:bodyPr rtlCol="0" anchor="ctr"/>
-            <a:lstStyle/>
-            <a:p>
-              <a:pPr algn="ctr"/>
-              <a:endParaRPr lang="en-US"/>
-            </a:p>
-          </p:txBody>
-        </p:sp>
-      </p:grpSp>
-      <p:grpSp>
-        <p:nvGrpSpPr>
-          <p:cNvPr id="593" name="Group 592">
-            <a:extLst>
-              <a:ext uri="{FF2B5EF4-FFF2-40B4-BE49-F238E27FC236}">
-                <a16:creationId xmlns:a16="http://schemas.microsoft.com/office/drawing/2014/main" id="{DC47680F-953F-74E4-24C9-2993E04DF660}"/>
-              </a:ext>
-            </a:extLst>
-          </p:cNvPr>
-          <p:cNvGrpSpPr/>
-          <p:nvPr/>
-        </p:nvGrpSpPr>
-        <p:grpSpPr>
-          <a:xfrm>
-            <a:off x="16919332" y="10895554"/>
-            <a:ext cx="847611" cy="310928"/>
-            <a:chOff x="1503088" y="10860378"/>
-            <a:chExt cx="846866" cy="310928"/>
-          </a:xfrm>
-        </p:grpSpPr>
-        <p:sp>
-          <p:nvSpPr>
-            <p:cNvPr id="596" name="Rectangle: Rounded Corners 595">
-              <a:extLst>
-                <a:ext uri="{FF2B5EF4-FFF2-40B4-BE49-F238E27FC236}">
-                  <a16:creationId xmlns:a16="http://schemas.microsoft.com/office/drawing/2014/main" id="{399381F1-86D8-43BB-FBA4-301FDF88142E}"/>
-                </a:ext>
-              </a:extLst>
-            </p:cNvPr>
-            <p:cNvSpPr/>
-            <p:nvPr/>
-          </p:nvSpPr>
-          <p:spPr>
-            <a:xfrm>
-              <a:off x="1503088" y="10860378"/>
-              <a:ext cx="846866" cy="310752"/>
-            </a:xfrm>
-            <a:prstGeom prst="roundRect">
-              <a:avLst/>
-            </a:prstGeom>
-            <a:solidFill>
-              <a:srgbClr val="01686A"/>
-            </a:solidFill>
-            <a:ln w="15875">
-              <a:noFill/>
-            </a:ln>
-          </p:spPr>
-          <p:style>
-            <a:lnRef idx="2">
-              <a:schemeClr val="accent1">
-                <a:shade val="15000"/>
-              </a:schemeClr>
-            </a:lnRef>
-            <a:fillRef idx="1">
-              <a:schemeClr val="accent1"/>
-            </a:fillRef>
-            <a:effectRef idx="0">
-              <a:schemeClr val="accent1"/>
-            </a:effectRef>
-            <a:fontRef idx="minor">
-              <a:schemeClr val="lt1"/>
-            </a:fontRef>
-          </p:style>
-          <p:txBody>
-            <a:bodyPr rtlCol="0" anchor="ctr"/>
-            <a:lstStyle/>
-            <a:p>
-              <a:pPr marL="182880" algn="ctr" rtl="1"/>
-              <a:r>
-                <a:rPr lang="en-US">
-                  <a:solidFill>
-                    <a:schemeClr val="bg1"/>
-                  </a:solidFill>
-                  <a:latin typeface="Bahij TheSansArabic Bold" panose="02040503050201020203" charset="-78"/>
-                  <a:cs typeface="Bahij TheSansArabic Bold" panose="02040503050201020203" charset="-78"/>
-                </a:rPr>
-                <a:t>—</a:t>
-              </a:r>
-            </a:p>
-          </p:txBody>
-        </p:sp>
-        <p:sp>
-          <p:nvSpPr>
-            <p:cNvPr id="597" name="Arrow: Down 596">
-              <a:extLst>
-                <a:ext uri="{FF2B5EF4-FFF2-40B4-BE49-F238E27FC236}">
-                  <a16:creationId xmlns:a16="http://schemas.microsoft.com/office/drawing/2014/main" id="{DE21E5C4-061D-D188-26A3-56AFDA5DCB58}"/>
-                </a:ext>
-              </a:extLst>
-            </p:cNvPr>
-            <p:cNvSpPr/>
-            <p:nvPr/>
-          </p:nvSpPr>
-          <p:spPr>
-            <a:xfrm>
-              <a:off x="2107178" y="10879033"/>
-              <a:ext cx="234654" cy="292273"/>
-            </a:xfrm>
-            <a:prstGeom prst="downArrow">
-              <a:avLst/>
-            </a:prstGeom>
-            <a:noFill/>
             <a:ln>
               <a:noFill/>
             </a:ln>
@@ -41752,7 +41091,7 @@
         </p:nvGrpSpPr>
         <p:grpSpPr>
           <a:xfrm>
-            <a:off x="14847405" y="4667075"/>
+            <a:off x="14847405" y="4979848"/>
             <a:ext cx="847611" cy="310752"/>
             <a:chOff x="-6600343" y="4603178"/>
             <a:chExt cx="846866" cy="310752"/>
@@ -41886,7 +41225,7 @@
         </p:nvGrpSpPr>
         <p:grpSpPr>
           <a:xfrm>
-            <a:off x="14847405" y="6224195"/>
+            <a:off x="14847405" y="6849741"/>
             <a:ext cx="847611" cy="310752"/>
             <a:chOff x="-6600343" y="6171548"/>
             <a:chExt cx="846866" cy="310752"/>
@@ -42020,7 +41359,7 @@
         </p:nvGrpSpPr>
         <p:grpSpPr>
           <a:xfrm>
-            <a:off x="14847405" y="7781315"/>
+            <a:off x="14847405" y="8719634"/>
             <a:ext cx="847611" cy="310752"/>
             <a:chOff x="-6600343" y="7739918"/>
             <a:chExt cx="846866" cy="310752"/>
@@ -42154,7 +41493,7 @@
         </p:nvGrpSpPr>
         <p:grpSpPr>
           <a:xfrm>
-            <a:off x="14847405" y="9338435"/>
+            <a:off x="14847405" y="10589527"/>
             <a:ext cx="847611" cy="310752"/>
             <a:chOff x="2691247" y="9303259"/>
             <a:chExt cx="847611" cy="310752"/>
@@ -42244,138 +41583,6 @@
             <a:solidFill>
               <a:srgbClr val="A9D18E"/>
             </a:solidFill>
-            <a:ln>
-              <a:noFill/>
-            </a:ln>
-          </p:spPr>
-          <p:style>
-            <a:lnRef idx="2">
-              <a:schemeClr val="accent1">
-                <a:shade val="15000"/>
-              </a:schemeClr>
-            </a:lnRef>
-            <a:fillRef idx="1">
-              <a:schemeClr val="accent1"/>
-            </a:fillRef>
-            <a:effectRef idx="0">
-              <a:schemeClr val="accent1"/>
-            </a:effectRef>
-            <a:fontRef idx="minor">
-              <a:schemeClr val="lt1"/>
-            </a:fontRef>
-          </p:style>
-          <p:txBody>
-            <a:bodyPr rtlCol="0" anchor="ctr"/>
-            <a:lstStyle/>
-            <a:p>
-              <a:pPr algn="ctr"/>
-              <a:endParaRPr lang="en-US"/>
-            </a:p>
-          </p:txBody>
-        </p:sp>
-      </p:grpSp>
-      <p:grpSp>
-        <p:nvGrpSpPr>
-          <p:cNvPr id="567" name="Group 566">
-            <a:extLst>
-              <a:ext uri="{FF2B5EF4-FFF2-40B4-BE49-F238E27FC236}">
-                <a16:creationId xmlns:a16="http://schemas.microsoft.com/office/drawing/2014/main" id="{3D371FF6-4088-A922-ADAE-13FD3AD9D25B}"/>
-              </a:ext>
-            </a:extLst>
-          </p:cNvPr>
-          <p:cNvGrpSpPr/>
-          <p:nvPr/>
-        </p:nvGrpSpPr>
-        <p:grpSpPr>
-          <a:xfrm>
-            <a:off x="14847405" y="10895554"/>
-            <a:ext cx="847611" cy="310928"/>
-            <a:chOff x="1503088" y="10860378"/>
-            <a:chExt cx="846866" cy="310928"/>
-          </a:xfrm>
-        </p:grpSpPr>
-        <p:sp>
-          <p:nvSpPr>
-            <p:cNvPr id="570" name="Rectangle: Rounded Corners 569">
-              <a:extLst>
-                <a:ext uri="{FF2B5EF4-FFF2-40B4-BE49-F238E27FC236}">
-                  <a16:creationId xmlns:a16="http://schemas.microsoft.com/office/drawing/2014/main" id="{B45C529C-FD60-1852-DB04-4802B2106ABA}"/>
-                </a:ext>
-              </a:extLst>
-            </p:cNvPr>
-            <p:cNvSpPr/>
-            <p:nvPr/>
-          </p:nvSpPr>
-          <p:spPr>
-            <a:xfrm>
-              <a:off x="1503088" y="10860378"/>
-              <a:ext cx="846866" cy="310752"/>
-            </a:xfrm>
-            <a:prstGeom prst="roundRect">
-              <a:avLst/>
-            </a:prstGeom>
-            <a:solidFill>
-              <a:srgbClr val="01686A"/>
-            </a:solidFill>
-            <a:ln w="15875">
-              <a:noFill/>
-            </a:ln>
-          </p:spPr>
-          <p:style>
-            <a:lnRef idx="2">
-              <a:schemeClr val="accent1">
-                <a:shade val="15000"/>
-              </a:schemeClr>
-            </a:lnRef>
-            <a:fillRef idx="1">
-              <a:schemeClr val="accent1"/>
-            </a:fillRef>
-            <a:effectRef idx="0">
-              <a:schemeClr val="accent1"/>
-            </a:effectRef>
-            <a:fontRef idx="minor">
-              <a:schemeClr val="lt1"/>
-            </a:fontRef>
-          </p:style>
-          <p:txBody>
-            <a:bodyPr rtlCol="0" anchor="ctr"/>
-            <a:lstStyle/>
-            <a:p>
-              <a:pPr marL="182880" algn="ctr" rtl="1"/>
-              <a:r>
-                <a:rPr lang="en-US">
-                  <a:solidFill>
-                    <a:schemeClr val="bg1"/>
-                  </a:solidFill>
-                  <a:latin typeface="Bahij TheSansArabic Bold" panose="02040503050201020203" charset="-78"/>
-                  <a:cs typeface="Bahij TheSansArabic Bold" panose="02040503050201020203" charset="-78"/>
-                </a:rPr>
-                <a:t>—</a:t>
-              </a:r>
-            </a:p>
-          </p:txBody>
-        </p:sp>
-        <p:sp>
-          <p:nvSpPr>
-            <p:cNvPr id="571" name="Arrow: Down 570">
-              <a:extLst>
-                <a:ext uri="{FF2B5EF4-FFF2-40B4-BE49-F238E27FC236}">
-                  <a16:creationId xmlns:a16="http://schemas.microsoft.com/office/drawing/2014/main" id="{A3824C6E-4F03-6E93-3F7D-213592176EC8}"/>
-                </a:ext>
-              </a:extLst>
-            </p:cNvPr>
-            <p:cNvSpPr/>
-            <p:nvPr/>
-          </p:nvSpPr>
-          <p:spPr>
-            <a:xfrm>
-              <a:off x="2107178" y="10879033"/>
-              <a:ext cx="234654" cy="292273"/>
-            </a:xfrm>
-            <a:prstGeom prst="downArrow">
-              <a:avLst/>
-            </a:prstGeom>
-            <a:noFill/>
             <a:ln>
               <a:noFill/>
             </a:ln>
@@ -42554,7 +41761,7 @@
         </p:nvGrpSpPr>
         <p:grpSpPr>
           <a:xfrm>
-            <a:off x="12775478" y="4667075"/>
+            <a:off x="12775478" y="4979848"/>
             <a:ext cx="847611" cy="310752"/>
             <a:chOff x="-6600343" y="4603178"/>
             <a:chExt cx="846866" cy="310752"/>
@@ -42688,7 +41895,7 @@
         </p:nvGrpSpPr>
         <p:grpSpPr>
           <a:xfrm>
-            <a:off x="12775478" y="6224195"/>
+            <a:off x="12775478" y="6849741"/>
             <a:ext cx="847611" cy="310752"/>
             <a:chOff x="-6600343" y="6171548"/>
             <a:chExt cx="846866" cy="310752"/>
@@ -42822,7 +42029,7 @@
         </p:nvGrpSpPr>
         <p:grpSpPr>
           <a:xfrm>
-            <a:off x="12775478" y="7781315"/>
+            <a:off x="12775478" y="8719634"/>
             <a:ext cx="847611" cy="310752"/>
             <a:chOff x="-6600343" y="7739918"/>
             <a:chExt cx="846866" cy="310752"/>
@@ -42956,7 +42163,7 @@
         </p:nvGrpSpPr>
         <p:grpSpPr>
           <a:xfrm>
-            <a:off x="12775478" y="9338435"/>
+            <a:off x="12775478" y="10589527"/>
             <a:ext cx="847611" cy="310752"/>
             <a:chOff x="977900" y="9303259"/>
             <a:chExt cx="847611" cy="310752"/>
@@ -43076,238 +42283,6 @@
           </p:txBody>
         </p:sp>
       </p:grpSp>
-      <p:grpSp>
-        <p:nvGrpSpPr>
-          <p:cNvPr id="289" name="Group 288">
-            <a:extLst>
-              <a:ext uri="{FF2B5EF4-FFF2-40B4-BE49-F238E27FC236}">
-                <a16:creationId xmlns:a16="http://schemas.microsoft.com/office/drawing/2014/main" id="{6B4878FD-FB13-571A-18A6-CF80B0C76696}"/>
-              </a:ext>
-            </a:extLst>
-          </p:cNvPr>
-          <p:cNvGrpSpPr/>
-          <p:nvPr/>
-        </p:nvGrpSpPr>
-        <p:grpSpPr>
-          <a:xfrm>
-            <a:off x="12775478" y="10895554"/>
-            <a:ext cx="847611" cy="310928"/>
-            <a:chOff x="1503088" y="10860378"/>
-            <a:chExt cx="846866" cy="310928"/>
-          </a:xfrm>
-        </p:grpSpPr>
-        <p:sp>
-          <p:nvSpPr>
-            <p:cNvPr id="290" name="Rectangle: Rounded Corners 289">
-              <a:extLst>
-                <a:ext uri="{FF2B5EF4-FFF2-40B4-BE49-F238E27FC236}">
-                  <a16:creationId xmlns:a16="http://schemas.microsoft.com/office/drawing/2014/main" id="{EAAC4237-AB9A-762C-D62F-4DD567EF3330}"/>
-                </a:ext>
-              </a:extLst>
-            </p:cNvPr>
-            <p:cNvSpPr/>
-            <p:nvPr/>
-          </p:nvSpPr>
-          <p:spPr>
-            <a:xfrm>
-              <a:off x="1503088" y="10860378"/>
-              <a:ext cx="846866" cy="310752"/>
-            </a:xfrm>
-            <a:prstGeom prst="roundRect">
-              <a:avLst/>
-            </a:prstGeom>
-            <a:solidFill>
-              <a:srgbClr val="01686A"/>
-            </a:solidFill>
-            <a:ln w="15875">
-              <a:noFill/>
-            </a:ln>
-          </p:spPr>
-          <p:style>
-            <a:lnRef idx="2">
-              <a:schemeClr val="accent1">
-                <a:shade val="15000"/>
-              </a:schemeClr>
-            </a:lnRef>
-            <a:fillRef idx="1">
-              <a:schemeClr val="accent1"/>
-            </a:fillRef>
-            <a:effectRef idx="0">
-              <a:schemeClr val="accent1"/>
-            </a:effectRef>
-            <a:fontRef idx="minor">
-              <a:schemeClr val="lt1"/>
-            </a:fontRef>
-          </p:style>
-          <p:txBody>
-            <a:bodyPr rtlCol="0" anchor="ctr"/>
-            <a:lstStyle/>
-            <a:p>
-              <a:pPr marL="182880" algn="ctr" rtl="1"/>
-              <a:r>
-                <a:rPr lang="en-US">
-                  <a:solidFill>
-                    <a:schemeClr val="bg1"/>
-                  </a:solidFill>
-                  <a:latin typeface="Bahij TheSansArabic Bold" panose="02040503050201020203" charset="-78"/>
-                  <a:cs typeface="Bahij TheSansArabic Bold" panose="02040503050201020203" charset="-78"/>
-                </a:rPr>
-                <a:t>—</a:t>
-              </a:r>
-            </a:p>
-          </p:txBody>
-        </p:sp>
-        <p:sp>
-          <p:nvSpPr>
-            <p:cNvPr id="291" name="Arrow: Down 290">
-              <a:extLst>
-                <a:ext uri="{FF2B5EF4-FFF2-40B4-BE49-F238E27FC236}">
-                  <a16:creationId xmlns:a16="http://schemas.microsoft.com/office/drawing/2014/main" id="{7FF57F4A-4509-2AD2-4976-D02E1F6E2FD6}"/>
-                </a:ext>
-              </a:extLst>
-            </p:cNvPr>
-            <p:cNvSpPr/>
-            <p:nvPr/>
-          </p:nvSpPr>
-          <p:spPr>
-            <a:xfrm>
-              <a:off x="2107178" y="10879033"/>
-              <a:ext cx="234654" cy="292273"/>
-            </a:xfrm>
-            <a:prstGeom prst="downArrow">
-              <a:avLst/>
-            </a:prstGeom>
-            <a:noFill/>
-            <a:ln>
-              <a:noFill/>
-            </a:ln>
-          </p:spPr>
-          <p:style>
-            <a:lnRef idx="2">
-              <a:schemeClr val="accent1">
-                <a:shade val="15000"/>
-              </a:schemeClr>
-            </a:lnRef>
-            <a:fillRef idx="1">
-              <a:schemeClr val="accent1"/>
-            </a:fillRef>
-            <a:effectRef idx="0">
-              <a:schemeClr val="accent1"/>
-            </a:effectRef>
-            <a:fontRef idx="minor">
-              <a:schemeClr val="lt1"/>
-            </a:fontRef>
-          </p:style>
-          <p:txBody>
-            <a:bodyPr rtlCol="0" anchor="ctr"/>
-            <a:lstStyle/>
-            <a:p>
-              <a:pPr algn="ctr"/>
-              <a:endParaRPr lang="en-US"/>
-            </a:p>
-          </p:txBody>
-        </p:sp>
-      </p:grpSp>
-      <p:sp>
-        <p:nvSpPr>
-          <p:cNvPr id="362" name="Arrow: Down 361">
-            <a:extLst>
-              <a:ext uri="{FF2B5EF4-FFF2-40B4-BE49-F238E27FC236}">
-                <a16:creationId xmlns:a16="http://schemas.microsoft.com/office/drawing/2014/main" id="{297DF2FD-A487-4E0A-961D-D8D8E4DC145F}"/>
-              </a:ext>
-            </a:extLst>
-          </p:cNvPr>
-          <p:cNvSpPr/>
-          <p:nvPr/>
-        </p:nvSpPr>
-        <p:spPr>
-          <a:xfrm flipV="1">
-            <a:off x="13354586" y="10904793"/>
-            <a:ext cx="234861" cy="292273"/>
-          </a:xfrm>
-          <a:prstGeom prst="downArrow">
-            <a:avLst/>
-          </a:prstGeom>
-          <a:noFill/>
-          <a:ln>
-            <a:noFill/>
-          </a:ln>
-        </p:spPr>
-        <p:style>
-          <a:lnRef idx="2">
-            <a:schemeClr val="accent1">
-              <a:shade val="15000"/>
-            </a:schemeClr>
-          </a:lnRef>
-          <a:fillRef idx="1">
-            <a:schemeClr val="accent1"/>
-          </a:fillRef>
-          <a:effectRef idx="0">
-            <a:schemeClr val="accent1"/>
-          </a:effectRef>
-          <a:fontRef idx="minor">
-            <a:schemeClr val="lt1"/>
-          </a:fontRef>
-        </p:style>
-        <p:txBody>
-          <a:bodyPr rtlCol="0" anchor="ctr"/>
-          <a:lstStyle/>
-          <a:p>
-            <a:pPr algn="ctr"/>
-            <a:endParaRPr lang="en-US"/>
-          </a:p>
-        </p:txBody>
-      </p:sp>
-      <p:sp>
-        <p:nvSpPr>
-          <p:cNvPr id="363" name="Arrow: Down 362">
-            <a:extLst>
-              <a:ext uri="{FF2B5EF4-FFF2-40B4-BE49-F238E27FC236}">
-                <a16:creationId xmlns:a16="http://schemas.microsoft.com/office/drawing/2014/main" id="{12A4AA0A-44C9-4CF9-8DD8-00B3C001E6C2}"/>
-              </a:ext>
-            </a:extLst>
-          </p:cNvPr>
-          <p:cNvSpPr/>
-          <p:nvPr/>
-        </p:nvSpPr>
-        <p:spPr>
-          <a:xfrm rot="10800000" flipV="1">
-            <a:off x="17533593" y="10921859"/>
-            <a:ext cx="234861" cy="292273"/>
-          </a:xfrm>
-          <a:prstGeom prst="downArrow">
-            <a:avLst/>
-          </a:prstGeom>
-          <a:noFill/>
-          <a:ln>
-            <a:noFill/>
-          </a:ln>
-        </p:spPr>
-        <p:style>
-          <a:lnRef idx="2">
-            <a:schemeClr val="accent1">
-              <a:shade val="15000"/>
-            </a:schemeClr>
-          </a:lnRef>
-          <a:fillRef idx="1">
-            <a:schemeClr val="accent1"/>
-          </a:fillRef>
-          <a:effectRef idx="0">
-            <a:schemeClr val="accent1"/>
-          </a:effectRef>
-          <a:fontRef idx="minor">
-            <a:schemeClr val="lt1"/>
-          </a:fontRef>
-        </p:style>
-        <p:txBody>
-          <a:bodyPr rtlCol="0" anchor="ctr"/>
-          <a:lstStyle/>
-          <a:p>
-            <a:pPr algn="ctr"/>
-            <a:endParaRPr lang="en-US"/>
-          </a:p>
-        </p:txBody>
-      </p:sp>
       <p:sp>
         <p:nvSpPr>
           <p:cNvPr id="359" name="Rectangle: Rounded Corners 358">
@@ -43323,7 +42298,7 @@
         <p:spPr>
           <a:xfrm>
             <a:off x="9960436" y="3059678"/>
-            <a:ext cx="1576718" cy="1265361"/>
+            <a:ext cx="1576718" cy="1572768"/>
           </a:xfrm>
           <a:prstGeom prst="roundRect">
             <a:avLst>
@@ -43378,8 +42353,8 @@
         </p:nvSpPr>
         <p:spPr>
           <a:xfrm>
-            <a:off x="9960436" y="4617767"/>
-            <a:ext cx="1576718" cy="1265361"/>
+            <a:off x="9960436" y="4930540"/>
+            <a:ext cx="1576718" cy="1572768"/>
           </a:xfrm>
           <a:prstGeom prst="roundRect">
             <a:avLst>
@@ -43434,8 +42409,8 @@
         </p:nvSpPr>
         <p:spPr>
           <a:xfrm>
-            <a:off x="9960436" y="6175856"/>
-            <a:ext cx="1576718" cy="1265361"/>
+            <a:off x="9960436" y="6801402"/>
+            <a:ext cx="1576718" cy="1572768"/>
           </a:xfrm>
           <a:prstGeom prst="roundRect">
             <a:avLst>
@@ -43490,8 +42465,8 @@
         </p:nvSpPr>
         <p:spPr>
           <a:xfrm>
-            <a:off x="9960436" y="7733945"/>
-            <a:ext cx="1576718" cy="1265361"/>
+            <a:off x="9960436" y="8672264"/>
+            <a:ext cx="1576718" cy="1572768"/>
           </a:xfrm>
           <a:prstGeom prst="roundRect">
             <a:avLst>
@@ -43546,64 +42521,8 @@
         </p:nvSpPr>
         <p:spPr>
           <a:xfrm>
-            <a:off x="9960436" y="9292034"/>
-            <a:ext cx="1576718" cy="1265361"/>
-          </a:xfrm>
-          <a:prstGeom prst="roundRect">
-            <a:avLst>
-              <a:gd name="adj" fmla="val 5149"/>
-            </a:avLst>
-          </a:prstGeom>
-          <a:solidFill>
-            <a:srgbClr val="FBFBFA"/>
-          </a:solidFill>
-          <a:ln>
-            <a:solidFill>
-              <a:srgbClr val="D9D9D9"/>
-            </a:solidFill>
-          </a:ln>
-        </p:spPr>
-        <p:style>
-          <a:lnRef idx="2">
-            <a:schemeClr val="accent1">
-              <a:shade val="15000"/>
-            </a:schemeClr>
-          </a:lnRef>
-          <a:fillRef idx="1">
-            <a:schemeClr val="accent1"/>
-          </a:fillRef>
-          <a:effectRef idx="0">
-            <a:schemeClr val="accent1"/>
-          </a:effectRef>
-          <a:fontRef idx="minor">
-            <a:schemeClr val="lt1"/>
-          </a:fontRef>
-        </p:style>
-        <p:txBody>
-          <a:bodyPr rtlCol="0" anchor="ctr"/>
-          <a:lstStyle/>
-          <a:p>
-            <a:pPr algn="ctr"/>
-            <a:endParaRPr lang="en-US"/>
-          </a:p>
-        </p:txBody>
-      </p:sp>
-      <p:sp>
-        <p:nvSpPr>
-          <p:cNvPr id="367" name="Rectangle: Rounded Corners 366">
-            <a:extLst>
-              <a:ext uri="{FF2B5EF4-FFF2-40B4-BE49-F238E27FC236}">
-                <a16:creationId xmlns:a16="http://schemas.microsoft.com/office/drawing/2014/main" id="{935E0495-4B46-4CCE-B6AD-EF00B8F1221E}"/>
-              </a:ext>
-            </a:extLst>
-          </p:cNvPr>
-          <p:cNvSpPr/>
-          <p:nvPr/>
-        </p:nvSpPr>
-        <p:spPr>
-          <a:xfrm>
-            <a:off x="9960436" y="10850125"/>
-            <a:ext cx="1576718" cy="1265361"/>
+            <a:off x="9960436" y="10543126"/>
+            <a:ext cx="1576718" cy="1572768"/>
           </a:xfrm>
           <a:prstGeom prst="roundRect">
             <a:avLst>
@@ -43871,7 +42790,7 @@
         </p:nvGrpSpPr>
         <p:grpSpPr>
           <a:xfrm>
-            <a:off x="10689996" y="4631899"/>
+            <a:off x="10689996" y="4944672"/>
             <a:ext cx="847611" cy="310752"/>
             <a:chOff x="-6600343" y="4603178"/>
             <a:chExt cx="846866" cy="310752"/>
@@ -44005,7 +42924,7 @@
         </p:nvGrpSpPr>
         <p:grpSpPr>
           <a:xfrm>
-            <a:off x="10689996" y="6189019"/>
+            <a:off x="10689996" y="6814565"/>
             <a:ext cx="847611" cy="310752"/>
             <a:chOff x="-6600343" y="6171548"/>
             <a:chExt cx="846866" cy="310752"/>
@@ -44139,7 +43058,7 @@
         </p:nvGrpSpPr>
         <p:grpSpPr>
           <a:xfrm>
-            <a:off x="10689996" y="7746139"/>
+            <a:off x="10689996" y="8684458"/>
             <a:ext cx="847611" cy="310752"/>
             <a:chOff x="-6600343" y="7739918"/>
             <a:chExt cx="846866" cy="310752"/>
@@ -44273,7 +43192,7 @@
         </p:nvGrpSpPr>
         <p:grpSpPr>
           <a:xfrm>
-            <a:off x="10689996" y="9303259"/>
+            <a:off x="10689996" y="10554351"/>
             <a:ext cx="847611" cy="310752"/>
             <a:chOff x="6117941" y="9303259"/>
             <a:chExt cx="847611" cy="310752"/>
@@ -44393,188 +43312,6 @@
           </p:txBody>
         </p:sp>
       </p:grpSp>
-      <p:grpSp>
-        <p:nvGrpSpPr>
-          <p:cNvPr id="385" name="Group 384">
-            <a:extLst>
-              <a:ext uri="{FF2B5EF4-FFF2-40B4-BE49-F238E27FC236}">
-                <a16:creationId xmlns:a16="http://schemas.microsoft.com/office/drawing/2014/main" id="{5AA0EAAF-720A-4EA0-BABA-79EB03765BFD}"/>
-              </a:ext>
-            </a:extLst>
-          </p:cNvPr>
-          <p:cNvGrpSpPr/>
-          <p:nvPr/>
-        </p:nvGrpSpPr>
-        <p:grpSpPr>
-          <a:xfrm>
-            <a:off x="10689996" y="10860378"/>
-            <a:ext cx="847611" cy="310928"/>
-            <a:chOff x="1503088" y="10860378"/>
-            <a:chExt cx="846866" cy="310928"/>
-          </a:xfrm>
-        </p:grpSpPr>
-        <p:sp>
-          <p:nvSpPr>
-            <p:cNvPr id="386" name="Rectangle: Rounded Corners 385">
-              <a:extLst>
-                <a:ext uri="{FF2B5EF4-FFF2-40B4-BE49-F238E27FC236}">
-                  <a16:creationId xmlns:a16="http://schemas.microsoft.com/office/drawing/2014/main" id="{26DCEEE1-6519-4C92-8C43-F08763A1ABC0}"/>
-                </a:ext>
-              </a:extLst>
-            </p:cNvPr>
-            <p:cNvSpPr/>
-            <p:nvPr/>
-          </p:nvSpPr>
-          <p:spPr>
-            <a:xfrm>
-              <a:off x="1503088" y="10860378"/>
-              <a:ext cx="846866" cy="310752"/>
-            </a:xfrm>
-            <a:prstGeom prst="roundRect">
-              <a:avLst/>
-            </a:prstGeom>
-            <a:solidFill>
-              <a:srgbClr val="01686A"/>
-            </a:solidFill>
-            <a:ln w="15875">
-              <a:noFill/>
-            </a:ln>
-          </p:spPr>
-          <p:style>
-            <a:lnRef idx="2">
-              <a:schemeClr val="accent1">
-                <a:shade val="15000"/>
-              </a:schemeClr>
-            </a:lnRef>
-            <a:fillRef idx="1">
-              <a:schemeClr val="accent1"/>
-            </a:fillRef>
-            <a:effectRef idx="0">
-              <a:schemeClr val="accent1"/>
-            </a:effectRef>
-            <a:fontRef idx="minor">
-              <a:schemeClr val="lt1"/>
-            </a:fontRef>
-          </p:style>
-          <p:txBody>
-            <a:bodyPr rtlCol="0" anchor="ctr"/>
-            <a:lstStyle/>
-            <a:p>
-              <a:pPr marL="182880" algn="ctr" rtl="1"/>
-              <a:r>
-                <a:rPr lang="en-US">
-                  <a:solidFill>
-                    <a:schemeClr val="bg1"/>
-                  </a:solidFill>
-                  <a:latin typeface="Bahij TheSansArabic Bold" panose="02040503050201020203" charset="-78"/>
-                  <a:cs typeface="Bahij TheSansArabic Bold" panose="02040503050201020203" charset="-78"/>
-                </a:rPr>
-                <a:t>—</a:t>
-              </a:r>
-            </a:p>
-          </p:txBody>
-        </p:sp>
-        <p:sp>
-          <p:nvSpPr>
-            <p:cNvPr id="387" name="Arrow: Down 386">
-              <a:extLst>
-                <a:ext uri="{FF2B5EF4-FFF2-40B4-BE49-F238E27FC236}">
-                  <a16:creationId xmlns:a16="http://schemas.microsoft.com/office/drawing/2014/main" id="{B5A55041-B5C9-48DA-8EB7-CBA213604C2D}"/>
-                </a:ext>
-              </a:extLst>
-            </p:cNvPr>
-            <p:cNvSpPr/>
-            <p:nvPr/>
-          </p:nvSpPr>
-          <p:spPr>
-            <a:xfrm>
-              <a:off x="2107178" y="10879033"/>
-              <a:ext cx="234654" cy="292273"/>
-            </a:xfrm>
-            <a:prstGeom prst="downArrow">
-              <a:avLst/>
-            </a:prstGeom>
-            <a:noFill/>
-            <a:ln>
-              <a:noFill/>
-            </a:ln>
-          </p:spPr>
-          <p:style>
-            <a:lnRef idx="2">
-              <a:schemeClr val="accent1">
-                <a:shade val="15000"/>
-              </a:schemeClr>
-            </a:lnRef>
-            <a:fillRef idx="1">
-              <a:schemeClr val="accent1"/>
-            </a:fillRef>
-            <a:effectRef idx="0">
-              <a:schemeClr val="accent1"/>
-            </a:effectRef>
-            <a:fontRef idx="minor">
-              <a:schemeClr val="lt1"/>
-            </a:fontRef>
-          </p:style>
-          <p:txBody>
-            <a:bodyPr rtlCol="0" anchor="ctr"/>
-            <a:lstStyle/>
-            <a:p>
-              <a:pPr algn="ctr"/>
-              <a:endParaRPr lang="en-US"/>
-            </a:p>
-          </p:txBody>
-        </p:sp>
-      </p:grpSp>
-      <p:sp>
-        <p:nvSpPr>
-          <p:cNvPr id="388" name="Arrow: Down 387">
-            <a:extLst>
-              <a:ext uri="{FF2B5EF4-FFF2-40B4-BE49-F238E27FC236}">
-                <a16:creationId xmlns:a16="http://schemas.microsoft.com/office/drawing/2014/main" id="{DF4AB646-79C9-48F4-BAD8-D85E8EFE15CE}"/>
-              </a:ext>
-            </a:extLst>
-          </p:cNvPr>
-          <p:cNvSpPr/>
-          <p:nvPr/>
-        </p:nvSpPr>
-        <p:spPr>
-          <a:xfrm flipV="1">
-            <a:off x="11249568" y="10850123"/>
-            <a:ext cx="234861" cy="292273"/>
-          </a:xfrm>
-          <a:prstGeom prst="downArrow">
-            <a:avLst/>
-          </a:prstGeom>
-          <a:noFill/>
-          <a:ln>
-            <a:noFill/>
-          </a:ln>
-        </p:spPr>
-        <p:style>
-          <a:lnRef idx="2">
-            <a:schemeClr val="accent1">
-              <a:shade val="15000"/>
-            </a:schemeClr>
-          </a:lnRef>
-          <a:fillRef idx="1">
-            <a:schemeClr val="accent1"/>
-          </a:fillRef>
-          <a:effectRef idx="0">
-            <a:schemeClr val="accent1"/>
-          </a:effectRef>
-          <a:fontRef idx="minor">
-            <a:schemeClr val="lt1"/>
-          </a:fontRef>
-        </p:style>
-        <p:txBody>
-          <a:bodyPr rtlCol="0" anchor="ctr"/>
-          <a:lstStyle/>
-          <a:p>
-            <a:pPr algn="ctr"/>
-            <a:endParaRPr lang="en-US"/>
-          </a:p>
-        </p:txBody>
-      </p:sp>
       <p:grpSp>
         <p:nvGrpSpPr>
           <p:cNvPr id="416" name="Group 415">
@@ -45575,56 +44312,6 @@
           </a:p>
         </p:txBody>
       </p:sp>
-      <p:sp>
-        <p:nvSpPr>
-          <p:cNvPr id="211" name="Arrow: Down 210">
-            <a:extLst>
-              <a:ext uri="{FF2B5EF4-FFF2-40B4-BE49-F238E27FC236}">
-                <a16:creationId xmlns:a16="http://schemas.microsoft.com/office/drawing/2014/main" id="{A8890B9E-90BF-4AD8-AB2A-1CBC883F2CBD}"/>
-              </a:ext>
-            </a:extLst>
-          </p:cNvPr>
-          <p:cNvSpPr/>
-          <p:nvPr/>
-        </p:nvSpPr>
-        <p:spPr>
-          <a:xfrm rot="10800000" flipV="1">
-            <a:off x="19580318" y="10902860"/>
-            <a:ext cx="234860" cy="292273"/>
-          </a:xfrm>
-          <a:prstGeom prst="downArrow">
-            <a:avLst/>
-          </a:prstGeom>
-          <a:noFill/>
-          <a:ln>
-            <a:noFill/>
-          </a:ln>
-        </p:spPr>
-        <p:style>
-          <a:lnRef idx="2">
-            <a:schemeClr val="accent1">
-              <a:shade val="15000"/>
-            </a:schemeClr>
-          </a:lnRef>
-          <a:fillRef idx="1">
-            <a:schemeClr val="accent1"/>
-          </a:fillRef>
-          <a:effectRef idx="0">
-            <a:schemeClr val="accent1"/>
-          </a:effectRef>
-          <a:fontRef idx="minor">
-            <a:schemeClr val="lt1"/>
-          </a:fontRef>
-        </p:style>
-        <p:txBody>
-          <a:bodyPr rtlCol="0" anchor="ctr"/>
-          <a:lstStyle/>
-          <a:p>
-            <a:pPr algn="ctr"/>
-            <a:endParaRPr lang="en-US"/>
-          </a:p>
-        </p:txBody>
-      </p:sp>
     </p:spTree>
     <p:extLst>
       <p:ext uri="{BB962C8B-B14F-4D97-AF65-F5344CB8AC3E}">
@@ -46534,7 +45221,7 @@
           <p:spPr>
             <a:xfrm>
               <a:off x="9413204" y="3059678"/>
-              <a:ext cx="3077501" cy="1265361"/>
+              <a:ext cx="3077501" cy="1572768"/>
             </a:xfrm>
             <a:prstGeom prst="roundRect">
               <a:avLst>
@@ -46589,8 +45276,8 @@
           </p:nvSpPr>
           <p:spPr>
             <a:xfrm>
-              <a:off x="9413203" y="4617767"/>
-              <a:ext cx="3077501" cy="1265361"/>
+              <a:off x="9413203" y="4930540"/>
+              <a:ext cx="3077501" cy="1572768"/>
             </a:xfrm>
             <a:prstGeom prst="roundRect">
               <a:avLst>
@@ -46645,8 +45332,8 @@
           </p:nvSpPr>
           <p:spPr>
             <a:xfrm>
-              <a:off x="9413203" y="6175857"/>
-              <a:ext cx="3077501" cy="1265361"/>
+              <a:off x="9413203" y="6801402"/>
+              <a:ext cx="3077501" cy="1572768"/>
             </a:xfrm>
             <a:prstGeom prst="roundRect">
               <a:avLst>
@@ -46701,8 +45388,8 @@
           </p:nvSpPr>
           <p:spPr>
             <a:xfrm>
-              <a:off x="9413203" y="7733946"/>
-              <a:ext cx="3077501" cy="1265361"/>
+              <a:off x="9413203" y="8672264"/>
+              <a:ext cx="3077501" cy="1572768"/>
             </a:xfrm>
             <a:prstGeom prst="roundRect">
               <a:avLst>
@@ -46757,64 +45444,8 @@
           </p:nvSpPr>
           <p:spPr>
             <a:xfrm>
-              <a:off x="9413203" y="9292036"/>
-              <a:ext cx="3077501" cy="1265361"/>
-            </a:xfrm>
-            <a:prstGeom prst="roundRect">
-              <a:avLst>
-                <a:gd name="adj" fmla="val 5149"/>
-              </a:avLst>
-            </a:prstGeom>
-            <a:solidFill>
-              <a:srgbClr val="FBFBFA"/>
-            </a:solidFill>
-            <a:ln>
-              <a:solidFill>
-                <a:srgbClr val="D9D9D9"/>
-              </a:solidFill>
-            </a:ln>
-          </p:spPr>
-          <p:style>
-            <a:lnRef idx="2">
-              <a:schemeClr val="accent1">
-                <a:shade val="15000"/>
-              </a:schemeClr>
-            </a:lnRef>
-            <a:fillRef idx="1">
-              <a:schemeClr val="accent1"/>
-            </a:fillRef>
-            <a:effectRef idx="0">
-              <a:schemeClr val="accent1"/>
-            </a:effectRef>
-            <a:fontRef idx="minor">
-              <a:schemeClr val="lt1"/>
-            </a:fontRef>
-          </p:style>
-          <p:txBody>
-            <a:bodyPr rtlCol="0" anchor="ctr"/>
-            <a:lstStyle/>
-            <a:p>
-              <a:pPr algn="ctr"/>
-              <a:endParaRPr lang="en-US"/>
-            </a:p>
-          </p:txBody>
-        </p:sp>
-        <p:sp>
-          <p:nvSpPr>
-            <p:cNvPr id="47" name="Rectangle: Rounded Corners 46">
-              <a:extLst>
-                <a:ext uri="{FF2B5EF4-FFF2-40B4-BE49-F238E27FC236}">
-                  <a16:creationId xmlns:a16="http://schemas.microsoft.com/office/drawing/2014/main" id="{55E13CBA-83D3-E50A-D122-FE69DA41FAA5}"/>
-                </a:ext>
-              </a:extLst>
-            </p:cNvPr>
-            <p:cNvSpPr/>
-            <p:nvPr/>
-          </p:nvSpPr>
-          <p:spPr>
-            <a:xfrm>
-              <a:off x="9413203" y="10850125"/>
-              <a:ext cx="3077501" cy="1265361"/>
+              <a:off x="9413203" y="10543126"/>
+              <a:ext cx="3077501" cy="1572768"/>
             </a:xfrm>
             <a:prstGeom prst="roundRect">
               <a:avLst>
@@ -46869,7 +45500,7 @@
           </p:nvSpPr>
           <p:spPr>
             <a:xfrm>
-              <a:off x="9326765" y="3499172"/>
+              <a:off x="9326765" y="3627957"/>
               <a:ext cx="3216069" cy="436210"/>
             </a:xfrm>
             <a:prstGeom prst="rect">
@@ -46926,7 +45557,7 @@
           </p:nvSpPr>
           <p:spPr>
             <a:xfrm>
-              <a:off x="9343918" y="5078551"/>
+              <a:off x="9343918" y="5498819"/>
               <a:ext cx="3216069" cy="436210"/>
             </a:xfrm>
             <a:prstGeom prst="rect">
@@ -46983,7 +45614,7 @@
           </p:nvSpPr>
           <p:spPr>
             <a:xfrm>
-              <a:off x="9370896" y="6629117"/>
+              <a:off x="9370896" y="7369681"/>
               <a:ext cx="3216069" cy="436210"/>
             </a:xfrm>
             <a:prstGeom prst="rect">
@@ -47040,7 +45671,7 @@
           </p:nvSpPr>
           <p:spPr>
             <a:xfrm>
-              <a:off x="9310448" y="8148522"/>
+              <a:off x="9310448" y="9240543"/>
               <a:ext cx="3216069" cy="436210"/>
             </a:xfrm>
             <a:prstGeom prst="rect">
@@ -47097,7 +45728,7 @@
           </p:nvSpPr>
           <p:spPr>
             <a:xfrm>
-              <a:off x="9364888" y="9733384"/>
+              <a:off x="9364888" y="11111405"/>
               <a:ext cx="3216069" cy="436210"/>
             </a:xfrm>
             <a:prstGeom prst="rect">
@@ -47136,63 +45767,6 @@
               <a:r>
                 <a:rPr lang="ar-SA"/>
                 <a:t>أخرى</a:t>
-              </a:r>
-            </a:p>
-          </p:txBody>
-        </p:sp>
-        <p:sp>
-          <p:nvSpPr>
-            <p:cNvPr id="102" name="TextBox 101">
-              <a:extLst>
-                <a:ext uri="{FF2B5EF4-FFF2-40B4-BE49-F238E27FC236}">
-                  <a16:creationId xmlns:a16="http://schemas.microsoft.com/office/drawing/2014/main" id="{07A5DABC-6412-B716-F9BE-0549AD3CA379}"/>
-                </a:ext>
-              </a:extLst>
-            </p:cNvPr>
-            <p:cNvSpPr txBox="1"/>
-            <p:nvPr/>
-          </p:nvSpPr>
-          <p:spPr>
-            <a:xfrm>
-              <a:off x="9343918" y="11288531"/>
-              <a:ext cx="3216069" cy="436210"/>
-            </a:xfrm>
-            <a:prstGeom prst="rect">
-              <a:avLst/>
-            </a:prstGeom>
-            <a:noFill/>
-          </p:spPr>
-          <p:txBody>
-            <a:bodyPr wrap="square" rtlCol="0">
-              <a:spAutoFit/>
-            </a:bodyPr>
-            <a:lstStyle>
-              <a:defPPr marR="0" lvl="0" algn="l" rtl="0">
-                <a:lnSpc>
-                  <a:spcPct val="100000"/>
-                </a:lnSpc>
-                <a:spcBef>
-                  <a:spcPts val="0"/>
-                </a:spcBef>
-                <a:spcAft>
-                  <a:spcPts val="0"/>
-                </a:spcAft>
-                <a:defRPr/>
-              </a:defPPr>
-              <a:lvl1pPr algn="ctr">
-                <a:defRPr sz="2400">
-                  <a:solidFill>
-                    <a:srgbClr val="106946"/>
-                  </a:solidFill>
-                  <a:latin typeface="Bahij TheSansArabic Bold" panose="02040503050201020203" charset="-78"/>
-                  <a:cs typeface="Bahij TheSansArabic Bold" panose="02040503050201020203" charset="-78"/>
-                </a:defRPr>
-              </a:lvl1pPr>
-            </a:lstStyle>
-            <a:p>
-              <a:r>
-                <a:rPr lang="ar-SA"/>
-                <a:t>نقل الملكية</a:t>
               </a:r>
             </a:p>
           </p:txBody>
@@ -47410,7 +45984,7 @@
         <p:spPr>
           <a:xfrm>
             <a:off x="12045918" y="3094854"/>
-            <a:ext cx="1576718" cy="1265361"/>
+            <a:ext cx="1576718" cy="1572768"/>
           </a:xfrm>
           <a:prstGeom prst="roundRect">
             <a:avLst>
@@ -47465,8 +46039,8 @@
         </p:nvSpPr>
         <p:spPr>
           <a:xfrm>
-            <a:off x="12045918" y="4652943"/>
-            <a:ext cx="1576718" cy="1265361"/>
+            <a:off x="12045918" y="4965716"/>
+            <a:ext cx="1576718" cy="1572768"/>
           </a:xfrm>
           <a:prstGeom prst="roundRect">
             <a:avLst>
@@ -47521,8 +46095,8 @@
         </p:nvSpPr>
         <p:spPr>
           <a:xfrm>
-            <a:off x="12045918" y="6211032"/>
-            <a:ext cx="1576718" cy="1265361"/>
+            <a:off x="12045918" y="6836578"/>
+            <a:ext cx="1576718" cy="1572768"/>
           </a:xfrm>
           <a:prstGeom prst="roundRect">
             <a:avLst>
@@ -47577,8 +46151,8 @@
         </p:nvSpPr>
         <p:spPr>
           <a:xfrm>
-            <a:off x="12045918" y="7769121"/>
-            <a:ext cx="1576718" cy="1265361"/>
+            <a:off x="12045918" y="8707440"/>
+            <a:ext cx="1576718" cy="1572768"/>
           </a:xfrm>
           <a:prstGeom prst="roundRect">
             <a:avLst>
@@ -47633,64 +46207,8 @@
         </p:nvSpPr>
         <p:spPr>
           <a:xfrm>
-            <a:off x="12045918" y="9327210"/>
-            <a:ext cx="1576718" cy="1265361"/>
-          </a:xfrm>
-          <a:prstGeom prst="roundRect">
-            <a:avLst>
-              <a:gd name="adj" fmla="val 5149"/>
-            </a:avLst>
-          </a:prstGeom>
-          <a:solidFill>
-            <a:srgbClr val="FBFBFA"/>
-          </a:solidFill>
-          <a:ln>
-            <a:solidFill>
-              <a:srgbClr val="D9D9D9"/>
-            </a:solidFill>
-          </a:ln>
-        </p:spPr>
-        <p:style>
-          <a:lnRef idx="2">
-            <a:schemeClr val="accent1">
-              <a:shade val="15000"/>
-            </a:schemeClr>
-          </a:lnRef>
-          <a:fillRef idx="1">
-            <a:schemeClr val="accent1"/>
-          </a:fillRef>
-          <a:effectRef idx="0">
-            <a:schemeClr val="accent1"/>
-          </a:effectRef>
-          <a:fontRef idx="minor">
-            <a:schemeClr val="lt1"/>
-          </a:fontRef>
-        </p:style>
-        <p:txBody>
-          <a:bodyPr rtlCol="0" anchor="ctr"/>
-          <a:lstStyle/>
-          <a:p>
-            <a:pPr algn="ctr"/>
-            <a:endParaRPr lang="en-US"/>
-          </a:p>
-        </p:txBody>
-      </p:sp>
-      <p:sp>
-        <p:nvSpPr>
-          <p:cNvPr id="241" name="Rectangle: Rounded Corners 240">
-            <a:extLst>
-              <a:ext uri="{FF2B5EF4-FFF2-40B4-BE49-F238E27FC236}">
-                <a16:creationId xmlns:a16="http://schemas.microsoft.com/office/drawing/2014/main" id="{F8B1E50D-10A1-C0DC-A8F2-E501659A4D7A}"/>
-              </a:ext>
-            </a:extLst>
-          </p:cNvPr>
-          <p:cNvSpPr/>
-          <p:nvPr/>
-        </p:nvSpPr>
-        <p:spPr>
-          <a:xfrm>
-            <a:off x="12045918" y="10885301"/>
-            <a:ext cx="1576718" cy="1265361"/>
+            <a:off x="12045918" y="10578302"/>
+            <a:ext cx="1576718" cy="1572768"/>
           </a:xfrm>
           <a:prstGeom prst="roundRect">
             <a:avLst>
@@ -47795,7 +46313,7 @@
         <p:spPr>
           <a:xfrm>
             <a:off x="14117845" y="3094854"/>
-            <a:ext cx="1576718" cy="1265361"/>
+            <a:ext cx="1576718" cy="1572768"/>
           </a:xfrm>
           <a:prstGeom prst="roundRect">
             <a:avLst>
@@ -47850,8 +46368,8 @@
         </p:nvSpPr>
         <p:spPr>
           <a:xfrm>
-            <a:off x="14117845" y="4652943"/>
-            <a:ext cx="1576718" cy="1265361"/>
+            <a:off x="14117845" y="4965716"/>
+            <a:ext cx="1576718" cy="1572768"/>
           </a:xfrm>
           <a:prstGeom prst="roundRect">
             <a:avLst>
@@ -47906,8 +46424,8 @@
         </p:nvSpPr>
         <p:spPr>
           <a:xfrm>
-            <a:off x="14117845" y="6211032"/>
-            <a:ext cx="1576718" cy="1265361"/>
+            <a:off x="14117845" y="6836578"/>
+            <a:ext cx="1576718" cy="1572768"/>
           </a:xfrm>
           <a:prstGeom prst="roundRect">
             <a:avLst>
@@ -47962,8 +46480,8 @@
         </p:nvSpPr>
         <p:spPr>
           <a:xfrm>
-            <a:off x="14117845" y="7769121"/>
-            <a:ext cx="1576718" cy="1265361"/>
+            <a:off x="14117845" y="8707440"/>
+            <a:ext cx="1576718" cy="1572768"/>
           </a:xfrm>
           <a:prstGeom prst="roundRect">
             <a:avLst>
@@ -48018,64 +46536,8 @@
         </p:nvSpPr>
         <p:spPr>
           <a:xfrm>
-            <a:off x="14117845" y="9327210"/>
-            <a:ext cx="1576718" cy="1265361"/>
-          </a:xfrm>
-          <a:prstGeom prst="roundRect">
-            <a:avLst>
-              <a:gd name="adj" fmla="val 5149"/>
-            </a:avLst>
-          </a:prstGeom>
-          <a:solidFill>
-            <a:srgbClr val="FBFBFA"/>
-          </a:solidFill>
-          <a:ln>
-            <a:solidFill>
-              <a:srgbClr val="D9D9D9"/>
-            </a:solidFill>
-          </a:ln>
-        </p:spPr>
-        <p:style>
-          <a:lnRef idx="2">
-            <a:schemeClr val="accent1">
-              <a:shade val="15000"/>
-            </a:schemeClr>
-          </a:lnRef>
-          <a:fillRef idx="1">
-            <a:schemeClr val="accent1"/>
-          </a:fillRef>
-          <a:effectRef idx="0">
-            <a:schemeClr val="accent1"/>
-          </a:effectRef>
-          <a:fontRef idx="minor">
-            <a:schemeClr val="lt1"/>
-          </a:fontRef>
-        </p:style>
-        <p:txBody>
-          <a:bodyPr rtlCol="0" anchor="ctr"/>
-          <a:lstStyle/>
-          <a:p>
-            <a:pPr algn="ctr"/>
-            <a:endParaRPr lang="en-US"/>
-          </a:p>
-        </p:txBody>
-      </p:sp>
-      <p:sp>
-        <p:nvSpPr>
-          <p:cNvPr id="560" name="Rectangle: Rounded Corners 559">
-            <a:extLst>
-              <a:ext uri="{FF2B5EF4-FFF2-40B4-BE49-F238E27FC236}">
-                <a16:creationId xmlns:a16="http://schemas.microsoft.com/office/drawing/2014/main" id="{1F44F292-CE10-63C9-93C6-508383DDA38B}"/>
-              </a:ext>
-            </a:extLst>
-          </p:cNvPr>
-          <p:cNvSpPr/>
-          <p:nvPr/>
-        </p:nvSpPr>
-        <p:spPr>
-          <a:xfrm>
-            <a:off x="14117845" y="10885301"/>
-            <a:ext cx="1576718" cy="1265361"/>
+            <a:off x="14117845" y="10578302"/>
+            <a:ext cx="1576718" cy="1572768"/>
           </a:xfrm>
           <a:prstGeom prst="roundRect">
             <a:avLst>
@@ -48180,7 +46642,7 @@
         <p:spPr>
           <a:xfrm>
             <a:off x="16189772" y="3094854"/>
-            <a:ext cx="1576718" cy="1265361"/>
+            <a:ext cx="1576718" cy="1572768"/>
           </a:xfrm>
           <a:prstGeom prst="roundRect">
             <a:avLst>
@@ -48235,8 +46697,8 @@
         </p:nvSpPr>
         <p:spPr>
           <a:xfrm>
-            <a:off x="16189772" y="4652943"/>
-            <a:ext cx="1576718" cy="1265361"/>
+            <a:off x="16189772" y="4965716"/>
+            <a:ext cx="1576718" cy="1572768"/>
           </a:xfrm>
           <a:prstGeom prst="roundRect">
             <a:avLst>
@@ -48291,8 +46753,8 @@
         </p:nvSpPr>
         <p:spPr>
           <a:xfrm>
-            <a:off x="16189772" y="6211032"/>
-            <a:ext cx="1576718" cy="1265361"/>
+            <a:off x="16189772" y="6836578"/>
+            <a:ext cx="1576718" cy="1572768"/>
           </a:xfrm>
           <a:prstGeom prst="roundRect">
             <a:avLst>
@@ -48347,8 +46809,8 @@
         </p:nvSpPr>
         <p:spPr>
           <a:xfrm>
-            <a:off x="16189772" y="7769121"/>
-            <a:ext cx="1576718" cy="1265361"/>
+            <a:off x="16189772" y="8707440"/>
+            <a:ext cx="1576718" cy="1572768"/>
           </a:xfrm>
           <a:prstGeom prst="roundRect">
             <a:avLst>
@@ -48403,64 +46865,8 @@
         </p:nvSpPr>
         <p:spPr>
           <a:xfrm>
-            <a:off x="16189772" y="9327210"/>
-            <a:ext cx="1576718" cy="1265361"/>
-          </a:xfrm>
-          <a:prstGeom prst="roundRect">
-            <a:avLst>
-              <a:gd name="adj" fmla="val 5149"/>
-            </a:avLst>
-          </a:prstGeom>
-          <a:solidFill>
-            <a:srgbClr val="FBFBFA"/>
-          </a:solidFill>
-          <a:ln>
-            <a:solidFill>
-              <a:srgbClr val="D9D9D9"/>
-            </a:solidFill>
-          </a:ln>
-        </p:spPr>
-        <p:style>
-          <a:lnRef idx="2">
-            <a:schemeClr val="accent1">
-              <a:shade val="15000"/>
-            </a:schemeClr>
-          </a:lnRef>
-          <a:fillRef idx="1">
-            <a:schemeClr val="accent1"/>
-          </a:fillRef>
-          <a:effectRef idx="0">
-            <a:schemeClr val="accent1"/>
-          </a:effectRef>
-          <a:fontRef idx="minor">
-            <a:schemeClr val="lt1"/>
-          </a:fontRef>
-        </p:style>
-        <p:txBody>
-          <a:bodyPr rtlCol="0" anchor="ctr"/>
-          <a:lstStyle/>
-          <a:p>
-            <a:pPr algn="ctr"/>
-            <a:endParaRPr lang="en-US"/>
-          </a:p>
-        </p:txBody>
-      </p:sp>
-      <p:sp>
-        <p:nvSpPr>
-          <p:cNvPr id="586" name="Rectangle: Rounded Corners 585">
-            <a:extLst>
-              <a:ext uri="{FF2B5EF4-FFF2-40B4-BE49-F238E27FC236}">
-                <a16:creationId xmlns:a16="http://schemas.microsoft.com/office/drawing/2014/main" id="{E5A30E40-92CB-3AFA-A66D-282BE4CD1505}"/>
-              </a:ext>
-            </a:extLst>
-          </p:cNvPr>
-          <p:cNvSpPr/>
-          <p:nvPr/>
-        </p:nvSpPr>
-        <p:spPr>
-          <a:xfrm>
-            <a:off x="16189772" y="10885301"/>
-            <a:ext cx="1576718" cy="1265361"/>
+            <a:off x="16189772" y="10578302"/>
+            <a:ext cx="1576718" cy="1572768"/>
           </a:xfrm>
           <a:prstGeom prst="roundRect">
             <a:avLst>
@@ -48565,7 +46971,7 @@
         <p:spPr>
           <a:xfrm>
             <a:off x="18261699" y="3094854"/>
-            <a:ext cx="1576718" cy="1265361"/>
+            <a:ext cx="1576718" cy="1572768"/>
           </a:xfrm>
           <a:prstGeom prst="roundRect">
             <a:avLst>
@@ -48620,8 +47026,8 @@
         </p:nvSpPr>
         <p:spPr>
           <a:xfrm>
-            <a:off x="18261699" y="4652943"/>
-            <a:ext cx="1576718" cy="1265361"/>
+            <a:off x="18261699" y="4965716"/>
+            <a:ext cx="1576718" cy="1572768"/>
           </a:xfrm>
           <a:prstGeom prst="roundRect">
             <a:avLst>
@@ -48676,8 +47082,8 @@
         </p:nvSpPr>
         <p:spPr>
           <a:xfrm>
-            <a:off x="18261699" y="6211032"/>
-            <a:ext cx="1576718" cy="1265361"/>
+            <a:off x="18261699" y="6836578"/>
+            <a:ext cx="1576718" cy="1572768"/>
           </a:xfrm>
           <a:prstGeom prst="roundRect">
             <a:avLst>
@@ -48732,8 +47138,8 @@
         </p:nvSpPr>
         <p:spPr>
           <a:xfrm>
-            <a:off x="18261699" y="7769121"/>
-            <a:ext cx="1576718" cy="1265361"/>
+            <a:off x="18261699" y="8707440"/>
+            <a:ext cx="1576718" cy="1572768"/>
           </a:xfrm>
           <a:prstGeom prst="roundRect">
             <a:avLst>
@@ -48788,64 +47194,8 @@
         </p:nvSpPr>
         <p:spPr>
           <a:xfrm>
-            <a:off x="18261699" y="9327210"/>
-            <a:ext cx="1576718" cy="1265361"/>
-          </a:xfrm>
-          <a:prstGeom prst="roundRect">
-            <a:avLst>
-              <a:gd name="adj" fmla="val 5149"/>
-            </a:avLst>
-          </a:prstGeom>
-          <a:solidFill>
-            <a:srgbClr val="FBFBFA"/>
-          </a:solidFill>
-          <a:ln>
-            <a:solidFill>
-              <a:srgbClr val="D9D9D9"/>
-            </a:solidFill>
-          </a:ln>
-        </p:spPr>
-        <p:style>
-          <a:lnRef idx="2">
-            <a:schemeClr val="accent1">
-              <a:shade val="15000"/>
-            </a:schemeClr>
-          </a:lnRef>
-          <a:fillRef idx="1">
-            <a:schemeClr val="accent1"/>
-          </a:fillRef>
-          <a:effectRef idx="0">
-            <a:schemeClr val="accent1"/>
-          </a:effectRef>
-          <a:fontRef idx="minor">
-            <a:schemeClr val="lt1"/>
-          </a:fontRef>
-        </p:style>
-        <p:txBody>
-          <a:bodyPr rtlCol="0" anchor="ctr"/>
-          <a:lstStyle/>
-          <a:p>
-            <a:pPr algn="ctr"/>
-            <a:endParaRPr lang="en-US"/>
-          </a:p>
-        </p:txBody>
-      </p:sp>
-      <p:sp>
-        <p:nvSpPr>
-          <p:cNvPr id="612" name="Rectangle: Rounded Corners 611">
-            <a:extLst>
-              <a:ext uri="{FF2B5EF4-FFF2-40B4-BE49-F238E27FC236}">
-                <a16:creationId xmlns:a16="http://schemas.microsoft.com/office/drawing/2014/main" id="{49062E3F-F265-5A77-B81B-E54EEDB119A1}"/>
-              </a:ext>
-            </a:extLst>
-          </p:cNvPr>
-          <p:cNvSpPr/>
-          <p:nvPr/>
-        </p:nvSpPr>
-        <p:spPr>
-          <a:xfrm>
-            <a:off x="18261699" y="10885301"/>
-            <a:ext cx="1576718" cy="1265361"/>
+            <a:off x="18261699" y="10578302"/>
+            <a:ext cx="1576718" cy="1572768"/>
           </a:xfrm>
           <a:prstGeom prst="roundRect">
             <a:avLst>
@@ -49203,7 +47553,7 @@
         </p:nvGrpSpPr>
         <p:grpSpPr>
           <a:xfrm>
-            <a:off x="18991259" y="4667075"/>
+            <a:off x="18991259" y="4979848"/>
             <a:ext cx="847611" cy="310752"/>
             <a:chOff x="-6600343" y="4603178"/>
             <a:chExt cx="846866" cy="310752"/>
@@ -49337,7 +47687,7 @@
         </p:nvGrpSpPr>
         <p:grpSpPr>
           <a:xfrm>
-            <a:off x="18991259" y="6224195"/>
+            <a:off x="18991259" y="6849741"/>
             <a:ext cx="847611" cy="310752"/>
             <a:chOff x="-6600343" y="6171548"/>
             <a:chExt cx="846866" cy="310752"/>
@@ -49471,7 +47821,7 @@
         </p:nvGrpSpPr>
         <p:grpSpPr>
           <a:xfrm>
-            <a:off x="18991259" y="7781315"/>
+            <a:off x="18991259" y="8719634"/>
             <a:ext cx="847611" cy="310752"/>
             <a:chOff x="-6600343" y="7739918"/>
             <a:chExt cx="846866" cy="310752"/>
@@ -49605,7 +47955,7 @@
         </p:nvGrpSpPr>
         <p:grpSpPr>
           <a:xfrm>
-            <a:off x="18991259" y="9338435"/>
+            <a:off x="18991259" y="10589527"/>
             <a:ext cx="847611" cy="310752"/>
             <a:chOff x="6117941" y="9303259"/>
             <a:chExt cx="847611" cy="310752"/>
@@ -49695,138 +48045,6 @@
             <a:solidFill>
               <a:srgbClr val="A9D18E"/>
             </a:solidFill>
-            <a:ln>
-              <a:noFill/>
-            </a:ln>
-          </p:spPr>
-          <p:style>
-            <a:lnRef idx="2">
-              <a:schemeClr val="accent1">
-                <a:shade val="15000"/>
-              </a:schemeClr>
-            </a:lnRef>
-            <a:fillRef idx="1">
-              <a:schemeClr val="accent1"/>
-            </a:fillRef>
-            <a:effectRef idx="0">
-              <a:schemeClr val="accent1"/>
-            </a:effectRef>
-            <a:fontRef idx="minor">
-              <a:schemeClr val="lt1"/>
-            </a:fontRef>
-          </p:style>
-          <p:txBody>
-            <a:bodyPr rtlCol="0" anchor="ctr"/>
-            <a:lstStyle/>
-            <a:p>
-              <a:pPr algn="ctr"/>
-              <a:endParaRPr lang="en-US"/>
-            </a:p>
-          </p:txBody>
-        </p:sp>
-      </p:grpSp>
-      <p:grpSp>
-        <p:nvGrpSpPr>
-          <p:cNvPr id="619" name="Group 618">
-            <a:extLst>
-              <a:ext uri="{FF2B5EF4-FFF2-40B4-BE49-F238E27FC236}">
-                <a16:creationId xmlns:a16="http://schemas.microsoft.com/office/drawing/2014/main" id="{A138208B-4CE5-2882-9D82-0221E23856B6}"/>
-              </a:ext>
-            </a:extLst>
-          </p:cNvPr>
-          <p:cNvGrpSpPr/>
-          <p:nvPr/>
-        </p:nvGrpSpPr>
-        <p:grpSpPr>
-          <a:xfrm>
-            <a:off x="18991259" y="10895554"/>
-            <a:ext cx="847611" cy="310928"/>
-            <a:chOff x="1503088" y="10860378"/>
-            <a:chExt cx="846866" cy="310928"/>
-          </a:xfrm>
-        </p:grpSpPr>
-        <p:sp>
-          <p:nvSpPr>
-            <p:cNvPr id="622" name="Rectangle: Rounded Corners 621">
-              <a:extLst>
-                <a:ext uri="{FF2B5EF4-FFF2-40B4-BE49-F238E27FC236}">
-                  <a16:creationId xmlns:a16="http://schemas.microsoft.com/office/drawing/2014/main" id="{37BB6836-6E03-2BAC-228A-8DAE6800CC16}"/>
-                </a:ext>
-              </a:extLst>
-            </p:cNvPr>
-            <p:cNvSpPr/>
-            <p:nvPr/>
-          </p:nvSpPr>
-          <p:spPr>
-            <a:xfrm>
-              <a:off x="1503088" y="10860378"/>
-              <a:ext cx="846866" cy="310752"/>
-            </a:xfrm>
-            <a:prstGeom prst="roundRect">
-              <a:avLst/>
-            </a:prstGeom>
-            <a:solidFill>
-              <a:srgbClr val="01686A"/>
-            </a:solidFill>
-            <a:ln w="15875">
-              <a:noFill/>
-            </a:ln>
-          </p:spPr>
-          <p:style>
-            <a:lnRef idx="2">
-              <a:schemeClr val="accent1">
-                <a:shade val="15000"/>
-              </a:schemeClr>
-            </a:lnRef>
-            <a:fillRef idx="1">
-              <a:schemeClr val="accent1"/>
-            </a:fillRef>
-            <a:effectRef idx="0">
-              <a:schemeClr val="accent1"/>
-            </a:effectRef>
-            <a:fontRef idx="minor">
-              <a:schemeClr val="lt1"/>
-            </a:fontRef>
-          </p:style>
-          <p:txBody>
-            <a:bodyPr rtlCol="0" anchor="ctr"/>
-            <a:lstStyle/>
-            <a:p>
-              <a:pPr marL="182880" algn="ctr" rtl="1"/>
-              <a:r>
-                <a:rPr lang="en-US">
-                  <a:solidFill>
-                    <a:schemeClr val="bg1"/>
-                  </a:solidFill>
-                  <a:latin typeface="Bahij TheSansArabic Bold" panose="02040503050201020203" charset="-78"/>
-                  <a:cs typeface="Bahij TheSansArabic Bold" panose="02040503050201020203" charset="-78"/>
-                </a:rPr>
-                <a:t>—</a:t>
-              </a:r>
-            </a:p>
-          </p:txBody>
-        </p:sp>
-        <p:sp>
-          <p:nvSpPr>
-            <p:cNvPr id="623" name="Arrow: Down 622">
-              <a:extLst>
-                <a:ext uri="{FF2B5EF4-FFF2-40B4-BE49-F238E27FC236}">
-                  <a16:creationId xmlns:a16="http://schemas.microsoft.com/office/drawing/2014/main" id="{F06B954B-6797-DBBD-C719-42FB69D7C703}"/>
-                </a:ext>
-              </a:extLst>
-            </p:cNvPr>
-            <p:cNvSpPr/>
-            <p:nvPr/>
-          </p:nvSpPr>
-          <p:spPr>
-            <a:xfrm>
-              <a:off x="2107178" y="10879033"/>
-              <a:ext cx="234654" cy="292273"/>
-            </a:xfrm>
-            <a:prstGeom prst="downArrow">
-              <a:avLst/>
-            </a:prstGeom>
-            <a:noFill/>
             <a:ln>
               <a:noFill/>
             </a:ln>
@@ -50005,7 +48223,7 @@
         </p:nvGrpSpPr>
         <p:grpSpPr>
           <a:xfrm>
-            <a:off x="16919332" y="4667075"/>
+            <a:off x="16919332" y="4979848"/>
             <a:ext cx="847611" cy="310752"/>
             <a:chOff x="-6600343" y="4603178"/>
             <a:chExt cx="846866" cy="310752"/>
@@ -50139,7 +48357,7 @@
         </p:nvGrpSpPr>
         <p:grpSpPr>
           <a:xfrm>
-            <a:off x="16919332" y="6224195"/>
+            <a:off x="16919332" y="6849741"/>
             <a:ext cx="847611" cy="310752"/>
             <a:chOff x="-6600343" y="6171548"/>
             <a:chExt cx="846866" cy="310752"/>
@@ -50273,7 +48491,7 @@
         </p:nvGrpSpPr>
         <p:grpSpPr>
           <a:xfrm>
-            <a:off x="16919332" y="7781315"/>
+            <a:off x="16919332" y="8719634"/>
             <a:ext cx="847611" cy="310752"/>
             <a:chOff x="-6600343" y="7739918"/>
             <a:chExt cx="846866" cy="310752"/>
@@ -50407,7 +48625,7 @@
         </p:nvGrpSpPr>
         <p:grpSpPr>
           <a:xfrm>
-            <a:off x="16919332" y="9338435"/>
+            <a:off x="16919332" y="10589527"/>
             <a:ext cx="847611" cy="310752"/>
             <a:chOff x="4404594" y="9303259"/>
             <a:chExt cx="847611" cy="310752"/>
@@ -50497,138 +48715,6 @@
             <a:solidFill>
               <a:srgbClr val="A9D18E"/>
             </a:solidFill>
-            <a:ln>
-              <a:noFill/>
-            </a:ln>
-          </p:spPr>
-          <p:style>
-            <a:lnRef idx="2">
-              <a:schemeClr val="accent1">
-                <a:shade val="15000"/>
-              </a:schemeClr>
-            </a:lnRef>
-            <a:fillRef idx="1">
-              <a:schemeClr val="accent1"/>
-            </a:fillRef>
-            <a:effectRef idx="0">
-              <a:schemeClr val="accent1"/>
-            </a:effectRef>
-            <a:fontRef idx="minor">
-              <a:schemeClr val="lt1"/>
-            </a:fontRef>
-          </p:style>
-          <p:txBody>
-            <a:bodyPr rtlCol="0" anchor="ctr"/>
-            <a:lstStyle/>
-            <a:p>
-              <a:pPr algn="ctr"/>
-              <a:endParaRPr lang="en-US"/>
-            </a:p>
-          </p:txBody>
-        </p:sp>
-      </p:grpSp>
-      <p:grpSp>
-        <p:nvGrpSpPr>
-          <p:cNvPr id="593" name="Group 592">
-            <a:extLst>
-              <a:ext uri="{FF2B5EF4-FFF2-40B4-BE49-F238E27FC236}">
-                <a16:creationId xmlns:a16="http://schemas.microsoft.com/office/drawing/2014/main" id="{DC47680F-953F-74E4-24C9-2993E04DF660}"/>
-              </a:ext>
-            </a:extLst>
-          </p:cNvPr>
-          <p:cNvGrpSpPr/>
-          <p:nvPr/>
-        </p:nvGrpSpPr>
-        <p:grpSpPr>
-          <a:xfrm>
-            <a:off x="16919332" y="10895554"/>
-            <a:ext cx="847611" cy="310928"/>
-            <a:chOff x="1503088" y="10860378"/>
-            <a:chExt cx="846866" cy="310928"/>
-          </a:xfrm>
-        </p:grpSpPr>
-        <p:sp>
-          <p:nvSpPr>
-            <p:cNvPr id="596" name="Rectangle: Rounded Corners 595">
-              <a:extLst>
-                <a:ext uri="{FF2B5EF4-FFF2-40B4-BE49-F238E27FC236}">
-                  <a16:creationId xmlns:a16="http://schemas.microsoft.com/office/drawing/2014/main" id="{399381F1-86D8-43BB-FBA4-301FDF88142E}"/>
-                </a:ext>
-              </a:extLst>
-            </p:cNvPr>
-            <p:cNvSpPr/>
-            <p:nvPr/>
-          </p:nvSpPr>
-          <p:spPr>
-            <a:xfrm>
-              <a:off x="1503088" y="10860378"/>
-              <a:ext cx="846866" cy="310752"/>
-            </a:xfrm>
-            <a:prstGeom prst="roundRect">
-              <a:avLst/>
-            </a:prstGeom>
-            <a:solidFill>
-              <a:srgbClr val="01686A"/>
-            </a:solidFill>
-            <a:ln w="15875">
-              <a:noFill/>
-            </a:ln>
-          </p:spPr>
-          <p:style>
-            <a:lnRef idx="2">
-              <a:schemeClr val="accent1">
-                <a:shade val="15000"/>
-              </a:schemeClr>
-            </a:lnRef>
-            <a:fillRef idx="1">
-              <a:schemeClr val="accent1"/>
-            </a:fillRef>
-            <a:effectRef idx="0">
-              <a:schemeClr val="accent1"/>
-            </a:effectRef>
-            <a:fontRef idx="minor">
-              <a:schemeClr val="lt1"/>
-            </a:fontRef>
-          </p:style>
-          <p:txBody>
-            <a:bodyPr rtlCol="0" anchor="ctr"/>
-            <a:lstStyle/>
-            <a:p>
-              <a:pPr marL="182880" algn="ctr" rtl="1"/>
-              <a:r>
-                <a:rPr lang="en-US">
-                  <a:solidFill>
-                    <a:schemeClr val="bg1"/>
-                  </a:solidFill>
-                  <a:latin typeface="Bahij TheSansArabic Bold" panose="02040503050201020203" charset="-78"/>
-                  <a:cs typeface="Bahij TheSansArabic Bold" panose="02040503050201020203" charset="-78"/>
-                </a:rPr>
-                <a:t>—</a:t>
-              </a:r>
-            </a:p>
-          </p:txBody>
-        </p:sp>
-        <p:sp>
-          <p:nvSpPr>
-            <p:cNvPr id="597" name="Arrow: Down 596">
-              <a:extLst>
-                <a:ext uri="{FF2B5EF4-FFF2-40B4-BE49-F238E27FC236}">
-                  <a16:creationId xmlns:a16="http://schemas.microsoft.com/office/drawing/2014/main" id="{DE21E5C4-061D-D188-26A3-56AFDA5DCB58}"/>
-                </a:ext>
-              </a:extLst>
-            </p:cNvPr>
-            <p:cNvSpPr/>
-            <p:nvPr/>
-          </p:nvSpPr>
-          <p:spPr>
-            <a:xfrm>
-              <a:off x="2107178" y="10879033"/>
-              <a:ext cx="234654" cy="292273"/>
-            </a:xfrm>
-            <a:prstGeom prst="downArrow">
-              <a:avLst/>
-            </a:prstGeom>
-            <a:noFill/>
             <a:ln>
               <a:noFill/>
             </a:ln>
@@ -50807,7 +48893,7 @@
         </p:nvSpPr>
         <p:spPr>
           <a:xfrm>
-            <a:off x="14847405" y="4667075"/>
+            <a:off x="14847405" y="4979848"/>
             <a:ext cx="847611" cy="310752"/>
           </a:xfrm>
           <a:prstGeom prst="roundRect">
@@ -50868,7 +48954,7 @@
         </p:nvGrpSpPr>
         <p:grpSpPr>
           <a:xfrm>
-            <a:off x="14847405" y="6224195"/>
+            <a:off x="14847405" y="6849741"/>
             <a:ext cx="847611" cy="310752"/>
             <a:chOff x="-6600343" y="6171548"/>
             <a:chExt cx="846866" cy="310752"/>
@@ -51002,7 +49088,7 @@
         </p:nvGrpSpPr>
         <p:grpSpPr>
           <a:xfrm>
-            <a:off x="14847405" y="7781315"/>
+            <a:off x="14847405" y="8719634"/>
             <a:ext cx="847611" cy="310752"/>
             <a:chOff x="-6600343" y="7739918"/>
             <a:chExt cx="846866" cy="310752"/>
@@ -51136,7 +49222,7 @@
         </p:nvGrpSpPr>
         <p:grpSpPr>
           <a:xfrm>
-            <a:off x="14847405" y="9338435"/>
+            <a:off x="14847405" y="10589527"/>
             <a:ext cx="847611" cy="310752"/>
             <a:chOff x="2691247" y="9303259"/>
             <a:chExt cx="847611" cy="310752"/>
@@ -51226,138 +49312,6 @@
             <a:solidFill>
               <a:srgbClr val="A9D18E"/>
             </a:solidFill>
-            <a:ln>
-              <a:noFill/>
-            </a:ln>
-          </p:spPr>
-          <p:style>
-            <a:lnRef idx="2">
-              <a:schemeClr val="accent1">
-                <a:shade val="15000"/>
-              </a:schemeClr>
-            </a:lnRef>
-            <a:fillRef idx="1">
-              <a:schemeClr val="accent1"/>
-            </a:fillRef>
-            <a:effectRef idx="0">
-              <a:schemeClr val="accent1"/>
-            </a:effectRef>
-            <a:fontRef idx="minor">
-              <a:schemeClr val="lt1"/>
-            </a:fontRef>
-          </p:style>
-          <p:txBody>
-            <a:bodyPr rtlCol="0" anchor="ctr"/>
-            <a:lstStyle/>
-            <a:p>
-              <a:pPr algn="ctr"/>
-              <a:endParaRPr lang="en-US"/>
-            </a:p>
-          </p:txBody>
-        </p:sp>
-      </p:grpSp>
-      <p:grpSp>
-        <p:nvGrpSpPr>
-          <p:cNvPr id="567" name="Group 566">
-            <a:extLst>
-              <a:ext uri="{FF2B5EF4-FFF2-40B4-BE49-F238E27FC236}">
-                <a16:creationId xmlns:a16="http://schemas.microsoft.com/office/drawing/2014/main" id="{3D371FF6-4088-A922-ADAE-13FD3AD9D25B}"/>
-              </a:ext>
-            </a:extLst>
-          </p:cNvPr>
-          <p:cNvGrpSpPr/>
-          <p:nvPr/>
-        </p:nvGrpSpPr>
-        <p:grpSpPr>
-          <a:xfrm>
-            <a:off x="14847405" y="10895554"/>
-            <a:ext cx="847611" cy="310928"/>
-            <a:chOff x="1503088" y="10860378"/>
-            <a:chExt cx="846866" cy="310928"/>
-          </a:xfrm>
-        </p:grpSpPr>
-        <p:sp>
-          <p:nvSpPr>
-            <p:cNvPr id="570" name="Rectangle: Rounded Corners 569">
-              <a:extLst>
-                <a:ext uri="{FF2B5EF4-FFF2-40B4-BE49-F238E27FC236}">
-                  <a16:creationId xmlns:a16="http://schemas.microsoft.com/office/drawing/2014/main" id="{B45C529C-FD60-1852-DB04-4802B2106ABA}"/>
-                </a:ext>
-              </a:extLst>
-            </p:cNvPr>
-            <p:cNvSpPr/>
-            <p:nvPr/>
-          </p:nvSpPr>
-          <p:spPr>
-            <a:xfrm>
-              <a:off x="1503088" y="10860378"/>
-              <a:ext cx="846866" cy="310752"/>
-            </a:xfrm>
-            <a:prstGeom prst="roundRect">
-              <a:avLst/>
-            </a:prstGeom>
-            <a:solidFill>
-              <a:srgbClr val="01686A"/>
-            </a:solidFill>
-            <a:ln w="15875">
-              <a:noFill/>
-            </a:ln>
-          </p:spPr>
-          <p:style>
-            <a:lnRef idx="2">
-              <a:schemeClr val="accent1">
-                <a:shade val="15000"/>
-              </a:schemeClr>
-            </a:lnRef>
-            <a:fillRef idx="1">
-              <a:schemeClr val="accent1"/>
-            </a:fillRef>
-            <a:effectRef idx="0">
-              <a:schemeClr val="accent1"/>
-            </a:effectRef>
-            <a:fontRef idx="minor">
-              <a:schemeClr val="lt1"/>
-            </a:fontRef>
-          </p:style>
-          <p:txBody>
-            <a:bodyPr rtlCol="0" anchor="ctr"/>
-            <a:lstStyle/>
-            <a:p>
-              <a:pPr marL="182880" algn="ctr" rtl="1"/>
-              <a:r>
-                <a:rPr lang="en-US">
-                  <a:solidFill>
-                    <a:schemeClr val="bg1"/>
-                  </a:solidFill>
-                  <a:latin typeface="Bahij TheSansArabic Bold" panose="02040503050201020203" charset="-78"/>
-                  <a:cs typeface="Bahij TheSansArabic Bold" panose="02040503050201020203" charset="-78"/>
-                </a:rPr>
-                <a:t>—</a:t>
-              </a:r>
-            </a:p>
-          </p:txBody>
-        </p:sp>
-        <p:sp>
-          <p:nvSpPr>
-            <p:cNvPr id="571" name="Arrow: Down 570">
-              <a:extLst>
-                <a:ext uri="{FF2B5EF4-FFF2-40B4-BE49-F238E27FC236}">
-                  <a16:creationId xmlns:a16="http://schemas.microsoft.com/office/drawing/2014/main" id="{A3824C6E-4F03-6E93-3F7D-213592176EC8}"/>
-                </a:ext>
-              </a:extLst>
-            </p:cNvPr>
-            <p:cNvSpPr/>
-            <p:nvPr/>
-          </p:nvSpPr>
-          <p:spPr>
-            <a:xfrm>
-              <a:off x="2107178" y="10879033"/>
-              <a:ext cx="234654" cy="292273"/>
-            </a:xfrm>
-            <a:prstGeom prst="downArrow">
-              <a:avLst/>
-            </a:prstGeom>
-            <a:noFill/>
             <a:ln>
               <a:noFill/>
             </a:ln>
@@ -51536,7 +49490,7 @@
         </p:nvGrpSpPr>
         <p:grpSpPr>
           <a:xfrm>
-            <a:off x="12775478" y="4667075"/>
+            <a:off x="12775478" y="4979848"/>
             <a:ext cx="847611" cy="310752"/>
             <a:chOff x="-6600343" y="4603178"/>
             <a:chExt cx="846866" cy="310752"/>
@@ -51670,7 +49624,7 @@
         </p:nvGrpSpPr>
         <p:grpSpPr>
           <a:xfrm>
-            <a:off x="12775478" y="6224195"/>
+            <a:off x="12775478" y="6849741"/>
             <a:ext cx="847611" cy="310752"/>
             <a:chOff x="-6600343" y="6171548"/>
             <a:chExt cx="846866" cy="310752"/>
@@ -51804,7 +49758,7 @@
         </p:nvGrpSpPr>
         <p:grpSpPr>
           <a:xfrm>
-            <a:off x="12775478" y="7781315"/>
+            <a:off x="12775478" y="8719634"/>
             <a:ext cx="847611" cy="310752"/>
             <a:chOff x="-6600343" y="7739918"/>
             <a:chExt cx="846866" cy="310752"/>
@@ -51938,7 +49892,7 @@
         </p:nvGrpSpPr>
         <p:grpSpPr>
           <a:xfrm>
-            <a:off x="12775478" y="9338435"/>
+            <a:off x="12775478" y="10589527"/>
             <a:ext cx="847611" cy="310752"/>
             <a:chOff x="977900" y="9303259"/>
             <a:chExt cx="847611" cy="310752"/>
@@ -52058,238 +50012,6 @@
           </p:txBody>
         </p:sp>
       </p:grpSp>
-      <p:grpSp>
-        <p:nvGrpSpPr>
-          <p:cNvPr id="289" name="Group 288">
-            <a:extLst>
-              <a:ext uri="{FF2B5EF4-FFF2-40B4-BE49-F238E27FC236}">
-                <a16:creationId xmlns:a16="http://schemas.microsoft.com/office/drawing/2014/main" id="{6B4878FD-FB13-571A-18A6-CF80B0C76696}"/>
-              </a:ext>
-            </a:extLst>
-          </p:cNvPr>
-          <p:cNvGrpSpPr/>
-          <p:nvPr/>
-        </p:nvGrpSpPr>
-        <p:grpSpPr>
-          <a:xfrm>
-            <a:off x="12775478" y="10895554"/>
-            <a:ext cx="847611" cy="310928"/>
-            <a:chOff x="1503088" y="10860378"/>
-            <a:chExt cx="846866" cy="310928"/>
-          </a:xfrm>
-        </p:grpSpPr>
-        <p:sp>
-          <p:nvSpPr>
-            <p:cNvPr id="290" name="Rectangle: Rounded Corners 289">
-              <a:extLst>
-                <a:ext uri="{FF2B5EF4-FFF2-40B4-BE49-F238E27FC236}">
-                  <a16:creationId xmlns:a16="http://schemas.microsoft.com/office/drawing/2014/main" id="{EAAC4237-AB9A-762C-D62F-4DD567EF3330}"/>
-                </a:ext>
-              </a:extLst>
-            </p:cNvPr>
-            <p:cNvSpPr/>
-            <p:nvPr/>
-          </p:nvSpPr>
-          <p:spPr>
-            <a:xfrm>
-              <a:off x="1503088" y="10860378"/>
-              <a:ext cx="846866" cy="310752"/>
-            </a:xfrm>
-            <a:prstGeom prst="roundRect">
-              <a:avLst/>
-            </a:prstGeom>
-            <a:solidFill>
-              <a:srgbClr val="01686A"/>
-            </a:solidFill>
-            <a:ln w="15875">
-              <a:noFill/>
-            </a:ln>
-          </p:spPr>
-          <p:style>
-            <a:lnRef idx="2">
-              <a:schemeClr val="accent1">
-                <a:shade val="15000"/>
-              </a:schemeClr>
-            </a:lnRef>
-            <a:fillRef idx="1">
-              <a:schemeClr val="accent1"/>
-            </a:fillRef>
-            <a:effectRef idx="0">
-              <a:schemeClr val="accent1"/>
-            </a:effectRef>
-            <a:fontRef idx="minor">
-              <a:schemeClr val="lt1"/>
-            </a:fontRef>
-          </p:style>
-          <p:txBody>
-            <a:bodyPr rtlCol="0" anchor="ctr"/>
-            <a:lstStyle/>
-            <a:p>
-              <a:pPr marL="182880" algn="ctr" rtl="1"/>
-              <a:r>
-                <a:rPr lang="en-US">
-                  <a:solidFill>
-                    <a:schemeClr val="bg1"/>
-                  </a:solidFill>
-                  <a:latin typeface="Bahij TheSansArabic Bold" panose="02040503050201020203" charset="-78"/>
-                  <a:cs typeface="Bahij TheSansArabic Bold" panose="02040503050201020203" charset="-78"/>
-                </a:rPr>
-                <a:t>—</a:t>
-              </a:r>
-            </a:p>
-          </p:txBody>
-        </p:sp>
-        <p:sp>
-          <p:nvSpPr>
-            <p:cNvPr id="291" name="Arrow: Down 290">
-              <a:extLst>
-                <a:ext uri="{FF2B5EF4-FFF2-40B4-BE49-F238E27FC236}">
-                  <a16:creationId xmlns:a16="http://schemas.microsoft.com/office/drawing/2014/main" id="{7FF57F4A-4509-2AD2-4976-D02E1F6E2FD6}"/>
-                </a:ext>
-              </a:extLst>
-            </p:cNvPr>
-            <p:cNvSpPr/>
-            <p:nvPr/>
-          </p:nvSpPr>
-          <p:spPr>
-            <a:xfrm>
-              <a:off x="2107178" y="10879033"/>
-              <a:ext cx="234654" cy="292273"/>
-            </a:xfrm>
-            <a:prstGeom prst="downArrow">
-              <a:avLst/>
-            </a:prstGeom>
-            <a:noFill/>
-            <a:ln>
-              <a:noFill/>
-            </a:ln>
-          </p:spPr>
-          <p:style>
-            <a:lnRef idx="2">
-              <a:schemeClr val="accent1">
-                <a:shade val="15000"/>
-              </a:schemeClr>
-            </a:lnRef>
-            <a:fillRef idx="1">
-              <a:schemeClr val="accent1"/>
-            </a:fillRef>
-            <a:effectRef idx="0">
-              <a:schemeClr val="accent1"/>
-            </a:effectRef>
-            <a:fontRef idx="minor">
-              <a:schemeClr val="lt1"/>
-            </a:fontRef>
-          </p:style>
-          <p:txBody>
-            <a:bodyPr rtlCol="0" anchor="ctr"/>
-            <a:lstStyle/>
-            <a:p>
-              <a:pPr algn="ctr"/>
-              <a:endParaRPr lang="en-US"/>
-            </a:p>
-          </p:txBody>
-        </p:sp>
-      </p:grpSp>
-      <p:sp>
-        <p:nvSpPr>
-          <p:cNvPr id="362" name="Arrow: Down 361">
-            <a:extLst>
-              <a:ext uri="{FF2B5EF4-FFF2-40B4-BE49-F238E27FC236}">
-                <a16:creationId xmlns:a16="http://schemas.microsoft.com/office/drawing/2014/main" id="{297DF2FD-A487-4E0A-961D-D8D8E4DC145F}"/>
-              </a:ext>
-            </a:extLst>
-          </p:cNvPr>
-          <p:cNvSpPr/>
-          <p:nvPr/>
-        </p:nvSpPr>
-        <p:spPr>
-          <a:xfrm flipV="1">
-            <a:off x="13354586" y="10904793"/>
-            <a:ext cx="234861" cy="292273"/>
-          </a:xfrm>
-          <a:prstGeom prst="downArrow">
-            <a:avLst/>
-          </a:prstGeom>
-          <a:noFill/>
-          <a:ln>
-            <a:noFill/>
-          </a:ln>
-        </p:spPr>
-        <p:style>
-          <a:lnRef idx="2">
-            <a:schemeClr val="accent1">
-              <a:shade val="15000"/>
-            </a:schemeClr>
-          </a:lnRef>
-          <a:fillRef idx="1">
-            <a:schemeClr val="accent1"/>
-          </a:fillRef>
-          <a:effectRef idx="0">
-            <a:schemeClr val="accent1"/>
-          </a:effectRef>
-          <a:fontRef idx="minor">
-            <a:schemeClr val="lt1"/>
-          </a:fontRef>
-        </p:style>
-        <p:txBody>
-          <a:bodyPr rtlCol="0" anchor="ctr"/>
-          <a:lstStyle/>
-          <a:p>
-            <a:pPr algn="ctr"/>
-            <a:endParaRPr lang="en-US"/>
-          </a:p>
-        </p:txBody>
-      </p:sp>
-      <p:sp>
-        <p:nvSpPr>
-          <p:cNvPr id="363" name="Arrow: Down 362">
-            <a:extLst>
-              <a:ext uri="{FF2B5EF4-FFF2-40B4-BE49-F238E27FC236}">
-                <a16:creationId xmlns:a16="http://schemas.microsoft.com/office/drawing/2014/main" id="{12A4AA0A-44C9-4CF9-8DD8-00B3C001E6C2}"/>
-              </a:ext>
-            </a:extLst>
-          </p:cNvPr>
-          <p:cNvSpPr/>
-          <p:nvPr/>
-        </p:nvSpPr>
-        <p:spPr>
-          <a:xfrm rot="10800000" flipV="1">
-            <a:off x="17533593" y="10921859"/>
-            <a:ext cx="234861" cy="292273"/>
-          </a:xfrm>
-          <a:prstGeom prst="downArrow">
-            <a:avLst/>
-          </a:prstGeom>
-          <a:noFill/>
-          <a:ln>
-            <a:noFill/>
-          </a:ln>
-        </p:spPr>
-        <p:style>
-          <a:lnRef idx="2">
-            <a:schemeClr val="accent1">
-              <a:shade val="15000"/>
-            </a:schemeClr>
-          </a:lnRef>
-          <a:fillRef idx="1">
-            <a:schemeClr val="accent1"/>
-          </a:fillRef>
-          <a:effectRef idx="0">
-            <a:schemeClr val="accent1"/>
-          </a:effectRef>
-          <a:fontRef idx="minor">
-            <a:schemeClr val="lt1"/>
-          </a:fontRef>
-        </p:style>
-        <p:txBody>
-          <a:bodyPr rtlCol="0" anchor="ctr"/>
-          <a:lstStyle/>
-          <a:p>
-            <a:pPr algn="ctr"/>
-            <a:endParaRPr lang="en-US"/>
-          </a:p>
-        </p:txBody>
-      </p:sp>
       <p:sp>
         <p:nvSpPr>
           <p:cNvPr id="359" name="Rectangle: Rounded Corners 358">
@@ -52305,7 +50027,7 @@
         <p:spPr>
           <a:xfrm>
             <a:off x="9960436" y="3059678"/>
-            <a:ext cx="1576718" cy="1265361"/>
+            <a:ext cx="1576718" cy="1572768"/>
           </a:xfrm>
           <a:prstGeom prst="roundRect">
             <a:avLst>
@@ -52360,8 +50082,8 @@
         </p:nvSpPr>
         <p:spPr>
           <a:xfrm>
-            <a:off x="9960436" y="4617767"/>
-            <a:ext cx="1576718" cy="1265361"/>
+            <a:off x="9960436" y="4930540"/>
+            <a:ext cx="1576718" cy="1572768"/>
           </a:xfrm>
           <a:prstGeom prst="roundRect">
             <a:avLst>
@@ -52416,8 +50138,8 @@
         </p:nvSpPr>
         <p:spPr>
           <a:xfrm>
-            <a:off x="9960436" y="6175856"/>
-            <a:ext cx="1576718" cy="1265361"/>
+            <a:off x="9960436" y="6801402"/>
+            <a:ext cx="1576718" cy="1572768"/>
           </a:xfrm>
           <a:prstGeom prst="roundRect">
             <a:avLst>
@@ -52472,8 +50194,8 @@
         </p:nvSpPr>
         <p:spPr>
           <a:xfrm>
-            <a:off x="9960436" y="7733945"/>
-            <a:ext cx="1576718" cy="1265361"/>
+            <a:off x="9960436" y="8672264"/>
+            <a:ext cx="1576718" cy="1572768"/>
           </a:xfrm>
           <a:prstGeom prst="roundRect">
             <a:avLst>
@@ -52528,64 +50250,8 @@
         </p:nvSpPr>
         <p:spPr>
           <a:xfrm>
-            <a:off x="9960436" y="9292034"/>
-            <a:ext cx="1576718" cy="1265361"/>
-          </a:xfrm>
-          <a:prstGeom prst="roundRect">
-            <a:avLst>
-              <a:gd name="adj" fmla="val 5149"/>
-            </a:avLst>
-          </a:prstGeom>
-          <a:solidFill>
-            <a:srgbClr val="FBFBFA"/>
-          </a:solidFill>
-          <a:ln>
-            <a:solidFill>
-              <a:srgbClr val="D9D9D9"/>
-            </a:solidFill>
-          </a:ln>
-        </p:spPr>
-        <p:style>
-          <a:lnRef idx="2">
-            <a:schemeClr val="accent1">
-              <a:shade val="15000"/>
-            </a:schemeClr>
-          </a:lnRef>
-          <a:fillRef idx="1">
-            <a:schemeClr val="accent1"/>
-          </a:fillRef>
-          <a:effectRef idx="0">
-            <a:schemeClr val="accent1"/>
-          </a:effectRef>
-          <a:fontRef idx="minor">
-            <a:schemeClr val="lt1"/>
-          </a:fontRef>
-        </p:style>
-        <p:txBody>
-          <a:bodyPr rtlCol="0" anchor="ctr"/>
-          <a:lstStyle/>
-          <a:p>
-            <a:pPr algn="ctr"/>
-            <a:endParaRPr lang="en-US"/>
-          </a:p>
-        </p:txBody>
-      </p:sp>
-      <p:sp>
-        <p:nvSpPr>
-          <p:cNvPr id="367" name="Rectangle: Rounded Corners 366">
-            <a:extLst>
-              <a:ext uri="{FF2B5EF4-FFF2-40B4-BE49-F238E27FC236}">
-                <a16:creationId xmlns:a16="http://schemas.microsoft.com/office/drawing/2014/main" id="{935E0495-4B46-4CCE-B6AD-EF00B8F1221E}"/>
-              </a:ext>
-            </a:extLst>
-          </p:cNvPr>
-          <p:cNvSpPr/>
-          <p:nvPr/>
-        </p:nvSpPr>
-        <p:spPr>
-          <a:xfrm>
-            <a:off x="9960436" y="10850125"/>
-            <a:ext cx="1576718" cy="1265361"/>
+            <a:off x="9960436" y="10543126"/>
+            <a:ext cx="1576718" cy="1572768"/>
           </a:xfrm>
           <a:prstGeom prst="roundRect">
             <a:avLst>
@@ -52853,7 +50519,7 @@
         </p:nvGrpSpPr>
         <p:grpSpPr>
           <a:xfrm>
-            <a:off x="10689996" y="4631899"/>
+            <a:off x="10689996" y="4944672"/>
             <a:ext cx="847611" cy="310752"/>
             <a:chOff x="-6600343" y="4603178"/>
             <a:chExt cx="846866" cy="310752"/>
@@ -52987,7 +50653,7 @@
         </p:nvGrpSpPr>
         <p:grpSpPr>
           <a:xfrm>
-            <a:off x="10689996" y="6189019"/>
+            <a:off x="10689996" y="6814565"/>
             <a:ext cx="847611" cy="310752"/>
             <a:chOff x="-6600343" y="6171548"/>
             <a:chExt cx="846866" cy="310752"/>
@@ -53121,7 +50787,7 @@
         </p:nvGrpSpPr>
         <p:grpSpPr>
           <a:xfrm>
-            <a:off x="10689996" y="7746139"/>
+            <a:off x="10689996" y="8684458"/>
             <a:ext cx="847611" cy="310752"/>
             <a:chOff x="-6600343" y="7739918"/>
             <a:chExt cx="846866" cy="310752"/>
@@ -53255,7 +50921,7 @@
         </p:nvGrpSpPr>
         <p:grpSpPr>
           <a:xfrm>
-            <a:off x="10689996" y="9303259"/>
+            <a:off x="10689996" y="10554351"/>
             <a:ext cx="847611" cy="310752"/>
             <a:chOff x="6117941" y="9303259"/>
             <a:chExt cx="847611" cy="310752"/>
@@ -53375,188 +51041,6 @@
           </p:txBody>
         </p:sp>
       </p:grpSp>
-      <p:grpSp>
-        <p:nvGrpSpPr>
-          <p:cNvPr id="385" name="Group 384">
-            <a:extLst>
-              <a:ext uri="{FF2B5EF4-FFF2-40B4-BE49-F238E27FC236}">
-                <a16:creationId xmlns:a16="http://schemas.microsoft.com/office/drawing/2014/main" id="{5AA0EAAF-720A-4EA0-BABA-79EB03765BFD}"/>
-              </a:ext>
-            </a:extLst>
-          </p:cNvPr>
-          <p:cNvGrpSpPr/>
-          <p:nvPr/>
-        </p:nvGrpSpPr>
-        <p:grpSpPr>
-          <a:xfrm>
-            <a:off x="10689996" y="10860378"/>
-            <a:ext cx="847611" cy="310928"/>
-            <a:chOff x="1503088" y="10860378"/>
-            <a:chExt cx="846866" cy="310928"/>
-          </a:xfrm>
-        </p:grpSpPr>
-        <p:sp>
-          <p:nvSpPr>
-            <p:cNvPr id="386" name="Rectangle: Rounded Corners 385">
-              <a:extLst>
-                <a:ext uri="{FF2B5EF4-FFF2-40B4-BE49-F238E27FC236}">
-                  <a16:creationId xmlns:a16="http://schemas.microsoft.com/office/drawing/2014/main" id="{26DCEEE1-6519-4C92-8C43-F08763A1ABC0}"/>
-                </a:ext>
-              </a:extLst>
-            </p:cNvPr>
-            <p:cNvSpPr/>
-            <p:nvPr/>
-          </p:nvSpPr>
-          <p:spPr>
-            <a:xfrm>
-              <a:off x="1503088" y="10860378"/>
-              <a:ext cx="846866" cy="310752"/>
-            </a:xfrm>
-            <a:prstGeom prst="roundRect">
-              <a:avLst/>
-            </a:prstGeom>
-            <a:solidFill>
-              <a:srgbClr val="01686A"/>
-            </a:solidFill>
-            <a:ln w="15875">
-              <a:noFill/>
-            </a:ln>
-          </p:spPr>
-          <p:style>
-            <a:lnRef idx="2">
-              <a:schemeClr val="accent1">
-                <a:shade val="15000"/>
-              </a:schemeClr>
-            </a:lnRef>
-            <a:fillRef idx="1">
-              <a:schemeClr val="accent1"/>
-            </a:fillRef>
-            <a:effectRef idx="0">
-              <a:schemeClr val="accent1"/>
-            </a:effectRef>
-            <a:fontRef idx="minor">
-              <a:schemeClr val="lt1"/>
-            </a:fontRef>
-          </p:style>
-          <p:txBody>
-            <a:bodyPr rtlCol="0" anchor="ctr"/>
-            <a:lstStyle/>
-            <a:p>
-              <a:pPr marL="182880" algn="ctr" rtl="1"/>
-              <a:r>
-                <a:rPr lang="en-US">
-                  <a:solidFill>
-                    <a:schemeClr val="bg1"/>
-                  </a:solidFill>
-                  <a:latin typeface="Bahij TheSansArabic Bold" panose="02040503050201020203" charset="-78"/>
-                  <a:cs typeface="Bahij TheSansArabic Bold" panose="02040503050201020203" charset="-78"/>
-                </a:rPr>
-                <a:t>—</a:t>
-              </a:r>
-            </a:p>
-          </p:txBody>
-        </p:sp>
-        <p:sp>
-          <p:nvSpPr>
-            <p:cNvPr id="387" name="Arrow: Down 386">
-              <a:extLst>
-                <a:ext uri="{FF2B5EF4-FFF2-40B4-BE49-F238E27FC236}">
-                  <a16:creationId xmlns:a16="http://schemas.microsoft.com/office/drawing/2014/main" id="{B5A55041-B5C9-48DA-8EB7-CBA213604C2D}"/>
-                </a:ext>
-              </a:extLst>
-            </p:cNvPr>
-            <p:cNvSpPr/>
-            <p:nvPr/>
-          </p:nvSpPr>
-          <p:spPr>
-            <a:xfrm>
-              <a:off x="2107178" y="10879033"/>
-              <a:ext cx="234654" cy="292273"/>
-            </a:xfrm>
-            <a:prstGeom prst="downArrow">
-              <a:avLst/>
-            </a:prstGeom>
-            <a:noFill/>
-            <a:ln>
-              <a:noFill/>
-            </a:ln>
-          </p:spPr>
-          <p:style>
-            <a:lnRef idx="2">
-              <a:schemeClr val="accent1">
-                <a:shade val="15000"/>
-              </a:schemeClr>
-            </a:lnRef>
-            <a:fillRef idx="1">
-              <a:schemeClr val="accent1"/>
-            </a:fillRef>
-            <a:effectRef idx="0">
-              <a:schemeClr val="accent1"/>
-            </a:effectRef>
-            <a:fontRef idx="minor">
-              <a:schemeClr val="lt1"/>
-            </a:fontRef>
-          </p:style>
-          <p:txBody>
-            <a:bodyPr rtlCol="0" anchor="ctr"/>
-            <a:lstStyle/>
-            <a:p>
-              <a:pPr algn="ctr"/>
-              <a:endParaRPr lang="en-US"/>
-            </a:p>
-          </p:txBody>
-        </p:sp>
-      </p:grpSp>
-      <p:sp>
-        <p:nvSpPr>
-          <p:cNvPr id="388" name="Arrow: Down 387">
-            <a:extLst>
-              <a:ext uri="{FF2B5EF4-FFF2-40B4-BE49-F238E27FC236}">
-                <a16:creationId xmlns:a16="http://schemas.microsoft.com/office/drawing/2014/main" id="{DF4AB646-79C9-48F4-BAD8-D85E8EFE15CE}"/>
-              </a:ext>
-            </a:extLst>
-          </p:cNvPr>
-          <p:cNvSpPr/>
-          <p:nvPr/>
-        </p:nvSpPr>
-        <p:spPr>
-          <a:xfrm flipV="1">
-            <a:off x="11249568" y="10850123"/>
-            <a:ext cx="234861" cy="292273"/>
-          </a:xfrm>
-          <a:prstGeom prst="downArrow">
-            <a:avLst/>
-          </a:prstGeom>
-          <a:noFill/>
-          <a:ln>
-            <a:noFill/>
-          </a:ln>
-        </p:spPr>
-        <p:style>
-          <a:lnRef idx="2">
-            <a:schemeClr val="accent1">
-              <a:shade val="15000"/>
-            </a:schemeClr>
-          </a:lnRef>
-          <a:fillRef idx="1">
-            <a:schemeClr val="accent1"/>
-          </a:fillRef>
-          <a:effectRef idx="0">
-            <a:schemeClr val="accent1"/>
-          </a:effectRef>
-          <a:fontRef idx="minor">
-            <a:schemeClr val="lt1"/>
-          </a:fontRef>
-        </p:style>
-        <p:txBody>
-          <a:bodyPr rtlCol="0" anchor="ctr"/>
-          <a:lstStyle/>
-          <a:p>
-            <a:pPr algn="ctr"/>
-            <a:endParaRPr lang="en-US"/>
-          </a:p>
-        </p:txBody>
-      </p:sp>
       <p:grpSp>
         <p:nvGrpSpPr>
           <p:cNvPr id="416" name="Group 415">

</xml_diff>

<commit_message>
Rename grand-total chart category
Co-Authored-By: Claude Opus 5.5 <noreply@anthropic.com>
Claude-Session: https://claude.ai/code/session_01D73U26FQnMJ6VM9LfvsWf3
</commit_message>
<xml_diff>
--- a/عرض_الإيرادات_سيناريوهات_إقفال_2026.pptx
+++ b/عرض_الإيرادات_سيناريوهات_إقفال_2026.pptx
@@ -3290,7 +3290,7 @@
               <c:strCache>
                 <c:ptCount val="1"/>
                 <c:pt idx="0">
-                  <c:v>نقل الملكية</c:v>
+                  <c:v>الإجمالي</c:v>
                 </c:pt>
               </c:strCache>
             </c:strRef>
@@ -3641,7 +3641,7 @@
               <c:strCache>
                 <c:ptCount val="1"/>
                 <c:pt idx="0">
-                  <c:v>نقل الملكية</c:v>
+                  <c:v>الإجمالي</c:v>
                 </c:pt>
               </c:strCache>
             </c:strRef>
@@ -7847,7 +7847,7 @@
               <c:strCache>
                 <c:ptCount val="1"/>
                 <c:pt idx="0">
-                  <c:v>نقل الملكية</c:v>
+                  <c:v>الإجمالي</c:v>
                 </c:pt>
               </c:strCache>
             </c:strRef>
@@ -8198,7 +8198,7 @@
               <c:strCache>
                 <c:ptCount val="1"/>
                 <c:pt idx="0">
-                  <c:v>نقل الملكية</c:v>
+                  <c:v>الإجمالي</c:v>
                 </c:pt>
               </c:strCache>
             </c:strRef>

</xml_diff>

<commit_message>
Update methodology box on slides 2-3 (numbers unchanged)
Co-Authored-By: Claude Opus 5.5 <noreply@anthropic.com>
Claude-Session: https://claude.ai/code/session_01D73U26FQnMJ6VM9LfvsWf3
</commit_message>
<xml_diff>
--- a/عرض_الإيرادات_سيناريوهات_إقفال_2026.pptx
+++ b/عرض_الإيرادات_سيناريوهات_إقفال_2026.pptx
@@ -44098,61 +44098,7 @@
                   <a:latin typeface="Bahij TheSansArabic Plain" panose="02040503050201020203" pitchFamily="18" charset="-78"/>
                   <a:cs typeface="Bahij TheSansArabic Plain" panose="02040503050201020203" pitchFamily="18" charset="-78"/>
                 </a:rPr>
-                <a:t>العوامل الخارجية:</a:t>
-              </a:r>
-            </a:p>
-            <a:p>
-              <a:pPr marL="285750" indent="-285750" algn="justLow" rtl="1">
-                <a:buFont typeface="Arial" panose="020B0604020202020204" pitchFamily="34" charset="0"/>
-                <a:buChar char="•"/>
-              </a:pPr>
-              <a:endParaRPr lang="ar-SA" sz="1800" b="1">
-                <a:solidFill>
-                  <a:srgbClr val="01686A"/>
-                </a:solidFill>
-                <a:latin typeface="Bahij TheSansArabic Plain" panose="02040503050201020203" pitchFamily="18" charset="-78"/>
-                <a:cs typeface="Bahij TheSansArabic Plain" panose="02040503050201020203" pitchFamily="18" charset="-78"/>
-              </a:endParaRPr>
-            </a:p>
-            <a:p>
-              <a:pPr marL="285750" indent="-285750" algn="justLow" rtl="1">
-                <a:buFont typeface="Arial" panose="020B0604020202020204" pitchFamily="34" charset="0"/>
-                <a:buChar char="•"/>
-              </a:pPr>
-              <a:r>
-                <a:rPr lang="ar-SA" sz="1800">
-                  <a:latin typeface="Bahij TheSansArabic Plain" panose="02040503050201020203" pitchFamily="18" charset="-78"/>
-                  <a:cs typeface="Bahij TheSansArabic Plain" panose="02040503050201020203" pitchFamily="18" charset="-78"/>
-                </a:rPr>
-                <a:t>تم العمل بنموذج </a:t>
-              </a:r>
-              <a:r>
-                <a:rPr lang="ar-SA" sz="1800" b="1">
-                  <a:latin typeface="Bahij TheSansArabic Plain" panose="02040503050201020203" pitchFamily="18" charset="-78"/>
-                  <a:cs typeface="Bahij TheSansArabic Plain" panose="02040503050201020203" pitchFamily="18" charset="-78"/>
-                </a:rPr>
-                <a:t>هولت </a:t>
-              </a:r>
-              <a:r>
-                <a:rPr lang="ar-SA" sz="1800" b="1" err="1">
-                  <a:latin typeface="Bahij TheSansArabic Plain" panose="02040503050201020203" pitchFamily="18" charset="-78"/>
-                  <a:cs typeface="Bahij TheSansArabic Plain" panose="02040503050201020203" pitchFamily="18" charset="-78"/>
-                </a:rPr>
-                <a:t>وينترز</a:t>
-              </a:r>
-              <a:r>
-                <a:rPr lang="ar-SA" sz="1800" b="1">
-                  <a:latin typeface="Bahij TheSansArabic Plain" panose="02040503050201020203" pitchFamily="18" charset="-78"/>
-                  <a:cs typeface="Bahij TheSansArabic Plain" panose="02040503050201020203" pitchFamily="18" charset="-78"/>
-                </a:rPr>
-                <a:t>  </a:t>
-              </a:r>
-              <a:r>
-                <a:rPr lang="ar-SA" sz="1800">
-                  <a:latin typeface="Bahij TheSansArabic Plain" panose="02040503050201020203" pitchFamily="18" charset="-78"/>
-                  <a:cs typeface="Bahij TheSansArabic Plain" panose="02040503050201020203" pitchFamily="18" charset="-78"/>
-                </a:rPr>
-                <a:t>هجين مبني على التوقع الأساس الكمي، مع تحويل العوامل الخارجية إلى نسب مئوية تُطبّق على كل نوع ايراد.</a:t>
+                <a:t xml:space="preserve">أساس السيناريوهات:</a:t>
               </a:r>
             </a:p>
             <a:p>
@@ -44172,7 +44118,21 @@
                   <a:latin typeface="Bahij TheSansArabic Plain" panose="02040503050201020203" pitchFamily="18" charset="-78"/>
                   <a:cs typeface="Bahij TheSansArabic Plain" panose="02040503050201020203" pitchFamily="18" charset="-78"/>
                 </a:rPr>
-                <a:t>ارتفاع الإيرادات الغير نفطية خلال النصف الأول من العام الحالي بشكل كبير عن المستهدف و حيث أن إيرادات القطع البلدي تشكل 24% منها.</a:t>
+                <a:t xml:space="preserve">تم التحقق من السيناريوهين بنموذج </a:t>
+              </a:r>
+              <a:r>
+                <a:rPr lang="ar-SA" sz="1800" b="1">
+                  <a:latin typeface="Bahij TheSansArabic Plain" panose="02040503050201020203" pitchFamily="18" charset="-78"/>
+                  <a:cs typeface="Bahij TheSansArabic Plain" panose="02040503050201020203" pitchFamily="18" charset="-78"/>
+                </a:rPr>
+                <a:t xml:space="preserve">هولت وينترز</a:t>
+              </a:r>
+              <a:r>
+                <a:rPr lang="ar-SA" sz="1800">
+                  <a:latin typeface="Bahij TheSansArabic Plain" panose="02040503050201020203" pitchFamily="18" charset="-78"/>
+                  <a:cs typeface="Bahij TheSansArabic Plain" panose="02040503050201020203" pitchFamily="18" charset="-78"/>
+                </a:rPr>
+                <a:t xml:space="preserve"> هجين على المحصل الشهري لكل تبويب (يناير 2023 – سبتمبر 2026)، مع استبعاد الدفعات الاستثنائية من بيانات التدريب ومعالجتها بشكل منفصل.</a:t>
               </a:r>
             </a:p>
             <a:p>
@@ -44192,21 +44152,7 @@
                   <a:latin typeface="Bahij TheSansArabic Plain" panose="02040503050201020203" pitchFamily="18" charset="-78"/>
                   <a:cs typeface="Bahij TheSansArabic Plain" panose="02040503050201020203" pitchFamily="18" charset="-78"/>
                 </a:rPr>
-                <a:t>السياحة والفعاليات: موسم الرياض يبدأ ~أكتوبر، +18م زائر في 2024 وتأثير اقتصادي ~256 مليار ريال، رفع 15%  </a:t>
-              </a:r>
-              <a:r>
-                <a:rPr lang="ar-SA" sz="1800" err="1">
-                  <a:latin typeface="Bahij TheSansArabic Plain" panose="02040503050201020203" pitchFamily="18" charset="-78"/>
-                  <a:cs typeface="Bahij TheSansArabic Plain" panose="02040503050201020203" pitchFamily="18" charset="-78"/>
-                </a:rPr>
-                <a:t>للتبويبات</a:t>
-              </a:r>
-              <a:r>
-                <a:rPr lang="ar-SA" sz="1800">
-                  <a:latin typeface="Bahij TheSansArabic Plain" panose="02040503050201020203" pitchFamily="18" charset="-78"/>
-                  <a:cs typeface="Bahij TheSansArabic Plain" panose="02040503050201020203" pitchFamily="18" charset="-78"/>
-                </a:rPr>
-                <a:t> ذات الصلة بالتراخيص والتصاريح والإيواء والتبغ.</a:t>
+                <a:t xml:space="preserve">اختبار النموذج على الربع الأخير من 2025: الفرق في الإجمالي +7% عن الفعلي.</a:t>
               </a:r>
             </a:p>
             <a:p>
@@ -44226,7 +44172,7 @@
                   <a:latin typeface="Bahij TheSansArabic Plain" panose="02040503050201020203" pitchFamily="18" charset="-78"/>
                   <a:cs typeface="Bahij TheSansArabic Plain" panose="02040503050201020203" pitchFamily="18" charset="-78"/>
                 </a:rPr>
-                <a:t>عوامل اجتماعية: زيادة مشاركة المرأة وتغير الإنفاق) رفع طفيف ~5% لإيرادات المستهلك.</a:t>
+                <a:t xml:space="preserve">السيناريو الأول يفترض وصول دفعة تأجير المرافق في نوفمبر، والسيناريو الثاني يفترض عدم وصولها خلال العام.</a:t>
               </a:r>
             </a:p>
             <a:p>
@@ -44241,10 +44187,13 @@
                 <a:buFont typeface="Arial" panose="020B0604020202020204" pitchFamily="34" charset="0"/>
                 <a:buChar char="•"/>
               </a:pPr>
-              <a:endParaRPr lang="ar-SA" sz="1800">
-                <a:latin typeface="Bahij TheSansArabic Plain" panose="02040503050201020203" pitchFamily="18" charset="-78"/>
-                <a:cs typeface="Bahij TheSansArabic Plain" panose="02040503050201020203" pitchFamily="18" charset="-78"/>
-              </a:endParaRPr>
+              <a:r>
+                <a:rPr lang="ar-SA" sz="1800">
+                  <a:latin typeface="Bahij TheSansArabic Plain" panose="02040503050201020203" pitchFamily="18" charset="-78"/>
+                  <a:cs typeface="Bahij TheSansArabic Plain" panose="02040503050201020203" pitchFamily="18" charset="-78"/>
+                </a:rPr>
+                <a:t xml:space="preserve">أرقام السيناريوهين متحفظة مقارنة بالتوقع الأوسط للنموذج.</a:t>
+              </a:r>
             </a:p>
           </p:txBody>
         </p:sp>
@@ -44307,7 +44256,7 @@
                 <a:latin typeface="Bahij TheSansArabic Bold" panose="02040503050201020203" pitchFamily="18" charset="-78"/>
                 <a:cs typeface="Bahij TheSansArabic Bold" panose="02040503050201020203" pitchFamily="18" charset="-78"/>
               </a:rPr>
-              <a:t>منهجية تنبؤ بالربع الأخير من عام 2025</a:t>
+              <a:t>منهجية تنبؤ بالربع الأخير من عام 2026</a:t>
             </a:r>
           </a:p>
         </p:txBody>
@@ -51827,61 +51776,7 @@
                   <a:latin typeface="Bahij TheSansArabic Plain" panose="02040503050201020203" pitchFamily="18" charset="-78"/>
                   <a:cs typeface="Bahij TheSansArabic Plain" panose="02040503050201020203" pitchFamily="18" charset="-78"/>
                 </a:rPr>
-                <a:t>العوامل الخارجية:</a:t>
-              </a:r>
-            </a:p>
-            <a:p>
-              <a:pPr marL="285750" indent="-285750" algn="justLow" rtl="1">
-                <a:buFont typeface="Arial" panose="020B0604020202020204" pitchFamily="34" charset="0"/>
-                <a:buChar char="•"/>
-              </a:pPr>
-              <a:endParaRPr lang="ar-SA" sz="1800" b="1">
-                <a:solidFill>
-                  <a:srgbClr val="01686A"/>
-                </a:solidFill>
-                <a:latin typeface="Bahij TheSansArabic Plain" panose="02040503050201020203" pitchFamily="18" charset="-78"/>
-                <a:cs typeface="Bahij TheSansArabic Plain" panose="02040503050201020203" pitchFamily="18" charset="-78"/>
-              </a:endParaRPr>
-            </a:p>
-            <a:p>
-              <a:pPr marL="285750" indent="-285750" algn="justLow" rtl="1">
-                <a:buFont typeface="Arial" panose="020B0604020202020204" pitchFamily="34" charset="0"/>
-                <a:buChar char="•"/>
-              </a:pPr>
-              <a:r>
-                <a:rPr lang="ar-SA" sz="1800">
-                  <a:latin typeface="Bahij TheSansArabic Plain" panose="02040503050201020203" pitchFamily="18" charset="-78"/>
-                  <a:cs typeface="Bahij TheSansArabic Plain" panose="02040503050201020203" pitchFamily="18" charset="-78"/>
-                </a:rPr>
-                <a:t>تم العمل بنموذج </a:t>
-              </a:r>
-              <a:r>
-                <a:rPr lang="ar-SA" sz="1800" b="1">
-                  <a:latin typeface="Bahij TheSansArabic Plain" panose="02040503050201020203" pitchFamily="18" charset="-78"/>
-                  <a:cs typeface="Bahij TheSansArabic Plain" panose="02040503050201020203" pitchFamily="18" charset="-78"/>
-                </a:rPr>
-                <a:t>هولت </a:t>
-              </a:r>
-              <a:r>
-                <a:rPr lang="ar-SA" sz="1800" b="1" err="1">
-                  <a:latin typeface="Bahij TheSansArabic Plain" panose="02040503050201020203" pitchFamily="18" charset="-78"/>
-                  <a:cs typeface="Bahij TheSansArabic Plain" panose="02040503050201020203" pitchFamily="18" charset="-78"/>
-                </a:rPr>
-                <a:t>وينترز</a:t>
-              </a:r>
-              <a:r>
-                <a:rPr lang="ar-SA" sz="1800" b="1">
-                  <a:latin typeface="Bahij TheSansArabic Plain" panose="02040503050201020203" pitchFamily="18" charset="-78"/>
-                  <a:cs typeface="Bahij TheSansArabic Plain" panose="02040503050201020203" pitchFamily="18" charset="-78"/>
-                </a:rPr>
-                <a:t>  </a:t>
-              </a:r>
-              <a:r>
-                <a:rPr lang="ar-SA" sz="1800">
-                  <a:latin typeface="Bahij TheSansArabic Plain" panose="02040503050201020203" pitchFamily="18" charset="-78"/>
-                  <a:cs typeface="Bahij TheSansArabic Plain" panose="02040503050201020203" pitchFamily="18" charset="-78"/>
-                </a:rPr>
-                <a:t>هجين مبني على التوقع الأساس الكمي، مع تحويل العوامل الخارجية إلى نسب مئوية تُطبّق على كل نوع ايراد.</a:t>
+                <a:t xml:space="preserve">أساس السيناريوهات:</a:t>
               </a:r>
             </a:p>
             <a:p>
@@ -51901,7 +51796,21 @@
                   <a:latin typeface="Bahij TheSansArabic Plain" panose="02040503050201020203" pitchFamily="18" charset="-78"/>
                   <a:cs typeface="Bahij TheSansArabic Plain" panose="02040503050201020203" pitchFamily="18" charset="-78"/>
                 </a:rPr>
-                <a:t>ارتفاع الإيرادات الغير نفطية خلال النصف الأول من العام الحالي بشكل كبير عن المستهدف و حيث أن إيرادات القطع البلدي تشكل 24% منها.</a:t>
+                <a:t xml:space="preserve">تم التحقق من السيناريوهين بنموذج </a:t>
+              </a:r>
+              <a:r>
+                <a:rPr lang="ar-SA" sz="1800" b="1">
+                  <a:latin typeface="Bahij TheSansArabic Plain" panose="02040503050201020203" pitchFamily="18" charset="-78"/>
+                  <a:cs typeface="Bahij TheSansArabic Plain" panose="02040503050201020203" pitchFamily="18" charset="-78"/>
+                </a:rPr>
+                <a:t xml:space="preserve">هولت وينترز</a:t>
+              </a:r>
+              <a:r>
+                <a:rPr lang="ar-SA" sz="1800">
+                  <a:latin typeface="Bahij TheSansArabic Plain" panose="02040503050201020203" pitchFamily="18" charset="-78"/>
+                  <a:cs typeface="Bahij TheSansArabic Plain" panose="02040503050201020203" pitchFamily="18" charset="-78"/>
+                </a:rPr>
+                <a:t xml:space="preserve"> هجين على المحصل الشهري لكل تبويب (يناير 2023 – سبتمبر 2026)، مع استبعاد الدفعات الاستثنائية من بيانات التدريب ومعالجتها بشكل منفصل.</a:t>
               </a:r>
             </a:p>
             <a:p>
@@ -51921,21 +51830,7 @@
                   <a:latin typeface="Bahij TheSansArabic Plain" panose="02040503050201020203" pitchFamily="18" charset="-78"/>
                   <a:cs typeface="Bahij TheSansArabic Plain" panose="02040503050201020203" pitchFamily="18" charset="-78"/>
                 </a:rPr>
-                <a:t>السياحة والفعاليات: موسم الرياض يبدأ ~أكتوبر، +18م زائر في 2024 وتأثير اقتصادي ~256 مليار ريال، رفع 15%  </a:t>
-              </a:r>
-              <a:r>
-                <a:rPr lang="ar-SA" sz="1800" err="1">
-                  <a:latin typeface="Bahij TheSansArabic Plain" panose="02040503050201020203" pitchFamily="18" charset="-78"/>
-                  <a:cs typeface="Bahij TheSansArabic Plain" panose="02040503050201020203" pitchFamily="18" charset="-78"/>
-                </a:rPr>
-                <a:t>للتبويبات</a:t>
-              </a:r>
-              <a:r>
-                <a:rPr lang="ar-SA" sz="1800">
-                  <a:latin typeface="Bahij TheSansArabic Plain" panose="02040503050201020203" pitchFamily="18" charset="-78"/>
-                  <a:cs typeface="Bahij TheSansArabic Plain" panose="02040503050201020203" pitchFamily="18" charset="-78"/>
-                </a:rPr>
-                <a:t> ذات الصلة بالتراخيص والتصاريح والإيواء والتبغ.</a:t>
+                <a:t xml:space="preserve">اختبار النموذج على الربع الأخير من 2025: الفرق في الإجمالي +7% عن الفعلي.</a:t>
               </a:r>
             </a:p>
             <a:p>
@@ -51955,7 +51850,7 @@
                   <a:latin typeface="Bahij TheSansArabic Plain" panose="02040503050201020203" pitchFamily="18" charset="-78"/>
                   <a:cs typeface="Bahij TheSansArabic Plain" panose="02040503050201020203" pitchFamily="18" charset="-78"/>
                 </a:rPr>
-                <a:t>عوامل اجتماعية: زيادة مشاركة المرأة وتغير الإنفاق) رفع طفيف ~5% لإيرادات المستهلك.</a:t>
+                <a:t xml:space="preserve">السيناريو الأول يفترض وصول دفعة تأجير المرافق في نوفمبر، والسيناريو الثاني يفترض عدم وصولها خلال العام.</a:t>
               </a:r>
             </a:p>
             <a:p>
@@ -51970,10 +51865,13 @@
                 <a:buFont typeface="Arial" panose="020B0604020202020204" pitchFamily="34" charset="0"/>
                 <a:buChar char="•"/>
               </a:pPr>
-              <a:endParaRPr lang="ar-SA" sz="1800">
-                <a:latin typeface="Bahij TheSansArabic Plain" panose="02040503050201020203" pitchFamily="18" charset="-78"/>
-                <a:cs typeface="Bahij TheSansArabic Plain" panose="02040503050201020203" pitchFamily="18" charset="-78"/>
-              </a:endParaRPr>
+              <a:r>
+                <a:rPr lang="ar-SA" sz="1800">
+                  <a:latin typeface="Bahij TheSansArabic Plain" panose="02040503050201020203" pitchFamily="18" charset="-78"/>
+                  <a:cs typeface="Bahij TheSansArabic Plain" panose="02040503050201020203" pitchFamily="18" charset="-78"/>
+                </a:rPr>
+                <a:t xml:space="preserve">أرقام السيناريوهين متحفظة مقارنة بالتوقع الأوسط للنموذج.</a:t>
+              </a:r>
             </a:p>
           </p:txBody>
         </p:sp>
@@ -52036,7 +51934,7 @@
                 <a:latin typeface="Bahij TheSansArabic Bold" panose="02040503050201020203" pitchFamily="18" charset="-78"/>
                 <a:cs typeface="Bahij TheSansArabic Bold" panose="02040503050201020203" pitchFamily="18" charset="-78"/>
               </a:rPr>
-              <a:t>منهجية تنبؤ بالربع الأخير من عام 2025</a:t>
+              <a:t>منهجية تنبؤ بالربع الأخير من عام 2026</a:t>
             </a:r>
           </a:p>
         </p:txBody>

</xml_diff>

<commit_message>
Add per-tab performance reasons to methodology box
Co-Authored-By: Claude Opus 5.5 <noreply@anthropic.com>
Claude-Session: https://claude.ai/code/session_01D73U26FQnMJ6VM9LfvsWf3
</commit_message>
<xml_diff>
--- a/عرض_الإيرادات_سيناريوهات_إقفال_2026.pptx
+++ b/عرض_الإيرادات_سيناريوهات_إقفال_2026.pptx
@@ -44087,112 +44087,166 @@
             <a:lstStyle/>
             <a:p>
               <a:pPr marL="285750" indent="-285750" algn="justLow" rtl="1">
+                <a:spcAft>
+                  <a:spcPts val="400"/>
+                </a:spcAft>
                 <a:buFont typeface="Arial" panose="020B0604020202020204" pitchFamily="34" charset="0"/>
                 <a:buChar char="•"/>
               </a:pPr>
               <a:r>
-                <a:rPr lang="ar-SA" sz="1800" b="1">
+                <a:rPr lang="ar-SA" sz="1500" b="1">
                   <a:solidFill>
                     <a:srgbClr val="01686A"/>
                   </a:solidFill>
                   <a:latin typeface="Bahij TheSansArabic Plain" panose="02040503050201020203" pitchFamily="18" charset="-78"/>
                   <a:cs typeface="Bahij TheSansArabic Plain" panose="02040503050201020203" pitchFamily="18" charset="-78"/>
                 </a:rPr>
-                <a:t xml:space="preserve">أساس السيناريوهات:</a:t>
+                <a:t xml:space="preserve">أسباب الأداء:</a:t>
               </a:r>
             </a:p>
             <a:p>
-              <a:pPr algn="justLow" rtl="1"/>
-              <a:endParaRPr lang="ar-SA" sz="1800">
-                <a:latin typeface="Bahij TheSansArabic Plain" panose="02040503050201020203" pitchFamily="18" charset="-78"/>
-                <a:cs typeface="Bahij TheSansArabic Plain" panose="02040503050201020203" pitchFamily="18" charset="-78"/>
-              </a:endParaRPr>
-            </a:p>
-            <a:p>
               <a:pPr marL="285750" indent="-285750" algn="justLow" rtl="1">
+                <a:spcAft>
+                  <a:spcPts val="400"/>
+                </a:spcAft>
                 <a:buFont typeface="Arial" panose="020B0604020202020204" pitchFamily="34" charset="0"/>
                 <a:buChar char="•"/>
               </a:pPr>
               <a:r>
-                <a:rPr lang="ar-SA" sz="1800">
+                <a:rPr lang="ar-SA" sz="1500">
                   <a:latin typeface="Bahij TheSansArabic Plain" panose="02040503050201020203" pitchFamily="18" charset="-78"/>
                   <a:cs typeface="Bahij TheSansArabic Plain" panose="02040503050201020203" pitchFamily="18" charset="-78"/>
                 </a:rPr>
-                <a:t xml:space="preserve">تم التحقق من السيناريوهين بنموذج </a:t>
+                <a:t xml:space="preserve">التوقع مبني على نموذج </a:t>
               </a:r>
               <a:r>
-                <a:rPr lang="ar-SA" sz="1800" b="1">
+                <a:rPr lang="ar-SA" sz="1500" b="1">
                   <a:latin typeface="Bahij TheSansArabic Plain" panose="02040503050201020203" pitchFamily="18" charset="-78"/>
                   <a:cs typeface="Bahij TheSansArabic Plain" panose="02040503050201020203" pitchFamily="18" charset="-78"/>
                 </a:rPr>
                 <a:t xml:space="preserve">هولت وينترز</a:t>
               </a:r>
               <a:r>
-                <a:rPr lang="ar-SA" sz="1800">
+                <a:rPr lang="ar-SA" sz="1500">
                   <a:latin typeface="Bahij TheSansArabic Plain" panose="02040503050201020203" pitchFamily="18" charset="-78"/>
                   <a:cs typeface="Bahij TheSansArabic Plain" panose="02040503050201020203" pitchFamily="18" charset="-78"/>
                 </a:rPr>
-                <a:t xml:space="preserve"> هجين على المحصل الشهري لكل تبويب (يناير 2023 – سبتمبر 2026)، مع استبعاد الدفعات الاستثنائية من بيانات التدريب ومعالجتها بشكل منفصل.</a:t>
+                <a:t xml:space="preserve"> هجين (اختبار الربع الأخير 2025: +7%). أسباب الأداء حسب التبويب مقارنة بنفس الفترة من العام الماضي:</a:t>
               </a:r>
             </a:p>
             <a:p>
-              <a:pPr algn="justLow" rtl="1"/>
-              <a:endParaRPr lang="ar-SA" sz="1800">
-                <a:latin typeface="Bahij TheSansArabic Plain" panose="02040503050201020203" pitchFamily="18" charset="-78"/>
-                <a:cs typeface="Bahij TheSansArabic Plain" panose="02040503050201020203" pitchFamily="18" charset="-78"/>
-              </a:endParaRPr>
-            </a:p>
-            <a:p>
               <a:pPr marL="285750" indent="-285750" algn="justLow" rtl="1">
+                <a:spcAft>
+                  <a:spcPts val="400"/>
+                </a:spcAft>
                 <a:buFont typeface="Arial" panose="020B0604020202020204" pitchFamily="34" charset="0"/>
                 <a:buChar char="•"/>
               </a:pPr>
               <a:r>
-                <a:rPr lang="ar-SA" sz="1800">
+                <a:rPr lang="ar-SA" sz="1500" b="1">
                   <a:latin typeface="Bahij TheSansArabic Plain" panose="02040503050201020203" pitchFamily="18" charset="-78"/>
                   <a:cs typeface="Bahij TheSansArabic Plain" panose="02040503050201020203" pitchFamily="18" charset="-78"/>
                 </a:rPr>
-                <a:t xml:space="preserve">اختبار النموذج على الربع الأخير من 2025: الفرق في الإجمالي +7% عن الفعلي.</a:t>
+                <a:t xml:space="preserve">إيرادات استثمارية: </a:t>
+              </a:r>
+              <a:r>
+                <a:rPr lang="ar-SA" sz="1500">
+                  <a:latin typeface="Bahij TheSansArabic Plain" panose="02040503050201020203" pitchFamily="18" charset="-78"/>
+                  <a:cs typeface="Bahij TheSansArabic Plain" panose="02040503050201020203" pitchFamily="18" charset="-78"/>
+                </a:rPr>
+                <a:t xml:space="preserve">ريع الأراضي +29% (644م) وتأجير المرافق +40% (429م)، ويفترض هذا السيناريو وصول دفعة تأجير المرافق في نوفمبر.</a:t>
               </a:r>
             </a:p>
             <a:p>
-              <a:pPr algn="justLow" rtl="1"/>
-              <a:endParaRPr lang="ar-SA" sz="1800">
-                <a:latin typeface="Bahij TheSansArabic Plain" panose="02040503050201020203" pitchFamily="18" charset="-78"/>
-                <a:cs typeface="Bahij TheSansArabic Plain" panose="02040503050201020203" pitchFamily="18" charset="-78"/>
-              </a:endParaRPr>
-            </a:p>
-            <a:p>
               <a:pPr marL="285750" indent="-285750" algn="justLow" rtl="1">
+                <a:spcAft>
+                  <a:spcPts val="400"/>
+                </a:spcAft>
                 <a:buFont typeface="Arial" panose="020B0604020202020204" pitchFamily="34" charset="0"/>
                 <a:buChar char="•"/>
               </a:pPr>
               <a:r>
-                <a:rPr lang="ar-SA" sz="1800">
+                <a:rPr lang="ar-SA" sz="1500" b="1">
                   <a:latin typeface="Bahij TheSansArabic Plain" panose="02040503050201020203" pitchFamily="18" charset="-78"/>
                   <a:cs typeface="Bahij TheSansArabic Plain" panose="02040503050201020203" pitchFamily="18" charset="-78"/>
                 </a:rPr>
-                <a:t xml:space="preserve">السيناريو الأول يفترض وصول دفعة تأجير المرافق في نوفمبر، والسيناريو الثاني يفترض عدم وصولها خلال العام.</a:t>
+                <a:t xml:space="preserve">الرسوم والتراخيص: </a:t>
+              </a:r>
+              <a:r>
+                <a:rPr lang="ar-SA" sz="1500">
+                  <a:latin typeface="Bahij TheSansArabic Plain" panose="02040503050201020203" pitchFamily="18" charset="-78"/>
+                  <a:cs typeface="Bahij TheSansArabic Plain" panose="02040503050201020203" pitchFamily="18" charset="-78"/>
+                </a:rPr>
+                <a:t xml:space="preserve">عند المستهدف حتى سبتمبر؛ تراجع تراخيص المباني 19% يقابله ارتفاع القرارات المساحية 57% وجمع النفايات 12%.</a:t>
               </a:r>
             </a:p>
             <a:p>
-              <a:pPr algn="justLow" rtl="1"/>
-              <a:endParaRPr lang="ar-SA" sz="1800">
-                <a:latin typeface="Bahij TheSansArabic Plain" panose="02040503050201020203" pitchFamily="18" charset="-78"/>
-                <a:cs typeface="Bahij TheSansArabic Plain" panose="02040503050201020203" pitchFamily="18" charset="-78"/>
-              </a:endParaRPr>
-            </a:p>
-            <a:p>
               <a:pPr marL="285750" indent="-285750" algn="justLow" rtl="1">
+                <a:spcAft>
+                  <a:spcPts val="400"/>
+                </a:spcAft>
                 <a:buFont typeface="Arial" panose="020B0604020202020204" pitchFamily="34" charset="0"/>
                 <a:buChar char="•"/>
               </a:pPr>
               <a:r>
-                <a:rPr lang="ar-SA" sz="1800">
+                <a:rPr lang="ar-SA" sz="1500" b="1">
                   <a:latin typeface="Bahij TheSansArabic Plain" panose="02040503050201020203" pitchFamily="18" charset="-78"/>
                   <a:cs typeface="Bahij TheSansArabic Plain" panose="02040503050201020203" pitchFamily="18" charset="-78"/>
                 </a:rPr>
-                <a:t xml:space="preserve">أرقام السيناريوهين متحفظة مقارنة بالتوقع الأوسط للنموذج.</a:t>
+                <a:t xml:space="preserve">جزاءات وغرامات: </a:t>
+              </a:r>
+              <a:r>
+                <a:rPr lang="ar-SA" sz="1500">
+                  <a:latin typeface="Bahij TheSansArabic Plain" panose="02040503050201020203" pitchFamily="18" charset="-78"/>
+                  <a:cs typeface="Bahij TheSansArabic Plain" panose="02040503050201020203" pitchFamily="18" charset="-78"/>
+                </a:rPr>
+                <a:t xml:space="preserve">تجاوز المستهدف بتحصيل استثنائي عبر التوريد والتنفيذ (جزاءات غير مصنفة 179م، والجزاءات والغرامات 103م) وارتفاع جزاءات الأنظمة 63%.</a:t>
+              </a:r>
+            </a:p>
+            <a:p>
+              <a:pPr marL="285750" indent="-285750" algn="justLow" rtl="1">
+                <a:spcAft>
+                  <a:spcPts val="400"/>
+                </a:spcAft>
+                <a:buFont typeface="Arial" panose="020B0604020202020204" pitchFamily="34" charset="0"/>
+                <a:buChar char="•"/>
+              </a:pPr>
+              <a:r>
+                <a:rPr lang="ar-SA" sz="1500" b="1">
+                  <a:latin typeface="Bahij TheSansArabic Plain" panose="02040503050201020203" pitchFamily="18" charset="-78"/>
+                  <a:cs typeface="Bahij TheSansArabic Plain" panose="02040503050201020203" pitchFamily="18" charset="-78"/>
+                </a:rPr>
+                <a:t xml:space="preserve">التبغ والإيواء: </a:t>
+              </a:r>
+              <a:r>
+                <a:rPr lang="ar-SA" sz="1500">
+                  <a:latin typeface="Bahij TheSansArabic Plain" panose="02040503050201020203" pitchFamily="18" charset="-78"/>
+                  <a:cs typeface="Bahij TheSansArabic Plain" panose="02040503050201020203" pitchFamily="18" charset="-78"/>
+                </a:rPr>
+                <a:t xml:space="preserve">انخفاض إشغال مرافق الإيواء 17% ورسوم مبيعات التبغ 9%، مع استقطاع 33م من إيرادات التبويب.</a:t>
+              </a:r>
+            </a:p>
+            <a:p>
+              <a:pPr marL="285750" indent="-285750" algn="justLow" rtl="1">
+                <a:spcAft>
+                  <a:spcPts val="400"/>
+                </a:spcAft>
+                <a:buFont typeface="Arial" panose="020B0604020202020204" pitchFamily="34" charset="0"/>
+                <a:buChar char="•"/>
+              </a:pPr>
+              <a:r>
+                <a:rPr lang="ar-SA" sz="1500" b="1">
+                  <a:latin typeface="Bahij TheSansArabic Plain" panose="02040503050201020203" pitchFamily="18" charset="-78"/>
+                  <a:cs typeface="Bahij TheSansArabic Plain" panose="02040503050201020203" pitchFamily="18" charset="-78"/>
+                </a:rPr>
+                <a:t xml:space="preserve">أخرى: </a:t>
+              </a:r>
+              <a:r>
+                <a:rPr lang="ar-SA" sz="1500">
+                  <a:latin typeface="Bahij TheSansArabic Plain" panose="02040503050201020203" pitchFamily="18" charset="-78"/>
+                  <a:cs typeface="Bahij TheSansArabic Plain" panose="02040503050201020203" pitchFamily="18" charset="-78"/>
+                </a:rPr>
+                <a:t xml:space="preserve">ارتفاع المبيعات الأخرى 109% (138م) وتوريد إيرادات متنوعة 55م.</a:t>
               </a:r>
             </a:p>
           </p:txBody>
@@ -51765,112 +51819,166 @@
             <a:lstStyle/>
             <a:p>
               <a:pPr marL="285750" indent="-285750" algn="justLow" rtl="1">
+                <a:spcAft>
+                  <a:spcPts val="400"/>
+                </a:spcAft>
                 <a:buFont typeface="Arial" panose="020B0604020202020204" pitchFamily="34" charset="0"/>
                 <a:buChar char="•"/>
               </a:pPr>
               <a:r>
-                <a:rPr lang="ar-SA" sz="1800" b="1">
+                <a:rPr lang="ar-SA" sz="1500" b="1">
                   <a:solidFill>
                     <a:srgbClr val="01686A"/>
                   </a:solidFill>
                   <a:latin typeface="Bahij TheSansArabic Plain" panose="02040503050201020203" pitchFamily="18" charset="-78"/>
                   <a:cs typeface="Bahij TheSansArabic Plain" panose="02040503050201020203" pitchFamily="18" charset="-78"/>
                 </a:rPr>
-                <a:t xml:space="preserve">أساس السيناريوهات:</a:t>
+                <a:t xml:space="preserve">أسباب الأداء:</a:t>
               </a:r>
             </a:p>
             <a:p>
-              <a:pPr algn="justLow" rtl="1"/>
-              <a:endParaRPr lang="ar-SA" sz="1800">
-                <a:latin typeface="Bahij TheSansArabic Plain" panose="02040503050201020203" pitchFamily="18" charset="-78"/>
-                <a:cs typeface="Bahij TheSansArabic Plain" panose="02040503050201020203" pitchFamily="18" charset="-78"/>
-              </a:endParaRPr>
-            </a:p>
-            <a:p>
               <a:pPr marL="285750" indent="-285750" algn="justLow" rtl="1">
+                <a:spcAft>
+                  <a:spcPts val="400"/>
+                </a:spcAft>
                 <a:buFont typeface="Arial" panose="020B0604020202020204" pitchFamily="34" charset="0"/>
                 <a:buChar char="•"/>
               </a:pPr>
               <a:r>
-                <a:rPr lang="ar-SA" sz="1800">
+                <a:rPr lang="ar-SA" sz="1500">
                   <a:latin typeface="Bahij TheSansArabic Plain" panose="02040503050201020203" pitchFamily="18" charset="-78"/>
                   <a:cs typeface="Bahij TheSansArabic Plain" panose="02040503050201020203" pitchFamily="18" charset="-78"/>
                 </a:rPr>
-                <a:t xml:space="preserve">تم التحقق من السيناريوهين بنموذج </a:t>
+                <a:t xml:space="preserve">التوقع مبني على نموذج </a:t>
               </a:r>
               <a:r>
-                <a:rPr lang="ar-SA" sz="1800" b="1">
+                <a:rPr lang="ar-SA" sz="1500" b="1">
                   <a:latin typeface="Bahij TheSansArabic Plain" panose="02040503050201020203" pitchFamily="18" charset="-78"/>
                   <a:cs typeface="Bahij TheSansArabic Plain" panose="02040503050201020203" pitchFamily="18" charset="-78"/>
                 </a:rPr>
                 <a:t xml:space="preserve">هولت وينترز</a:t>
               </a:r>
               <a:r>
-                <a:rPr lang="ar-SA" sz="1800">
+                <a:rPr lang="ar-SA" sz="1500">
                   <a:latin typeface="Bahij TheSansArabic Plain" panose="02040503050201020203" pitchFamily="18" charset="-78"/>
                   <a:cs typeface="Bahij TheSansArabic Plain" panose="02040503050201020203" pitchFamily="18" charset="-78"/>
                 </a:rPr>
-                <a:t xml:space="preserve"> هجين على المحصل الشهري لكل تبويب (يناير 2023 – سبتمبر 2026)، مع استبعاد الدفعات الاستثنائية من بيانات التدريب ومعالجتها بشكل منفصل.</a:t>
+                <a:t xml:space="preserve"> هجين (اختبار الربع الأخير 2025: +7%). أسباب الأداء حسب التبويب مقارنة بنفس الفترة من العام الماضي:</a:t>
               </a:r>
             </a:p>
             <a:p>
-              <a:pPr algn="justLow" rtl="1"/>
-              <a:endParaRPr lang="ar-SA" sz="1800">
-                <a:latin typeface="Bahij TheSansArabic Plain" panose="02040503050201020203" pitchFamily="18" charset="-78"/>
-                <a:cs typeface="Bahij TheSansArabic Plain" panose="02040503050201020203" pitchFamily="18" charset="-78"/>
-              </a:endParaRPr>
-            </a:p>
-            <a:p>
               <a:pPr marL="285750" indent="-285750" algn="justLow" rtl="1">
+                <a:spcAft>
+                  <a:spcPts val="400"/>
+                </a:spcAft>
                 <a:buFont typeface="Arial" panose="020B0604020202020204" pitchFamily="34" charset="0"/>
                 <a:buChar char="•"/>
               </a:pPr>
               <a:r>
-                <a:rPr lang="ar-SA" sz="1800">
+                <a:rPr lang="ar-SA" sz="1500" b="1">
                   <a:latin typeface="Bahij TheSansArabic Plain" panose="02040503050201020203" pitchFamily="18" charset="-78"/>
                   <a:cs typeface="Bahij TheSansArabic Plain" panose="02040503050201020203" pitchFamily="18" charset="-78"/>
                 </a:rPr>
-                <a:t xml:space="preserve">اختبار النموذج على الربع الأخير من 2025: الفرق في الإجمالي +7% عن الفعلي.</a:t>
+                <a:t xml:space="preserve">إيرادات استثمارية: </a:t>
+              </a:r>
+              <a:r>
+                <a:rPr lang="ar-SA" sz="1500">
+                  <a:latin typeface="Bahij TheSansArabic Plain" panose="02040503050201020203" pitchFamily="18" charset="-78"/>
+                  <a:cs typeface="Bahij TheSansArabic Plain" panose="02040503050201020203" pitchFamily="18" charset="-78"/>
+                </a:rPr>
+                <a:t xml:space="preserve">ريع الأراضي +29% (644م) وتأجير المرافق +40% (429م)، ويفترض هذا السيناريو عدم وصول دفعة تأجير المرافق خلال العام، لذا يقل التبويب عن المستهدف.</a:t>
               </a:r>
             </a:p>
             <a:p>
-              <a:pPr algn="justLow" rtl="1"/>
-              <a:endParaRPr lang="ar-SA" sz="1800">
-                <a:latin typeface="Bahij TheSansArabic Plain" panose="02040503050201020203" pitchFamily="18" charset="-78"/>
-                <a:cs typeface="Bahij TheSansArabic Plain" panose="02040503050201020203" pitchFamily="18" charset="-78"/>
-              </a:endParaRPr>
-            </a:p>
-            <a:p>
               <a:pPr marL="285750" indent="-285750" algn="justLow" rtl="1">
+                <a:spcAft>
+                  <a:spcPts val="400"/>
+                </a:spcAft>
                 <a:buFont typeface="Arial" panose="020B0604020202020204" pitchFamily="34" charset="0"/>
                 <a:buChar char="•"/>
               </a:pPr>
               <a:r>
-                <a:rPr lang="ar-SA" sz="1800">
+                <a:rPr lang="ar-SA" sz="1500" b="1">
                   <a:latin typeface="Bahij TheSansArabic Plain" panose="02040503050201020203" pitchFamily="18" charset="-78"/>
                   <a:cs typeface="Bahij TheSansArabic Plain" panose="02040503050201020203" pitchFamily="18" charset="-78"/>
                 </a:rPr>
-                <a:t xml:space="preserve">السيناريو الأول يفترض وصول دفعة تأجير المرافق في نوفمبر، والسيناريو الثاني يفترض عدم وصولها خلال العام.</a:t>
+                <a:t xml:space="preserve">الرسوم والتراخيص: </a:t>
+              </a:r>
+              <a:r>
+                <a:rPr lang="ar-SA" sz="1500">
+                  <a:latin typeface="Bahij TheSansArabic Plain" panose="02040503050201020203" pitchFamily="18" charset="-78"/>
+                  <a:cs typeface="Bahij TheSansArabic Plain" panose="02040503050201020203" pitchFamily="18" charset="-78"/>
+                </a:rPr>
+                <a:t xml:space="preserve">عند المستهدف حتى سبتمبر؛ تراجع تراخيص المباني 19% يقابله ارتفاع القرارات المساحية 57% وجمع النفايات 12%.</a:t>
               </a:r>
             </a:p>
             <a:p>
-              <a:pPr algn="justLow" rtl="1"/>
-              <a:endParaRPr lang="ar-SA" sz="1800">
-                <a:latin typeface="Bahij TheSansArabic Plain" panose="02040503050201020203" pitchFamily="18" charset="-78"/>
-                <a:cs typeface="Bahij TheSansArabic Plain" panose="02040503050201020203" pitchFamily="18" charset="-78"/>
-              </a:endParaRPr>
-            </a:p>
-            <a:p>
               <a:pPr marL="285750" indent="-285750" algn="justLow" rtl="1">
+                <a:spcAft>
+                  <a:spcPts val="400"/>
+                </a:spcAft>
                 <a:buFont typeface="Arial" panose="020B0604020202020204" pitchFamily="34" charset="0"/>
                 <a:buChar char="•"/>
               </a:pPr>
               <a:r>
-                <a:rPr lang="ar-SA" sz="1800">
+                <a:rPr lang="ar-SA" sz="1500" b="1">
                   <a:latin typeface="Bahij TheSansArabic Plain" panose="02040503050201020203" pitchFamily="18" charset="-78"/>
                   <a:cs typeface="Bahij TheSansArabic Plain" panose="02040503050201020203" pitchFamily="18" charset="-78"/>
                 </a:rPr>
-                <a:t xml:space="preserve">أرقام السيناريوهين متحفظة مقارنة بالتوقع الأوسط للنموذج.</a:t>
+                <a:t xml:space="preserve">جزاءات وغرامات: </a:t>
+              </a:r>
+              <a:r>
+                <a:rPr lang="ar-SA" sz="1500">
+                  <a:latin typeface="Bahij TheSansArabic Plain" panose="02040503050201020203" pitchFamily="18" charset="-78"/>
+                  <a:cs typeface="Bahij TheSansArabic Plain" panose="02040503050201020203" pitchFamily="18" charset="-78"/>
+                </a:rPr>
+                <a:t xml:space="preserve">تجاوز المستهدف بتحصيل استثنائي عبر التوريد والتنفيذ (جزاءات غير مصنفة 179م، والجزاءات والغرامات 103م) وارتفاع جزاءات الأنظمة 63%.</a:t>
+              </a:r>
+            </a:p>
+            <a:p>
+              <a:pPr marL="285750" indent="-285750" algn="justLow" rtl="1">
+                <a:spcAft>
+                  <a:spcPts val="400"/>
+                </a:spcAft>
+                <a:buFont typeface="Arial" panose="020B0604020202020204" pitchFamily="34" charset="0"/>
+                <a:buChar char="•"/>
+              </a:pPr>
+              <a:r>
+                <a:rPr lang="ar-SA" sz="1500" b="1">
+                  <a:latin typeface="Bahij TheSansArabic Plain" panose="02040503050201020203" pitchFamily="18" charset="-78"/>
+                  <a:cs typeface="Bahij TheSansArabic Plain" panose="02040503050201020203" pitchFamily="18" charset="-78"/>
+                </a:rPr>
+                <a:t xml:space="preserve">التبغ والإيواء: </a:t>
+              </a:r>
+              <a:r>
+                <a:rPr lang="ar-SA" sz="1500">
+                  <a:latin typeface="Bahij TheSansArabic Plain" panose="02040503050201020203" pitchFamily="18" charset="-78"/>
+                  <a:cs typeface="Bahij TheSansArabic Plain" panose="02040503050201020203" pitchFamily="18" charset="-78"/>
+                </a:rPr>
+                <a:t xml:space="preserve">انخفاض إشغال مرافق الإيواء 17% ورسوم مبيعات التبغ 9%، مع استقطاع 33م من إيرادات التبويب.</a:t>
+              </a:r>
+            </a:p>
+            <a:p>
+              <a:pPr marL="285750" indent="-285750" algn="justLow" rtl="1">
+                <a:spcAft>
+                  <a:spcPts val="400"/>
+                </a:spcAft>
+                <a:buFont typeface="Arial" panose="020B0604020202020204" pitchFamily="34" charset="0"/>
+                <a:buChar char="•"/>
+              </a:pPr>
+              <a:r>
+                <a:rPr lang="ar-SA" sz="1500" b="1">
+                  <a:latin typeface="Bahij TheSansArabic Plain" panose="02040503050201020203" pitchFamily="18" charset="-78"/>
+                  <a:cs typeface="Bahij TheSansArabic Plain" panose="02040503050201020203" pitchFamily="18" charset="-78"/>
+                </a:rPr>
+                <a:t xml:space="preserve">أخرى: </a:t>
+              </a:r>
+              <a:r>
+                <a:rPr lang="ar-SA" sz="1500">
+                  <a:latin typeface="Bahij TheSansArabic Plain" panose="02040503050201020203" pitchFamily="18" charset="-78"/>
+                  <a:cs typeface="Bahij TheSansArabic Plain" panose="02040503050201020203" pitchFamily="18" charset="-78"/>
+                </a:rPr>
+                <a:t xml:space="preserve">ارتفاع المبيعات الأخرى 109% (138م) وتوريد إيرادات متنوعة 55م.</a:t>
               </a:r>
             </a:p>
           </p:txBody>

</xml_diff>

<commit_message>
Add two incentive slides (scenario 1 and 2) to revenue deck
Co-Authored-By: Claude Opus 5.5 <noreply@anthropic.com>
Claude-Session: https://claude.ai/code/session_01D73U26FQnMJ6VM9LfvsWf3
</commit_message>
<xml_diff>
--- a/عرض_الإيرادات_سيناريوهات_إقفال_2026.pptx
+++ b/عرض_الإيرادات_سيناريوهات_إقفال_2026.pptx
@@ -15,6 +15,8 @@
     <p:sldId id="509" r:id="rId3"/>
     <p:sldId id="1448944975" r:id="rId4"/>
     <p:sldId id="1448944974" r:id="rId5"/>
+    <p:sldId id="1448944980" r:id="rId905"/>
+    <p:sldId id="1448944981" r:id="rId906"/>
     <p:sldId id="507" r:id="rId6"/>
   </p:sldIdLst>
   <p:sldSz cx="24384000" cy="13716000"/>
@@ -52171,6 +52173,4242 @@
 </p:sld>
 </file>
 
+<file path=ppt/slides/slide5.xml><?xml version="1.0" encoding="utf-8"?>
+<p:sld xmlns:a="http://schemas.openxmlformats.org/drawingml/2006/main" xmlns:r="http://schemas.openxmlformats.org/officeDocument/2006/relationships" xmlns:p="http://schemas.openxmlformats.org/presentationml/2006/main">
+  <p:cSld>
+    <p:spTree>
+      <p:nvGrpSpPr>
+        <p:cNvPr id="1" name="">
+          <a:extLst>
+            <a:ext uri="{FF2B5EF4-FFF2-40B4-BE49-F238E27FC236}">
+              <a16:creationId xmlns:a16="http://schemas.microsoft.com/office/drawing/2014/main" id="{1188DBA1-EB05-F5A5-81C7-676B509E2F15}"/>
+            </a:ext>
+          </a:extLst>
+        </p:cNvPr>
+        <p:cNvGrpSpPr/>
+        <p:nvPr/>
+      </p:nvGrpSpPr>
+      <p:grpSpPr>
+        <a:xfrm>
+          <a:off x="0" y="0"/>
+          <a:ext cx="0" cy="0"/>
+          <a:chOff x="0" y="0"/>
+          <a:chExt cx="0" cy="0"/>
+        </a:xfrm>
+      </p:grpSpPr>
+      <p:sp>
+        <p:nvSpPr>
+          <p:cNvPr id="28" name="Rectangle 27">
+            <a:extLst>
+              <a:ext uri="{FF2B5EF4-FFF2-40B4-BE49-F238E27FC236}">
+                <a16:creationId xmlns:a16="http://schemas.microsoft.com/office/drawing/2014/main" id="{721FCA79-B689-3E5C-ED9B-34B1063C05B4}"/>
+              </a:ext>
+            </a:extLst>
+          </p:cNvPr>
+          <p:cNvSpPr/>
+          <p:nvPr/>
+        </p:nvSpPr>
+        <p:spPr>
+          <a:xfrm>
+            <a:off x="115617" y="2279209"/>
+            <a:ext cx="24020043" cy="10406156"/>
+          </a:xfrm>
+          <a:prstGeom prst="rect">
+            <a:avLst/>
+          </a:prstGeom>
+          <a:solidFill>
+            <a:srgbClr val="F5F5F5"/>
+          </a:solidFill>
+          <a:ln>
+            <a:solidFill>
+              <a:schemeClr val="bg1">
+                <a:lumMod val="85000"/>
+              </a:schemeClr>
+            </a:solidFill>
+          </a:ln>
+        </p:spPr>
+        <p:style>
+          <a:lnRef idx="2">
+            <a:schemeClr val="accent1">
+              <a:shade val="15000"/>
+            </a:schemeClr>
+          </a:lnRef>
+          <a:fillRef idx="1">
+            <a:schemeClr val="accent1"/>
+          </a:fillRef>
+          <a:effectRef idx="0">
+            <a:schemeClr val="accent1"/>
+          </a:effectRef>
+          <a:fontRef idx="minor">
+            <a:schemeClr val="lt1"/>
+          </a:fontRef>
+        </p:style>
+        <p:txBody>
+          <a:bodyPr rtlCol="0" anchor="ctr"/>
+          <a:lstStyle/>
+          <a:p>
+            <a:pPr algn="ctr"/>
+            <a:endParaRPr lang="en-US"/>
+          </a:p>
+        </p:txBody>
+      </p:sp>
+      <p:grpSp>
+        <p:nvGrpSpPr>
+          <p:cNvPr id="4" name="Group 3">
+            <a:extLst>
+              <a:ext uri="{FF2B5EF4-FFF2-40B4-BE49-F238E27FC236}">
+                <a16:creationId xmlns:a16="http://schemas.microsoft.com/office/drawing/2014/main" id="{B1AA1666-FA68-0FBD-24A5-DBD7AE6470F6}"/>
+              </a:ext>
+            </a:extLst>
+          </p:cNvPr>
+          <p:cNvGrpSpPr/>
+          <p:nvPr/>
+        </p:nvGrpSpPr>
+        <p:grpSpPr>
+          <a:xfrm>
+            <a:off x="6688186" y="263023"/>
+            <a:ext cx="17695824" cy="799889"/>
+            <a:chOff x="6897658" y="1223860"/>
+            <a:chExt cx="5473691" cy="430888"/>
+          </a:xfrm>
+        </p:grpSpPr>
+        <p:grpSp>
+          <p:nvGrpSpPr>
+            <p:cNvPr id="13" name="Group 12">
+              <a:extLst>
+                <a:ext uri="{FF2B5EF4-FFF2-40B4-BE49-F238E27FC236}">
+                  <a16:creationId xmlns:a16="http://schemas.microsoft.com/office/drawing/2014/main" id="{B077B9B0-E000-558F-4C96-FDDA0EC5B271}"/>
+                </a:ext>
+              </a:extLst>
+            </p:cNvPr>
+            <p:cNvGrpSpPr/>
+            <p:nvPr/>
+          </p:nvGrpSpPr>
+          <p:grpSpPr>
+            <a:xfrm>
+              <a:off x="6897658" y="1223860"/>
+              <a:ext cx="5473691" cy="430888"/>
+              <a:chOff x="1533984" y="1062731"/>
+              <a:chExt cx="10852794" cy="854330"/>
+            </a:xfrm>
+          </p:grpSpPr>
+          <p:sp>
+            <p:nvSpPr>
+              <p:cNvPr id="14" name="Freeform 13">
+                <a:extLst>
+                  <a:ext uri="{FF2B5EF4-FFF2-40B4-BE49-F238E27FC236}">
+                    <a16:creationId xmlns:a16="http://schemas.microsoft.com/office/drawing/2014/main" id="{43AEBF43-D85C-E14A-311F-917168516D90}"/>
+                  </a:ext>
+                </a:extLst>
+              </p:cNvPr>
+              <p:cNvSpPr/>
+              <p:nvPr/>
+            </p:nvSpPr>
+            <p:spPr>
+              <a:xfrm>
+                <a:off x="4893052" y="1072296"/>
+                <a:ext cx="7493726" cy="844765"/>
+              </a:xfrm>
+              <a:custGeom>
+                <a:avLst/>
+                <a:gdLst>
+                  <a:gd name="connsiteX0" fmla="*/ 7493726 w 7493726"/>
+                  <a:gd name="connsiteY0" fmla="*/ 0 h 844765"/>
+                  <a:gd name="connsiteX1" fmla="*/ 7493726 w 7493726"/>
+                  <a:gd name="connsiteY1" fmla="*/ 844765 h 844765"/>
+                  <a:gd name="connsiteX2" fmla="*/ 0 w 7493726"/>
+                  <a:gd name="connsiteY2" fmla="*/ 836298 h 844765"/>
+                  <a:gd name="connsiteX3" fmla="*/ 508000 w 7493726"/>
+                  <a:gd name="connsiteY3" fmla="*/ 16933 h 844765"/>
+                  <a:gd name="connsiteX4" fmla="*/ 7493726 w 7493726"/>
+                  <a:gd name="connsiteY4" fmla="*/ 0 h 844765"/>
+                  <a:gd name="connsiteX5" fmla="*/ 690975 w 7493726"/>
+                  <a:gd name="connsiteY5" fmla="*/ 105483 h 844765"/>
+                  <a:gd name="connsiteX6" fmla="*/ 563975 w 7493726"/>
+                  <a:gd name="connsiteY6" fmla="*/ 319779 h 844765"/>
+                  <a:gd name="connsiteX7" fmla="*/ 817975 w 7493726"/>
+                  <a:gd name="connsiteY7" fmla="*/ 319779 h 844765"/>
+                  <a:gd name="connsiteX8" fmla="*/ 690975 w 7493726"/>
+                  <a:gd name="connsiteY8" fmla="*/ 105483 h 844765"/>
+                  <a:gd name="connsiteX9" fmla="*/ 256198 w 7493726"/>
+                  <a:gd name="connsiteY9" fmla="*/ 515369 h 844765"/>
+                  <a:gd name="connsiteX10" fmla="*/ 383198 w 7493726"/>
+                  <a:gd name="connsiteY10" fmla="*/ 729665 h 844765"/>
+                  <a:gd name="connsiteX11" fmla="*/ 510198 w 7493726"/>
+                  <a:gd name="connsiteY11" fmla="*/ 515369 h 844765"/>
+                  <a:gd name="connsiteX12" fmla="*/ 256198 w 7493726"/>
+                  <a:gd name="connsiteY12" fmla="*/ 515369 h 844765"/>
+                </a:gdLst>
+                <a:ahLst/>
+                <a:cxnLst>
+                  <a:cxn ang="0">
+                    <a:pos x="connsiteX0" y="connsiteY0"/>
+                  </a:cxn>
+                  <a:cxn ang="0">
+                    <a:pos x="connsiteX1" y="connsiteY1"/>
+                  </a:cxn>
+                  <a:cxn ang="0">
+                    <a:pos x="connsiteX2" y="connsiteY2"/>
+                  </a:cxn>
+                  <a:cxn ang="0">
+                    <a:pos x="connsiteX3" y="connsiteY3"/>
+                  </a:cxn>
+                  <a:cxn ang="0">
+                    <a:pos x="connsiteX4" y="connsiteY4"/>
+                  </a:cxn>
+                  <a:cxn ang="0">
+                    <a:pos x="connsiteX5" y="connsiteY5"/>
+                  </a:cxn>
+                  <a:cxn ang="0">
+                    <a:pos x="connsiteX6" y="connsiteY6"/>
+                  </a:cxn>
+                  <a:cxn ang="0">
+                    <a:pos x="connsiteX7" y="connsiteY7"/>
+                  </a:cxn>
+                  <a:cxn ang="0">
+                    <a:pos x="connsiteX8" y="connsiteY8"/>
+                  </a:cxn>
+                  <a:cxn ang="0">
+                    <a:pos x="connsiteX9" y="connsiteY9"/>
+                  </a:cxn>
+                  <a:cxn ang="0">
+                    <a:pos x="connsiteX10" y="connsiteY10"/>
+                  </a:cxn>
+                  <a:cxn ang="0">
+                    <a:pos x="connsiteX11" y="connsiteY11"/>
+                  </a:cxn>
+                  <a:cxn ang="0">
+                    <a:pos x="connsiteX12" y="connsiteY12"/>
+                  </a:cxn>
+                </a:cxnLst>
+                <a:rect l="l" t="t" r="r" b="b"/>
+                <a:pathLst>
+                  <a:path w="7493726" h="844765">
+                    <a:moveTo>
+                      <a:pt x="7493726" y="0"/>
+                    </a:moveTo>
+                    <a:lnTo>
+                      <a:pt x="7493726" y="844765"/>
+                    </a:lnTo>
+                    <a:lnTo>
+                      <a:pt x="0" y="836298"/>
+                    </a:lnTo>
+                    <a:lnTo>
+                      <a:pt x="508000" y="16933"/>
+                    </a:lnTo>
+                    <a:lnTo>
+                      <a:pt x="7493726" y="0"/>
+                    </a:lnTo>
+                    <a:close/>
+                    <a:moveTo>
+                      <a:pt x="690975" y="105483"/>
+                    </a:moveTo>
+                    <a:lnTo>
+                      <a:pt x="563975" y="319779"/>
+                    </a:lnTo>
+                    <a:lnTo>
+                      <a:pt x="817975" y="319779"/>
+                    </a:lnTo>
+                    <a:lnTo>
+                      <a:pt x="690975" y="105483"/>
+                    </a:lnTo>
+                    <a:close/>
+                    <a:moveTo>
+                      <a:pt x="256198" y="515369"/>
+                    </a:moveTo>
+                    <a:lnTo>
+                      <a:pt x="383198" y="729665"/>
+                    </a:lnTo>
+                    <a:lnTo>
+                      <a:pt x="510198" y="515369"/>
+                    </a:lnTo>
+                    <a:lnTo>
+                      <a:pt x="256198" y="515369"/>
+                    </a:lnTo>
+                    <a:close/>
+                  </a:path>
+                </a:pathLst>
+              </a:custGeom>
+              <a:solidFill>
+                <a:srgbClr val="106946"/>
+              </a:solidFill>
+              <a:ln>
+                <a:noFill/>
+              </a:ln>
+            </p:spPr>
+            <p:style>
+              <a:lnRef idx="2">
+                <a:schemeClr val="accent1">
+                  <a:shade val="15000"/>
+                </a:schemeClr>
+              </a:lnRef>
+              <a:fillRef idx="1">
+                <a:schemeClr val="accent1"/>
+              </a:fillRef>
+              <a:effectRef idx="0">
+                <a:schemeClr val="accent1"/>
+              </a:effectRef>
+              <a:fontRef idx="minor">
+                <a:schemeClr val="lt1"/>
+              </a:fontRef>
+            </p:style>
+            <p:txBody>
+              <a:bodyPr wrap="square" rtlCol="0" anchor="ctr">
+                <a:noAutofit/>
+              </a:bodyPr>
+              <a:lstStyle/>
+              <a:p>
+                <a:pPr algn="ctr"/>
+                <a:endParaRPr lang="en-LB" sz="3608"/>
+              </a:p>
+            </p:txBody>
+          </p:sp>
+          <p:sp>
+            <p:nvSpPr>
+              <p:cNvPr id="15" name="Triangle 14">
+                <a:extLst>
+                  <a:ext uri="{FF2B5EF4-FFF2-40B4-BE49-F238E27FC236}">
+                    <a16:creationId xmlns:a16="http://schemas.microsoft.com/office/drawing/2014/main" id="{971A2D07-8145-90A5-B6CC-2651DCC71C78}"/>
+                  </a:ext>
+                </a:extLst>
+              </p:cNvPr>
+              <p:cNvSpPr/>
+              <p:nvPr/>
+            </p:nvSpPr>
+            <p:spPr>
+              <a:xfrm>
+                <a:off x="4703493" y="1177779"/>
+                <a:ext cx="254000" cy="214296"/>
+              </a:xfrm>
+              <a:prstGeom prst="triangle">
+                <a:avLst/>
+              </a:prstGeom>
+              <a:solidFill>
+                <a:srgbClr val="106946"/>
+              </a:solidFill>
+              <a:ln>
+                <a:noFill/>
+              </a:ln>
+            </p:spPr>
+            <p:style>
+              <a:lnRef idx="2">
+                <a:schemeClr val="accent1">
+                  <a:shade val="15000"/>
+                </a:schemeClr>
+              </a:lnRef>
+              <a:fillRef idx="1">
+                <a:schemeClr val="accent1"/>
+              </a:fillRef>
+              <a:effectRef idx="0">
+                <a:schemeClr val="accent1"/>
+              </a:effectRef>
+              <a:fontRef idx="minor">
+                <a:schemeClr val="lt1"/>
+              </a:fontRef>
+            </p:style>
+            <p:txBody>
+              <a:bodyPr rtlCol="0" anchor="ctr"/>
+              <a:lstStyle/>
+              <a:p>
+                <a:pPr algn="ctr"/>
+                <a:endParaRPr lang="en-LB" sz="3608"/>
+              </a:p>
+            </p:txBody>
+          </p:sp>
+          <p:sp>
+            <p:nvSpPr>
+              <p:cNvPr id="16" name="Triangle 15">
+                <a:extLst>
+                  <a:ext uri="{FF2B5EF4-FFF2-40B4-BE49-F238E27FC236}">
+                    <a16:creationId xmlns:a16="http://schemas.microsoft.com/office/drawing/2014/main" id="{A3A0A86C-7A03-6BE9-10B4-6C131016B2A1}"/>
+                  </a:ext>
+                </a:extLst>
+              </p:cNvPr>
+              <p:cNvSpPr/>
+              <p:nvPr/>
+            </p:nvSpPr>
+            <p:spPr>
+              <a:xfrm>
+                <a:off x="3535093" y="1177779"/>
+                <a:ext cx="254000" cy="214296"/>
+              </a:xfrm>
+              <a:prstGeom prst="triangle">
+                <a:avLst/>
+              </a:prstGeom>
+              <a:solidFill>
+                <a:srgbClr val="106946"/>
+              </a:solidFill>
+              <a:ln>
+                <a:noFill/>
+              </a:ln>
+            </p:spPr>
+            <p:style>
+              <a:lnRef idx="2">
+                <a:schemeClr val="accent1">
+                  <a:shade val="15000"/>
+                </a:schemeClr>
+              </a:lnRef>
+              <a:fillRef idx="1">
+                <a:schemeClr val="accent1"/>
+              </a:fillRef>
+              <a:effectRef idx="0">
+                <a:schemeClr val="accent1"/>
+              </a:effectRef>
+              <a:fontRef idx="minor">
+                <a:schemeClr val="lt1"/>
+              </a:fontRef>
+            </p:style>
+            <p:txBody>
+              <a:bodyPr rtlCol="0" anchor="ctr"/>
+              <a:lstStyle/>
+              <a:p>
+                <a:pPr algn="ctr"/>
+                <a:endParaRPr lang="en-LB" sz="3608"/>
+              </a:p>
+            </p:txBody>
+          </p:sp>
+          <p:sp>
+            <p:nvSpPr>
+              <p:cNvPr id="17" name="Triangle 16">
+                <a:extLst>
+                  <a:ext uri="{FF2B5EF4-FFF2-40B4-BE49-F238E27FC236}">
+                    <a16:creationId xmlns:a16="http://schemas.microsoft.com/office/drawing/2014/main" id="{60505BCC-68E6-C3E2-1E15-4B0D96BCFC05}"/>
+                  </a:ext>
+                </a:extLst>
+              </p:cNvPr>
+              <p:cNvSpPr/>
+              <p:nvPr/>
+            </p:nvSpPr>
+            <p:spPr>
+              <a:xfrm>
+                <a:off x="2375160" y="1177779"/>
+                <a:ext cx="254000" cy="214296"/>
+              </a:xfrm>
+              <a:prstGeom prst="triangle">
+                <a:avLst/>
+              </a:prstGeom>
+              <a:solidFill>
+                <a:srgbClr val="106946"/>
+              </a:solidFill>
+              <a:ln>
+                <a:noFill/>
+              </a:ln>
+            </p:spPr>
+            <p:style>
+              <a:lnRef idx="2">
+                <a:schemeClr val="accent1">
+                  <a:shade val="15000"/>
+                </a:schemeClr>
+              </a:lnRef>
+              <a:fillRef idx="1">
+                <a:schemeClr val="accent1"/>
+              </a:fillRef>
+              <a:effectRef idx="0">
+                <a:schemeClr val="accent1"/>
+              </a:effectRef>
+              <a:fontRef idx="minor">
+                <a:schemeClr val="lt1"/>
+              </a:fontRef>
+            </p:style>
+            <p:txBody>
+              <a:bodyPr rtlCol="0" anchor="ctr"/>
+              <a:lstStyle/>
+              <a:p>
+                <a:pPr algn="ctr"/>
+                <a:endParaRPr lang="en-LB" sz="3608"/>
+              </a:p>
+            </p:txBody>
+          </p:sp>
+          <p:sp>
+            <p:nvSpPr>
+              <p:cNvPr id="18" name="Triangle 17">
+                <a:extLst>
+                  <a:ext uri="{FF2B5EF4-FFF2-40B4-BE49-F238E27FC236}">
+                    <a16:creationId xmlns:a16="http://schemas.microsoft.com/office/drawing/2014/main" id="{5F9BEA0D-604B-CEF5-3C7B-DBBB37AD871C}"/>
+                  </a:ext>
+                </a:extLst>
+              </p:cNvPr>
+              <p:cNvSpPr/>
+              <p:nvPr/>
+            </p:nvSpPr>
+            <p:spPr>
+              <a:xfrm rot="10800000">
+                <a:off x="4404184" y="1587665"/>
+                <a:ext cx="254000" cy="214296"/>
+              </a:xfrm>
+              <a:prstGeom prst="triangle">
+                <a:avLst/>
+              </a:prstGeom>
+              <a:solidFill>
+                <a:srgbClr val="106946"/>
+              </a:solidFill>
+              <a:ln>
+                <a:noFill/>
+              </a:ln>
+            </p:spPr>
+            <p:style>
+              <a:lnRef idx="2">
+                <a:schemeClr val="accent1">
+                  <a:shade val="15000"/>
+                </a:schemeClr>
+              </a:lnRef>
+              <a:fillRef idx="1">
+                <a:schemeClr val="accent1"/>
+              </a:fillRef>
+              <a:effectRef idx="0">
+                <a:schemeClr val="accent1"/>
+              </a:effectRef>
+              <a:fontRef idx="minor">
+                <a:schemeClr val="lt1"/>
+              </a:fontRef>
+            </p:style>
+            <p:txBody>
+              <a:bodyPr rtlCol="0" anchor="ctr"/>
+              <a:lstStyle/>
+              <a:p>
+                <a:pPr algn="ctr"/>
+                <a:endParaRPr lang="en-LB" sz="3608"/>
+              </a:p>
+            </p:txBody>
+          </p:sp>
+          <p:sp>
+            <p:nvSpPr>
+              <p:cNvPr id="19" name="Triangle 18">
+                <a:extLst>
+                  <a:ext uri="{FF2B5EF4-FFF2-40B4-BE49-F238E27FC236}">
+                    <a16:creationId xmlns:a16="http://schemas.microsoft.com/office/drawing/2014/main" id="{5EA82A37-70C7-5527-5353-42652B1479D9}"/>
+                  </a:ext>
+                </a:extLst>
+              </p:cNvPr>
+              <p:cNvSpPr/>
+              <p:nvPr/>
+            </p:nvSpPr>
+            <p:spPr>
+              <a:xfrm rot="10800000">
+                <a:off x="2660051" y="1587665"/>
+                <a:ext cx="254000" cy="214296"/>
+              </a:xfrm>
+              <a:prstGeom prst="triangle">
+                <a:avLst/>
+              </a:prstGeom>
+              <a:solidFill>
+                <a:srgbClr val="106946"/>
+              </a:solidFill>
+              <a:ln>
+                <a:noFill/>
+              </a:ln>
+            </p:spPr>
+            <p:style>
+              <a:lnRef idx="2">
+                <a:schemeClr val="accent1">
+                  <a:shade val="15000"/>
+                </a:schemeClr>
+              </a:lnRef>
+              <a:fillRef idx="1">
+                <a:schemeClr val="accent1"/>
+              </a:fillRef>
+              <a:effectRef idx="0">
+                <a:schemeClr val="accent1"/>
+              </a:effectRef>
+              <a:fontRef idx="minor">
+                <a:schemeClr val="lt1"/>
+              </a:fontRef>
+            </p:style>
+            <p:txBody>
+              <a:bodyPr rtlCol="0" anchor="ctr"/>
+              <a:lstStyle/>
+              <a:p>
+                <a:pPr algn="ctr"/>
+                <a:endParaRPr lang="en-LB" sz="3608"/>
+              </a:p>
+            </p:txBody>
+          </p:sp>
+          <p:sp>
+            <p:nvSpPr>
+              <p:cNvPr id="20" name="Triangle 19">
+                <a:extLst>
+                  <a:ext uri="{FF2B5EF4-FFF2-40B4-BE49-F238E27FC236}">
+                    <a16:creationId xmlns:a16="http://schemas.microsoft.com/office/drawing/2014/main" id="{F97C3E02-72F4-6D04-133C-A0DFEDBD3441}"/>
+                  </a:ext>
+                </a:extLst>
+              </p:cNvPr>
+              <p:cNvSpPr/>
+              <p:nvPr/>
+            </p:nvSpPr>
+            <p:spPr>
+              <a:xfrm rot="10800000">
+                <a:off x="1533984" y="1587665"/>
+                <a:ext cx="254000" cy="214296"/>
+              </a:xfrm>
+              <a:prstGeom prst="triangle">
+                <a:avLst/>
+              </a:prstGeom>
+              <a:solidFill>
+                <a:srgbClr val="106946"/>
+              </a:solidFill>
+              <a:ln>
+                <a:noFill/>
+              </a:ln>
+            </p:spPr>
+            <p:style>
+              <a:lnRef idx="2">
+                <a:schemeClr val="accent1">
+                  <a:shade val="15000"/>
+                </a:schemeClr>
+              </a:lnRef>
+              <a:fillRef idx="1">
+                <a:schemeClr val="accent1"/>
+              </a:fillRef>
+              <a:effectRef idx="0">
+                <a:schemeClr val="accent1"/>
+              </a:effectRef>
+              <a:fontRef idx="minor">
+                <a:schemeClr val="lt1"/>
+              </a:fontRef>
+            </p:style>
+            <p:txBody>
+              <a:bodyPr rtlCol="0" anchor="ctr"/>
+              <a:lstStyle/>
+              <a:p>
+                <a:pPr algn="ctr"/>
+                <a:endParaRPr lang="en-LB" sz="3608"/>
+              </a:p>
+            </p:txBody>
+          </p:sp>
+          <p:sp>
+            <p:nvSpPr>
+              <p:cNvPr id="21" name="Triangle 20">
+                <a:extLst>
+                  <a:ext uri="{FF2B5EF4-FFF2-40B4-BE49-F238E27FC236}">
+                    <a16:creationId xmlns:a16="http://schemas.microsoft.com/office/drawing/2014/main" id="{6682F398-CA34-8C50-5EB0-7A89436F0811}"/>
+                  </a:ext>
+                </a:extLst>
+              </p:cNvPr>
+              <p:cNvSpPr/>
+              <p:nvPr/>
+            </p:nvSpPr>
+            <p:spPr>
+              <a:xfrm>
+                <a:off x="2900093" y="1685779"/>
+                <a:ext cx="254000" cy="214296"/>
+              </a:xfrm>
+              <a:prstGeom prst="triangle">
+                <a:avLst/>
+              </a:prstGeom>
+              <a:solidFill>
+                <a:srgbClr val="106946"/>
+              </a:solidFill>
+              <a:ln>
+                <a:noFill/>
+              </a:ln>
+            </p:spPr>
+            <p:style>
+              <a:lnRef idx="2">
+                <a:schemeClr val="accent1">
+                  <a:shade val="15000"/>
+                </a:schemeClr>
+              </a:lnRef>
+              <a:fillRef idx="1">
+                <a:schemeClr val="accent1"/>
+              </a:fillRef>
+              <a:effectRef idx="0">
+                <a:schemeClr val="accent1"/>
+              </a:effectRef>
+              <a:fontRef idx="minor">
+                <a:schemeClr val="lt1"/>
+              </a:fontRef>
+            </p:style>
+            <p:txBody>
+              <a:bodyPr rtlCol="0" anchor="ctr"/>
+              <a:lstStyle/>
+              <a:p>
+                <a:pPr algn="ctr"/>
+                <a:endParaRPr lang="en-LB" sz="3608"/>
+              </a:p>
+            </p:txBody>
+          </p:sp>
+          <p:sp>
+            <p:nvSpPr>
+              <p:cNvPr id="22" name="Triangle 21">
+                <a:extLst>
+                  <a:ext uri="{FF2B5EF4-FFF2-40B4-BE49-F238E27FC236}">
+                    <a16:creationId xmlns:a16="http://schemas.microsoft.com/office/drawing/2014/main" id="{724B218E-B970-C895-FE75-CB461BB5BD59}"/>
+                  </a:ext>
+                </a:extLst>
+              </p:cNvPr>
+              <p:cNvSpPr/>
+              <p:nvPr/>
+            </p:nvSpPr>
+            <p:spPr>
+              <a:xfrm>
+                <a:off x="4127759" y="1685779"/>
+                <a:ext cx="254000" cy="214296"/>
+              </a:xfrm>
+              <a:prstGeom prst="triangle">
+                <a:avLst/>
+              </a:prstGeom>
+              <a:solidFill>
+                <a:srgbClr val="106946"/>
+              </a:solidFill>
+              <a:ln>
+                <a:noFill/>
+              </a:ln>
+            </p:spPr>
+            <p:style>
+              <a:lnRef idx="2">
+                <a:schemeClr val="accent1">
+                  <a:shade val="15000"/>
+                </a:schemeClr>
+              </a:lnRef>
+              <a:fillRef idx="1">
+                <a:schemeClr val="accent1"/>
+              </a:fillRef>
+              <a:effectRef idx="0">
+                <a:schemeClr val="accent1"/>
+              </a:effectRef>
+              <a:fontRef idx="minor">
+                <a:schemeClr val="lt1"/>
+              </a:fontRef>
+            </p:style>
+            <p:txBody>
+              <a:bodyPr rtlCol="0" anchor="ctr"/>
+              <a:lstStyle/>
+              <a:p>
+                <a:pPr algn="ctr"/>
+                <a:endParaRPr lang="en-LB" sz="3608"/>
+              </a:p>
+            </p:txBody>
+          </p:sp>
+          <p:sp>
+            <p:nvSpPr>
+              <p:cNvPr id="23" name="Triangle 22">
+                <a:extLst>
+                  <a:ext uri="{FF2B5EF4-FFF2-40B4-BE49-F238E27FC236}">
+                    <a16:creationId xmlns:a16="http://schemas.microsoft.com/office/drawing/2014/main" id="{53D5A865-70C6-51F1-FB5E-CE3D00F567AB}"/>
+                  </a:ext>
+                </a:extLst>
+              </p:cNvPr>
+              <p:cNvSpPr/>
+              <p:nvPr/>
+            </p:nvSpPr>
+            <p:spPr>
+              <a:xfrm rot="10800000">
+                <a:off x="4404184" y="1062731"/>
+                <a:ext cx="254000" cy="214296"/>
+              </a:xfrm>
+              <a:prstGeom prst="triangle">
+                <a:avLst/>
+              </a:prstGeom>
+              <a:solidFill>
+                <a:srgbClr val="106946"/>
+              </a:solidFill>
+              <a:ln>
+                <a:noFill/>
+              </a:ln>
+            </p:spPr>
+            <p:style>
+              <a:lnRef idx="2">
+                <a:schemeClr val="accent1">
+                  <a:shade val="15000"/>
+                </a:schemeClr>
+              </a:lnRef>
+              <a:fillRef idx="1">
+                <a:schemeClr val="accent1"/>
+              </a:fillRef>
+              <a:effectRef idx="0">
+                <a:schemeClr val="accent1"/>
+              </a:effectRef>
+              <a:fontRef idx="minor">
+                <a:schemeClr val="lt1"/>
+              </a:fontRef>
+            </p:style>
+            <p:txBody>
+              <a:bodyPr rtlCol="0" anchor="ctr"/>
+              <a:lstStyle/>
+              <a:p>
+                <a:pPr algn="ctr"/>
+                <a:endParaRPr lang="en-LB" sz="3608"/>
+              </a:p>
+            </p:txBody>
+          </p:sp>
+          <p:sp>
+            <p:nvSpPr>
+              <p:cNvPr id="24" name="Triangle 23">
+                <a:extLst>
+                  <a:ext uri="{FF2B5EF4-FFF2-40B4-BE49-F238E27FC236}">
+                    <a16:creationId xmlns:a16="http://schemas.microsoft.com/office/drawing/2014/main" id="{B5B815C1-5E26-6603-DED0-9459C7E19A83}"/>
+                  </a:ext>
+                </a:extLst>
+              </p:cNvPr>
+              <p:cNvSpPr/>
+              <p:nvPr/>
+            </p:nvSpPr>
+            <p:spPr>
+              <a:xfrm rot="10800000">
+                <a:off x="4988384" y="1062731"/>
+                <a:ext cx="254000" cy="214296"/>
+              </a:xfrm>
+              <a:prstGeom prst="triangle">
+                <a:avLst/>
+              </a:prstGeom>
+              <a:solidFill>
+                <a:srgbClr val="106946"/>
+              </a:solidFill>
+              <a:ln>
+                <a:noFill/>
+              </a:ln>
+            </p:spPr>
+            <p:style>
+              <a:lnRef idx="2">
+                <a:schemeClr val="accent1">
+                  <a:shade val="15000"/>
+                </a:schemeClr>
+              </a:lnRef>
+              <a:fillRef idx="1">
+                <a:schemeClr val="accent1"/>
+              </a:fillRef>
+              <a:effectRef idx="0">
+                <a:schemeClr val="accent1"/>
+              </a:effectRef>
+              <a:fontRef idx="minor">
+                <a:schemeClr val="lt1"/>
+              </a:fontRef>
+            </p:style>
+            <p:txBody>
+              <a:bodyPr rtlCol="0" anchor="ctr"/>
+              <a:lstStyle/>
+              <a:p>
+                <a:pPr algn="ctr"/>
+                <a:endParaRPr lang="en-LB" sz="3608"/>
+              </a:p>
+            </p:txBody>
+          </p:sp>
+        </p:grpSp>
+        <p:sp>
+          <p:nvSpPr>
+            <p:cNvPr id="3" name="TextBox 2">
+              <a:extLst>
+                <a:ext uri="{FF2B5EF4-FFF2-40B4-BE49-F238E27FC236}">
+                  <a16:creationId xmlns:a16="http://schemas.microsoft.com/office/drawing/2014/main" id="{D390DDCD-CC36-5797-C43D-3229F88E660A}"/>
+                </a:ext>
+              </a:extLst>
+            </p:cNvPr>
+            <p:cNvSpPr txBox="1"/>
+            <p:nvPr/>
+          </p:nvSpPr>
+          <p:spPr>
+            <a:xfrm>
+              <a:off x="9033163" y="1296547"/>
+              <a:ext cx="3250365" cy="281851"/>
+            </a:xfrm>
+            <a:prstGeom prst="rect">
+              <a:avLst/>
+            </a:prstGeom>
+            <a:noFill/>
+          </p:spPr>
+          <p:txBody>
+            <a:bodyPr wrap="square">
+              <a:spAutoFit/>
+            </a:bodyPr>
+            <a:lstStyle/>
+            <a:p>
+              <a:pPr algn="justLow" defTabSz="916000" rtl="1">
+                <a:buClr>
+                  <a:prstClr val="white"/>
+                </a:buClr>
+                <a:buSzPts val="3600"/>
+              </a:pPr>
+              <a:r>
+                <a:rPr lang="ar-SA" sz="2800" kern="1200">
+                  <a:solidFill>
+                    <a:schemeClr val="bg1"/>
+                  </a:solidFill>
+                  <a:latin typeface="Bahij TheSansArabic ExtraBold" panose="02040503050201020203" pitchFamily="18" charset="-78"/>
+                  <a:ea typeface="Cairo"/>
+                  <a:cs typeface="Bahij TheSansArabic ExtraBold" panose="02040503050201020203" pitchFamily="18" charset="-78"/>
+                  <a:sym typeface="Cairo"/>
+                </a:rPr>
+                <a:t>السيناريو الأول — حوافز الموظفين</a:t>
+              </a:r>
+            </a:p>
+          </p:txBody>
+        </p:sp>
+      </p:grpSp>
+      <p:sp>
+        <p:nvSpPr>
+          <p:cNvPr id="261" name="Rectangle: Rounded Corners 260">
+            <a:extLst>
+              <a:ext uri="{FF2B5EF4-FFF2-40B4-BE49-F238E27FC236}">
+                <a16:creationId xmlns:a16="http://schemas.microsoft.com/office/drawing/2014/main" id="{DAD97482-DCB9-B82E-756E-F2042308EA9D}"/>
+              </a:ext>
+            </a:extLst>
+          </p:cNvPr>
+          <p:cNvSpPr/>
+          <p:nvPr/>
+        </p:nvSpPr>
+        <p:spPr>
+          <a:xfrm>
+            <a:off x="115617" y="1488435"/>
+            <a:ext cx="24020043" cy="815152"/>
+          </a:xfrm>
+          <a:prstGeom prst="roundRect">
+            <a:avLst>
+              <a:gd name="adj" fmla="val 6592"/>
+            </a:avLst>
+          </a:prstGeom>
+          <a:solidFill>
+            <a:schemeClr val="bg1">
+              <a:lumMod val="95000"/>
+            </a:schemeClr>
+          </a:solidFill>
+          <a:ln>
+            <a:solidFill>
+              <a:schemeClr val="bg1">
+                <a:lumMod val="75000"/>
+              </a:schemeClr>
+            </a:solidFill>
+          </a:ln>
+        </p:spPr>
+        <p:style>
+          <a:lnRef idx="2">
+            <a:schemeClr val="accent1">
+              <a:shade val="15000"/>
+            </a:schemeClr>
+          </a:lnRef>
+          <a:fillRef idx="1">
+            <a:schemeClr val="accent1"/>
+          </a:fillRef>
+          <a:effectRef idx="0">
+            <a:schemeClr val="accent1"/>
+          </a:effectRef>
+          <a:fontRef idx="minor">
+            <a:schemeClr val="lt1"/>
+          </a:fontRef>
+        </p:style>
+        <p:txBody>
+          <a:bodyPr rtlCol="0" anchor="ctr"/>
+          <a:lstStyle/>
+          <a:p>
+            <a:pPr algn="ctr"/>
+            <a:endParaRPr lang="en-US"/>
+          </a:p>
+        </p:txBody>
+      </p:sp>
+      <p:sp>
+        <p:nvSpPr>
+          <p:cNvPr id="262" name="TextBox 261">
+            <a:extLst>
+              <a:ext uri="{FF2B5EF4-FFF2-40B4-BE49-F238E27FC236}">
+                <a16:creationId xmlns:a16="http://schemas.microsoft.com/office/drawing/2014/main" id="{16500E24-021A-35C8-66DF-5AA0FD806ECC}"/>
+              </a:ext>
+            </a:extLst>
+          </p:cNvPr>
+          <p:cNvSpPr txBox="1"/>
+          <p:nvPr/>
+        </p:nvSpPr>
+        <p:spPr>
+          <a:xfrm>
+            <a:off x="13682652" y="1628448"/>
+            <a:ext cx="9192723" cy="523220"/>
+          </a:xfrm>
+          <a:prstGeom prst="rect">
+            <a:avLst/>
+          </a:prstGeom>
+          <a:noFill/>
+        </p:spPr>
+        <p:txBody>
+          <a:bodyPr wrap="square" rtlCol="0">
+            <a:spAutoFit/>
+          </a:bodyPr>
+          <a:lstStyle/>
+          <a:p>
+            <a:pPr algn="r"/>
+            <a:r>
+              <a:rPr lang="ar-SA" sz="2800">
+                <a:solidFill>
+                  <a:srgbClr val="106946"/>
+                </a:solidFill>
+                <a:latin typeface="Bahij TheSansArabic Bold" panose="02040503050201020203" charset="-78"/>
+                <a:cs typeface="Bahij TheSansArabic Bold" panose="02040503050201020203" charset="-78"/>
+              </a:rPr>
+              <a:t>حوافز تحقيق الإيرادات وفق شروط الزيادة عن المقدّر</a:t>
+            </a:r>
+            <a:endParaRPr lang="en-US" sz="2800">
+              <a:solidFill>
+                <a:srgbClr val="106946"/>
+              </a:solidFill>
+              <a:latin typeface="Bahij TheSansArabic Bold" panose="02040503050201020203" charset="-78"/>
+              <a:cs typeface="Bahij TheSansArabic Bold" panose="02040503050201020203" charset="-78"/>
+            </a:endParaRPr>
+          </a:p>
+        </p:txBody>
+      </p:sp>
+      <p:sp>
+        <p:nvSpPr>
+          <p:cNvPr id="263" name="Rectangle 262">
+            <a:extLst>
+              <a:ext uri="{FF2B5EF4-FFF2-40B4-BE49-F238E27FC236}">
+                <a16:creationId xmlns:a16="http://schemas.microsoft.com/office/drawing/2014/main" id="{3B200D8B-A145-970E-19BB-80D4C3F87E17}"/>
+              </a:ext>
+            </a:extLst>
+          </p:cNvPr>
+          <p:cNvSpPr/>
+          <p:nvPr/>
+        </p:nvSpPr>
+        <p:spPr>
+          <a:xfrm>
+            <a:off x="22963694" y="1482075"/>
+            <a:ext cx="1171966" cy="846429"/>
+          </a:xfrm>
+          <a:prstGeom prst="rect">
+            <a:avLst/>
+          </a:prstGeom>
+          <a:solidFill>
+            <a:srgbClr val="106946"/>
+          </a:solidFill>
+          <a:ln>
+            <a:noFill/>
+          </a:ln>
+        </p:spPr>
+        <p:style>
+          <a:lnRef idx="2">
+            <a:schemeClr val="accent1">
+              <a:shade val="15000"/>
+            </a:schemeClr>
+          </a:lnRef>
+          <a:fillRef idx="1">
+            <a:schemeClr val="accent1"/>
+          </a:fillRef>
+          <a:effectRef idx="0">
+            <a:schemeClr val="accent1"/>
+          </a:effectRef>
+          <a:fontRef idx="minor">
+            <a:schemeClr val="lt1"/>
+          </a:fontRef>
+        </p:style>
+        <p:txBody>
+          <a:bodyPr rtlCol="0" anchor="ctr"/>
+          <a:lstStyle/>
+          <a:p>
+            <a:pPr algn="ctr"/>
+            <a:endParaRPr lang="en-US"/>
+          </a:p>
+        </p:txBody>
+      </p:sp>
+      <p:pic>
+        <p:nvPicPr>
+          <p:cNvPr id="264" name="Graphic 263" descr="Upward trend with solid fill">
+            <a:extLst>
+              <a:ext uri="{FF2B5EF4-FFF2-40B4-BE49-F238E27FC236}">
+                <a16:creationId xmlns:a16="http://schemas.microsoft.com/office/drawing/2014/main" id="{96CA829E-BCA4-2340-484B-01D0B7EA25FD}"/>
+              </a:ext>
+            </a:extLst>
+          </p:cNvPr>
+          <p:cNvPicPr>
+            <a:picLocks noChangeAspect="1"/>
+          </p:cNvPicPr>
+          <p:nvPr/>
+        </p:nvPicPr>
+        <p:blipFill>
+          <a:blip>
+            <a:extLst>
+              <a:ext uri="{96DAC541-7B7A-43D3-8B79-37D633B846F1}">
+                <asvg:svgBlip xmlns:asvg="http://schemas.microsoft.com/office/drawing/2016/SVG/main" r:embed="rId3"/>
+              </a:ext>
+            </a:extLst>
+          </a:blip>
+          <a:stretch>
+            <a:fillRect/>
+          </a:stretch>
+        </p:blipFill>
+        <p:spPr>
+          <a:xfrm>
+            <a:off x="23145423" y="1521744"/>
+            <a:ext cx="757465" cy="757465"/>
+          </a:xfrm>
+          <a:prstGeom prst="rect">
+            <a:avLst/>
+          </a:prstGeom>
+        </p:spPr>
+      </p:pic>
+      <p:sp>
+        <p:nvSpPr>
+          <p:cNvPr id="1001" name="Inc 1001"/>
+          <p:cNvSpPr/>
+          <p:nvPr/>
+        </p:nvSpPr>
+        <p:spPr>
+          <a:xfrm>
+            <a:off x="17850000" y="2620000"/>
+            <a:ext cx="5950000" cy="2900000"/>
+          </a:xfrm>
+          <a:prstGeom prst="roundRect">
+            <a:avLst>
+              <a:gd name="adj" fmla="val 8000"/>
+            </a:avLst>
+          </a:prstGeom>
+          <a:solidFill>
+            <a:srgbClr val="FFFFFF"/>
+          </a:solidFill>
+          <a:ln w="19050">
+            <a:solidFill>
+              <a:srgbClr val="D9D9D9"/>
+            </a:solidFill>
+          </a:ln>
+          <a:effectLst>
+            <a:outerShdw blurRad="190500" dist="38100" dir="5400000" algn="t" rotWithShape="0">
+              <a:srgbClr val="000000">
+                <a:alpha val="18000"/>
+              </a:srgbClr>
+            </a:outerShdw>
+          </a:effectLst>
+        </p:spPr>
+        <p:txBody>
+          <a:bodyPr wrap="square" lIns="91440" rIns="91440" tIns="45720" bIns="45720" rtlCol="1" anchor="ctr">
+            <a:normAutofit/>
+          </a:bodyPr>
+          <a:lstStyle/>
+          <a:p>
+            <a:pPr algn="ctr" rtl="1">
+              <a:spcBef>
+                <a:spcPts val="0"/>
+              </a:spcBef>
+            </a:pPr>
+            <a:r>
+              <a:rPr lang="ar-SA" sz="2600" dirty="0">
+                <a:solidFill>
+                  <a:srgbClr val="595959"/>
+                </a:solidFill>
+                <a:latin typeface="Bahij TheSansArabic Bold"/>
+                <a:cs typeface="Bahij TheSansArabic Bold"/>
+              </a:rPr>
+              <a:t>إجمالي الإيرادات المقدّرة</a:t>
+            </a:r>
+          </a:p>
+          <a:p>
+            <a:pPr algn="ctr" rtl="1">
+              <a:spcBef>
+                <a:spcPts val="1200"/>
+              </a:spcBef>
+            </a:pPr>
+            <a:r>
+              <a:rPr lang="ar-SA" sz="6000" dirty="0">
+                <a:solidFill>
+                  <a:srgbClr val="01686A"/>
+                </a:solidFill>
+                <a:latin typeface="Bahij TheSansArabic Bold"/>
+                <a:cs typeface="Bahij TheSansArabic Bold"/>
+              </a:rPr>
+              <a:t>2,839.3</a:t>
+            </a:r>
+          </a:p>
+          <a:p>
+            <a:pPr algn="ctr" rtl="1">
+              <a:spcBef>
+                <a:spcPts val="0"/>
+              </a:spcBef>
+            </a:pPr>
+            <a:r>
+              <a:rPr lang="ar-SA" sz="2000" dirty="0">
+                <a:solidFill>
+                  <a:srgbClr val="595959"/>
+                </a:solidFill>
+                <a:latin typeface="Bahij TheSansArabic Plain"/>
+                <a:cs typeface="Bahij TheSansArabic Plain"/>
+              </a:rPr>
+              <a:t>مليون ريال</a:t>
+            </a:r>
+          </a:p>
+        </p:txBody>
+      </p:sp>
+      <p:sp>
+        <p:nvSpPr>
+          <p:cNvPr id="1002" name="Inc 1002"/>
+          <p:cNvSpPr/>
+          <p:nvPr/>
+        </p:nvSpPr>
+        <p:spPr>
+          <a:xfrm>
+            <a:off x="11650000" y="2620000"/>
+            <a:ext cx="5950000" cy="2900000"/>
+          </a:xfrm>
+          <a:prstGeom prst="roundRect">
+            <a:avLst>
+              <a:gd name="adj" fmla="val 8000"/>
+            </a:avLst>
+          </a:prstGeom>
+          <a:solidFill>
+            <a:srgbClr val="FFFFFF"/>
+          </a:solidFill>
+          <a:ln w="19050">
+            <a:solidFill>
+              <a:srgbClr val="D9D9D9"/>
+            </a:solidFill>
+          </a:ln>
+          <a:effectLst>
+            <a:outerShdw blurRad="190500" dist="38100" dir="5400000" algn="t" rotWithShape="0">
+              <a:srgbClr val="000000">
+                <a:alpha val="18000"/>
+              </a:srgbClr>
+            </a:outerShdw>
+          </a:effectLst>
+        </p:spPr>
+        <p:txBody>
+          <a:bodyPr wrap="square" lIns="91440" rIns="91440" tIns="45720" bIns="45720" rtlCol="1" anchor="ctr">
+            <a:normAutofit/>
+          </a:bodyPr>
+          <a:lstStyle/>
+          <a:p>
+            <a:pPr algn="ctr" rtl="1">
+              <a:spcBef>
+                <a:spcPts val="0"/>
+              </a:spcBef>
+            </a:pPr>
+            <a:r>
+              <a:rPr lang="ar-SA" sz="2600" dirty="0">
+                <a:solidFill>
+                  <a:srgbClr val="595959"/>
+                </a:solidFill>
+                <a:latin typeface="Bahij TheSansArabic Bold"/>
+                <a:cs typeface="Bahij TheSansArabic Bold"/>
+              </a:rPr>
+              <a:t>إجمالي الإيرادات المحصّلة</a:t>
+            </a:r>
+          </a:p>
+          <a:p>
+            <a:pPr algn="ctr" rtl="1">
+              <a:spcBef>
+                <a:spcPts val="1200"/>
+              </a:spcBef>
+            </a:pPr>
+            <a:r>
+              <a:rPr lang="ar-SA" sz="6000" dirty="0">
+                <a:solidFill>
+                  <a:srgbClr val="01686A"/>
+                </a:solidFill>
+                <a:latin typeface="Bahij TheSansArabic Bold"/>
+                <a:cs typeface="Bahij TheSansArabic Bold"/>
+              </a:rPr>
+              <a:t>3,378.9</a:t>
+            </a:r>
+          </a:p>
+          <a:p>
+            <a:pPr algn="ctr" rtl="1">
+              <a:spcBef>
+                <a:spcPts val="0"/>
+              </a:spcBef>
+            </a:pPr>
+            <a:r>
+              <a:rPr lang="ar-SA" sz="2000" dirty="0">
+                <a:solidFill>
+                  <a:srgbClr val="595959"/>
+                </a:solidFill>
+                <a:latin typeface="Bahij TheSansArabic Plain"/>
+                <a:cs typeface="Bahij TheSansArabic Plain"/>
+              </a:rPr>
+              <a:t>مليون ريال</a:t>
+            </a:r>
+          </a:p>
+        </p:txBody>
+      </p:sp>
+      <p:sp>
+        <p:nvSpPr>
+          <p:cNvPr id="1003" name="Inc 1003"/>
+          <p:cNvSpPr/>
+          <p:nvPr/>
+        </p:nvSpPr>
+        <p:spPr>
+          <a:xfrm>
+            <a:off x="580000" y="2500000"/>
+            <a:ext cx="10820000" cy="3140000"/>
+          </a:xfrm>
+          <a:prstGeom prst="roundRect">
+            <a:avLst>
+              <a:gd name="adj" fmla="val 8000"/>
+            </a:avLst>
+          </a:prstGeom>
+          <a:solidFill>
+            <a:srgbClr val="106946"/>
+          </a:solidFill>
+          <a:ln>
+            <a:noFill/>
+          </a:ln>
+          <a:effectLst>
+            <a:outerShdw blurRad="190500" dist="38100" dir="5400000" algn="t" rotWithShape="0">
+              <a:srgbClr val="000000">
+                <a:alpha val="18000"/>
+              </a:srgbClr>
+            </a:outerShdw>
+          </a:effectLst>
+        </p:spPr>
+        <p:txBody>
+          <a:bodyPr wrap="square" lIns="91440" rIns="91440" tIns="45720" bIns="45720" rtlCol="1" anchor="ctr">
+            <a:normAutofit/>
+          </a:bodyPr>
+          <a:lstStyle/>
+          <a:p>
+            <a:pPr algn="ctr" rtl="1">
+              <a:spcBef>
+                <a:spcPts val="0"/>
+              </a:spcBef>
+            </a:pPr>
+            <a:r>
+              <a:rPr lang="ar-SA" sz="3200" dirty="0">
+                <a:solidFill>
+                  <a:srgbClr val="FFFFFF"/>
+                </a:solidFill>
+                <a:latin typeface="Bahij TheSansArabic Bold"/>
+                <a:cs typeface="Bahij TheSansArabic Bold"/>
+              </a:rPr>
+              <a:t>فائض الإيرادات</a:t>
+            </a:r>
+          </a:p>
+          <a:p>
+            <a:pPr algn="ctr" rtl="1">
+              <a:spcBef>
+                <a:spcPts val="600"/>
+              </a:spcBef>
+            </a:pPr>
+            <a:r>
+              <a:rPr lang="ar-SA" sz="9600" dirty="0">
+                <a:solidFill>
+                  <a:srgbClr val="FFFFFF"/>
+                </a:solidFill>
+                <a:latin typeface="Bahij TheSansArabic Bold"/>
+                <a:cs typeface="Bahij TheSansArabic Bold"/>
+              </a:rPr>
+              <a:t>539.6</a:t>
+            </a:r>
+          </a:p>
+          <a:p>
+            <a:pPr algn="ctr" rtl="1">
+              <a:spcBef>
+                <a:spcPts val="0"/>
+              </a:spcBef>
+            </a:pPr>
+            <a:r>
+              <a:rPr lang="ar-SA" sz="2200" dirty="0">
+                <a:solidFill>
+                  <a:srgbClr val="E2F0D9"/>
+                </a:solidFill>
+                <a:latin typeface="Bahij TheSansArabic Plain"/>
+                <a:cs typeface="Bahij TheSansArabic Plain"/>
+              </a:rPr>
+              <a:t>مليون ريال  |  زيادة 19.0% عن المقدّر</a:t>
+            </a:r>
+          </a:p>
+        </p:txBody>
+      </p:sp>
+      <p:sp>
+        <p:nvSpPr>
+          <p:cNvPr id="1004" name="Inc 1004"/>
+          <p:cNvSpPr/>
+          <p:nvPr/>
+        </p:nvSpPr>
+        <p:spPr>
+          <a:xfrm>
+            <a:off x="580000" y="5470000"/>
+            <a:ext cx="23220000" cy="420000"/>
+          </a:xfrm>
+          <a:prstGeom prst="roundRect">
+            <a:avLst>
+              <a:gd name="adj" fmla="val 8000"/>
+            </a:avLst>
+          </a:prstGeom>
+          <a:noFill/>
+          <a:ln>
+            <a:noFill/>
+          </a:ln>
+        </p:spPr>
+        <p:txBody>
+          <a:bodyPr wrap="square" lIns="91440" rIns="91440" tIns="45720" bIns="45720" rtlCol="1" anchor="ctr">
+            <a:normAutofit/>
+          </a:bodyPr>
+          <a:lstStyle/>
+          <a:p>
+            <a:pPr algn="r" rtl="1">
+              <a:spcBef>
+                <a:spcPts val="0"/>
+              </a:spcBef>
+            </a:pPr>
+            <a:r>
+              <a:rPr lang="ar-SA" sz="2600" dirty="0">
+                <a:solidFill>
+                  <a:srgbClr val="01686A"/>
+                </a:solidFill>
+                <a:latin typeface="Bahij TheSansArabic Bold"/>
+                <a:cs typeface="Bahij TheSansArabic Bold"/>
+              </a:rPr>
+              <a:t>شروط احتساب الحوافز</a:t>
+            </a:r>
+          </a:p>
+        </p:txBody>
+      </p:sp>
+      <p:sp>
+        <p:nvSpPr>
+          <p:cNvPr id="1005" name="Inc 1005"/>
+          <p:cNvSpPr/>
+          <p:nvPr/>
+        </p:nvSpPr>
+        <p:spPr>
+          <a:xfrm>
+            <a:off x="16700000" y="5950000"/>
+            <a:ext cx="7100000" cy="3500000"/>
+          </a:xfrm>
+          <a:prstGeom prst="roundRect">
+            <a:avLst>
+              <a:gd name="adj" fmla="val 8000"/>
+            </a:avLst>
+          </a:prstGeom>
+          <a:solidFill>
+            <a:srgbClr val="FFFFFF"/>
+          </a:solidFill>
+          <a:ln w="25400">
+            <a:solidFill>
+              <a:srgbClr val="01686A"/>
+            </a:solidFill>
+          </a:ln>
+          <a:effectLst>
+            <a:outerShdw blurRad="190500" dist="38100" dir="5400000" algn="t" rotWithShape="0">
+              <a:srgbClr val="000000">
+                <a:alpha val="18000"/>
+              </a:srgbClr>
+            </a:outerShdw>
+          </a:effectLst>
+        </p:spPr>
+        <p:txBody>
+          <a:bodyPr wrap="square" lIns="91440" rIns="91440" tIns="45720" bIns="45720" rtlCol="1" anchor="ctr">
+            <a:normAutofit/>
+          </a:bodyPr>
+          <a:lstStyle/>
+          <a:p>
+            <a:endParaRPr lang="ar-SA"/>
+          </a:p>
+        </p:txBody>
+      </p:sp>
+      <p:sp>
+        <p:nvSpPr>
+          <p:cNvPr id="1006" name="Inc 1006"/>
+          <p:cNvSpPr/>
+          <p:nvPr/>
+        </p:nvSpPr>
+        <p:spPr>
+          <a:xfrm>
+            <a:off x="22650000" y="6200000"/>
+            <a:ext cx="850000" cy="850000"/>
+          </a:xfrm>
+          <a:prstGeom prst="ellipse">
+            <a:avLst/>
+          </a:prstGeom>
+          <a:solidFill>
+            <a:srgbClr val="01686A"/>
+          </a:solidFill>
+          <a:ln>
+            <a:noFill/>
+          </a:ln>
+        </p:spPr>
+        <p:txBody>
+          <a:bodyPr wrap="square" lIns="91440" rIns="91440" tIns="45720" bIns="45720" rtlCol="1" anchor="ctr">
+            <a:normAutofit/>
+          </a:bodyPr>
+          <a:lstStyle/>
+          <a:p>
+            <a:pPr algn="ctr" rtl="1">
+              <a:spcBef>
+                <a:spcPts val="0"/>
+              </a:spcBef>
+            </a:pPr>
+            <a:r>
+              <a:rPr lang="ar-SA" sz="3200" dirty="0">
+                <a:solidFill>
+                  <a:srgbClr val="FFFFFF"/>
+                </a:solidFill>
+                <a:latin typeface="Bahij TheSansArabic Bold"/>
+                <a:cs typeface="Bahij TheSansArabic Bold"/>
+              </a:rPr>
+              <a:t>1</a:t>
+            </a:r>
+          </a:p>
+        </p:txBody>
+      </p:sp>
+      <p:sp>
+        <p:nvSpPr>
+          <p:cNvPr id="1007" name="Inc 1007"/>
+          <p:cNvSpPr/>
+          <p:nvPr/>
+        </p:nvSpPr>
+        <p:spPr>
+          <a:xfrm>
+            <a:off x="16950000" y="6130000"/>
+            <a:ext cx="5600000" cy="1250000"/>
+          </a:xfrm>
+          <a:prstGeom prst="roundRect">
+            <a:avLst>
+              <a:gd name="adj" fmla="val 8000"/>
+            </a:avLst>
+          </a:prstGeom>
+          <a:noFill/>
+          <a:ln>
+            <a:noFill/>
+          </a:ln>
+        </p:spPr>
+        <p:txBody>
+          <a:bodyPr wrap="square" lIns="91440" rIns="91440" tIns="45720" bIns="45720" rtlCol="1" anchor="ctr">
+            <a:normAutofit/>
+          </a:bodyPr>
+          <a:lstStyle/>
+          <a:p>
+            <a:pPr algn="r" rtl="1">
+              <a:spcBef>
+                <a:spcPts val="0"/>
+              </a:spcBef>
+            </a:pPr>
+            <a:r>
+              <a:rPr lang="ar-SA" sz="2200" dirty="0">
+                <a:solidFill>
+                  <a:srgbClr val="262626"/>
+                </a:solidFill>
+                <a:latin typeface="Bahij TheSansArabic Bold"/>
+                <a:cs typeface="Bahij TheSansArabic Bold"/>
+              </a:rPr>
+              <a:t>عند تحقيق أي زيادة عن الإيرادات المقدّرة يُخصَّص 12% من المقدّر</a:t>
+            </a:r>
+          </a:p>
+        </p:txBody>
+      </p:sp>
+      <p:sp>
+        <p:nvSpPr>
+          <p:cNvPr id="1008" name="Inc 1008"/>
+          <p:cNvSpPr/>
+          <p:nvPr/>
+        </p:nvSpPr>
+        <p:spPr>
+          <a:xfrm>
+            <a:off x="17100000" y="7600000"/>
+            <a:ext cx="6300000" cy="1600000"/>
+          </a:xfrm>
+          <a:prstGeom prst="roundRect">
+            <a:avLst>
+              <a:gd name="adj" fmla="val 12000"/>
+            </a:avLst>
+          </a:prstGeom>
+          <a:solidFill>
+            <a:srgbClr val="F2F8F8"/>
+          </a:solidFill>
+          <a:ln>
+            <a:noFill/>
+          </a:ln>
+        </p:spPr>
+        <p:txBody>
+          <a:bodyPr wrap="square" lIns="91440" rIns="91440" tIns="45720" bIns="45720" rtlCol="1" anchor="ctr">
+            <a:normAutofit/>
+          </a:bodyPr>
+          <a:lstStyle/>
+          <a:p>
+            <a:pPr algn="ctr" rtl="1">
+              <a:spcBef>
+                <a:spcPts val="0"/>
+              </a:spcBef>
+            </a:pPr>
+            <a:r>
+              <a:rPr lang="ar-SA" sz="6000" dirty="0">
+                <a:solidFill>
+                  <a:srgbClr val="01686A"/>
+                </a:solidFill>
+                <a:latin typeface="Bahij TheSansArabic Bold"/>
+                <a:cs typeface="Bahij TheSansArabic Bold"/>
+              </a:rPr>
+              <a:t>340.7</a:t>
+            </a:r>
+          </a:p>
+          <a:p>
+            <a:pPr algn="ctr" rtl="1">
+              <a:spcBef>
+                <a:spcPts val="0"/>
+              </a:spcBef>
+            </a:pPr>
+            <a:r>
+              <a:rPr lang="ar-SA" sz="2000" dirty="0">
+                <a:solidFill>
+                  <a:srgbClr val="595959"/>
+                </a:solidFill>
+                <a:latin typeface="Bahij TheSansArabic Plain"/>
+                <a:cs typeface="Bahij TheSansArabic Plain"/>
+              </a:rPr>
+              <a:t>مليون ريال</a:t>
+            </a:r>
+          </a:p>
+        </p:txBody>
+      </p:sp>
+      <p:sp>
+        <p:nvSpPr>
+          <p:cNvPr id="1009" name="Arrow 1009"/>
+          <p:cNvSpPr/>
+          <p:nvPr/>
+        </p:nvSpPr>
+        <p:spPr>
+          <a:xfrm>
+            <a:off x="15880000" y="7350000"/>
+            <a:ext cx="640000" cy="700000"/>
+          </a:xfrm>
+          <a:prstGeom prst="leftArrow">
+            <a:avLst/>
+          </a:prstGeom>
+          <a:solidFill>
+            <a:srgbClr val="00B050"/>
+          </a:solidFill>
+          <a:ln>
+            <a:noFill/>
+          </a:ln>
+        </p:spPr>
+        <p:txBody>
+          <a:bodyPr/>
+          <a:lstStyle/>
+          <a:p>
+            <a:endParaRPr lang="ar-SA"/>
+          </a:p>
+        </p:txBody>
+      </p:sp>
+      <p:sp>
+        <p:nvSpPr>
+          <p:cNvPr id="1010" name="Inc 1010"/>
+          <p:cNvSpPr/>
+          <p:nvPr/>
+        </p:nvSpPr>
+        <p:spPr>
+          <a:xfrm>
+            <a:off x="8640000" y="5950000"/>
+            <a:ext cx="7100000" cy="3500000"/>
+          </a:xfrm>
+          <a:prstGeom prst="roundRect">
+            <a:avLst>
+              <a:gd name="adj" fmla="val 8000"/>
+            </a:avLst>
+          </a:prstGeom>
+          <a:solidFill>
+            <a:srgbClr val="FFFFFF"/>
+          </a:solidFill>
+          <a:ln w="25400">
+            <a:solidFill>
+              <a:srgbClr val="01686A"/>
+            </a:solidFill>
+          </a:ln>
+          <a:effectLst>
+            <a:outerShdw blurRad="190500" dist="38100" dir="5400000" algn="t" rotWithShape="0">
+              <a:srgbClr val="000000">
+                <a:alpha val="18000"/>
+              </a:srgbClr>
+            </a:outerShdw>
+          </a:effectLst>
+        </p:spPr>
+        <p:txBody>
+          <a:bodyPr wrap="square" lIns="91440" rIns="91440" tIns="45720" bIns="45720" rtlCol="1" anchor="ctr">
+            <a:normAutofit/>
+          </a:bodyPr>
+          <a:lstStyle/>
+          <a:p>
+            <a:endParaRPr lang="ar-SA"/>
+          </a:p>
+        </p:txBody>
+      </p:sp>
+      <p:sp>
+        <p:nvSpPr>
+          <p:cNvPr id="1011" name="Inc 1011"/>
+          <p:cNvSpPr/>
+          <p:nvPr/>
+        </p:nvSpPr>
+        <p:spPr>
+          <a:xfrm>
+            <a:off x="14590000" y="6200000"/>
+            <a:ext cx="850000" cy="850000"/>
+          </a:xfrm>
+          <a:prstGeom prst="ellipse">
+            <a:avLst/>
+          </a:prstGeom>
+          <a:solidFill>
+            <a:srgbClr val="01686A"/>
+          </a:solidFill>
+          <a:ln>
+            <a:noFill/>
+          </a:ln>
+        </p:spPr>
+        <p:txBody>
+          <a:bodyPr wrap="square" lIns="91440" rIns="91440" tIns="45720" bIns="45720" rtlCol="1" anchor="ctr">
+            <a:normAutofit/>
+          </a:bodyPr>
+          <a:lstStyle/>
+          <a:p>
+            <a:pPr algn="ctr" rtl="1">
+              <a:spcBef>
+                <a:spcPts val="0"/>
+              </a:spcBef>
+            </a:pPr>
+            <a:r>
+              <a:rPr lang="ar-SA" sz="3200" dirty="0">
+                <a:solidFill>
+                  <a:srgbClr val="FFFFFF"/>
+                </a:solidFill>
+                <a:latin typeface="Bahij TheSansArabic Bold"/>
+                <a:cs typeface="Bahij TheSansArabic Bold"/>
+              </a:rPr>
+              <a:t>2</a:t>
+            </a:r>
+          </a:p>
+        </p:txBody>
+      </p:sp>
+      <p:sp>
+        <p:nvSpPr>
+          <p:cNvPr id="1012" name="Inc 1012"/>
+          <p:cNvSpPr/>
+          <p:nvPr/>
+        </p:nvSpPr>
+        <p:spPr>
+          <a:xfrm>
+            <a:off x="8890000" y="6130000"/>
+            <a:ext cx="5600000" cy="1250000"/>
+          </a:xfrm>
+          <a:prstGeom prst="roundRect">
+            <a:avLst>
+              <a:gd name="adj" fmla="val 8000"/>
+            </a:avLst>
+          </a:prstGeom>
+          <a:noFill/>
+          <a:ln>
+            <a:noFill/>
+          </a:ln>
+        </p:spPr>
+        <p:txBody>
+          <a:bodyPr wrap="square" lIns="91440" rIns="91440" tIns="45720" bIns="45720" rtlCol="1" anchor="ctr">
+            <a:normAutofit/>
+          </a:bodyPr>
+          <a:lstStyle/>
+          <a:p>
+            <a:pPr algn="r" rtl="1">
+              <a:spcBef>
+                <a:spcPts val="0"/>
+              </a:spcBef>
+            </a:pPr>
+            <a:r>
+              <a:rPr lang="ar-SA" sz="2200" dirty="0">
+                <a:solidFill>
+                  <a:srgbClr val="262626"/>
+                </a:solidFill>
+                <a:latin typeface="Bahij TheSansArabic Bold"/>
+                <a:cs typeface="Bahij TheSansArabic Bold"/>
+              </a:rPr>
+              <a:t>إجمالي الحوافز: 25% من مبلغ الـ12%</a:t>
+            </a:r>
+          </a:p>
+        </p:txBody>
+      </p:sp>
+      <p:sp>
+        <p:nvSpPr>
+          <p:cNvPr id="1013" name="Inc 1013"/>
+          <p:cNvSpPr/>
+          <p:nvPr/>
+        </p:nvSpPr>
+        <p:spPr>
+          <a:xfrm>
+            <a:off x="9040000" y="7600000"/>
+            <a:ext cx="6300000" cy="1600000"/>
+          </a:xfrm>
+          <a:prstGeom prst="roundRect">
+            <a:avLst>
+              <a:gd name="adj" fmla="val 12000"/>
+            </a:avLst>
+          </a:prstGeom>
+          <a:solidFill>
+            <a:srgbClr val="F2F8F8"/>
+          </a:solidFill>
+          <a:ln>
+            <a:noFill/>
+          </a:ln>
+        </p:spPr>
+        <p:txBody>
+          <a:bodyPr wrap="square" lIns="91440" rIns="91440" tIns="45720" bIns="45720" rtlCol="1" anchor="ctr">
+            <a:normAutofit/>
+          </a:bodyPr>
+          <a:lstStyle/>
+          <a:p>
+            <a:pPr algn="ctr" rtl="1">
+              <a:spcBef>
+                <a:spcPts val="0"/>
+              </a:spcBef>
+            </a:pPr>
+            <a:r>
+              <a:rPr lang="ar-SA" sz="6000" dirty="0">
+                <a:solidFill>
+                  <a:srgbClr val="01686A"/>
+                </a:solidFill>
+                <a:latin typeface="Bahij TheSansArabic Bold"/>
+                <a:cs typeface="Bahij TheSansArabic Bold"/>
+              </a:rPr>
+              <a:t>85.2</a:t>
+            </a:r>
+          </a:p>
+          <a:p>
+            <a:pPr algn="ctr" rtl="1">
+              <a:spcBef>
+                <a:spcPts val="0"/>
+              </a:spcBef>
+            </a:pPr>
+            <a:r>
+              <a:rPr lang="ar-SA" sz="2000" dirty="0">
+                <a:solidFill>
+                  <a:srgbClr val="595959"/>
+                </a:solidFill>
+                <a:latin typeface="Bahij TheSansArabic Plain"/>
+                <a:cs typeface="Bahij TheSansArabic Plain"/>
+              </a:rPr>
+              <a:t>مليون ريال</a:t>
+            </a:r>
+          </a:p>
+        </p:txBody>
+      </p:sp>
+      <p:sp>
+        <p:nvSpPr>
+          <p:cNvPr id="1014" name="Arrow 1014"/>
+          <p:cNvSpPr/>
+          <p:nvPr/>
+        </p:nvSpPr>
+        <p:spPr>
+          <a:xfrm>
+            <a:off x="7820000" y="7350000"/>
+            <a:ext cx="640000" cy="700000"/>
+          </a:xfrm>
+          <a:prstGeom prst="leftArrow">
+            <a:avLst/>
+          </a:prstGeom>
+          <a:solidFill>
+            <a:srgbClr val="00B050"/>
+          </a:solidFill>
+          <a:ln>
+            <a:noFill/>
+          </a:ln>
+        </p:spPr>
+        <p:txBody>
+          <a:bodyPr/>
+          <a:lstStyle/>
+          <a:p>
+            <a:endParaRPr lang="ar-SA"/>
+          </a:p>
+        </p:txBody>
+      </p:sp>
+      <p:sp>
+        <p:nvSpPr>
+          <p:cNvPr id="1015" name="Inc 1015"/>
+          <p:cNvSpPr/>
+          <p:nvPr/>
+        </p:nvSpPr>
+        <p:spPr>
+          <a:xfrm>
+            <a:off x="580000" y="5950000"/>
+            <a:ext cx="7100000" cy="3500000"/>
+          </a:xfrm>
+          <a:prstGeom prst="roundRect">
+            <a:avLst>
+              <a:gd name="adj" fmla="val 8000"/>
+            </a:avLst>
+          </a:prstGeom>
+          <a:solidFill>
+            <a:srgbClr val="FFFFFF"/>
+          </a:solidFill>
+          <a:ln w="25400">
+            <a:solidFill>
+              <a:srgbClr val="01686A"/>
+            </a:solidFill>
+          </a:ln>
+          <a:effectLst>
+            <a:outerShdw blurRad="190500" dist="38100" dir="5400000" algn="t" rotWithShape="0">
+              <a:srgbClr val="000000">
+                <a:alpha val="18000"/>
+              </a:srgbClr>
+            </a:outerShdw>
+          </a:effectLst>
+        </p:spPr>
+        <p:txBody>
+          <a:bodyPr wrap="square" lIns="91440" rIns="91440" tIns="45720" bIns="45720" rtlCol="1" anchor="ctr">
+            <a:normAutofit/>
+          </a:bodyPr>
+          <a:lstStyle/>
+          <a:p>
+            <a:endParaRPr lang="ar-SA"/>
+          </a:p>
+        </p:txBody>
+      </p:sp>
+      <p:sp>
+        <p:nvSpPr>
+          <p:cNvPr id="1016" name="Inc 1016"/>
+          <p:cNvSpPr/>
+          <p:nvPr/>
+        </p:nvSpPr>
+        <p:spPr>
+          <a:xfrm>
+            <a:off x="6530000" y="6200000"/>
+            <a:ext cx="850000" cy="850000"/>
+          </a:xfrm>
+          <a:prstGeom prst="ellipse">
+            <a:avLst/>
+          </a:prstGeom>
+          <a:solidFill>
+            <a:srgbClr val="01686A"/>
+          </a:solidFill>
+          <a:ln>
+            <a:noFill/>
+          </a:ln>
+        </p:spPr>
+        <p:txBody>
+          <a:bodyPr wrap="square" lIns="91440" rIns="91440" tIns="45720" bIns="45720" rtlCol="1" anchor="ctr">
+            <a:normAutofit/>
+          </a:bodyPr>
+          <a:lstStyle/>
+          <a:p>
+            <a:pPr algn="ctr" rtl="1">
+              <a:spcBef>
+                <a:spcPts val="0"/>
+              </a:spcBef>
+            </a:pPr>
+            <a:r>
+              <a:rPr lang="ar-SA" sz="3200" dirty="0">
+                <a:solidFill>
+                  <a:srgbClr val="FFFFFF"/>
+                </a:solidFill>
+                <a:latin typeface="Bahij TheSansArabic Bold"/>
+                <a:cs typeface="Bahij TheSansArabic Bold"/>
+              </a:rPr>
+              <a:t>3</a:t>
+            </a:r>
+          </a:p>
+        </p:txBody>
+      </p:sp>
+      <p:sp>
+        <p:nvSpPr>
+          <p:cNvPr id="1017" name="Inc 1017"/>
+          <p:cNvSpPr/>
+          <p:nvPr/>
+        </p:nvSpPr>
+        <p:spPr>
+          <a:xfrm>
+            <a:off x="830000" y="6130000"/>
+            <a:ext cx="5600000" cy="1250000"/>
+          </a:xfrm>
+          <a:prstGeom prst="roundRect">
+            <a:avLst>
+              <a:gd name="adj" fmla="val 8000"/>
+            </a:avLst>
+          </a:prstGeom>
+          <a:noFill/>
+          <a:ln>
+            <a:noFill/>
+          </a:ln>
+        </p:spPr>
+        <p:txBody>
+          <a:bodyPr wrap="square" lIns="91440" rIns="91440" tIns="45720" bIns="45720" rtlCol="1" anchor="ctr">
+            <a:normAutofit/>
+          </a:bodyPr>
+          <a:lstStyle/>
+          <a:p>
+            <a:pPr algn="r" rtl="1">
+              <a:spcBef>
+                <a:spcPts val="0"/>
+              </a:spcBef>
+            </a:pPr>
+            <a:r>
+              <a:rPr lang="ar-SA" sz="2200" dirty="0">
+                <a:solidFill>
+                  <a:srgbClr val="262626"/>
+                </a:solidFill>
+                <a:latin typeface="Bahij TheSansArabic Bold"/>
+                <a:cs typeface="Bahij TheSansArabic Bold"/>
+              </a:rPr>
+              <a:t>حوافز الموظفين: 40% من إجمالي الحوافز</a:t>
+            </a:r>
+          </a:p>
+        </p:txBody>
+      </p:sp>
+      <p:sp>
+        <p:nvSpPr>
+          <p:cNvPr id="1018" name="Inc 1018"/>
+          <p:cNvSpPr/>
+          <p:nvPr/>
+        </p:nvSpPr>
+        <p:spPr>
+          <a:xfrm>
+            <a:off x="980000" y="7600000"/>
+            <a:ext cx="6300000" cy="1600000"/>
+          </a:xfrm>
+          <a:prstGeom prst="roundRect">
+            <a:avLst>
+              <a:gd name="adj" fmla="val 12000"/>
+            </a:avLst>
+          </a:prstGeom>
+          <a:solidFill>
+            <a:srgbClr val="F2F8F8"/>
+          </a:solidFill>
+          <a:ln>
+            <a:noFill/>
+          </a:ln>
+        </p:spPr>
+        <p:txBody>
+          <a:bodyPr wrap="square" lIns="91440" rIns="91440" tIns="45720" bIns="45720" rtlCol="1" anchor="ctr">
+            <a:normAutofit/>
+          </a:bodyPr>
+          <a:lstStyle/>
+          <a:p>
+            <a:pPr algn="ctr" rtl="1">
+              <a:spcBef>
+                <a:spcPts val="0"/>
+              </a:spcBef>
+            </a:pPr>
+            <a:r>
+              <a:rPr lang="ar-SA" sz="6000" dirty="0">
+                <a:solidFill>
+                  <a:srgbClr val="01686A"/>
+                </a:solidFill>
+                <a:latin typeface="Bahij TheSansArabic Bold"/>
+                <a:cs typeface="Bahij TheSansArabic Bold"/>
+              </a:rPr>
+              <a:t>34.1</a:t>
+            </a:r>
+          </a:p>
+          <a:p>
+            <a:pPr algn="ctr" rtl="1">
+              <a:spcBef>
+                <a:spcPts val="0"/>
+              </a:spcBef>
+            </a:pPr>
+            <a:r>
+              <a:rPr lang="ar-SA" sz="2000" dirty="0">
+                <a:solidFill>
+                  <a:srgbClr val="595959"/>
+                </a:solidFill>
+                <a:latin typeface="Bahij TheSansArabic Plain"/>
+                <a:cs typeface="Bahij TheSansArabic Plain"/>
+              </a:rPr>
+              <a:t>مليون ريال</a:t>
+            </a:r>
+          </a:p>
+        </p:txBody>
+      </p:sp>
+      <p:sp>
+        <p:nvSpPr>
+          <p:cNvPr id="1019" name="Inc 1019"/>
+          <p:cNvSpPr/>
+          <p:nvPr/>
+        </p:nvSpPr>
+        <p:spPr>
+          <a:xfrm>
+            <a:off x="580000" y="9900000"/>
+            <a:ext cx="23220000" cy="2580000"/>
+          </a:xfrm>
+          <a:prstGeom prst="roundRect">
+            <a:avLst>
+              <a:gd name="adj" fmla="val 8000"/>
+            </a:avLst>
+          </a:prstGeom>
+          <a:solidFill>
+            <a:srgbClr val="01686A"/>
+          </a:solidFill>
+          <a:ln>
+            <a:noFill/>
+          </a:ln>
+          <a:effectLst>
+            <a:outerShdw blurRad="190500" dist="38100" dir="5400000" algn="t" rotWithShape="0">
+              <a:srgbClr val="000000">
+                <a:alpha val="18000"/>
+              </a:srgbClr>
+            </a:outerShdw>
+          </a:effectLst>
+        </p:spPr>
+        <p:txBody>
+          <a:bodyPr wrap="square" lIns="91440" rIns="91440" tIns="45720" bIns="45720" rtlCol="1" anchor="ctr">
+            <a:normAutofit/>
+          </a:bodyPr>
+          <a:lstStyle/>
+          <a:p>
+            <a:pPr algn="ctr" rtl="1">
+              <a:spcBef>
+                <a:spcPts val="0"/>
+              </a:spcBef>
+            </a:pPr>
+            <a:r>
+              <a:rPr lang="ar-SA" sz="3600" dirty="0">
+                <a:solidFill>
+                  <a:srgbClr val="FFFFFF"/>
+                </a:solidFill>
+                <a:latin typeface="Bahij TheSansArabic Bold"/>
+                <a:cs typeface="Bahij TheSansArabic Bold"/>
+              </a:rPr>
+              <a:t>حوافز الموظفين</a:t>
+            </a:r>
+          </a:p>
+          <a:p>
+            <a:pPr algn="ctr" rtl="1">
+              <a:spcBef>
+                <a:spcPts val="0"/>
+              </a:spcBef>
+            </a:pPr>
+            <a:r>
+              <a:rPr lang="ar-SA" sz="10000" dirty="0">
+                <a:solidFill>
+                  <a:srgbClr val="FFFFFF"/>
+                </a:solidFill>
+                <a:latin typeface="Bahij TheSansArabic Bold"/>
+                <a:cs typeface="Bahij TheSansArabic Bold"/>
+              </a:rPr>
+              <a:t>34.1</a:t>
+            </a:r>
+          </a:p>
+          <a:p>
+            <a:pPr algn="ctr" rtl="1">
+              <a:spcBef>
+                <a:spcPts val="0"/>
+              </a:spcBef>
+            </a:pPr>
+            <a:r>
+              <a:rPr lang="ar-SA" sz="2200" dirty="0">
+                <a:solidFill>
+                  <a:srgbClr val="E2F0D9"/>
+                </a:solidFill>
+                <a:latin typeface="Bahij TheSansArabic Plain"/>
+                <a:cs typeface="Bahij TheSansArabic Plain"/>
+              </a:rPr>
+              <a:t>مليون ريال  —  40% من إجمالي الحوافز</a:t>
+            </a:r>
+          </a:p>
+        </p:txBody>
+      </p:sp>
+    </p:spTree>
+    <p:extLst>
+      <p:ext uri="{BB962C8B-B14F-4D97-AF65-F5344CB8AC3E}">
+        <p14:creationId xmlns:p14="http://schemas.microsoft.com/office/powerpoint/2010/main" val="2964614212"/>
+      </p:ext>
+    </p:extLst>
+  </p:cSld>
+  <p:clrMapOvr>
+    <a:masterClrMapping/>
+  </p:clrMapOvr>
+</p:sld>
+</file>
+
+<file path=ppt/slides/slide6.xml><?xml version="1.0" encoding="utf-8"?>
+<p:sld xmlns:a="http://schemas.openxmlformats.org/drawingml/2006/main" xmlns:r="http://schemas.openxmlformats.org/officeDocument/2006/relationships" xmlns:p="http://schemas.openxmlformats.org/presentationml/2006/main">
+  <p:cSld>
+    <p:spTree>
+      <p:nvGrpSpPr>
+        <p:cNvPr id="1" name="">
+          <a:extLst>
+            <a:ext uri="{FF2B5EF4-FFF2-40B4-BE49-F238E27FC236}">
+              <a16:creationId xmlns:a16="http://schemas.microsoft.com/office/drawing/2014/main" id="{1188DBA1-EB05-F5A5-81C7-676B509E2F15}"/>
+            </a:ext>
+          </a:extLst>
+        </p:cNvPr>
+        <p:cNvGrpSpPr/>
+        <p:nvPr/>
+      </p:nvGrpSpPr>
+      <p:grpSpPr>
+        <a:xfrm>
+          <a:off x="0" y="0"/>
+          <a:ext cx="0" cy="0"/>
+          <a:chOff x="0" y="0"/>
+          <a:chExt cx="0" cy="0"/>
+        </a:xfrm>
+      </p:grpSpPr>
+      <p:sp>
+        <p:nvSpPr>
+          <p:cNvPr id="28" name="Rectangle 27">
+            <a:extLst>
+              <a:ext uri="{FF2B5EF4-FFF2-40B4-BE49-F238E27FC236}">
+                <a16:creationId xmlns:a16="http://schemas.microsoft.com/office/drawing/2014/main" id="{721FCA79-B689-3E5C-ED9B-34B1063C05B4}"/>
+              </a:ext>
+            </a:extLst>
+          </p:cNvPr>
+          <p:cNvSpPr/>
+          <p:nvPr/>
+        </p:nvSpPr>
+        <p:spPr>
+          <a:xfrm>
+            <a:off x="115617" y="2279209"/>
+            <a:ext cx="24020043" cy="10406156"/>
+          </a:xfrm>
+          <a:prstGeom prst="rect">
+            <a:avLst/>
+          </a:prstGeom>
+          <a:solidFill>
+            <a:srgbClr val="F5F5F5"/>
+          </a:solidFill>
+          <a:ln>
+            <a:solidFill>
+              <a:schemeClr val="bg1">
+                <a:lumMod val="85000"/>
+              </a:schemeClr>
+            </a:solidFill>
+          </a:ln>
+        </p:spPr>
+        <p:style>
+          <a:lnRef idx="2">
+            <a:schemeClr val="accent1">
+              <a:shade val="15000"/>
+            </a:schemeClr>
+          </a:lnRef>
+          <a:fillRef idx="1">
+            <a:schemeClr val="accent1"/>
+          </a:fillRef>
+          <a:effectRef idx="0">
+            <a:schemeClr val="accent1"/>
+          </a:effectRef>
+          <a:fontRef idx="minor">
+            <a:schemeClr val="lt1"/>
+          </a:fontRef>
+        </p:style>
+        <p:txBody>
+          <a:bodyPr rtlCol="0" anchor="ctr"/>
+          <a:lstStyle/>
+          <a:p>
+            <a:pPr algn="ctr"/>
+            <a:endParaRPr lang="en-US"/>
+          </a:p>
+        </p:txBody>
+      </p:sp>
+      <p:grpSp>
+        <p:nvGrpSpPr>
+          <p:cNvPr id="4" name="Group 3">
+            <a:extLst>
+              <a:ext uri="{FF2B5EF4-FFF2-40B4-BE49-F238E27FC236}">
+                <a16:creationId xmlns:a16="http://schemas.microsoft.com/office/drawing/2014/main" id="{B1AA1666-FA68-0FBD-24A5-DBD7AE6470F6}"/>
+              </a:ext>
+            </a:extLst>
+          </p:cNvPr>
+          <p:cNvGrpSpPr/>
+          <p:nvPr/>
+        </p:nvGrpSpPr>
+        <p:grpSpPr>
+          <a:xfrm>
+            <a:off x="6688186" y="263023"/>
+            <a:ext cx="17695824" cy="799889"/>
+            <a:chOff x="6897658" y="1223860"/>
+            <a:chExt cx="5473691" cy="430888"/>
+          </a:xfrm>
+        </p:grpSpPr>
+        <p:grpSp>
+          <p:nvGrpSpPr>
+            <p:cNvPr id="13" name="Group 12">
+              <a:extLst>
+                <a:ext uri="{FF2B5EF4-FFF2-40B4-BE49-F238E27FC236}">
+                  <a16:creationId xmlns:a16="http://schemas.microsoft.com/office/drawing/2014/main" id="{B077B9B0-E000-558F-4C96-FDDA0EC5B271}"/>
+                </a:ext>
+              </a:extLst>
+            </p:cNvPr>
+            <p:cNvGrpSpPr/>
+            <p:nvPr/>
+          </p:nvGrpSpPr>
+          <p:grpSpPr>
+            <a:xfrm>
+              <a:off x="6897658" y="1223860"/>
+              <a:ext cx="5473691" cy="430888"/>
+              <a:chOff x="1533984" y="1062731"/>
+              <a:chExt cx="10852794" cy="854330"/>
+            </a:xfrm>
+          </p:grpSpPr>
+          <p:sp>
+            <p:nvSpPr>
+              <p:cNvPr id="14" name="Freeform 13">
+                <a:extLst>
+                  <a:ext uri="{FF2B5EF4-FFF2-40B4-BE49-F238E27FC236}">
+                    <a16:creationId xmlns:a16="http://schemas.microsoft.com/office/drawing/2014/main" id="{43AEBF43-D85C-E14A-311F-917168516D90}"/>
+                  </a:ext>
+                </a:extLst>
+              </p:cNvPr>
+              <p:cNvSpPr/>
+              <p:nvPr/>
+            </p:nvSpPr>
+            <p:spPr>
+              <a:xfrm>
+                <a:off x="4893052" y="1072296"/>
+                <a:ext cx="7493726" cy="844765"/>
+              </a:xfrm>
+              <a:custGeom>
+                <a:avLst/>
+                <a:gdLst>
+                  <a:gd name="connsiteX0" fmla="*/ 7493726 w 7493726"/>
+                  <a:gd name="connsiteY0" fmla="*/ 0 h 844765"/>
+                  <a:gd name="connsiteX1" fmla="*/ 7493726 w 7493726"/>
+                  <a:gd name="connsiteY1" fmla="*/ 844765 h 844765"/>
+                  <a:gd name="connsiteX2" fmla="*/ 0 w 7493726"/>
+                  <a:gd name="connsiteY2" fmla="*/ 836298 h 844765"/>
+                  <a:gd name="connsiteX3" fmla="*/ 508000 w 7493726"/>
+                  <a:gd name="connsiteY3" fmla="*/ 16933 h 844765"/>
+                  <a:gd name="connsiteX4" fmla="*/ 7493726 w 7493726"/>
+                  <a:gd name="connsiteY4" fmla="*/ 0 h 844765"/>
+                  <a:gd name="connsiteX5" fmla="*/ 690975 w 7493726"/>
+                  <a:gd name="connsiteY5" fmla="*/ 105483 h 844765"/>
+                  <a:gd name="connsiteX6" fmla="*/ 563975 w 7493726"/>
+                  <a:gd name="connsiteY6" fmla="*/ 319779 h 844765"/>
+                  <a:gd name="connsiteX7" fmla="*/ 817975 w 7493726"/>
+                  <a:gd name="connsiteY7" fmla="*/ 319779 h 844765"/>
+                  <a:gd name="connsiteX8" fmla="*/ 690975 w 7493726"/>
+                  <a:gd name="connsiteY8" fmla="*/ 105483 h 844765"/>
+                  <a:gd name="connsiteX9" fmla="*/ 256198 w 7493726"/>
+                  <a:gd name="connsiteY9" fmla="*/ 515369 h 844765"/>
+                  <a:gd name="connsiteX10" fmla="*/ 383198 w 7493726"/>
+                  <a:gd name="connsiteY10" fmla="*/ 729665 h 844765"/>
+                  <a:gd name="connsiteX11" fmla="*/ 510198 w 7493726"/>
+                  <a:gd name="connsiteY11" fmla="*/ 515369 h 844765"/>
+                  <a:gd name="connsiteX12" fmla="*/ 256198 w 7493726"/>
+                  <a:gd name="connsiteY12" fmla="*/ 515369 h 844765"/>
+                </a:gdLst>
+                <a:ahLst/>
+                <a:cxnLst>
+                  <a:cxn ang="0">
+                    <a:pos x="connsiteX0" y="connsiteY0"/>
+                  </a:cxn>
+                  <a:cxn ang="0">
+                    <a:pos x="connsiteX1" y="connsiteY1"/>
+                  </a:cxn>
+                  <a:cxn ang="0">
+                    <a:pos x="connsiteX2" y="connsiteY2"/>
+                  </a:cxn>
+                  <a:cxn ang="0">
+                    <a:pos x="connsiteX3" y="connsiteY3"/>
+                  </a:cxn>
+                  <a:cxn ang="0">
+                    <a:pos x="connsiteX4" y="connsiteY4"/>
+                  </a:cxn>
+                  <a:cxn ang="0">
+                    <a:pos x="connsiteX5" y="connsiteY5"/>
+                  </a:cxn>
+                  <a:cxn ang="0">
+                    <a:pos x="connsiteX6" y="connsiteY6"/>
+                  </a:cxn>
+                  <a:cxn ang="0">
+                    <a:pos x="connsiteX7" y="connsiteY7"/>
+                  </a:cxn>
+                  <a:cxn ang="0">
+                    <a:pos x="connsiteX8" y="connsiteY8"/>
+                  </a:cxn>
+                  <a:cxn ang="0">
+                    <a:pos x="connsiteX9" y="connsiteY9"/>
+                  </a:cxn>
+                  <a:cxn ang="0">
+                    <a:pos x="connsiteX10" y="connsiteY10"/>
+                  </a:cxn>
+                  <a:cxn ang="0">
+                    <a:pos x="connsiteX11" y="connsiteY11"/>
+                  </a:cxn>
+                  <a:cxn ang="0">
+                    <a:pos x="connsiteX12" y="connsiteY12"/>
+                  </a:cxn>
+                </a:cxnLst>
+                <a:rect l="l" t="t" r="r" b="b"/>
+                <a:pathLst>
+                  <a:path w="7493726" h="844765">
+                    <a:moveTo>
+                      <a:pt x="7493726" y="0"/>
+                    </a:moveTo>
+                    <a:lnTo>
+                      <a:pt x="7493726" y="844765"/>
+                    </a:lnTo>
+                    <a:lnTo>
+                      <a:pt x="0" y="836298"/>
+                    </a:lnTo>
+                    <a:lnTo>
+                      <a:pt x="508000" y="16933"/>
+                    </a:lnTo>
+                    <a:lnTo>
+                      <a:pt x="7493726" y="0"/>
+                    </a:lnTo>
+                    <a:close/>
+                    <a:moveTo>
+                      <a:pt x="690975" y="105483"/>
+                    </a:moveTo>
+                    <a:lnTo>
+                      <a:pt x="563975" y="319779"/>
+                    </a:lnTo>
+                    <a:lnTo>
+                      <a:pt x="817975" y="319779"/>
+                    </a:lnTo>
+                    <a:lnTo>
+                      <a:pt x="690975" y="105483"/>
+                    </a:lnTo>
+                    <a:close/>
+                    <a:moveTo>
+                      <a:pt x="256198" y="515369"/>
+                    </a:moveTo>
+                    <a:lnTo>
+                      <a:pt x="383198" y="729665"/>
+                    </a:lnTo>
+                    <a:lnTo>
+                      <a:pt x="510198" y="515369"/>
+                    </a:lnTo>
+                    <a:lnTo>
+                      <a:pt x="256198" y="515369"/>
+                    </a:lnTo>
+                    <a:close/>
+                  </a:path>
+                </a:pathLst>
+              </a:custGeom>
+              <a:solidFill>
+                <a:srgbClr val="106946"/>
+              </a:solidFill>
+              <a:ln>
+                <a:noFill/>
+              </a:ln>
+            </p:spPr>
+            <p:style>
+              <a:lnRef idx="2">
+                <a:schemeClr val="accent1">
+                  <a:shade val="15000"/>
+                </a:schemeClr>
+              </a:lnRef>
+              <a:fillRef idx="1">
+                <a:schemeClr val="accent1"/>
+              </a:fillRef>
+              <a:effectRef idx="0">
+                <a:schemeClr val="accent1"/>
+              </a:effectRef>
+              <a:fontRef idx="minor">
+                <a:schemeClr val="lt1"/>
+              </a:fontRef>
+            </p:style>
+            <p:txBody>
+              <a:bodyPr wrap="square" rtlCol="0" anchor="ctr">
+                <a:noAutofit/>
+              </a:bodyPr>
+              <a:lstStyle/>
+              <a:p>
+                <a:pPr algn="ctr"/>
+                <a:endParaRPr lang="en-LB" sz="3608"/>
+              </a:p>
+            </p:txBody>
+          </p:sp>
+          <p:sp>
+            <p:nvSpPr>
+              <p:cNvPr id="15" name="Triangle 14">
+                <a:extLst>
+                  <a:ext uri="{FF2B5EF4-FFF2-40B4-BE49-F238E27FC236}">
+                    <a16:creationId xmlns:a16="http://schemas.microsoft.com/office/drawing/2014/main" id="{971A2D07-8145-90A5-B6CC-2651DCC71C78}"/>
+                  </a:ext>
+                </a:extLst>
+              </p:cNvPr>
+              <p:cNvSpPr/>
+              <p:nvPr/>
+            </p:nvSpPr>
+            <p:spPr>
+              <a:xfrm>
+                <a:off x="4703493" y="1177779"/>
+                <a:ext cx="254000" cy="214296"/>
+              </a:xfrm>
+              <a:prstGeom prst="triangle">
+                <a:avLst/>
+              </a:prstGeom>
+              <a:solidFill>
+                <a:srgbClr val="106946"/>
+              </a:solidFill>
+              <a:ln>
+                <a:noFill/>
+              </a:ln>
+            </p:spPr>
+            <p:style>
+              <a:lnRef idx="2">
+                <a:schemeClr val="accent1">
+                  <a:shade val="15000"/>
+                </a:schemeClr>
+              </a:lnRef>
+              <a:fillRef idx="1">
+                <a:schemeClr val="accent1"/>
+              </a:fillRef>
+              <a:effectRef idx="0">
+                <a:schemeClr val="accent1"/>
+              </a:effectRef>
+              <a:fontRef idx="minor">
+                <a:schemeClr val="lt1"/>
+              </a:fontRef>
+            </p:style>
+            <p:txBody>
+              <a:bodyPr rtlCol="0" anchor="ctr"/>
+              <a:lstStyle/>
+              <a:p>
+                <a:pPr algn="ctr"/>
+                <a:endParaRPr lang="en-LB" sz="3608"/>
+              </a:p>
+            </p:txBody>
+          </p:sp>
+          <p:sp>
+            <p:nvSpPr>
+              <p:cNvPr id="16" name="Triangle 15">
+                <a:extLst>
+                  <a:ext uri="{FF2B5EF4-FFF2-40B4-BE49-F238E27FC236}">
+                    <a16:creationId xmlns:a16="http://schemas.microsoft.com/office/drawing/2014/main" id="{A3A0A86C-7A03-6BE9-10B4-6C131016B2A1}"/>
+                  </a:ext>
+                </a:extLst>
+              </p:cNvPr>
+              <p:cNvSpPr/>
+              <p:nvPr/>
+            </p:nvSpPr>
+            <p:spPr>
+              <a:xfrm>
+                <a:off x="3535093" y="1177779"/>
+                <a:ext cx="254000" cy="214296"/>
+              </a:xfrm>
+              <a:prstGeom prst="triangle">
+                <a:avLst/>
+              </a:prstGeom>
+              <a:solidFill>
+                <a:srgbClr val="106946"/>
+              </a:solidFill>
+              <a:ln>
+                <a:noFill/>
+              </a:ln>
+            </p:spPr>
+            <p:style>
+              <a:lnRef idx="2">
+                <a:schemeClr val="accent1">
+                  <a:shade val="15000"/>
+                </a:schemeClr>
+              </a:lnRef>
+              <a:fillRef idx="1">
+                <a:schemeClr val="accent1"/>
+              </a:fillRef>
+              <a:effectRef idx="0">
+                <a:schemeClr val="accent1"/>
+              </a:effectRef>
+              <a:fontRef idx="minor">
+                <a:schemeClr val="lt1"/>
+              </a:fontRef>
+            </p:style>
+            <p:txBody>
+              <a:bodyPr rtlCol="0" anchor="ctr"/>
+              <a:lstStyle/>
+              <a:p>
+                <a:pPr algn="ctr"/>
+                <a:endParaRPr lang="en-LB" sz="3608"/>
+              </a:p>
+            </p:txBody>
+          </p:sp>
+          <p:sp>
+            <p:nvSpPr>
+              <p:cNvPr id="17" name="Triangle 16">
+                <a:extLst>
+                  <a:ext uri="{FF2B5EF4-FFF2-40B4-BE49-F238E27FC236}">
+                    <a16:creationId xmlns:a16="http://schemas.microsoft.com/office/drawing/2014/main" id="{60505BCC-68E6-C3E2-1E15-4B0D96BCFC05}"/>
+                  </a:ext>
+                </a:extLst>
+              </p:cNvPr>
+              <p:cNvSpPr/>
+              <p:nvPr/>
+            </p:nvSpPr>
+            <p:spPr>
+              <a:xfrm>
+                <a:off x="2375160" y="1177779"/>
+                <a:ext cx="254000" cy="214296"/>
+              </a:xfrm>
+              <a:prstGeom prst="triangle">
+                <a:avLst/>
+              </a:prstGeom>
+              <a:solidFill>
+                <a:srgbClr val="106946"/>
+              </a:solidFill>
+              <a:ln>
+                <a:noFill/>
+              </a:ln>
+            </p:spPr>
+            <p:style>
+              <a:lnRef idx="2">
+                <a:schemeClr val="accent1">
+                  <a:shade val="15000"/>
+                </a:schemeClr>
+              </a:lnRef>
+              <a:fillRef idx="1">
+                <a:schemeClr val="accent1"/>
+              </a:fillRef>
+              <a:effectRef idx="0">
+                <a:schemeClr val="accent1"/>
+              </a:effectRef>
+              <a:fontRef idx="minor">
+                <a:schemeClr val="lt1"/>
+              </a:fontRef>
+            </p:style>
+            <p:txBody>
+              <a:bodyPr rtlCol="0" anchor="ctr"/>
+              <a:lstStyle/>
+              <a:p>
+                <a:pPr algn="ctr"/>
+                <a:endParaRPr lang="en-LB" sz="3608"/>
+              </a:p>
+            </p:txBody>
+          </p:sp>
+          <p:sp>
+            <p:nvSpPr>
+              <p:cNvPr id="18" name="Triangle 17">
+                <a:extLst>
+                  <a:ext uri="{FF2B5EF4-FFF2-40B4-BE49-F238E27FC236}">
+                    <a16:creationId xmlns:a16="http://schemas.microsoft.com/office/drawing/2014/main" id="{5F9BEA0D-604B-CEF5-3C7B-DBBB37AD871C}"/>
+                  </a:ext>
+                </a:extLst>
+              </p:cNvPr>
+              <p:cNvSpPr/>
+              <p:nvPr/>
+            </p:nvSpPr>
+            <p:spPr>
+              <a:xfrm rot="10800000">
+                <a:off x="4404184" y="1587665"/>
+                <a:ext cx="254000" cy="214296"/>
+              </a:xfrm>
+              <a:prstGeom prst="triangle">
+                <a:avLst/>
+              </a:prstGeom>
+              <a:solidFill>
+                <a:srgbClr val="106946"/>
+              </a:solidFill>
+              <a:ln>
+                <a:noFill/>
+              </a:ln>
+            </p:spPr>
+            <p:style>
+              <a:lnRef idx="2">
+                <a:schemeClr val="accent1">
+                  <a:shade val="15000"/>
+                </a:schemeClr>
+              </a:lnRef>
+              <a:fillRef idx="1">
+                <a:schemeClr val="accent1"/>
+              </a:fillRef>
+              <a:effectRef idx="0">
+                <a:schemeClr val="accent1"/>
+              </a:effectRef>
+              <a:fontRef idx="minor">
+                <a:schemeClr val="lt1"/>
+              </a:fontRef>
+            </p:style>
+            <p:txBody>
+              <a:bodyPr rtlCol="0" anchor="ctr"/>
+              <a:lstStyle/>
+              <a:p>
+                <a:pPr algn="ctr"/>
+                <a:endParaRPr lang="en-LB" sz="3608"/>
+              </a:p>
+            </p:txBody>
+          </p:sp>
+          <p:sp>
+            <p:nvSpPr>
+              <p:cNvPr id="19" name="Triangle 18">
+                <a:extLst>
+                  <a:ext uri="{FF2B5EF4-FFF2-40B4-BE49-F238E27FC236}">
+                    <a16:creationId xmlns:a16="http://schemas.microsoft.com/office/drawing/2014/main" id="{5EA82A37-70C7-5527-5353-42652B1479D9}"/>
+                  </a:ext>
+                </a:extLst>
+              </p:cNvPr>
+              <p:cNvSpPr/>
+              <p:nvPr/>
+            </p:nvSpPr>
+            <p:spPr>
+              <a:xfrm rot="10800000">
+                <a:off x="2660051" y="1587665"/>
+                <a:ext cx="254000" cy="214296"/>
+              </a:xfrm>
+              <a:prstGeom prst="triangle">
+                <a:avLst/>
+              </a:prstGeom>
+              <a:solidFill>
+                <a:srgbClr val="106946"/>
+              </a:solidFill>
+              <a:ln>
+                <a:noFill/>
+              </a:ln>
+            </p:spPr>
+            <p:style>
+              <a:lnRef idx="2">
+                <a:schemeClr val="accent1">
+                  <a:shade val="15000"/>
+                </a:schemeClr>
+              </a:lnRef>
+              <a:fillRef idx="1">
+                <a:schemeClr val="accent1"/>
+              </a:fillRef>
+              <a:effectRef idx="0">
+                <a:schemeClr val="accent1"/>
+              </a:effectRef>
+              <a:fontRef idx="minor">
+                <a:schemeClr val="lt1"/>
+              </a:fontRef>
+            </p:style>
+            <p:txBody>
+              <a:bodyPr rtlCol="0" anchor="ctr"/>
+              <a:lstStyle/>
+              <a:p>
+                <a:pPr algn="ctr"/>
+                <a:endParaRPr lang="en-LB" sz="3608"/>
+              </a:p>
+            </p:txBody>
+          </p:sp>
+          <p:sp>
+            <p:nvSpPr>
+              <p:cNvPr id="20" name="Triangle 19">
+                <a:extLst>
+                  <a:ext uri="{FF2B5EF4-FFF2-40B4-BE49-F238E27FC236}">
+                    <a16:creationId xmlns:a16="http://schemas.microsoft.com/office/drawing/2014/main" id="{F97C3E02-72F4-6D04-133C-A0DFEDBD3441}"/>
+                  </a:ext>
+                </a:extLst>
+              </p:cNvPr>
+              <p:cNvSpPr/>
+              <p:nvPr/>
+            </p:nvSpPr>
+            <p:spPr>
+              <a:xfrm rot="10800000">
+                <a:off x="1533984" y="1587665"/>
+                <a:ext cx="254000" cy="214296"/>
+              </a:xfrm>
+              <a:prstGeom prst="triangle">
+                <a:avLst/>
+              </a:prstGeom>
+              <a:solidFill>
+                <a:srgbClr val="106946"/>
+              </a:solidFill>
+              <a:ln>
+                <a:noFill/>
+              </a:ln>
+            </p:spPr>
+            <p:style>
+              <a:lnRef idx="2">
+                <a:schemeClr val="accent1">
+                  <a:shade val="15000"/>
+                </a:schemeClr>
+              </a:lnRef>
+              <a:fillRef idx="1">
+                <a:schemeClr val="accent1"/>
+              </a:fillRef>
+              <a:effectRef idx="0">
+                <a:schemeClr val="accent1"/>
+              </a:effectRef>
+              <a:fontRef idx="minor">
+                <a:schemeClr val="lt1"/>
+              </a:fontRef>
+            </p:style>
+            <p:txBody>
+              <a:bodyPr rtlCol="0" anchor="ctr"/>
+              <a:lstStyle/>
+              <a:p>
+                <a:pPr algn="ctr"/>
+                <a:endParaRPr lang="en-LB" sz="3608"/>
+              </a:p>
+            </p:txBody>
+          </p:sp>
+          <p:sp>
+            <p:nvSpPr>
+              <p:cNvPr id="21" name="Triangle 20">
+                <a:extLst>
+                  <a:ext uri="{FF2B5EF4-FFF2-40B4-BE49-F238E27FC236}">
+                    <a16:creationId xmlns:a16="http://schemas.microsoft.com/office/drawing/2014/main" id="{6682F398-CA34-8C50-5EB0-7A89436F0811}"/>
+                  </a:ext>
+                </a:extLst>
+              </p:cNvPr>
+              <p:cNvSpPr/>
+              <p:nvPr/>
+            </p:nvSpPr>
+            <p:spPr>
+              <a:xfrm>
+                <a:off x="2900093" y="1685779"/>
+                <a:ext cx="254000" cy="214296"/>
+              </a:xfrm>
+              <a:prstGeom prst="triangle">
+                <a:avLst/>
+              </a:prstGeom>
+              <a:solidFill>
+                <a:srgbClr val="106946"/>
+              </a:solidFill>
+              <a:ln>
+                <a:noFill/>
+              </a:ln>
+            </p:spPr>
+            <p:style>
+              <a:lnRef idx="2">
+                <a:schemeClr val="accent1">
+                  <a:shade val="15000"/>
+                </a:schemeClr>
+              </a:lnRef>
+              <a:fillRef idx="1">
+                <a:schemeClr val="accent1"/>
+              </a:fillRef>
+              <a:effectRef idx="0">
+                <a:schemeClr val="accent1"/>
+              </a:effectRef>
+              <a:fontRef idx="minor">
+                <a:schemeClr val="lt1"/>
+              </a:fontRef>
+            </p:style>
+            <p:txBody>
+              <a:bodyPr rtlCol="0" anchor="ctr"/>
+              <a:lstStyle/>
+              <a:p>
+                <a:pPr algn="ctr"/>
+                <a:endParaRPr lang="en-LB" sz="3608"/>
+              </a:p>
+            </p:txBody>
+          </p:sp>
+          <p:sp>
+            <p:nvSpPr>
+              <p:cNvPr id="22" name="Triangle 21">
+                <a:extLst>
+                  <a:ext uri="{FF2B5EF4-FFF2-40B4-BE49-F238E27FC236}">
+                    <a16:creationId xmlns:a16="http://schemas.microsoft.com/office/drawing/2014/main" id="{724B218E-B970-C895-FE75-CB461BB5BD59}"/>
+                  </a:ext>
+                </a:extLst>
+              </p:cNvPr>
+              <p:cNvSpPr/>
+              <p:nvPr/>
+            </p:nvSpPr>
+            <p:spPr>
+              <a:xfrm>
+                <a:off x="4127759" y="1685779"/>
+                <a:ext cx="254000" cy="214296"/>
+              </a:xfrm>
+              <a:prstGeom prst="triangle">
+                <a:avLst/>
+              </a:prstGeom>
+              <a:solidFill>
+                <a:srgbClr val="106946"/>
+              </a:solidFill>
+              <a:ln>
+                <a:noFill/>
+              </a:ln>
+            </p:spPr>
+            <p:style>
+              <a:lnRef idx="2">
+                <a:schemeClr val="accent1">
+                  <a:shade val="15000"/>
+                </a:schemeClr>
+              </a:lnRef>
+              <a:fillRef idx="1">
+                <a:schemeClr val="accent1"/>
+              </a:fillRef>
+              <a:effectRef idx="0">
+                <a:schemeClr val="accent1"/>
+              </a:effectRef>
+              <a:fontRef idx="minor">
+                <a:schemeClr val="lt1"/>
+              </a:fontRef>
+            </p:style>
+            <p:txBody>
+              <a:bodyPr rtlCol="0" anchor="ctr"/>
+              <a:lstStyle/>
+              <a:p>
+                <a:pPr algn="ctr"/>
+                <a:endParaRPr lang="en-LB" sz="3608"/>
+              </a:p>
+            </p:txBody>
+          </p:sp>
+          <p:sp>
+            <p:nvSpPr>
+              <p:cNvPr id="23" name="Triangle 22">
+                <a:extLst>
+                  <a:ext uri="{FF2B5EF4-FFF2-40B4-BE49-F238E27FC236}">
+                    <a16:creationId xmlns:a16="http://schemas.microsoft.com/office/drawing/2014/main" id="{53D5A865-70C6-51F1-FB5E-CE3D00F567AB}"/>
+                  </a:ext>
+                </a:extLst>
+              </p:cNvPr>
+              <p:cNvSpPr/>
+              <p:nvPr/>
+            </p:nvSpPr>
+            <p:spPr>
+              <a:xfrm rot="10800000">
+                <a:off x="4404184" y="1062731"/>
+                <a:ext cx="254000" cy="214296"/>
+              </a:xfrm>
+              <a:prstGeom prst="triangle">
+                <a:avLst/>
+              </a:prstGeom>
+              <a:solidFill>
+                <a:srgbClr val="106946"/>
+              </a:solidFill>
+              <a:ln>
+                <a:noFill/>
+              </a:ln>
+            </p:spPr>
+            <p:style>
+              <a:lnRef idx="2">
+                <a:schemeClr val="accent1">
+                  <a:shade val="15000"/>
+                </a:schemeClr>
+              </a:lnRef>
+              <a:fillRef idx="1">
+                <a:schemeClr val="accent1"/>
+              </a:fillRef>
+              <a:effectRef idx="0">
+                <a:schemeClr val="accent1"/>
+              </a:effectRef>
+              <a:fontRef idx="minor">
+                <a:schemeClr val="lt1"/>
+              </a:fontRef>
+            </p:style>
+            <p:txBody>
+              <a:bodyPr rtlCol="0" anchor="ctr"/>
+              <a:lstStyle/>
+              <a:p>
+                <a:pPr algn="ctr"/>
+                <a:endParaRPr lang="en-LB" sz="3608"/>
+              </a:p>
+            </p:txBody>
+          </p:sp>
+          <p:sp>
+            <p:nvSpPr>
+              <p:cNvPr id="24" name="Triangle 23">
+                <a:extLst>
+                  <a:ext uri="{FF2B5EF4-FFF2-40B4-BE49-F238E27FC236}">
+                    <a16:creationId xmlns:a16="http://schemas.microsoft.com/office/drawing/2014/main" id="{B5B815C1-5E26-6603-DED0-9459C7E19A83}"/>
+                  </a:ext>
+                </a:extLst>
+              </p:cNvPr>
+              <p:cNvSpPr/>
+              <p:nvPr/>
+            </p:nvSpPr>
+            <p:spPr>
+              <a:xfrm rot="10800000">
+                <a:off x="4988384" y="1062731"/>
+                <a:ext cx="254000" cy="214296"/>
+              </a:xfrm>
+              <a:prstGeom prst="triangle">
+                <a:avLst/>
+              </a:prstGeom>
+              <a:solidFill>
+                <a:srgbClr val="106946"/>
+              </a:solidFill>
+              <a:ln>
+                <a:noFill/>
+              </a:ln>
+            </p:spPr>
+            <p:style>
+              <a:lnRef idx="2">
+                <a:schemeClr val="accent1">
+                  <a:shade val="15000"/>
+                </a:schemeClr>
+              </a:lnRef>
+              <a:fillRef idx="1">
+                <a:schemeClr val="accent1"/>
+              </a:fillRef>
+              <a:effectRef idx="0">
+                <a:schemeClr val="accent1"/>
+              </a:effectRef>
+              <a:fontRef idx="minor">
+                <a:schemeClr val="lt1"/>
+              </a:fontRef>
+            </p:style>
+            <p:txBody>
+              <a:bodyPr rtlCol="0" anchor="ctr"/>
+              <a:lstStyle/>
+              <a:p>
+                <a:pPr algn="ctr"/>
+                <a:endParaRPr lang="en-LB" sz="3608"/>
+              </a:p>
+            </p:txBody>
+          </p:sp>
+        </p:grpSp>
+        <p:sp>
+          <p:nvSpPr>
+            <p:cNvPr id="3" name="TextBox 2">
+              <a:extLst>
+                <a:ext uri="{FF2B5EF4-FFF2-40B4-BE49-F238E27FC236}">
+                  <a16:creationId xmlns:a16="http://schemas.microsoft.com/office/drawing/2014/main" id="{D390DDCD-CC36-5797-C43D-3229F88E660A}"/>
+                </a:ext>
+              </a:extLst>
+            </p:cNvPr>
+            <p:cNvSpPr txBox="1"/>
+            <p:nvPr/>
+          </p:nvSpPr>
+          <p:spPr>
+            <a:xfrm>
+              <a:off x="9033163" y="1296547"/>
+              <a:ext cx="3250365" cy="281851"/>
+            </a:xfrm>
+            <a:prstGeom prst="rect">
+              <a:avLst/>
+            </a:prstGeom>
+            <a:noFill/>
+          </p:spPr>
+          <p:txBody>
+            <a:bodyPr wrap="square">
+              <a:spAutoFit/>
+            </a:bodyPr>
+            <a:lstStyle/>
+            <a:p>
+              <a:pPr algn="justLow" defTabSz="916000" rtl="1">
+                <a:buClr>
+                  <a:prstClr val="white"/>
+                </a:buClr>
+                <a:buSzPts val="3600"/>
+              </a:pPr>
+              <a:r>
+                <a:rPr lang="ar-SA" sz="2800" kern="1200">
+                  <a:solidFill>
+                    <a:schemeClr val="bg1"/>
+                  </a:solidFill>
+                  <a:latin typeface="Bahij TheSansArabic ExtraBold" panose="02040503050201020203" pitchFamily="18" charset="-78"/>
+                  <a:ea typeface="Cairo"/>
+                  <a:cs typeface="Bahij TheSansArabic ExtraBold" panose="02040503050201020203" pitchFamily="18" charset="-78"/>
+                  <a:sym typeface="Cairo"/>
+                </a:rPr>
+                <a:t>السيناريو الثاني — حوافز الموظفين</a:t>
+              </a:r>
+            </a:p>
+          </p:txBody>
+        </p:sp>
+      </p:grpSp>
+      <p:sp>
+        <p:nvSpPr>
+          <p:cNvPr id="261" name="Rectangle: Rounded Corners 260">
+            <a:extLst>
+              <a:ext uri="{FF2B5EF4-FFF2-40B4-BE49-F238E27FC236}">
+                <a16:creationId xmlns:a16="http://schemas.microsoft.com/office/drawing/2014/main" id="{DAD97482-DCB9-B82E-756E-F2042308EA9D}"/>
+              </a:ext>
+            </a:extLst>
+          </p:cNvPr>
+          <p:cNvSpPr/>
+          <p:nvPr/>
+        </p:nvSpPr>
+        <p:spPr>
+          <a:xfrm>
+            <a:off x="115617" y="1488435"/>
+            <a:ext cx="24020043" cy="815152"/>
+          </a:xfrm>
+          <a:prstGeom prst="roundRect">
+            <a:avLst>
+              <a:gd name="adj" fmla="val 6592"/>
+            </a:avLst>
+          </a:prstGeom>
+          <a:solidFill>
+            <a:schemeClr val="bg1">
+              <a:lumMod val="95000"/>
+            </a:schemeClr>
+          </a:solidFill>
+          <a:ln>
+            <a:solidFill>
+              <a:schemeClr val="bg1">
+                <a:lumMod val="75000"/>
+              </a:schemeClr>
+            </a:solidFill>
+          </a:ln>
+        </p:spPr>
+        <p:style>
+          <a:lnRef idx="2">
+            <a:schemeClr val="accent1">
+              <a:shade val="15000"/>
+            </a:schemeClr>
+          </a:lnRef>
+          <a:fillRef idx="1">
+            <a:schemeClr val="accent1"/>
+          </a:fillRef>
+          <a:effectRef idx="0">
+            <a:schemeClr val="accent1"/>
+          </a:effectRef>
+          <a:fontRef idx="minor">
+            <a:schemeClr val="lt1"/>
+          </a:fontRef>
+        </p:style>
+        <p:txBody>
+          <a:bodyPr rtlCol="0" anchor="ctr"/>
+          <a:lstStyle/>
+          <a:p>
+            <a:pPr algn="ctr"/>
+            <a:endParaRPr lang="en-US"/>
+          </a:p>
+        </p:txBody>
+      </p:sp>
+      <p:sp>
+        <p:nvSpPr>
+          <p:cNvPr id="262" name="TextBox 261">
+            <a:extLst>
+              <a:ext uri="{FF2B5EF4-FFF2-40B4-BE49-F238E27FC236}">
+                <a16:creationId xmlns:a16="http://schemas.microsoft.com/office/drawing/2014/main" id="{16500E24-021A-35C8-66DF-5AA0FD806ECC}"/>
+              </a:ext>
+            </a:extLst>
+          </p:cNvPr>
+          <p:cNvSpPr txBox="1"/>
+          <p:nvPr/>
+        </p:nvSpPr>
+        <p:spPr>
+          <a:xfrm>
+            <a:off x="13682652" y="1628448"/>
+            <a:ext cx="9192723" cy="523220"/>
+          </a:xfrm>
+          <a:prstGeom prst="rect">
+            <a:avLst/>
+          </a:prstGeom>
+          <a:noFill/>
+        </p:spPr>
+        <p:txBody>
+          <a:bodyPr wrap="square" rtlCol="0">
+            <a:spAutoFit/>
+          </a:bodyPr>
+          <a:lstStyle/>
+          <a:p>
+            <a:pPr algn="r"/>
+            <a:r>
+              <a:rPr lang="ar-SA" sz="2800">
+                <a:solidFill>
+                  <a:srgbClr val="106946"/>
+                </a:solidFill>
+                <a:latin typeface="Bahij TheSansArabic Bold" panose="02040503050201020203" charset="-78"/>
+                <a:cs typeface="Bahij TheSansArabic Bold" panose="02040503050201020203" charset="-78"/>
+              </a:rPr>
+              <a:t>حوافز تحقيق الإيرادات وفق شروط الزيادة عن المقدّر</a:t>
+            </a:r>
+            <a:endParaRPr lang="en-US" sz="2800">
+              <a:solidFill>
+                <a:srgbClr val="106946"/>
+              </a:solidFill>
+              <a:latin typeface="Bahij TheSansArabic Bold" panose="02040503050201020203" charset="-78"/>
+              <a:cs typeface="Bahij TheSansArabic Bold" panose="02040503050201020203" charset="-78"/>
+            </a:endParaRPr>
+          </a:p>
+        </p:txBody>
+      </p:sp>
+      <p:sp>
+        <p:nvSpPr>
+          <p:cNvPr id="263" name="Rectangle 262">
+            <a:extLst>
+              <a:ext uri="{FF2B5EF4-FFF2-40B4-BE49-F238E27FC236}">
+                <a16:creationId xmlns:a16="http://schemas.microsoft.com/office/drawing/2014/main" id="{3B200D8B-A145-970E-19BB-80D4C3F87E17}"/>
+              </a:ext>
+            </a:extLst>
+          </p:cNvPr>
+          <p:cNvSpPr/>
+          <p:nvPr/>
+        </p:nvSpPr>
+        <p:spPr>
+          <a:xfrm>
+            <a:off x="22963694" y="1482075"/>
+            <a:ext cx="1171966" cy="846429"/>
+          </a:xfrm>
+          <a:prstGeom prst="rect">
+            <a:avLst/>
+          </a:prstGeom>
+          <a:solidFill>
+            <a:srgbClr val="106946"/>
+          </a:solidFill>
+          <a:ln>
+            <a:noFill/>
+          </a:ln>
+        </p:spPr>
+        <p:style>
+          <a:lnRef idx="2">
+            <a:schemeClr val="accent1">
+              <a:shade val="15000"/>
+            </a:schemeClr>
+          </a:lnRef>
+          <a:fillRef idx="1">
+            <a:schemeClr val="accent1"/>
+          </a:fillRef>
+          <a:effectRef idx="0">
+            <a:schemeClr val="accent1"/>
+          </a:effectRef>
+          <a:fontRef idx="minor">
+            <a:schemeClr val="lt1"/>
+          </a:fontRef>
+        </p:style>
+        <p:txBody>
+          <a:bodyPr rtlCol="0" anchor="ctr"/>
+          <a:lstStyle/>
+          <a:p>
+            <a:pPr algn="ctr"/>
+            <a:endParaRPr lang="en-US"/>
+          </a:p>
+        </p:txBody>
+      </p:sp>
+      <p:pic>
+        <p:nvPicPr>
+          <p:cNvPr id="264" name="Graphic 263" descr="Upward trend with solid fill">
+            <a:extLst>
+              <a:ext uri="{FF2B5EF4-FFF2-40B4-BE49-F238E27FC236}">
+                <a16:creationId xmlns:a16="http://schemas.microsoft.com/office/drawing/2014/main" id="{96CA829E-BCA4-2340-484B-01D0B7EA25FD}"/>
+              </a:ext>
+            </a:extLst>
+          </p:cNvPr>
+          <p:cNvPicPr>
+            <a:picLocks noChangeAspect="1"/>
+          </p:cNvPicPr>
+          <p:nvPr/>
+        </p:nvPicPr>
+        <p:blipFill>
+          <a:blip>
+            <a:extLst>
+              <a:ext uri="{96DAC541-7B7A-43D3-8B79-37D633B846F1}">
+                <asvg:svgBlip xmlns:asvg="http://schemas.microsoft.com/office/drawing/2016/SVG/main" r:embed="rId3"/>
+              </a:ext>
+            </a:extLst>
+          </a:blip>
+          <a:stretch>
+            <a:fillRect/>
+          </a:stretch>
+        </p:blipFill>
+        <p:spPr>
+          <a:xfrm>
+            <a:off x="23145423" y="1521744"/>
+            <a:ext cx="757465" cy="757465"/>
+          </a:xfrm>
+          <a:prstGeom prst="rect">
+            <a:avLst/>
+          </a:prstGeom>
+        </p:spPr>
+      </p:pic>
+      <p:sp>
+        <p:nvSpPr>
+          <p:cNvPr id="1020" name="Inc 1020"/>
+          <p:cNvSpPr/>
+          <p:nvPr/>
+        </p:nvSpPr>
+        <p:spPr>
+          <a:xfrm>
+            <a:off x="17850000" y="2620000"/>
+            <a:ext cx="5950000" cy="2900000"/>
+          </a:xfrm>
+          <a:prstGeom prst="roundRect">
+            <a:avLst>
+              <a:gd name="adj" fmla="val 8000"/>
+            </a:avLst>
+          </a:prstGeom>
+          <a:solidFill>
+            <a:srgbClr val="FFFFFF"/>
+          </a:solidFill>
+          <a:ln w="19050">
+            <a:solidFill>
+              <a:srgbClr val="D9D9D9"/>
+            </a:solidFill>
+          </a:ln>
+          <a:effectLst>
+            <a:outerShdw blurRad="190500" dist="38100" dir="5400000" algn="t" rotWithShape="0">
+              <a:srgbClr val="000000">
+                <a:alpha val="18000"/>
+              </a:srgbClr>
+            </a:outerShdw>
+          </a:effectLst>
+        </p:spPr>
+        <p:txBody>
+          <a:bodyPr wrap="square" lIns="91440" rIns="91440" tIns="45720" bIns="45720" rtlCol="1" anchor="ctr">
+            <a:normAutofit/>
+          </a:bodyPr>
+          <a:lstStyle/>
+          <a:p>
+            <a:pPr algn="ctr" rtl="1">
+              <a:spcBef>
+                <a:spcPts val="0"/>
+              </a:spcBef>
+            </a:pPr>
+            <a:r>
+              <a:rPr lang="ar-SA" sz="2600" dirty="0">
+                <a:solidFill>
+                  <a:srgbClr val="595959"/>
+                </a:solidFill>
+                <a:latin typeface="Bahij TheSansArabic Bold"/>
+                <a:cs typeface="Bahij TheSansArabic Bold"/>
+              </a:rPr>
+              <a:t>إجمالي الإيرادات المقدّرة</a:t>
+            </a:r>
+          </a:p>
+          <a:p>
+            <a:pPr algn="ctr" rtl="1">
+              <a:spcBef>
+                <a:spcPts val="1200"/>
+              </a:spcBef>
+            </a:pPr>
+            <a:r>
+              <a:rPr lang="ar-SA" sz="6000" dirty="0">
+                <a:solidFill>
+                  <a:srgbClr val="01686A"/>
+                </a:solidFill>
+                <a:latin typeface="Bahij TheSansArabic Bold"/>
+                <a:cs typeface="Bahij TheSansArabic Bold"/>
+              </a:rPr>
+              <a:t>2,839.3</a:t>
+            </a:r>
+          </a:p>
+          <a:p>
+            <a:pPr algn="ctr" rtl="1">
+              <a:spcBef>
+                <a:spcPts val="0"/>
+              </a:spcBef>
+            </a:pPr>
+            <a:r>
+              <a:rPr lang="ar-SA" sz="2000" dirty="0">
+                <a:solidFill>
+                  <a:srgbClr val="595959"/>
+                </a:solidFill>
+                <a:latin typeface="Bahij TheSansArabic Plain"/>
+                <a:cs typeface="Bahij TheSansArabic Plain"/>
+              </a:rPr>
+              <a:t>مليون ريال</a:t>
+            </a:r>
+          </a:p>
+        </p:txBody>
+      </p:sp>
+      <p:sp>
+        <p:nvSpPr>
+          <p:cNvPr id="1021" name="Inc 1021"/>
+          <p:cNvSpPr/>
+          <p:nvPr/>
+        </p:nvSpPr>
+        <p:spPr>
+          <a:xfrm>
+            <a:off x="11650000" y="2620000"/>
+            <a:ext cx="5950000" cy="2900000"/>
+          </a:xfrm>
+          <a:prstGeom prst="roundRect">
+            <a:avLst>
+              <a:gd name="adj" fmla="val 8000"/>
+            </a:avLst>
+          </a:prstGeom>
+          <a:solidFill>
+            <a:srgbClr val="FFFFFF"/>
+          </a:solidFill>
+          <a:ln w="19050">
+            <a:solidFill>
+              <a:srgbClr val="D9D9D9"/>
+            </a:solidFill>
+          </a:ln>
+          <a:effectLst>
+            <a:outerShdw blurRad="190500" dist="38100" dir="5400000" algn="t" rotWithShape="0">
+              <a:srgbClr val="000000">
+                <a:alpha val="18000"/>
+              </a:srgbClr>
+            </a:outerShdw>
+          </a:effectLst>
+        </p:spPr>
+        <p:txBody>
+          <a:bodyPr wrap="square" lIns="91440" rIns="91440" tIns="45720" bIns="45720" rtlCol="1" anchor="ctr">
+            <a:normAutofit/>
+          </a:bodyPr>
+          <a:lstStyle/>
+          <a:p>
+            <a:pPr algn="ctr" rtl="1">
+              <a:spcBef>
+                <a:spcPts val="0"/>
+              </a:spcBef>
+            </a:pPr>
+            <a:r>
+              <a:rPr lang="ar-SA" sz="2600" dirty="0">
+                <a:solidFill>
+                  <a:srgbClr val="595959"/>
+                </a:solidFill>
+                <a:latin typeface="Bahij TheSansArabic Bold"/>
+                <a:cs typeface="Bahij TheSansArabic Bold"/>
+              </a:rPr>
+              <a:t>إجمالي الإيرادات المحصّلة</a:t>
+            </a:r>
+          </a:p>
+          <a:p>
+            <a:pPr algn="ctr" rtl="1">
+              <a:spcBef>
+                <a:spcPts val="1200"/>
+              </a:spcBef>
+            </a:pPr>
+            <a:r>
+              <a:rPr lang="ar-SA" sz="6000" dirty="0">
+                <a:solidFill>
+                  <a:srgbClr val="01686A"/>
+                </a:solidFill>
+                <a:latin typeface="Bahij TheSansArabic Bold"/>
+                <a:cs typeface="Bahij TheSansArabic Bold"/>
+              </a:rPr>
+              <a:t>2,824.7</a:t>
+            </a:r>
+          </a:p>
+          <a:p>
+            <a:pPr algn="ctr" rtl="1">
+              <a:spcBef>
+                <a:spcPts val="0"/>
+              </a:spcBef>
+            </a:pPr>
+            <a:r>
+              <a:rPr lang="ar-SA" sz="2000" dirty="0">
+                <a:solidFill>
+                  <a:srgbClr val="595959"/>
+                </a:solidFill>
+                <a:latin typeface="Bahij TheSansArabic Plain"/>
+                <a:cs typeface="Bahij TheSansArabic Plain"/>
+              </a:rPr>
+              <a:t>مليون ريال</a:t>
+            </a:r>
+          </a:p>
+        </p:txBody>
+      </p:sp>
+      <p:sp>
+        <p:nvSpPr>
+          <p:cNvPr id="1022" name="Inc 1022"/>
+          <p:cNvSpPr/>
+          <p:nvPr/>
+        </p:nvSpPr>
+        <p:spPr>
+          <a:xfrm>
+            <a:off x="580000" y="2500000"/>
+            <a:ext cx="10820000" cy="3140000"/>
+          </a:xfrm>
+          <a:prstGeom prst="roundRect">
+            <a:avLst>
+              <a:gd name="adj" fmla="val 8000"/>
+            </a:avLst>
+          </a:prstGeom>
+          <a:solidFill>
+            <a:srgbClr val="C00000"/>
+          </a:solidFill>
+          <a:ln>
+            <a:noFill/>
+          </a:ln>
+          <a:effectLst>
+            <a:outerShdw blurRad="190500" dist="38100" dir="5400000" algn="t" rotWithShape="0">
+              <a:srgbClr val="000000">
+                <a:alpha val="18000"/>
+              </a:srgbClr>
+            </a:outerShdw>
+          </a:effectLst>
+        </p:spPr>
+        <p:txBody>
+          <a:bodyPr wrap="square" lIns="91440" rIns="91440" tIns="45720" bIns="45720" rtlCol="1" anchor="ctr">
+            <a:normAutofit/>
+          </a:bodyPr>
+          <a:lstStyle/>
+          <a:p>
+            <a:pPr algn="ctr" rtl="1">
+              <a:spcBef>
+                <a:spcPts val="0"/>
+              </a:spcBef>
+            </a:pPr>
+            <a:r>
+              <a:rPr lang="ar-SA" sz="3200" dirty="0">
+                <a:solidFill>
+                  <a:srgbClr val="FFFFFF"/>
+                </a:solidFill>
+                <a:latin typeface="Bahij TheSansArabic Bold"/>
+                <a:cs typeface="Bahij TheSansArabic Bold"/>
+              </a:rPr>
+              <a:t>فائض الإيرادات</a:t>
+            </a:r>
+          </a:p>
+          <a:p>
+            <a:pPr algn="ctr" rtl="1">
+              <a:spcBef>
+                <a:spcPts val="600"/>
+              </a:spcBef>
+            </a:pPr>
+            <a:r>
+              <a:rPr lang="ar-SA" sz="8000" dirty="0">
+                <a:solidFill>
+                  <a:srgbClr val="FFFFFF"/>
+                </a:solidFill>
+                <a:latin typeface="Bahij TheSansArabic Bold"/>
+                <a:cs typeface="Bahij TheSansArabic Bold"/>
+              </a:rPr>
+              <a:t>لا يوجد فائض</a:t>
+            </a:r>
+          </a:p>
+          <a:p>
+            <a:pPr algn="ctr" rtl="1">
+              <a:spcBef>
+                <a:spcPts val="0"/>
+              </a:spcBef>
+            </a:pPr>
+            <a:r>
+              <a:rPr lang="ar-SA" sz="2200" dirty="0">
+                <a:solidFill>
+                  <a:srgbClr val="F8CBAD"/>
+                </a:solidFill>
+                <a:latin typeface="Bahij TheSansArabic Plain"/>
+                <a:cs typeface="Bahij TheSansArabic Plain"/>
+              </a:rPr>
+              <a:t>المحصّل أقل من المقدّر بـ 14.6 مليون ريال</a:t>
+            </a:r>
+          </a:p>
+        </p:txBody>
+      </p:sp>
+      <p:sp>
+        <p:nvSpPr>
+          <p:cNvPr id="1023" name="Inc 1023"/>
+          <p:cNvSpPr/>
+          <p:nvPr/>
+        </p:nvSpPr>
+        <p:spPr>
+          <a:xfrm>
+            <a:off x="580000" y="5470000"/>
+            <a:ext cx="23220000" cy="420000"/>
+          </a:xfrm>
+          <a:prstGeom prst="roundRect">
+            <a:avLst>
+              <a:gd name="adj" fmla="val 8000"/>
+            </a:avLst>
+          </a:prstGeom>
+          <a:noFill/>
+          <a:ln>
+            <a:noFill/>
+          </a:ln>
+        </p:spPr>
+        <p:txBody>
+          <a:bodyPr wrap="square" lIns="91440" rIns="91440" tIns="45720" bIns="45720" rtlCol="1" anchor="ctr">
+            <a:normAutofit/>
+          </a:bodyPr>
+          <a:lstStyle/>
+          <a:p>
+            <a:pPr algn="r" rtl="1">
+              <a:spcBef>
+                <a:spcPts val="0"/>
+              </a:spcBef>
+            </a:pPr>
+            <a:r>
+              <a:rPr lang="ar-SA" sz="2600" dirty="0">
+                <a:solidFill>
+                  <a:srgbClr val="01686A"/>
+                </a:solidFill>
+                <a:latin typeface="Bahij TheSansArabic Bold"/>
+                <a:cs typeface="Bahij TheSansArabic Bold"/>
+              </a:rPr>
+              <a:t>شروط احتساب الحوافز</a:t>
+            </a:r>
+          </a:p>
+        </p:txBody>
+      </p:sp>
+      <p:sp>
+        <p:nvSpPr>
+          <p:cNvPr id="1024" name="Inc 1024"/>
+          <p:cNvSpPr/>
+          <p:nvPr/>
+        </p:nvSpPr>
+        <p:spPr>
+          <a:xfrm>
+            <a:off x="16700000" y="5950000"/>
+            <a:ext cx="7100000" cy="3500000"/>
+          </a:xfrm>
+          <a:prstGeom prst="roundRect">
+            <a:avLst>
+              <a:gd name="adj" fmla="val 8000"/>
+            </a:avLst>
+          </a:prstGeom>
+          <a:solidFill>
+            <a:srgbClr val="FFFFFF"/>
+          </a:solidFill>
+          <a:ln w="25400">
+            <a:solidFill>
+              <a:srgbClr val="01686A"/>
+            </a:solidFill>
+          </a:ln>
+          <a:effectLst>
+            <a:outerShdw blurRad="190500" dist="38100" dir="5400000" algn="t" rotWithShape="0">
+              <a:srgbClr val="000000">
+                <a:alpha val="18000"/>
+              </a:srgbClr>
+            </a:outerShdw>
+          </a:effectLst>
+        </p:spPr>
+        <p:txBody>
+          <a:bodyPr wrap="square" lIns="91440" rIns="91440" tIns="45720" bIns="45720" rtlCol="1" anchor="ctr">
+            <a:normAutofit/>
+          </a:bodyPr>
+          <a:lstStyle/>
+          <a:p>
+            <a:endParaRPr lang="ar-SA"/>
+          </a:p>
+        </p:txBody>
+      </p:sp>
+      <p:sp>
+        <p:nvSpPr>
+          <p:cNvPr id="1025" name="Inc 1025"/>
+          <p:cNvSpPr/>
+          <p:nvPr/>
+        </p:nvSpPr>
+        <p:spPr>
+          <a:xfrm>
+            <a:off x="22650000" y="6200000"/>
+            <a:ext cx="850000" cy="850000"/>
+          </a:xfrm>
+          <a:prstGeom prst="ellipse">
+            <a:avLst/>
+          </a:prstGeom>
+          <a:solidFill>
+            <a:srgbClr val="01686A"/>
+          </a:solidFill>
+          <a:ln>
+            <a:noFill/>
+          </a:ln>
+        </p:spPr>
+        <p:txBody>
+          <a:bodyPr wrap="square" lIns="91440" rIns="91440" tIns="45720" bIns="45720" rtlCol="1" anchor="ctr">
+            <a:normAutofit/>
+          </a:bodyPr>
+          <a:lstStyle/>
+          <a:p>
+            <a:pPr algn="ctr" rtl="1">
+              <a:spcBef>
+                <a:spcPts val="0"/>
+              </a:spcBef>
+            </a:pPr>
+            <a:r>
+              <a:rPr lang="ar-SA" sz="3200" dirty="0">
+                <a:solidFill>
+                  <a:srgbClr val="FFFFFF"/>
+                </a:solidFill>
+                <a:latin typeface="Bahij TheSansArabic Bold"/>
+                <a:cs typeface="Bahij TheSansArabic Bold"/>
+              </a:rPr>
+              <a:t>1</a:t>
+            </a:r>
+          </a:p>
+        </p:txBody>
+      </p:sp>
+      <p:sp>
+        <p:nvSpPr>
+          <p:cNvPr id="1026" name="Inc 1026"/>
+          <p:cNvSpPr/>
+          <p:nvPr/>
+        </p:nvSpPr>
+        <p:spPr>
+          <a:xfrm>
+            <a:off x="16950000" y="6130000"/>
+            <a:ext cx="5600000" cy="1250000"/>
+          </a:xfrm>
+          <a:prstGeom prst="roundRect">
+            <a:avLst>
+              <a:gd name="adj" fmla="val 8000"/>
+            </a:avLst>
+          </a:prstGeom>
+          <a:noFill/>
+          <a:ln>
+            <a:noFill/>
+          </a:ln>
+        </p:spPr>
+        <p:txBody>
+          <a:bodyPr wrap="square" lIns="91440" rIns="91440" tIns="45720" bIns="45720" rtlCol="1" anchor="ctr">
+            <a:normAutofit/>
+          </a:bodyPr>
+          <a:lstStyle/>
+          <a:p>
+            <a:pPr algn="r" rtl="1">
+              <a:spcBef>
+                <a:spcPts val="0"/>
+              </a:spcBef>
+            </a:pPr>
+            <a:r>
+              <a:rPr lang="ar-SA" sz="2200" dirty="0">
+                <a:solidFill>
+                  <a:srgbClr val="262626"/>
+                </a:solidFill>
+                <a:latin typeface="Bahij TheSansArabic Bold"/>
+                <a:cs typeface="Bahij TheSansArabic Bold"/>
+              </a:rPr>
+              <a:t>عند تحقيق أي زيادة عن الإيرادات المقدّرة يُخصَّص 12% من المقدّر</a:t>
+            </a:r>
+          </a:p>
+        </p:txBody>
+      </p:sp>
+      <p:sp>
+        <p:nvSpPr>
+          <p:cNvPr id="1027" name="Inc 1027"/>
+          <p:cNvSpPr/>
+          <p:nvPr/>
+        </p:nvSpPr>
+        <p:spPr>
+          <a:xfrm>
+            <a:off x="17100000" y="7600000"/>
+            <a:ext cx="6300000" cy="1600000"/>
+          </a:xfrm>
+          <a:prstGeom prst="roundRect">
+            <a:avLst>
+              <a:gd name="adj" fmla="val 12000"/>
+            </a:avLst>
+          </a:prstGeom>
+          <a:solidFill>
+            <a:srgbClr val="F2F8F8"/>
+          </a:solidFill>
+          <a:ln>
+            <a:noFill/>
+          </a:ln>
+        </p:spPr>
+        <p:txBody>
+          <a:bodyPr wrap="square" lIns="91440" rIns="91440" tIns="45720" bIns="45720" rtlCol="1" anchor="ctr">
+            <a:normAutofit/>
+          </a:bodyPr>
+          <a:lstStyle/>
+          <a:p>
+            <a:pPr algn="ctr" rtl="1">
+              <a:spcBef>
+                <a:spcPts val="0"/>
+              </a:spcBef>
+            </a:pPr>
+            <a:r>
+              <a:rPr lang="ar-SA" sz="6000" dirty="0">
+                <a:solidFill>
+                  <a:srgbClr val="595959"/>
+                </a:solidFill>
+                <a:latin typeface="Bahij TheSansArabic Bold"/>
+                <a:cs typeface="Bahij TheSansArabic Bold"/>
+              </a:rPr>
+              <a:t>0</a:t>
+            </a:r>
+          </a:p>
+          <a:p>
+            <a:pPr algn="ctr" rtl="1">
+              <a:spcBef>
+                <a:spcPts val="0"/>
+              </a:spcBef>
+            </a:pPr>
+            <a:r>
+              <a:rPr lang="ar-SA" sz="2000" dirty="0">
+                <a:solidFill>
+                  <a:srgbClr val="595959"/>
+                </a:solidFill>
+                <a:latin typeface="Bahij TheSansArabic Plain"/>
+                <a:cs typeface="Bahij TheSansArabic Plain"/>
+              </a:rPr>
+              <a:t>مليون ريال</a:t>
+            </a:r>
+          </a:p>
+        </p:txBody>
+      </p:sp>
+      <p:sp>
+        <p:nvSpPr>
+          <p:cNvPr id="1028" name="Arrow 1028"/>
+          <p:cNvSpPr/>
+          <p:nvPr/>
+        </p:nvSpPr>
+        <p:spPr>
+          <a:xfrm>
+            <a:off x="15880000" y="7350000"/>
+            <a:ext cx="640000" cy="700000"/>
+          </a:xfrm>
+          <a:prstGeom prst="leftArrow">
+            <a:avLst/>
+          </a:prstGeom>
+          <a:solidFill>
+            <a:srgbClr val="00B050"/>
+          </a:solidFill>
+          <a:ln>
+            <a:noFill/>
+          </a:ln>
+        </p:spPr>
+        <p:txBody>
+          <a:bodyPr/>
+          <a:lstStyle/>
+          <a:p>
+            <a:endParaRPr lang="ar-SA"/>
+          </a:p>
+        </p:txBody>
+      </p:sp>
+      <p:sp>
+        <p:nvSpPr>
+          <p:cNvPr id="1029" name="Inc 1029"/>
+          <p:cNvSpPr/>
+          <p:nvPr/>
+        </p:nvSpPr>
+        <p:spPr>
+          <a:xfrm>
+            <a:off x="8640000" y="5950000"/>
+            <a:ext cx="7100000" cy="3500000"/>
+          </a:xfrm>
+          <a:prstGeom prst="roundRect">
+            <a:avLst>
+              <a:gd name="adj" fmla="val 8000"/>
+            </a:avLst>
+          </a:prstGeom>
+          <a:solidFill>
+            <a:srgbClr val="FFFFFF"/>
+          </a:solidFill>
+          <a:ln w="25400">
+            <a:solidFill>
+              <a:srgbClr val="01686A"/>
+            </a:solidFill>
+          </a:ln>
+          <a:effectLst>
+            <a:outerShdw blurRad="190500" dist="38100" dir="5400000" algn="t" rotWithShape="0">
+              <a:srgbClr val="000000">
+                <a:alpha val="18000"/>
+              </a:srgbClr>
+            </a:outerShdw>
+          </a:effectLst>
+        </p:spPr>
+        <p:txBody>
+          <a:bodyPr wrap="square" lIns="91440" rIns="91440" tIns="45720" bIns="45720" rtlCol="1" anchor="ctr">
+            <a:normAutofit/>
+          </a:bodyPr>
+          <a:lstStyle/>
+          <a:p>
+            <a:endParaRPr lang="ar-SA"/>
+          </a:p>
+        </p:txBody>
+      </p:sp>
+      <p:sp>
+        <p:nvSpPr>
+          <p:cNvPr id="1030" name="Inc 1030"/>
+          <p:cNvSpPr/>
+          <p:nvPr/>
+        </p:nvSpPr>
+        <p:spPr>
+          <a:xfrm>
+            <a:off x="14590000" y="6200000"/>
+            <a:ext cx="850000" cy="850000"/>
+          </a:xfrm>
+          <a:prstGeom prst="ellipse">
+            <a:avLst/>
+          </a:prstGeom>
+          <a:solidFill>
+            <a:srgbClr val="01686A"/>
+          </a:solidFill>
+          <a:ln>
+            <a:noFill/>
+          </a:ln>
+        </p:spPr>
+        <p:txBody>
+          <a:bodyPr wrap="square" lIns="91440" rIns="91440" tIns="45720" bIns="45720" rtlCol="1" anchor="ctr">
+            <a:normAutofit/>
+          </a:bodyPr>
+          <a:lstStyle/>
+          <a:p>
+            <a:pPr algn="ctr" rtl="1">
+              <a:spcBef>
+                <a:spcPts val="0"/>
+              </a:spcBef>
+            </a:pPr>
+            <a:r>
+              <a:rPr lang="ar-SA" sz="3200" dirty="0">
+                <a:solidFill>
+                  <a:srgbClr val="FFFFFF"/>
+                </a:solidFill>
+                <a:latin typeface="Bahij TheSansArabic Bold"/>
+                <a:cs typeface="Bahij TheSansArabic Bold"/>
+              </a:rPr>
+              <a:t>2</a:t>
+            </a:r>
+          </a:p>
+        </p:txBody>
+      </p:sp>
+      <p:sp>
+        <p:nvSpPr>
+          <p:cNvPr id="1031" name="Inc 1031"/>
+          <p:cNvSpPr/>
+          <p:nvPr/>
+        </p:nvSpPr>
+        <p:spPr>
+          <a:xfrm>
+            <a:off x="8890000" y="6130000"/>
+            <a:ext cx="5600000" cy="1250000"/>
+          </a:xfrm>
+          <a:prstGeom prst="roundRect">
+            <a:avLst>
+              <a:gd name="adj" fmla="val 8000"/>
+            </a:avLst>
+          </a:prstGeom>
+          <a:noFill/>
+          <a:ln>
+            <a:noFill/>
+          </a:ln>
+        </p:spPr>
+        <p:txBody>
+          <a:bodyPr wrap="square" lIns="91440" rIns="91440" tIns="45720" bIns="45720" rtlCol="1" anchor="ctr">
+            <a:normAutofit/>
+          </a:bodyPr>
+          <a:lstStyle/>
+          <a:p>
+            <a:pPr algn="r" rtl="1">
+              <a:spcBef>
+                <a:spcPts val="0"/>
+              </a:spcBef>
+            </a:pPr>
+            <a:r>
+              <a:rPr lang="ar-SA" sz="2200" dirty="0">
+                <a:solidFill>
+                  <a:srgbClr val="262626"/>
+                </a:solidFill>
+                <a:latin typeface="Bahij TheSansArabic Bold"/>
+                <a:cs typeface="Bahij TheSansArabic Bold"/>
+              </a:rPr>
+              <a:t>إجمالي الحوافز: 25% من مبلغ الـ12%</a:t>
+            </a:r>
+          </a:p>
+        </p:txBody>
+      </p:sp>
+      <p:sp>
+        <p:nvSpPr>
+          <p:cNvPr id="1032" name="Inc 1032"/>
+          <p:cNvSpPr/>
+          <p:nvPr/>
+        </p:nvSpPr>
+        <p:spPr>
+          <a:xfrm>
+            <a:off x="9040000" y="7600000"/>
+            <a:ext cx="6300000" cy="1600000"/>
+          </a:xfrm>
+          <a:prstGeom prst="roundRect">
+            <a:avLst>
+              <a:gd name="adj" fmla="val 12000"/>
+            </a:avLst>
+          </a:prstGeom>
+          <a:solidFill>
+            <a:srgbClr val="F2F8F8"/>
+          </a:solidFill>
+          <a:ln>
+            <a:noFill/>
+          </a:ln>
+        </p:spPr>
+        <p:txBody>
+          <a:bodyPr wrap="square" lIns="91440" rIns="91440" tIns="45720" bIns="45720" rtlCol="1" anchor="ctr">
+            <a:normAutofit/>
+          </a:bodyPr>
+          <a:lstStyle/>
+          <a:p>
+            <a:pPr algn="ctr" rtl="1">
+              <a:spcBef>
+                <a:spcPts val="0"/>
+              </a:spcBef>
+            </a:pPr>
+            <a:r>
+              <a:rPr lang="ar-SA" sz="6000" dirty="0">
+                <a:solidFill>
+                  <a:srgbClr val="595959"/>
+                </a:solidFill>
+                <a:latin typeface="Bahij TheSansArabic Bold"/>
+                <a:cs typeface="Bahij TheSansArabic Bold"/>
+              </a:rPr>
+              <a:t>0</a:t>
+            </a:r>
+          </a:p>
+          <a:p>
+            <a:pPr algn="ctr" rtl="1">
+              <a:spcBef>
+                <a:spcPts val="0"/>
+              </a:spcBef>
+            </a:pPr>
+            <a:r>
+              <a:rPr lang="ar-SA" sz="2000" dirty="0">
+                <a:solidFill>
+                  <a:srgbClr val="595959"/>
+                </a:solidFill>
+                <a:latin typeface="Bahij TheSansArabic Plain"/>
+                <a:cs typeface="Bahij TheSansArabic Plain"/>
+              </a:rPr>
+              <a:t>مليون ريال</a:t>
+            </a:r>
+          </a:p>
+        </p:txBody>
+      </p:sp>
+      <p:sp>
+        <p:nvSpPr>
+          <p:cNvPr id="1033" name="Arrow 1033"/>
+          <p:cNvSpPr/>
+          <p:nvPr/>
+        </p:nvSpPr>
+        <p:spPr>
+          <a:xfrm>
+            <a:off x="7820000" y="7350000"/>
+            <a:ext cx="640000" cy="700000"/>
+          </a:xfrm>
+          <a:prstGeom prst="leftArrow">
+            <a:avLst/>
+          </a:prstGeom>
+          <a:solidFill>
+            <a:srgbClr val="00B050"/>
+          </a:solidFill>
+          <a:ln>
+            <a:noFill/>
+          </a:ln>
+        </p:spPr>
+        <p:txBody>
+          <a:bodyPr/>
+          <a:lstStyle/>
+          <a:p>
+            <a:endParaRPr lang="ar-SA"/>
+          </a:p>
+        </p:txBody>
+      </p:sp>
+      <p:sp>
+        <p:nvSpPr>
+          <p:cNvPr id="1034" name="Inc 1034"/>
+          <p:cNvSpPr/>
+          <p:nvPr/>
+        </p:nvSpPr>
+        <p:spPr>
+          <a:xfrm>
+            <a:off x="580000" y="5950000"/>
+            <a:ext cx="7100000" cy="3500000"/>
+          </a:xfrm>
+          <a:prstGeom prst="roundRect">
+            <a:avLst>
+              <a:gd name="adj" fmla="val 8000"/>
+            </a:avLst>
+          </a:prstGeom>
+          <a:solidFill>
+            <a:srgbClr val="FFFFFF"/>
+          </a:solidFill>
+          <a:ln w="25400">
+            <a:solidFill>
+              <a:srgbClr val="01686A"/>
+            </a:solidFill>
+          </a:ln>
+          <a:effectLst>
+            <a:outerShdw blurRad="190500" dist="38100" dir="5400000" algn="t" rotWithShape="0">
+              <a:srgbClr val="000000">
+                <a:alpha val="18000"/>
+              </a:srgbClr>
+            </a:outerShdw>
+          </a:effectLst>
+        </p:spPr>
+        <p:txBody>
+          <a:bodyPr wrap="square" lIns="91440" rIns="91440" tIns="45720" bIns="45720" rtlCol="1" anchor="ctr">
+            <a:normAutofit/>
+          </a:bodyPr>
+          <a:lstStyle/>
+          <a:p>
+            <a:endParaRPr lang="ar-SA"/>
+          </a:p>
+        </p:txBody>
+      </p:sp>
+      <p:sp>
+        <p:nvSpPr>
+          <p:cNvPr id="1035" name="Inc 1035"/>
+          <p:cNvSpPr/>
+          <p:nvPr/>
+        </p:nvSpPr>
+        <p:spPr>
+          <a:xfrm>
+            <a:off x="6530000" y="6200000"/>
+            <a:ext cx="850000" cy="850000"/>
+          </a:xfrm>
+          <a:prstGeom prst="ellipse">
+            <a:avLst/>
+          </a:prstGeom>
+          <a:solidFill>
+            <a:srgbClr val="01686A"/>
+          </a:solidFill>
+          <a:ln>
+            <a:noFill/>
+          </a:ln>
+        </p:spPr>
+        <p:txBody>
+          <a:bodyPr wrap="square" lIns="91440" rIns="91440" tIns="45720" bIns="45720" rtlCol="1" anchor="ctr">
+            <a:normAutofit/>
+          </a:bodyPr>
+          <a:lstStyle/>
+          <a:p>
+            <a:pPr algn="ctr" rtl="1">
+              <a:spcBef>
+                <a:spcPts val="0"/>
+              </a:spcBef>
+            </a:pPr>
+            <a:r>
+              <a:rPr lang="ar-SA" sz="3200" dirty="0">
+                <a:solidFill>
+                  <a:srgbClr val="FFFFFF"/>
+                </a:solidFill>
+                <a:latin typeface="Bahij TheSansArabic Bold"/>
+                <a:cs typeface="Bahij TheSansArabic Bold"/>
+              </a:rPr>
+              <a:t>3</a:t>
+            </a:r>
+          </a:p>
+        </p:txBody>
+      </p:sp>
+      <p:sp>
+        <p:nvSpPr>
+          <p:cNvPr id="1036" name="Inc 1036"/>
+          <p:cNvSpPr/>
+          <p:nvPr/>
+        </p:nvSpPr>
+        <p:spPr>
+          <a:xfrm>
+            <a:off x="830000" y="6130000"/>
+            <a:ext cx="5600000" cy="1250000"/>
+          </a:xfrm>
+          <a:prstGeom prst="roundRect">
+            <a:avLst>
+              <a:gd name="adj" fmla="val 8000"/>
+            </a:avLst>
+          </a:prstGeom>
+          <a:noFill/>
+          <a:ln>
+            <a:noFill/>
+          </a:ln>
+        </p:spPr>
+        <p:txBody>
+          <a:bodyPr wrap="square" lIns="91440" rIns="91440" tIns="45720" bIns="45720" rtlCol="1" anchor="ctr">
+            <a:normAutofit/>
+          </a:bodyPr>
+          <a:lstStyle/>
+          <a:p>
+            <a:pPr algn="r" rtl="1">
+              <a:spcBef>
+                <a:spcPts val="0"/>
+              </a:spcBef>
+            </a:pPr>
+            <a:r>
+              <a:rPr lang="ar-SA" sz="2200" dirty="0">
+                <a:solidFill>
+                  <a:srgbClr val="262626"/>
+                </a:solidFill>
+                <a:latin typeface="Bahij TheSansArabic Bold"/>
+                <a:cs typeface="Bahij TheSansArabic Bold"/>
+              </a:rPr>
+              <a:t>حوافز الموظفين: 40% من إجمالي الحوافز</a:t>
+            </a:r>
+          </a:p>
+        </p:txBody>
+      </p:sp>
+      <p:sp>
+        <p:nvSpPr>
+          <p:cNvPr id="1037" name="Inc 1037"/>
+          <p:cNvSpPr/>
+          <p:nvPr/>
+        </p:nvSpPr>
+        <p:spPr>
+          <a:xfrm>
+            <a:off x="980000" y="7600000"/>
+            <a:ext cx="6300000" cy="1600000"/>
+          </a:xfrm>
+          <a:prstGeom prst="roundRect">
+            <a:avLst>
+              <a:gd name="adj" fmla="val 12000"/>
+            </a:avLst>
+          </a:prstGeom>
+          <a:solidFill>
+            <a:srgbClr val="F2F8F8"/>
+          </a:solidFill>
+          <a:ln>
+            <a:noFill/>
+          </a:ln>
+        </p:spPr>
+        <p:txBody>
+          <a:bodyPr wrap="square" lIns="91440" rIns="91440" tIns="45720" bIns="45720" rtlCol="1" anchor="ctr">
+            <a:normAutofit/>
+          </a:bodyPr>
+          <a:lstStyle/>
+          <a:p>
+            <a:pPr algn="ctr" rtl="1">
+              <a:spcBef>
+                <a:spcPts val="0"/>
+              </a:spcBef>
+            </a:pPr>
+            <a:r>
+              <a:rPr lang="ar-SA" sz="6000" dirty="0">
+                <a:solidFill>
+                  <a:srgbClr val="595959"/>
+                </a:solidFill>
+                <a:latin typeface="Bahij TheSansArabic Bold"/>
+                <a:cs typeface="Bahij TheSansArabic Bold"/>
+              </a:rPr>
+              <a:t>0</a:t>
+            </a:r>
+          </a:p>
+          <a:p>
+            <a:pPr algn="ctr" rtl="1">
+              <a:spcBef>
+                <a:spcPts val="0"/>
+              </a:spcBef>
+            </a:pPr>
+            <a:r>
+              <a:rPr lang="ar-SA" sz="2000" dirty="0">
+                <a:solidFill>
+                  <a:srgbClr val="595959"/>
+                </a:solidFill>
+                <a:latin typeface="Bahij TheSansArabic Plain"/>
+                <a:cs typeface="Bahij TheSansArabic Plain"/>
+              </a:rPr>
+              <a:t>مليون ريال</a:t>
+            </a:r>
+          </a:p>
+        </p:txBody>
+      </p:sp>
+      <p:sp>
+        <p:nvSpPr>
+          <p:cNvPr id="1038" name="Inc 1038"/>
+          <p:cNvSpPr/>
+          <p:nvPr/>
+        </p:nvSpPr>
+        <p:spPr>
+          <a:xfrm>
+            <a:off x="580000" y="9900000"/>
+            <a:ext cx="23220000" cy="2580000"/>
+          </a:xfrm>
+          <a:prstGeom prst="roundRect">
+            <a:avLst>
+              <a:gd name="adj" fmla="val 8000"/>
+            </a:avLst>
+          </a:prstGeom>
+          <a:solidFill>
+            <a:srgbClr val="7F7F7F"/>
+          </a:solidFill>
+          <a:ln>
+            <a:noFill/>
+          </a:ln>
+          <a:effectLst>
+            <a:outerShdw blurRad="190500" dist="38100" dir="5400000" algn="t" rotWithShape="0">
+              <a:srgbClr val="000000">
+                <a:alpha val="18000"/>
+              </a:srgbClr>
+            </a:outerShdw>
+          </a:effectLst>
+        </p:spPr>
+        <p:txBody>
+          <a:bodyPr wrap="square" lIns="91440" rIns="91440" tIns="45720" bIns="45720" rtlCol="1" anchor="ctr">
+            <a:normAutofit/>
+          </a:bodyPr>
+          <a:lstStyle/>
+          <a:p>
+            <a:pPr algn="ctr" rtl="1">
+              <a:spcBef>
+                <a:spcPts val="0"/>
+              </a:spcBef>
+            </a:pPr>
+            <a:r>
+              <a:rPr lang="ar-SA" sz="3600" dirty="0">
+                <a:solidFill>
+                  <a:srgbClr val="FFFFFF"/>
+                </a:solidFill>
+                <a:latin typeface="Bahij TheSansArabic Bold"/>
+                <a:cs typeface="Bahij TheSansArabic Bold"/>
+              </a:rPr>
+              <a:t>حوافز الموظفين</a:t>
+            </a:r>
+          </a:p>
+          <a:p>
+            <a:pPr algn="ctr" rtl="1">
+              <a:spcBef>
+                <a:spcPts val="0"/>
+              </a:spcBef>
+            </a:pPr>
+            <a:r>
+              <a:rPr lang="ar-SA" sz="10000" dirty="0">
+                <a:solidFill>
+                  <a:srgbClr val="FFFFFF"/>
+                </a:solidFill>
+                <a:latin typeface="Bahij TheSansArabic Bold"/>
+                <a:cs typeface="Bahij TheSansArabic Bold"/>
+              </a:rPr>
+              <a:t>0</a:t>
+            </a:r>
+          </a:p>
+          <a:p>
+            <a:pPr algn="ctr" rtl="1">
+              <a:spcBef>
+                <a:spcPts val="0"/>
+              </a:spcBef>
+            </a:pPr>
+            <a:r>
+              <a:rPr lang="ar-SA" sz="2200" dirty="0">
+                <a:solidFill>
+                  <a:srgbClr val="FFFFFF"/>
+                </a:solidFill>
+                <a:latin typeface="Bahij TheSansArabic Plain"/>
+                <a:cs typeface="Bahij TheSansArabic Plain"/>
+              </a:rPr>
+              <a:t>لم يتحقق شرط الزيادة عن الإيرادات المقدّرة، فلا تُستحق حوافز</a:t>
+            </a:r>
+          </a:p>
+        </p:txBody>
+      </p:sp>
+    </p:spTree>
+    <p:extLst>
+      <p:ext uri="{BB962C8B-B14F-4D97-AF65-F5344CB8AC3E}">
+        <p14:creationId xmlns:p14="http://schemas.microsoft.com/office/powerpoint/2010/main" val="2964614212"/>
+      </p:ext>
+    </p:extLst>
+  </p:cSld>
+  <p:clrMapOvr>
+    <a:masterClrMapping/>
+  </p:clrMapOvr>
+</p:sld>
+</file>
+
 <file path=ppt/tags/tag1.xml><?xml version="1.0" encoding="utf-8"?>
 <p:tagLst xmlns:a="http://schemas.openxmlformats.org/drawingml/2006/main" xmlns:r="http://schemas.openxmlformats.org/officeDocument/2006/relationships" xmlns:p="http://schemas.openxmlformats.org/presentationml/2006/main">
   <p:tag name="THINKCELLSHAPEDONOTDELETE" val="thinkcellActiveDocDoNotDelete"/>

</xml_diff>

<commit_message>
Show the third incentive condition once (merged into employee incentives card)
Co-Authored-By: Claude Opus 5.5 <noreply@anthropic.com>
Claude-Session: https://claude.ai/code/session_01D73U26FQnMJ6VM9LfvsWf3
</commit_message>
<xml_diff>
--- a/عرض_الإيرادات_سيناريوهات_إقفال_2026.pptx
+++ b/عرض_الإيرادات_سيناريوهات_إقفال_2026.pptx
@@ -53552,8 +53552,8 @@
         </p:nvSpPr>
         <p:spPr>
           <a:xfrm>
-            <a:off x="16700000" y="5950000"/>
-            <a:ext cx="7100000" cy="3500000"/>
+            <a:off x="12900000" y="5950000"/>
+            <a:ext cx="10900000" cy="3500000"/>
           </a:xfrm>
           <a:prstGeom prst="roundRect">
             <a:avLst>
@@ -53639,8 +53639,8 @@
         </p:nvSpPr>
         <p:spPr>
           <a:xfrm>
-            <a:off x="16950000" y="6130000"/>
-            <a:ext cx="5600000" cy="1250000"/>
+            <a:off x="13150000" y="6130000"/>
+            <a:ext cx="9400000" cy="1250000"/>
           </a:xfrm>
           <a:prstGeom prst="roundRect">
             <a:avLst>
@@ -53684,8 +53684,8 @@
         </p:nvSpPr>
         <p:spPr>
           <a:xfrm>
-            <a:off x="17100000" y="7600000"/>
-            <a:ext cx="6300000" cy="1600000"/>
+            <a:off x="13300000" y="7600000"/>
+            <a:ext cx="10100000" cy="1600000"/>
           </a:xfrm>
           <a:prstGeom prst="roundRect">
             <a:avLst>
@@ -53748,8 +53748,8 @@
         </p:nvSpPr>
         <p:spPr>
           <a:xfrm>
-            <a:off x="15880000" y="7350000"/>
-            <a:ext cx="640000" cy="700000"/>
+            <a:off x="11840000" y="7350000"/>
+            <a:ext cx="880000" cy="700000"/>
           </a:xfrm>
           <a:prstGeom prst="leftArrow">
             <a:avLst/>
@@ -53777,8 +53777,8 @@
         </p:nvSpPr>
         <p:spPr>
           <a:xfrm>
-            <a:off x="8640000" y="5950000"/>
-            <a:ext cx="7100000" cy="3500000"/>
+            <a:off x="580000" y="5950000"/>
+            <a:ext cx="10900000" cy="3500000"/>
           </a:xfrm>
           <a:prstGeom prst="roundRect">
             <a:avLst>
@@ -53819,7 +53819,7 @@
         </p:nvSpPr>
         <p:spPr>
           <a:xfrm>
-            <a:off x="14590000" y="6200000"/>
+            <a:off x="10330000" y="6200000"/>
             <a:ext cx="850000" cy="850000"/>
           </a:xfrm>
           <a:prstGeom prst="ellipse">
@@ -53864,8 +53864,8 @@
         </p:nvSpPr>
         <p:spPr>
           <a:xfrm>
-            <a:off x="8890000" y="6130000"/>
-            <a:ext cx="5600000" cy="1250000"/>
+            <a:off x="830000" y="6130000"/>
+            <a:ext cx="9400000" cy="1250000"/>
           </a:xfrm>
           <a:prstGeom prst="roundRect">
             <a:avLst>
@@ -53909,8 +53909,8 @@
         </p:nvSpPr>
         <p:spPr>
           <a:xfrm>
-            <a:off x="9040000" y="7600000"/>
-            <a:ext cx="6300000" cy="1600000"/>
+            <a:off x="980000" y="7600000"/>
+            <a:ext cx="10100000" cy="1600000"/>
           </a:xfrm>
           <a:prstGeom prst="roundRect">
             <a:avLst>
@@ -53967,232 +53967,7 @@
       </p:sp>
       <p:sp>
         <p:nvSpPr>
-          <p:cNvPr id="1014" name="Arrow 1014"/>
-          <p:cNvSpPr/>
-          <p:nvPr/>
-        </p:nvSpPr>
-        <p:spPr>
-          <a:xfrm>
-            <a:off x="7820000" y="7350000"/>
-            <a:ext cx="640000" cy="700000"/>
-          </a:xfrm>
-          <a:prstGeom prst="leftArrow">
-            <a:avLst/>
-          </a:prstGeom>
-          <a:solidFill>
-            <a:srgbClr val="00B050"/>
-          </a:solidFill>
-          <a:ln>
-            <a:noFill/>
-          </a:ln>
-        </p:spPr>
-        <p:txBody>
-          <a:bodyPr/>
-          <a:lstStyle/>
-          <a:p>
-            <a:endParaRPr lang="ar-SA"/>
-          </a:p>
-        </p:txBody>
-      </p:sp>
-      <p:sp>
-        <p:nvSpPr>
-          <p:cNvPr id="1015" name="Inc 1015"/>
-          <p:cNvSpPr/>
-          <p:nvPr/>
-        </p:nvSpPr>
-        <p:spPr>
-          <a:xfrm>
-            <a:off x="580000" y="5950000"/>
-            <a:ext cx="7100000" cy="3500000"/>
-          </a:xfrm>
-          <a:prstGeom prst="roundRect">
-            <a:avLst>
-              <a:gd name="adj" fmla="val 8000"/>
-            </a:avLst>
-          </a:prstGeom>
-          <a:solidFill>
-            <a:srgbClr val="FFFFFF"/>
-          </a:solidFill>
-          <a:ln w="25400">
-            <a:solidFill>
-              <a:srgbClr val="01686A"/>
-            </a:solidFill>
-          </a:ln>
-          <a:effectLst>
-            <a:outerShdw blurRad="190500" dist="38100" dir="5400000" algn="t" rotWithShape="0">
-              <a:srgbClr val="000000">
-                <a:alpha val="18000"/>
-              </a:srgbClr>
-            </a:outerShdw>
-          </a:effectLst>
-        </p:spPr>
-        <p:txBody>
-          <a:bodyPr wrap="square" lIns="91440" rIns="91440" tIns="45720" bIns="45720" rtlCol="1" anchor="ctr">
-            <a:normAutofit/>
-          </a:bodyPr>
-          <a:lstStyle/>
-          <a:p>
-            <a:endParaRPr lang="ar-SA"/>
-          </a:p>
-        </p:txBody>
-      </p:sp>
-      <p:sp>
-        <p:nvSpPr>
-          <p:cNvPr id="1016" name="Inc 1016"/>
-          <p:cNvSpPr/>
-          <p:nvPr/>
-        </p:nvSpPr>
-        <p:spPr>
-          <a:xfrm>
-            <a:off x="6530000" y="6200000"/>
-            <a:ext cx="850000" cy="850000"/>
-          </a:xfrm>
-          <a:prstGeom prst="ellipse">
-            <a:avLst/>
-          </a:prstGeom>
-          <a:solidFill>
-            <a:srgbClr val="01686A"/>
-          </a:solidFill>
-          <a:ln>
-            <a:noFill/>
-          </a:ln>
-        </p:spPr>
-        <p:txBody>
-          <a:bodyPr wrap="square" lIns="91440" rIns="91440" tIns="45720" bIns="45720" rtlCol="1" anchor="ctr">
-            <a:normAutofit/>
-          </a:bodyPr>
-          <a:lstStyle/>
-          <a:p>
-            <a:pPr algn="ctr" rtl="1">
-              <a:spcBef>
-                <a:spcPts val="0"/>
-              </a:spcBef>
-            </a:pPr>
-            <a:r>
-              <a:rPr lang="ar-SA" sz="3200" dirty="0">
-                <a:solidFill>
-                  <a:srgbClr val="FFFFFF"/>
-                </a:solidFill>
-                <a:latin typeface="Bahij TheSansArabic Bold"/>
-                <a:cs typeface="Bahij TheSansArabic Bold"/>
-              </a:rPr>
-              <a:t>3</a:t>
-            </a:r>
-          </a:p>
-        </p:txBody>
-      </p:sp>
-      <p:sp>
-        <p:nvSpPr>
-          <p:cNvPr id="1017" name="Inc 1017"/>
-          <p:cNvSpPr/>
-          <p:nvPr/>
-        </p:nvSpPr>
-        <p:spPr>
-          <a:xfrm>
-            <a:off x="830000" y="6130000"/>
-            <a:ext cx="5600000" cy="1250000"/>
-          </a:xfrm>
-          <a:prstGeom prst="roundRect">
-            <a:avLst>
-              <a:gd name="adj" fmla="val 8000"/>
-            </a:avLst>
-          </a:prstGeom>
-          <a:noFill/>
-          <a:ln>
-            <a:noFill/>
-          </a:ln>
-        </p:spPr>
-        <p:txBody>
-          <a:bodyPr wrap="square" lIns="91440" rIns="91440" tIns="45720" bIns="45720" rtlCol="1" anchor="ctr">
-            <a:normAutofit/>
-          </a:bodyPr>
-          <a:lstStyle/>
-          <a:p>
-            <a:pPr algn="r" rtl="1">
-              <a:spcBef>
-                <a:spcPts val="0"/>
-              </a:spcBef>
-            </a:pPr>
-            <a:r>
-              <a:rPr lang="ar-SA" sz="2200" dirty="0">
-                <a:solidFill>
-                  <a:srgbClr val="262626"/>
-                </a:solidFill>
-                <a:latin typeface="Bahij TheSansArabic Bold"/>
-                <a:cs typeface="Bahij TheSansArabic Bold"/>
-              </a:rPr>
-              <a:t>حوافز الموظفين: 40% من إجمالي الحوافز</a:t>
-            </a:r>
-          </a:p>
-        </p:txBody>
-      </p:sp>
-      <p:sp>
-        <p:nvSpPr>
-          <p:cNvPr id="1018" name="Inc 1018"/>
-          <p:cNvSpPr/>
-          <p:nvPr/>
-        </p:nvSpPr>
-        <p:spPr>
-          <a:xfrm>
-            <a:off x="980000" y="7600000"/>
-            <a:ext cx="6300000" cy="1600000"/>
-          </a:xfrm>
-          <a:prstGeom prst="roundRect">
-            <a:avLst>
-              <a:gd name="adj" fmla="val 12000"/>
-            </a:avLst>
-          </a:prstGeom>
-          <a:solidFill>
-            <a:srgbClr val="F2F8F8"/>
-          </a:solidFill>
-          <a:ln>
-            <a:noFill/>
-          </a:ln>
-        </p:spPr>
-        <p:txBody>
-          <a:bodyPr wrap="square" lIns="91440" rIns="91440" tIns="45720" bIns="45720" rtlCol="1" anchor="ctr">
-            <a:normAutofit/>
-          </a:bodyPr>
-          <a:lstStyle/>
-          <a:p>
-            <a:pPr algn="ctr" rtl="1">
-              <a:spcBef>
-                <a:spcPts val="0"/>
-              </a:spcBef>
-            </a:pPr>
-            <a:r>
-              <a:rPr lang="ar-SA" sz="6000" dirty="0">
-                <a:solidFill>
-                  <a:srgbClr val="01686A"/>
-                </a:solidFill>
-                <a:latin typeface="Bahij TheSansArabic Bold"/>
-                <a:cs typeface="Bahij TheSansArabic Bold"/>
-              </a:rPr>
-              <a:t>34.1</a:t>
-            </a:r>
-          </a:p>
-          <a:p>
-            <a:pPr algn="ctr" rtl="1">
-              <a:spcBef>
-                <a:spcPts val="0"/>
-              </a:spcBef>
-            </a:pPr>
-            <a:r>
-              <a:rPr lang="ar-SA" sz="2000" dirty="0">
-                <a:solidFill>
-                  <a:srgbClr val="595959"/>
-                </a:solidFill>
-                <a:latin typeface="Bahij TheSansArabic Plain"/>
-                <a:cs typeface="Bahij TheSansArabic Plain"/>
-              </a:rPr>
-              <a:t>مليون ريال</a:t>
-            </a:r>
-          </a:p>
-        </p:txBody>
-      </p:sp>
-      <p:sp>
-        <p:nvSpPr>
-          <p:cNvPr id="1019" name="Inc 1019"/>
+          <p:cNvPr id="1014" name="Inc 1014"/>
           <p:cNvSpPr/>
           <p:nvPr/>
         </p:nvSpPr>
@@ -54273,7 +54048,97 @@
                 <a:latin typeface="Bahij TheSansArabic Plain"/>
                 <a:cs typeface="Bahij TheSansArabic Plain"/>
               </a:rPr>
-              <a:t>مليون ريال  —  40% من إجمالي الحوافز</a:t>
+              <a:t>مليون ريال</a:t>
+            </a:r>
+          </a:p>
+        </p:txBody>
+      </p:sp>
+      <p:sp>
+        <p:nvSpPr>
+          <p:cNvPr id="1015" name="Inc 1015"/>
+          <p:cNvSpPr/>
+          <p:nvPr/>
+        </p:nvSpPr>
+        <p:spPr>
+          <a:xfrm>
+            <a:off x="22770000" y="10200000"/>
+            <a:ext cx="850000" cy="850000"/>
+          </a:xfrm>
+          <a:prstGeom prst="ellipse">
+            <a:avLst/>
+          </a:prstGeom>
+          <a:solidFill>
+            <a:srgbClr val="FFFFFF"/>
+          </a:solidFill>
+          <a:ln>
+            <a:noFill/>
+          </a:ln>
+        </p:spPr>
+        <p:txBody>
+          <a:bodyPr wrap="square" lIns="91440" rIns="91440" tIns="45720" bIns="45720" rtlCol="1" anchor="ctr">
+            <a:normAutofit/>
+          </a:bodyPr>
+          <a:lstStyle/>
+          <a:p>
+            <a:pPr algn="ctr" rtl="1">
+              <a:spcBef>
+                <a:spcPts val="0"/>
+              </a:spcBef>
+            </a:pPr>
+            <a:r>
+              <a:rPr lang="ar-SA" sz="3200" dirty="0">
+                <a:solidFill>
+                  <a:srgbClr val="01686A"/>
+                </a:solidFill>
+                <a:latin typeface="Bahij TheSansArabic Bold"/>
+                <a:cs typeface="Bahij TheSansArabic Bold"/>
+              </a:rPr>
+              <a:t>3</a:t>
+            </a:r>
+          </a:p>
+        </p:txBody>
+      </p:sp>
+      <p:sp>
+        <p:nvSpPr>
+          <p:cNvPr id="1016" name="Inc 1016"/>
+          <p:cNvSpPr/>
+          <p:nvPr/>
+        </p:nvSpPr>
+        <p:spPr>
+          <a:xfrm>
+            <a:off x="14200000" y="10200000"/>
+            <a:ext cx="8450000" cy="850000"/>
+          </a:xfrm>
+          <a:prstGeom prst="roundRect">
+            <a:avLst>
+              <a:gd name="adj" fmla="val 8000"/>
+            </a:avLst>
+          </a:prstGeom>
+          <a:noFill/>
+          <a:ln>
+            <a:noFill/>
+          </a:ln>
+        </p:spPr>
+        <p:txBody>
+          <a:bodyPr wrap="square" lIns="91440" rIns="91440" tIns="45720" bIns="45720" rtlCol="1" anchor="ctr">
+            <a:normAutofit/>
+          </a:bodyPr>
+          <a:lstStyle/>
+          <a:p>
+            <a:pPr algn="r" rtl="1">
+              <a:spcBef>
+                <a:spcPts val="0"/>
+              </a:spcBef>
+            </a:pPr>
+            <a:r>
+              <a:rPr lang="ar-SA" sz="2200" dirty="0">
+                <a:solidFill>
+                  <a:srgbClr val="FFFFFF"/>
+                </a:solidFill>
+                <a:latin typeface="Bahij TheSansArabic Bold"/>
+                <a:cs typeface="Bahij TheSansArabic Bold"/>
+              </a:rPr>
+              <a:t>حوافز الموظفين: 40% من إجمالي الحوافز</a:t>
             </a:r>
           </a:p>
         </p:txBody>
@@ -55351,7 +55216,7 @@
       </p:pic>
       <p:sp>
         <p:nvSpPr>
-          <p:cNvPr id="1020" name="Inc 1020"/>
+          <p:cNvPr id="1017" name="Inc 1017"/>
           <p:cNvSpPr/>
           <p:nvPr/>
         </p:nvSpPr>
@@ -55441,7 +55306,7 @@
       </p:sp>
       <p:sp>
         <p:nvSpPr>
-          <p:cNvPr id="1021" name="Inc 1021"/>
+          <p:cNvPr id="1018" name="Inc 1018"/>
           <p:cNvSpPr/>
           <p:nvPr/>
         </p:nvSpPr>
@@ -55531,7 +55396,7 @@
       </p:sp>
       <p:sp>
         <p:nvSpPr>
-          <p:cNvPr id="1022" name="Inc 1022"/>
+          <p:cNvPr id="1019" name="Inc 1019"/>
           <p:cNvSpPr/>
           <p:nvPr/>
         </p:nvSpPr>
@@ -55619,7 +55484,7 @@
       </p:sp>
       <p:sp>
         <p:nvSpPr>
-          <p:cNvPr id="1023" name="Inc 1023"/>
+          <p:cNvPr id="1020" name="Inc 1020"/>
           <p:cNvSpPr/>
           <p:nvPr/>
         </p:nvSpPr>
@@ -55664,14 +55529,14 @@
       </p:sp>
       <p:sp>
         <p:nvSpPr>
-          <p:cNvPr id="1024" name="Inc 1024"/>
+          <p:cNvPr id="1021" name="Inc 1021"/>
           <p:cNvSpPr/>
           <p:nvPr/>
         </p:nvSpPr>
         <p:spPr>
           <a:xfrm>
-            <a:off x="16700000" y="5950000"/>
-            <a:ext cx="7100000" cy="3500000"/>
+            <a:off x="12900000" y="5950000"/>
+            <a:ext cx="10900000" cy="3500000"/>
           </a:xfrm>
           <a:prstGeom prst="roundRect">
             <a:avLst>
@@ -55706,7 +55571,7 @@
       </p:sp>
       <p:sp>
         <p:nvSpPr>
-          <p:cNvPr id="1025" name="Inc 1025"/>
+          <p:cNvPr id="1022" name="Inc 1022"/>
           <p:cNvSpPr/>
           <p:nvPr/>
         </p:nvSpPr>
@@ -55751,14 +55616,14 @@
       </p:sp>
       <p:sp>
         <p:nvSpPr>
-          <p:cNvPr id="1026" name="Inc 1026"/>
+          <p:cNvPr id="1023" name="Inc 1023"/>
           <p:cNvSpPr/>
           <p:nvPr/>
         </p:nvSpPr>
         <p:spPr>
           <a:xfrm>
-            <a:off x="16950000" y="6130000"/>
-            <a:ext cx="5600000" cy="1250000"/>
+            <a:off x="13150000" y="6130000"/>
+            <a:ext cx="9400000" cy="1250000"/>
           </a:xfrm>
           <a:prstGeom prst="roundRect">
             <a:avLst>
@@ -55796,14 +55661,14 @@
       </p:sp>
       <p:sp>
         <p:nvSpPr>
-          <p:cNvPr id="1027" name="Inc 1027"/>
+          <p:cNvPr id="1024" name="Inc 1024"/>
           <p:cNvSpPr/>
           <p:nvPr/>
         </p:nvSpPr>
         <p:spPr>
           <a:xfrm>
-            <a:off x="17100000" y="7600000"/>
-            <a:ext cx="6300000" cy="1600000"/>
+            <a:off x="13300000" y="7600000"/>
+            <a:ext cx="10100000" cy="1600000"/>
           </a:xfrm>
           <a:prstGeom prst="roundRect">
             <a:avLst>
@@ -55860,14 +55725,14 @@
       </p:sp>
       <p:sp>
         <p:nvSpPr>
-          <p:cNvPr id="1028" name="Arrow 1028"/>
+          <p:cNvPr id="1025" name="Arrow 1025"/>
           <p:cNvSpPr/>
           <p:nvPr/>
         </p:nvSpPr>
         <p:spPr>
           <a:xfrm>
-            <a:off x="15880000" y="7350000"/>
-            <a:ext cx="640000" cy="700000"/>
+            <a:off x="11840000" y="7350000"/>
+            <a:ext cx="880000" cy="700000"/>
           </a:xfrm>
           <a:prstGeom prst="leftArrow">
             <a:avLst/>
@@ -55889,14 +55754,14 @@
       </p:sp>
       <p:sp>
         <p:nvSpPr>
-          <p:cNvPr id="1029" name="Inc 1029"/>
+          <p:cNvPr id="1026" name="Inc 1026"/>
           <p:cNvSpPr/>
           <p:nvPr/>
         </p:nvSpPr>
         <p:spPr>
           <a:xfrm>
-            <a:off x="8640000" y="5950000"/>
-            <a:ext cx="7100000" cy="3500000"/>
+            <a:off x="580000" y="5950000"/>
+            <a:ext cx="10900000" cy="3500000"/>
           </a:xfrm>
           <a:prstGeom prst="roundRect">
             <a:avLst>
@@ -55931,13 +55796,13 @@
       </p:sp>
       <p:sp>
         <p:nvSpPr>
-          <p:cNvPr id="1030" name="Inc 1030"/>
+          <p:cNvPr id="1027" name="Inc 1027"/>
           <p:cNvSpPr/>
           <p:nvPr/>
         </p:nvSpPr>
         <p:spPr>
           <a:xfrm>
-            <a:off x="14590000" y="6200000"/>
+            <a:off x="10330000" y="6200000"/>
             <a:ext cx="850000" cy="850000"/>
           </a:xfrm>
           <a:prstGeom prst="ellipse">
@@ -55976,14 +55841,14 @@
       </p:sp>
       <p:sp>
         <p:nvSpPr>
-          <p:cNvPr id="1031" name="Inc 1031"/>
+          <p:cNvPr id="1028" name="Inc 1028"/>
           <p:cNvSpPr/>
           <p:nvPr/>
         </p:nvSpPr>
         <p:spPr>
           <a:xfrm>
-            <a:off x="8890000" y="6130000"/>
-            <a:ext cx="5600000" cy="1250000"/>
+            <a:off x="830000" y="6130000"/>
+            <a:ext cx="9400000" cy="1250000"/>
           </a:xfrm>
           <a:prstGeom prst="roundRect">
             <a:avLst>
@@ -56021,14 +55886,14 @@
       </p:sp>
       <p:sp>
         <p:nvSpPr>
-          <p:cNvPr id="1032" name="Inc 1032"/>
+          <p:cNvPr id="1029" name="Inc 1029"/>
           <p:cNvSpPr/>
           <p:nvPr/>
         </p:nvSpPr>
         <p:spPr>
           <a:xfrm>
-            <a:off x="9040000" y="7600000"/>
-            <a:ext cx="6300000" cy="1600000"/>
+            <a:off x="980000" y="7600000"/>
+            <a:ext cx="10100000" cy="1600000"/>
           </a:xfrm>
           <a:prstGeom prst="roundRect">
             <a:avLst>
@@ -56085,232 +55950,7 @@
       </p:sp>
       <p:sp>
         <p:nvSpPr>
-          <p:cNvPr id="1033" name="Arrow 1033"/>
-          <p:cNvSpPr/>
-          <p:nvPr/>
-        </p:nvSpPr>
-        <p:spPr>
-          <a:xfrm>
-            <a:off x="7820000" y="7350000"/>
-            <a:ext cx="640000" cy="700000"/>
-          </a:xfrm>
-          <a:prstGeom prst="leftArrow">
-            <a:avLst/>
-          </a:prstGeom>
-          <a:solidFill>
-            <a:srgbClr val="00B050"/>
-          </a:solidFill>
-          <a:ln>
-            <a:noFill/>
-          </a:ln>
-        </p:spPr>
-        <p:txBody>
-          <a:bodyPr/>
-          <a:lstStyle/>
-          <a:p>
-            <a:endParaRPr lang="ar-SA"/>
-          </a:p>
-        </p:txBody>
-      </p:sp>
-      <p:sp>
-        <p:nvSpPr>
-          <p:cNvPr id="1034" name="Inc 1034"/>
-          <p:cNvSpPr/>
-          <p:nvPr/>
-        </p:nvSpPr>
-        <p:spPr>
-          <a:xfrm>
-            <a:off x="580000" y="5950000"/>
-            <a:ext cx="7100000" cy="3500000"/>
-          </a:xfrm>
-          <a:prstGeom prst="roundRect">
-            <a:avLst>
-              <a:gd name="adj" fmla="val 8000"/>
-            </a:avLst>
-          </a:prstGeom>
-          <a:solidFill>
-            <a:srgbClr val="FFFFFF"/>
-          </a:solidFill>
-          <a:ln w="25400">
-            <a:solidFill>
-              <a:srgbClr val="01686A"/>
-            </a:solidFill>
-          </a:ln>
-          <a:effectLst>
-            <a:outerShdw blurRad="190500" dist="38100" dir="5400000" algn="t" rotWithShape="0">
-              <a:srgbClr val="000000">
-                <a:alpha val="18000"/>
-              </a:srgbClr>
-            </a:outerShdw>
-          </a:effectLst>
-        </p:spPr>
-        <p:txBody>
-          <a:bodyPr wrap="square" lIns="91440" rIns="91440" tIns="45720" bIns="45720" rtlCol="1" anchor="ctr">
-            <a:normAutofit/>
-          </a:bodyPr>
-          <a:lstStyle/>
-          <a:p>
-            <a:endParaRPr lang="ar-SA"/>
-          </a:p>
-        </p:txBody>
-      </p:sp>
-      <p:sp>
-        <p:nvSpPr>
-          <p:cNvPr id="1035" name="Inc 1035"/>
-          <p:cNvSpPr/>
-          <p:nvPr/>
-        </p:nvSpPr>
-        <p:spPr>
-          <a:xfrm>
-            <a:off x="6530000" y="6200000"/>
-            <a:ext cx="850000" cy="850000"/>
-          </a:xfrm>
-          <a:prstGeom prst="ellipse">
-            <a:avLst/>
-          </a:prstGeom>
-          <a:solidFill>
-            <a:srgbClr val="01686A"/>
-          </a:solidFill>
-          <a:ln>
-            <a:noFill/>
-          </a:ln>
-        </p:spPr>
-        <p:txBody>
-          <a:bodyPr wrap="square" lIns="91440" rIns="91440" tIns="45720" bIns="45720" rtlCol="1" anchor="ctr">
-            <a:normAutofit/>
-          </a:bodyPr>
-          <a:lstStyle/>
-          <a:p>
-            <a:pPr algn="ctr" rtl="1">
-              <a:spcBef>
-                <a:spcPts val="0"/>
-              </a:spcBef>
-            </a:pPr>
-            <a:r>
-              <a:rPr lang="ar-SA" sz="3200" dirty="0">
-                <a:solidFill>
-                  <a:srgbClr val="FFFFFF"/>
-                </a:solidFill>
-                <a:latin typeface="Bahij TheSansArabic Bold"/>
-                <a:cs typeface="Bahij TheSansArabic Bold"/>
-              </a:rPr>
-              <a:t>3</a:t>
-            </a:r>
-          </a:p>
-        </p:txBody>
-      </p:sp>
-      <p:sp>
-        <p:nvSpPr>
-          <p:cNvPr id="1036" name="Inc 1036"/>
-          <p:cNvSpPr/>
-          <p:nvPr/>
-        </p:nvSpPr>
-        <p:spPr>
-          <a:xfrm>
-            <a:off x="830000" y="6130000"/>
-            <a:ext cx="5600000" cy="1250000"/>
-          </a:xfrm>
-          <a:prstGeom prst="roundRect">
-            <a:avLst>
-              <a:gd name="adj" fmla="val 8000"/>
-            </a:avLst>
-          </a:prstGeom>
-          <a:noFill/>
-          <a:ln>
-            <a:noFill/>
-          </a:ln>
-        </p:spPr>
-        <p:txBody>
-          <a:bodyPr wrap="square" lIns="91440" rIns="91440" tIns="45720" bIns="45720" rtlCol="1" anchor="ctr">
-            <a:normAutofit/>
-          </a:bodyPr>
-          <a:lstStyle/>
-          <a:p>
-            <a:pPr algn="r" rtl="1">
-              <a:spcBef>
-                <a:spcPts val="0"/>
-              </a:spcBef>
-            </a:pPr>
-            <a:r>
-              <a:rPr lang="ar-SA" sz="2200" dirty="0">
-                <a:solidFill>
-                  <a:srgbClr val="262626"/>
-                </a:solidFill>
-                <a:latin typeface="Bahij TheSansArabic Bold"/>
-                <a:cs typeface="Bahij TheSansArabic Bold"/>
-              </a:rPr>
-              <a:t>حوافز الموظفين: 40% من إجمالي الحوافز</a:t>
-            </a:r>
-          </a:p>
-        </p:txBody>
-      </p:sp>
-      <p:sp>
-        <p:nvSpPr>
-          <p:cNvPr id="1037" name="Inc 1037"/>
-          <p:cNvSpPr/>
-          <p:nvPr/>
-        </p:nvSpPr>
-        <p:spPr>
-          <a:xfrm>
-            <a:off x="980000" y="7600000"/>
-            <a:ext cx="6300000" cy="1600000"/>
-          </a:xfrm>
-          <a:prstGeom prst="roundRect">
-            <a:avLst>
-              <a:gd name="adj" fmla="val 12000"/>
-            </a:avLst>
-          </a:prstGeom>
-          <a:solidFill>
-            <a:srgbClr val="F2F8F8"/>
-          </a:solidFill>
-          <a:ln>
-            <a:noFill/>
-          </a:ln>
-        </p:spPr>
-        <p:txBody>
-          <a:bodyPr wrap="square" lIns="91440" rIns="91440" tIns="45720" bIns="45720" rtlCol="1" anchor="ctr">
-            <a:normAutofit/>
-          </a:bodyPr>
-          <a:lstStyle/>
-          <a:p>
-            <a:pPr algn="ctr" rtl="1">
-              <a:spcBef>
-                <a:spcPts val="0"/>
-              </a:spcBef>
-            </a:pPr>
-            <a:r>
-              <a:rPr lang="ar-SA" sz="6000" dirty="0">
-                <a:solidFill>
-                  <a:srgbClr val="595959"/>
-                </a:solidFill>
-                <a:latin typeface="Bahij TheSansArabic Bold"/>
-                <a:cs typeface="Bahij TheSansArabic Bold"/>
-              </a:rPr>
-              <a:t>0</a:t>
-            </a:r>
-          </a:p>
-          <a:p>
-            <a:pPr algn="ctr" rtl="1">
-              <a:spcBef>
-                <a:spcPts val="0"/>
-              </a:spcBef>
-            </a:pPr>
-            <a:r>
-              <a:rPr lang="ar-SA" sz="2000" dirty="0">
-                <a:solidFill>
-                  <a:srgbClr val="595959"/>
-                </a:solidFill>
-                <a:latin typeface="Bahij TheSansArabic Plain"/>
-                <a:cs typeface="Bahij TheSansArabic Plain"/>
-              </a:rPr>
-              <a:t>مليون ريال</a:t>
-            </a:r>
-          </a:p>
-        </p:txBody>
-      </p:sp>
-      <p:sp>
-        <p:nvSpPr>
-          <p:cNvPr id="1038" name="Inc 1038"/>
+          <p:cNvPr id="1030" name="Inc 1030"/>
           <p:cNvSpPr/>
           <p:nvPr/>
         </p:nvSpPr>
@@ -56392,6 +56032,96 @@
                 <a:cs typeface="Bahij TheSansArabic Plain"/>
               </a:rPr>
               <a:t>لم يتحقق شرط الزيادة عن الإيرادات المقدّرة، فلا تُستحق حوافز</a:t>
+            </a:r>
+          </a:p>
+        </p:txBody>
+      </p:sp>
+      <p:sp>
+        <p:nvSpPr>
+          <p:cNvPr id="1031" name="Inc 1031"/>
+          <p:cNvSpPr/>
+          <p:nvPr/>
+        </p:nvSpPr>
+        <p:spPr>
+          <a:xfrm>
+            <a:off x="22770000" y="10200000"/>
+            <a:ext cx="850000" cy="850000"/>
+          </a:xfrm>
+          <a:prstGeom prst="ellipse">
+            <a:avLst/>
+          </a:prstGeom>
+          <a:solidFill>
+            <a:srgbClr val="FFFFFF"/>
+          </a:solidFill>
+          <a:ln>
+            <a:noFill/>
+          </a:ln>
+        </p:spPr>
+        <p:txBody>
+          <a:bodyPr wrap="square" lIns="91440" rIns="91440" tIns="45720" bIns="45720" rtlCol="1" anchor="ctr">
+            <a:normAutofit/>
+          </a:bodyPr>
+          <a:lstStyle/>
+          <a:p>
+            <a:pPr algn="ctr" rtl="1">
+              <a:spcBef>
+                <a:spcPts val="0"/>
+              </a:spcBef>
+            </a:pPr>
+            <a:r>
+              <a:rPr lang="ar-SA" sz="3200" dirty="0">
+                <a:solidFill>
+                  <a:srgbClr val="7F7F7F"/>
+                </a:solidFill>
+                <a:latin typeface="Bahij TheSansArabic Bold"/>
+                <a:cs typeface="Bahij TheSansArabic Bold"/>
+              </a:rPr>
+              <a:t>3</a:t>
+            </a:r>
+          </a:p>
+        </p:txBody>
+      </p:sp>
+      <p:sp>
+        <p:nvSpPr>
+          <p:cNvPr id="1032" name="Inc 1032"/>
+          <p:cNvSpPr/>
+          <p:nvPr/>
+        </p:nvSpPr>
+        <p:spPr>
+          <a:xfrm>
+            <a:off x="14200000" y="10200000"/>
+            <a:ext cx="8450000" cy="850000"/>
+          </a:xfrm>
+          <a:prstGeom prst="roundRect">
+            <a:avLst>
+              <a:gd name="adj" fmla="val 8000"/>
+            </a:avLst>
+          </a:prstGeom>
+          <a:noFill/>
+          <a:ln>
+            <a:noFill/>
+          </a:ln>
+        </p:spPr>
+        <p:txBody>
+          <a:bodyPr wrap="square" lIns="91440" rIns="91440" tIns="45720" bIns="45720" rtlCol="1" anchor="ctr">
+            <a:normAutofit/>
+          </a:bodyPr>
+          <a:lstStyle/>
+          <a:p>
+            <a:pPr algn="r" rtl="1">
+              <a:spcBef>
+                <a:spcPts val="0"/>
+              </a:spcBef>
+            </a:pPr>
+            <a:r>
+              <a:rPr lang="ar-SA" sz="2200" dirty="0">
+                <a:solidFill>
+                  <a:srgbClr val="FFFFFF"/>
+                </a:solidFill>
+                <a:latin typeface="Bahij TheSansArabic Bold"/>
+                <a:cs typeface="Bahij TheSansArabic Bold"/>
+              </a:rPr>
+              <a:t>حوافز الموظفين: 40% من إجمالي الحوافز</a:t>
             </a:r>
           </a:p>
         </p:txBody>

</xml_diff>